<commit_message>
Data Harness deck: slides 7 and 8 in the muted black style
Slide 7 (build order) moves to black: grey phases, yellow only on phase
5 (first real patients), gradient bars on the three rules. Slide 8 (PHI
governance): grey cards, blue status and flow lines, yellow gates,
gradient frames on the four additions. muted() gains per-slide accent
options.

Co-Authored-By: Claude Opus 5.5 <noreply@anthropic.com>
Claude-Session: https://claude.ai/code/session_01Hf94kqMzSofkkrQm7kpNba
</commit_message>
<xml_diff>
--- a/poc/data_harness/Ascension Agentic Harness - Data Harness.pptx
+++ b/poc/data_harness/Ascension Agentic Harness - Data Harness.pptx
@@ -22625,7 +22625,7 @@
             <a:r>
               <a:rPr sz="800" b="1" i="0" spc="300">
                 <a:solidFill>
-                  <a:srgbClr val="00D6F2"/>
+                  <a:srgbClr val="6EA8FF"/>
                 </a:solidFill>
                 <a:latin typeface="Trenda IG Text"/>
               </a:rPr>
@@ -22659,7 +22659,7 @@
             <a:r>
               <a:rPr sz="2200" b="1" i="0">
                 <a:solidFill>
-                  <a:srgbClr val="FFFFFF"/>
+                  <a:srgbClr val="F2F2F2"/>
                 </a:solidFill>
                 <a:latin typeface="Trenda IG Text"/>
               </a:rPr>
@@ -22693,7 +22693,7 @@
             <a:r>
               <a:rPr sz="1050" b="0" i="0">
                 <a:solidFill>
-                  <a:srgbClr val="BFBFBF"/>
+                  <a:srgbClr val="B3B3B3"/>
                 </a:solidFill>
                 <a:latin typeface="Trenda IG Text"/>
               </a:rPr>
@@ -22727,7 +22727,7 @@
             <a:r>
               <a:rPr sz="640" b="1" i="0" spc="120">
                 <a:solidFill>
-                  <a:srgbClr val="FFFFFF"/>
+                  <a:srgbClr val="F2F2F2"/>
                 </a:solidFill>
                 <a:latin typeface="Trenda IG Text"/>
               </a:rPr>
@@ -22869,7 +22869,7 @@
             <a:r>
               <a:rPr sz="540" b="1" i="0">
                 <a:solidFill>
-                  <a:srgbClr val="FFFFFF"/>
+                  <a:srgbClr val="F2F2F2"/>
                 </a:solidFill>
                 <a:latin typeface="Trenda IG Text"/>
               </a:rPr>
@@ -23022,7 +23022,7 @@
             <a:r>
               <a:rPr sz="540" b="1" i="0">
                 <a:solidFill>
-                  <a:srgbClr val="FFFFFF"/>
+                  <a:srgbClr val="F2F2F2"/>
                 </a:solidFill>
                 <a:latin typeface="Trenda IG Text"/>
               </a:rPr>
@@ -23175,7 +23175,7 @@
             <a:r>
               <a:rPr sz="540" b="1" i="0">
                 <a:solidFill>
-                  <a:srgbClr val="FFFFFF"/>
+                  <a:srgbClr val="F2F2F2"/>
                 </a:solidFill>
                 <a:latin typeface="Trenda IG Text"/>
               </a:rPr>
@@ -23328,7 +23328,7 @@
             <a:r>
               <a:rPr sz="540" b="1" i="0">
                 <a:solidFill>
-                  <a:srgbClr val="FFFFFF"/>
+                  <a:srgbClr val="F2F2F2"/>
                 </a:solidFill>
                 <a:latin typeface="Trenda IG Text"/>
               </a:rPr>
@@ -23362,9 +23362,9 @@
           <a:prstGeom prst="line">
             <a:avLst/>
           </a:prstGeom>
-          <a:ln w="15875">
+          <a:ln w="9525">
             <a:solidFill>
-              <a:srgbClr val="00D6F2"/>
+              <a:srgbClr val="5B8DEF"/>
             </a:solidFill>
           </a:ln>
         </p:spPr>
@@ -23397,9 +23397,9 @@
           <a:prstGeom prst="line">
             <a:avLst/>
           </a:prstGeom>
-          <a:ln w="15875">
+          <a:ln w="9525">
             <a:solidFill>
-              <a:srgbClr val="00D6F2"/>
+              <a:srgbClr val="5B8DEF"/>
             </a:solidFill>
           </a:ln>
         </p:spPr>
@@ -23432,9 +23432,9 @@
           <a:prstGeom prst="line">
             <a:avLst/>
           </a:prstGeom>
-          <a:ln w="15875">
+          <a:ln w="9525">
             <a:solidFill>
-              <a:srgbClr val="00D6F2"/>
+              <a:srgbClr val="5B8DEF"/>
             </a:solidFill>
             <a:tailEnd type="triangle" w="med" len="med"/>
           </a:ln>
@@ -23468,9 +23468,9 @@
           <a:prstGeom prst="line">
             <a:avLst/>
           </a:prstGeom>
-          <a:ln w="15875">
+          <a:ln w="9525">
             <a:solidFill>
-              <a:srgbClr val="00D6F2"/>
+              <a:srgbClr val="5B8DEF"/>
             </a:solidFill>
           </a:ln>
         </p:spPr>
@@ -23503,9 +23503,9 @@
           <a:prstGeom prst="line">
             <a:avLst/>
           </a:prstGeom>
-          <a:ln w="15875">
+          <a:ln w="9525">
             <a:solidFill>
-              <a:srgbClr val="00D6F2"/>
+              <a:srgbClr val="5B8DEF"/>
             </a:solidFill>
           </a:ln>
         </p:spPr>
@@ -23538,9 +23538,9 @@
           <a:prstGeom prst="line">
             <a:avLst/>
           </a:prstGeom>
-          <a:ln w="15875">
+          <a:ln w="9525">
             <a:solidFill>
-              <a:srgbClr val="00D6F2"/>
+              <a:srgbClr val="5B8DEF"/>
             </a:solidFill>
             <a:tailEnd type="triangle" w="med" len="med"/>
           </a:ln>
@@ -23574,9 +23574,9 @@
           <a:prstGeom prst="line">
             <a:avLst/>
           </a:prstGeom>
-          <a:ln w="15875">
+          <a:ln w="9525">
             <a:solidFill>
-              <a:srgbClr val="00D6F2"/>
+              <a:srgbClr val="5B8DEF"/>
             </a:solidFill>
           </a:ln>
         </p:spPr>
@@ -23609,9 +23609,9 @@
           <a:prstGeom prst="line">
             <a:avLst/>
           </a:prstGeom>
-          <a:ln w="15875">
+          <a:ln w="9525">
             <a:solidFill>
-              <a:srgbClr val="00D6F2"/>
+              <a:srgbClr val="5B8DEF"/>
             </a:solidFill>
           </a:ln>
         </p:spPr>
@@ -23644,9 +23644,9 @@
           <a:prstGeom prst="line">
             <a:avLst/>
           </a:prstGeom>
-          <a:ln w="15875">
+          <a:ln w="9525">
             <a:solidFill>
-              <a:srgbClr val="00D6F2"/>
+              <a:srgbClr val="5B8DEF"/>
             </a:solidFill>
             <a:tailEnd type="triangle" w="med" len="med"/>
           </a:ln>
@@ -23680,9 +23680,9 @@
           <a:prstGeom prst="line">
             <a:avLst/>
           </a:prstGeom>
-          <a:ln w="15875">
+          <a:ln w="9525">
             <a:solidFill>
-              <a:srgbClr val="00D6F2"/>
+              <a:srgbClr val="5B8DEF"/>
             </a:solidFill>
           </a:ln>
         </p:spPr>
@@ -23715,9 +23715,9 @@
           <a:prstGeom prst="line">
             <a:avLst/>
           </a:prstGeom>
-          <a:ln w="15875">
+          <a:ln w="9525">
             <a:solidFill>
-              <a:srgbClr val="00D6F2"/>
+              <a:srgbClr val="5B8DEF"/>
             </a:solidFill>
           </a:ln>
         </p:spPr>
@@ -23750,9 +23750,9 @@
           <a:prstGeom prst="line">
             <a:avLst/>
           </a:prstGeom>
-          <a:ln w="15875">
+          <a:ln w="9525">
             <a:solidFill>
-              <a:srgbClr val="00D6F2"/>
+              <a:srgbClr val="5B8DEF"/>
             </a:solidFill>
             <a:tailEnd type="triangle" w="med" len="med"/>
           </a:ln>
@@ -23786,9 +23786,9 @@
           <a:prstGeom prst="line">
             <a:avLst/>
           </a:prstGeom>
-          <a:ln w="15875">
+          <a:ln w="9525">
             <a:solidFill>
-              <a:srgbClr val="00D6F2"/>
+              <a:srgbClr val="5B8DEF"/>
             </a:solidFill>
           </a:ln>
         </p:spPr>
@@ -23821,9 +23821,9 @@
           <a:prstGeom prst="line">
             <a:avLst/>
           </a:prstGeom>
-          <a:ln w="15875">
+          <a:ln w="9525">
             <a:solidFill>
-              <a:srgbClr val="00D6F2"/>
+              <a:srgbClr val="5B8DEF"/>
             </a:solidFill>
           </a:ln>
         </p:spPr>
@@ -23856,9 +23856,9 @@
           <a:prstGeom prst="line">
             <a:avLst/>
           </a:prstGeom>
-          <a:ln w="15875">
+          <a:ln w="9525">
             <a:solidFill>
-              <a:srgbClr val="00D6F2"/>
+              <a:srgbClr val="5B8DEF"/>
             </a:solidFill>
             <a:tailEnd type="triangle" w="med" len="med"/>
           </a:ln>
@@ -23892,9 +23892,9 @@
           <a:prstGeom prst="line">
             <a:avLst/>
           </a:prstGeom>
-          <a:ln w="15875">
+          <a:ln w="9525">
             <a:solidFill>
-              <a:srgbClr val="00D6F2"/>
+              <a:srgbClr val="5B8DEF"/>
             </a:solidFill>
           </a:ln>
         </p:spPr>
@@ -23927,9 +23927,9 @@
           <a:prstGeom prst="line">
             <a:avLst/>
           </a:prstGeom>
-          <a:ln w="15875">
+          <a:ln w="9525">
             <a:solidFill>
-              <a:srgbClr val="00D6F2"/>
+              <a:srgbClr val="5B8DEF"/>
             </a:solidFill>
           </a:ln>
         </p:spPr>
@@ -23962,9 +23962,9 @@
           <a:prstGeom prst="line">
             <a:avLst/>
           </a:prstGeom>
-          <a:ln w="15875">
+          <a:ln w="9525">
             <a:solidFill>
-              <a:srgbClr val="00D6F2"/>
+              <a:srgbClr val="5B8DEF"/>
             </a:solidFill>
             <a:tailEnd type="triangle" w="med" len="med"/>
           </a:ln>
@@ -23998,9 +23998,9 @@
           <a:prstGeom prst="line">
             <a:avLst/>
           </a:prstGeom>
-          <a:ln w="15875">
+          <a:ln w="9525">
             <a:solidFill>
-              <a:srgbClr val="8B7CD8"/>
+              <a:srgbClr val="4A4A4A"/>
             </a:solidFill>
             <a:prstDash val="dash"/>
           </a:ln>
@@ -24034,9 +24034,9 @@
           <a:prstGeom prst="line">
             <a:avLst/>
           </a:prstGeom>
-          <a:ln w="15875">
+          <a:ln w="9525">
             <a:solidFill>
-              <a:srgbClr val="8B7CD8"/>
+              <a:srgbClr val="4A4A4A"/>
             </a:solidFill>
             <a:prstDash val="dash"/>
             <a:tailEnd type="triangle" w="med" len="med"/>
@@ -24071,9 +24071,9 @@
           <a:prstGeom prst="line">
             <a:avLst/>
           </a:prstGeom>
-          <a:ln w="15875">
+          <a:ln w="9525">
             <a:solidFill>
-              <a:srgbClr val="8B7CD8"/>
+              <a:srgbClr val="4A4A4A"/>
             </a:solidFill>
             <a:prstDash val="dash"/>
             <a:tailEnd type="triangle" w="med" len="med"/>
@@ -24113,9 +24113,9 @@
           <a:solidFill>
             <a:srgbClr val="000000"/>
           </a:solidFill>
-          <a:ln w="12700">
+          <a:ln w="7620">
             <a:solidFill>
-              <a:srgbClr val="3A3A3A"/>
+              <a:srgbClr val="333333"/>
             </a:solidFill>
           </a:ln>
           <a:effectLst/>
@@ -24170,7 +24170,7 @@
             <a:r>
               <a:rPr sz="560" b="1" i="0">
                 <a:solidFill>
-                  <a:srgbClr val="FFFFFF"/>
+                  <a:srgbClr val="F2F2F2"/>
                 </a:solidFill>
                 <a:latin typeface="Trenda IG Text"/>
               </a:rPr>
@@ -24196,9 +24196,9 @@
             </a:avLst>
           </a:prstGeom>
           <a:noFill/>
-          <a:ln w="9525">
+          <a:ln w="6350">
             <a:solidFill>
-              <a:srgbClr val="BFBFBF"/>
+              <a:srgbClr val="6B6B6B"/>
             </a:solidFill>
           </a:ln>
           <a:effectLst/>
@@ -24249,7 +24249,7 @@
             <a:r>
               <a:rPr sz="420" b="1" i="0" spc="80">
                 <a:solidFill>
-                  <a:srgbClr val="BFBFBF"/>
+                  <a:srgbClr val="B3B3B3"/>
                 </a:solidFill>
                 <a:latin typeface="Trenda IG Text"/>
               </a:rPr>
@@ -24275,9 +24275,9 @@
             </a:avLst>
           </a:prstGeom>
           <a:solidFill>
-            <a:srgbClr val="2B2508"/>
+            <a:srgbClr val="161616"/>
           </a:solidFill>
-          <a:ln w="12700">
+          <a:ln w="7620">
             <a:solidFill>
               <a:srgbClr val="FFD700"/>
             </a:solidFill>
@@ -24334,7 +24334,7 @@
             <a:r>
               <a:rPr sz="560" b="1" i="0">
                 <a:solidFill>
-                  <a:srgbClr val="FFFFFF"/>
+                  <a:srgbClr val="F2F2F2"/>
                 </a:solidFill>
                 <a:latin typeface="Trenda IG Text"/>
               </a:rPr>
@@ -24360,9 +24360,9 @@
             </a:avLst>
           </a:prstGeom>
           <a:noFill/>
-          <a:ln w="9525">
+          <a:ln w="6350">
             <a:solidFill>
-              <a:srgbClr val="BFBFBF"/>
+              <a:srgbClr val="6B6B6B"/>
             </a:solidFill>
           </a:ln>
           <a:effectLst/>
@@ -24413,7 +24413,7 @@
             <a:r>
               <a:rPr sz="420" b="1" i="0" spc="80">
                 <a:solidFill>
-                  <a:srgbClr val="BFBFBF"/>
+                  <a:srgbClr val="B3B3B3"/>
                 </a:solidFill>
                 <a:latin typeface="Trenda IG Text"/>
               </a:rPr>
@@ -24441,9 +24441,9 @@
           <a:solidFill>
             <a:srgbClr val="000000"/>
           </a:solidFill>
-          <a:ln w="12700">
+          <a:ln w="7620">
             <a:solidFill>
-              <a:srgbClr val="3A3A3A"/>
+              <a:srgbClr val="333333"/>
             </a:solidFill>
           </a:ln>
           <a:effectLst/>
@@ -24498,7 +24498,7 @@
             <a:r>
               <a:rPr sz="560" b="1" i="0">
                 <a:solidFill>
-                  <a:srgbClr val="FFFFFF"/>
+                  <a:srgbClr val="F2F2F2"/>
                 </a:solidFill>
                 <a:latin typeface="Trenda IG Text"/>
               </a:rPr>
@@ -24524,9 +24524,9 @@
             </a:avLst>
           </a:prstGeom>
           <a:noFill/>
-          <a:ln w="9525">
+          <a:ln w="6350">
             <a:solidFill>
-              <a:srgbClr val="56E13B"/>
+              <a:srgbClr val="4A4A4A"/>
             </a:solidFill>
           </a:ln>
           <a:effectLst/>
@@ -24577,7 +24577,7 @@
             <a:r>
               <a:rPr sz="420" b="1" i="0" spc="80">
                 <a:solidFill>
-                  <a:srgbClr val="56E13B"/>
+                  <a:srgbClr val="F2F2F2"/>
                 </a:solidFill>
                 <a:latin typeface="Trenda IG Text"/>
               </a:rPr>
@@ -24603,9 +24603,9 @@
             </a:avLst>
           </a:prstGeom>
           <a:solidFill>
-            <a:srgbClr val="2B2508"/>
+            <a:srgbClr val="161616"/>
           </a:solidFill>
-          <a:ln w="12700">
+          <a:ln w="7620">
             <a:solidFill>
               <a:srgbClr val="FFD700"/>
             </a:solidFill>
@@ -24663,7 +24663,7 @@
             <a:r>
               <a:rPr sz="560" b="1" i="0">
                 <a:solidFill>
-                  <a:srgbClr val="FFFFFF"/>
+                  <a:srgbClr val="F2F2F2"/>
                 </a:solidFill>
                 <a:latin typeface="Trenda IG Text"/>
               </a:rPr>
@@ -24689,9 +24689,9 @@
             </a:avLst>
           </a:prstGeom>
           <a:noFill/>
-          <a:ln w="9525">
+          <a:ln w="6350">
             <a:solidFill>
-              <a:srgbClr val="56E13B"/>
+              <a:srgbClr val="4A4A4A"/>
             </a:solidFill>
           </a:ln>
           <a:effectLst/>
@@ -24742,7 +24742,7 @@
             <a:r>
               <a:rPr sz="420" b="1" i="0" spc="80">
                 <a:solidFill>
-                  <a:srgbClr val="56E13B"/>
+                  <a:srgbClr val="F2F2F2"/>
                 </a:solidFill>
                 <a:latin typeface="Trenda IG Text"/>
               </a:rPr>
@@ -24770,9 +24770,9 @@
           <a:solidFill>
             <a:srgbClr val="000000"/>
           </a:solidFill>
-          <a:ln w="12700">
+          <a:ln w="7620">
             <a:solidFill>
-              <a:srgbClr val="3A3A3A"/>
+              <a:srgbClr val="333333"/>
             </a:solidFill>
           </a:ln>
           <a:effectLst/>
@@ -24827,7 +24827,7 @@
             <a:r>
               <a:rPr sz="560" b="1" i="0">
                 <a:solidFill>
-                  <a:srgbClr val="FFFFFF"/>
+                  <a:srgbClr val="F2F2F2"/>
                 </a:solidFill>
                 <a:latin typeface="Trenda IG Text"/>
               </a:rPr>
@@ -24853,9 +24853,9 @@
             </a:avLst>
           </a:prstGeom>
           <a:noFill/>
-          <a:ln w="9525">
+          <a:ln w="6350">
             <a:solidFill>
-              <a:srgbClr val="00D6F2"/>
+              <a:srgbClr val="5B8DEF"/>
             </a:solidFill>
           </a:ln>
           <a:effectLst/>
@@ -24906,7 +24906,7 @@
             <a:r>
               <a:rPr sz="420" b="1" i="0" spc="80">
                 <a:solidFill>
-                  <a:srgbClr val="00D6F2"/>
+                  <a:srgbClr val="6EA8FF"/>
                 </a:solidFill>
                 <a:latin typeface="Trenda IG Text"/>
               </a:rPr>
@@ -24934,9 +24934,9 @@
           <a:solidFill>
             <a:srgbClr val="000000"/>
           </a:solidFill>
-          <a:ln w="12700">
+          <a:ln w="7620">
             <a:solidFill>
-              <a:srgbClr val="3A3A3A"/>
+              <a:srgbClr val="333333"/>
             </a:solidFill>
           </a:ln>
           <a:effectLst/>
@@ -24991,7 +24991,7 @@
             <a:r>
               <a:rPr sz="560" b="1" i="0">
                 <a:solidFill>
-                  <a:srgbClr val="FFFFFF"/>
+                  <a:srgbClr val="F2F2F2"/>
                 </a:solidFill>
                 <a:latin typeface="Trenda IG Text"/>
               </a:rPr>
@@ -25017,9 +25017,9 @@
             </a:avLst>
           </a:prstGeom>
           <a:noFill/>
-          <a:ln w="9525">
+          <a:ln w="6350">
             <a:solidFill>
-              <a:srgbClr val="00D6F2"/>
+              <a:srgbClr val="5B8DEF"/>
             </a:solidFill>
           </a:ln>
           <a:effectLst/>
@@ -25070,7 +25070,7 @@
             <a:r>
               <a:rPr sz="420" b="1" i="0" spc="80">
                 <a:solidFill>
-                  <a:srgbClr val="00D6F2"/>
+                  <a:srgbClr val="6EA8FF"/>
                 </a:solidFill>
                 <a:latin typeface="Trenda IG Text"/>
               </a:rPr>
@@ -25098,9 +25098,9 @@
           <a:solidFill>
             <a:srgbClr val="000000"/>
           </a:solidFill>
-          <a:ln w="12700">
+          <a:ln w="7620">
             <a:solidFill>
-              <a:srgbClr val="3A3A3A"/>
+              <a:srgbClr val="333333"/>
             </a:solidFill>
           </a:ln>
           <a:effectLst/>
@@ -25155,7 +25155,7 @@
             <a:r>
               <a:rPr sz="560" b="1" i="0">
                 <a:solidFill>
-                  <a:srgbClr val="FFFFFF"/>
+                  <a:srgbClr val="F2F2F2"/>
                 </a:solidFill>
                 <a:latin typeface="Trenda IG Text"/>
               </a:rPr>
@@ -25181,9 +25181,9 @@
             </a:avLst>
           </a:prstGeom>
           <a:noFill/>
-          <a:ln w="9525">
+          <a:ln w="6350">
             <a:solidFill>
-              <a:srgbClr val="56E13B"/>
+              <a:srgbClr val="4A4A4A"/>
             </a:solidFill>
           </a:ln>
           <a:effectLst/>
@@ -25234,7 +25234,7 @@
             <a:r>
               <a:rPr sz="420" b="1" i="0" spc="80">
                 <a:solidFill>
-                  <a:srgbClr val="56E13B"/>
+                  <a:srgbClr val="F2F2F2"/>
                 </a:solidFill>
                 <a:latin typeface="Trenda IG Text"/>
               </a:rPr>
@@ -25262,9 +25262,9 @@
           <a:solidFill>
             <a:srgbClr val="000000"/>
           </a:solidFill>
-          <a:ln w="12700">
+          <a:ln w="7620">
             <a:solidFill>
-              <a:srgbClr val="8B7CD8"/>
+              <a:srgbClr val="4A4A4A"/>
             </a:solidFill>
             <a:prstDash val="dash"/>
           </a:ln>
@@ -25320,7 +25320,7 @@
             <a:r>
               <a:rPr sz="560" b="1" i="0">
                 <a:solidFill>
-                  <a:srgbClr val="FFFFFF"/>
+                  <a:srgbClr val="F2F2F2"/>
                 </a:solidFill>
                 <a:latin typeface="Trenda IG Text"/>
               </a:rPr>
@@ -25346,9 +25346,9 @@
             </a:avLst>
           </a:prstGeom>
           <a:noFill/>
-          <a:ln w="9525">
+          <a:ln w="6350">
             <a:solidFill>
-              <a:srgbClr val="8B7CD8"/>
+              <a:srgbClr val="4A4A4A"/>
             </a:solidFill>
           </a:ln>
           <a:effectLst/>
@@ -25399,7 +25399,7 @@
             <a:r>
               <a:rPr sz="420" b="1" i="0" spc="80">
                 <a:solidFill>
-                  <a:srgbClr val="8B7CD8"/>
+                  <a:srgbClr val="F2F2F2"/>
                 </a:solidFill>
                 <a:latin typeface="Trenda IG Text"/>
               </a:rPr>
@@ -25433,7 +25433,7 @@
             <a:r>
               <a:rPr sz="580" b="1" i="0">
                 <a:solidFill>
-                  <a:srgbClr val="8B7CD8"/>
+                  <a:srgbClr val="F2F2F2"/>
                 </a:solidFill>
                 <a:latin typeface="Trenda IG Text"/>
               </a:rPr>
@@ -25442,7 +25442,7 @@
             <a:r>
               <a:rPr sz="580" b="0" i="0">
                 <a:solidFill>
-                  <a:srgbClr val="BFBFBF"/>
+                  <a:srgbClr val="B3B3B3"/>
                 </a:solidFill>
                 <a:latin typeface="Trenda IG Text"/>
               </a:rPr>
@@ -25470,9 +25470,9 @@
           <a:solidFill>
             <a:srgbClr val="141414"/>
           </a:solidFill>
-          <a:ln w="9525">
+          <a:ln w="6350">
             <a:solidFill>
-              <a:srgbClr val="3A3A3A"/>
+              <a:srgbClr val="333333"/>
             </a:solidFill>
           </a:ln>
           <a:effectLst/>
@@ -25690,7 +25690,7 @@
             <a:avLst/>
           </a:prstGeom>
           <a:solidFill>
-            <a:srgbClr val="FF0069"/>
+            <a:srgbClr val="2B2B2B"/>
           </a:solidFill>
           <a:ln>
             <a:noFill/>
@@ -25742,7 +25742,7 @@
             <a:r>
               <a:rPr sz="660" b="1" i="0">
                 <a:solidFill>
-                  <a:srgbClr val="FF0069"/>
+                  <a:srgbClr val="F2F2F2"/>
                 </a:solidFill>
                 <a:latin typeface="Trenda IG Text"/>
               </a:rPr>
@@ -25776,7 +25776,7 @@
             <a:r>
               <a:rPr sz="580" b="0" i="0">
                 <a:solidFill>
-                  <a:srgbClr val="FFFFFF"/>
+                  <a:srgbClr val="F2F2F2"/>
                 </a:solidFill>
                 <a:latin typeface="Trenda IG Text"/>
               </a:rPr>
@@ -25810,7 +25810,7 @@
             <a:r>
               <a:rPr sz="580" b="0" i="0">
                 <a:solidFill>
-                  <a:srgbClr val="BFBFBF"/>
+                  <a:srgbClr val="B3B3B3"/>
                 </a:solidFill>
                 <a:latin typeface="Trenda IG Text"/>
               </a:rPr>
@@ -25876,7 +25876,7 @@
             <a:avLst/>
           </a:prstGeom>
           <a:solidFill>
-            <a:srgbClr val="FA8B35"/>
+            <a:srgbClr val="2B2B2B"/>
           </a:solidFill>
           <a:ln>
             <a:noFill/>
@@ -25928,7 +25928,7 @@
             <a:r>
               <a:rPr sz="660" b="1" i="0">
                 <a:solidFill>
-                  <a:srgbClr val="FA8B35"/>
+                  <a:srgbClr val="F2F2F2"/>
                 </a:solidFill>
                 <a:latin typeface="Trenda IG Text"/>
               </a:rPr>
@@ -25962,7 +25962,7 @@
             <a:r>
               <a:rPr sz="580" b="0" i="0">
                 <a:solidFill>
-                  <a:srgbClr val="FFFFFF"/>
+                  <a:srgbClr val="F2F2F2"/>
                 </a:solidFill>
                 <a:latin typeface="Trenda IG Text"/>
               </a:rPr>
@@ -25996,7 +25996,7 @@
             <a:r>
               <a:rPr sz="580" b="0" i="0">
                 <a:solidFill>
-                  <a:srgbClr val="BFBFBF"/>
+                  <a:srgbClr val="B3B3B3"/>
                 </a:solidFill>
                 <a:latin typeface="Trenda IG Text"/>
               </a:rPr>
@@ -26062,7 +26062,7 @@
             <a:avLst/>
           </a:prstGeom>
           <a:solidFill>
-            <a:srgbClr val="56E13B"/>
+            <a:srgbClr val="2B2B2B"/>
           </a:solidFill>
           <a:ln>
             <a:noFill/>
@@ -26114,7 +26114,7 @@
             <a:r>
               <a:rPr sz="660" b="1" i="0">
                 <a:solidFill>
-                  <a:srgbClr val="56E13B"/>
+                  <a:srgbClr val="F2F2F2"/>
                 </a:solidFill>
                 <a:latin typeface="Trenda IG Text"/>
               </a:rPr>
@@ -26148,7 +26148,7 @@
             <a:r>
               <a:rPr sz="580" b="0" i="0">
                 <a:solidFill>
-                  <a:srgbClr val="FFFFFF"/>
+                  <a:srgbClr val="F2F2F2"/>
                 </a:solidFill>
                 <a:latin typeface="Trenda IG Text"/>
               </a:rPr>
@@ -26182,7 +26182,7 @@
             <a:r>
               <a:rPr sz="580" b="0" i="0">
                 <a:solidFill>
-                  <a:srgbClr val="BFBFBF"/>
+                  <a:srgbClr val="B3B3B3"/>
                 </a:solidFill>
                 <a:latin typeface="Trenda IG Text"/>
               </a:rPr>
@@ -26216,7 +26216,7 @@
             <a:r>
               <a:rPr sz="600" b="0" i="0">
                 <a:solidFill>
-                  <a:srgbClr val="FFFFFF"/>
+                  <a:srgbClr val="F2F2F2"/>
                 </a:solidFill>
                 <a:latin typeface="Trenda IG Text"/>
               </a:rPr>
@@ -26259,7 +26259,7 @@
             <a:r>
               <a:rPr sz="640" b="1" i="0" spc="120">
                 <a:solidFill>
-                  <a:srgbClr val="8B7CD8"/>
+                  <a:srgbClr val="F2F2F2"/>
                 </a:solidFill>
                 <a:latin typeface="Trenda IG Text"/>
               </a:rPr>
@@ -26268,7 +26268,7 @@
             <a:r>
               <a:rPr sz="640" b="0" i="0">
                 <a:solidFill>
-                  <a:srgbClr val="BFBFBF"/>
+                  <a:srgbClr val="B3B3B3"/>
                 </a:solidFill>
                 <a:latin typeface="Trenda IG Text"/>
               </a:rPr>
@@ -26285,23 +26285,71 @@
         </p:nvSpPr>
         <p:spPr>
           <a:xfrm>
-            <a:off x="411480" y="4187952"/>
-            <a:ext cx="2759202" cy="1536192"/>
+            <a:off x="393192" y="4169664"/>
+            <a:ext cx="2795778" cy="1572768"/>
           </a:xfrm>
           <a:prstGeom prst="roundRect">
             <a:avLst>
               <a:gd name="adj" fmla="val 5000"/>
             </a:avLst>
           </a:prstGeom>
+          <a:gradFill rotWithShape="1">
+            <a:gsLst>
+              <a:gs pos="0">
+                <a:srgbClr val="FFD700"/>
+              </a:gs>
+              <a:gs pos="50000">
+                <a:srgbClr val="FF0069"/>
+              </a:gs>
+              <a:gs pos="100000">
+                <a:srgbClr val="00D6F2"/>
+              </a:gs>
+            </a:gsLst>
+            <a:lin ang="0" scaled="0"/>
+          </a:gradFill>
+          <a:effectLst/>
+          <a:ln>
+            <a:noFill/>
+          </a:ln>
+        </p:spPr>
+        <p:style>
+          <a:lnRef idx="1">
+            <a:schemeClr val="accent1"/>
+          </a:lnRef>
+          <a:fillRef idx="3">
+            <a:schemeClr val="accent1"/>
+          </a:fillRef>
+          <a:effectRef idx="2">
+            <a:schemeClr val="accent1"/>
+          </a:effectRef>
+          <a:fontRef idx="minor">
+            <a:schemeClr val="lt1"/>
+          </a:fontRef>
+        </p:style>
+      </p:sp>
+      <p:sp>
+        <p:nvSpPr>
+          <p:cNvPr id="98" name="Shape 93"/>
+          <p:cNvSpPr/>
+          <p:nvPr/>
+        </p:nvSpPr>
+        <p:spPr>
+          <a:xfrm>
+            <a:off x="411480" y="4187952"/>
+            <a:ext cx="2759202" cy="1536192"/>
+          </a:xfrm>
+          <a:prstGeom prst="roundRect">
+            <a:avLst>
+              <a:gd name="adj" fmla="val 5000"/>
+            </a:avLst>
+          </a:prstGeom>
           <a:solidFill>
             <a:srgbClr val="141414"/>
           </a:solidFill>
-          <a:ln w="12700">
-            <a:solidFill>
-              <a:srgbClr val="FFD700"/>
-            </a:solidFill>
-          </a:ln>
           <a:effectLst/>
+          <a:ln>
+            <a:noFill/>
+          </a:ln>
         </p:spPr>
         <p:style>
           <a:lnRef idx="1">
@@ -26338,7 +26386,7 @@
             <a:avLst/>
           </a:prstGeom>
           <a:solidFill>
-            <a:srgbClr val="FFD700"/>
+            <a:srgbClr val="2B2B2B"/>
           </a:solidFill>
           <a:ln>
             <a:noFill/>
@@ -26390,7 +26438,7 @@
             <a:r>
               <a:rPr sz="720" b="1" i="0">
                 <a:solidFill>
-                  <a:srgbClr val="000000"/>
+                  <a:srgbClr val="F2F2F2"/>
                 </a:solidFill>
                 <a:latin typeface="Trenda IG Text"/>
               </a:rPr>
@@ -26399,7 +26447,7 @@
             <a:r>
               <a:rPr sz="720" b="1" i="0">
                 <a:solidFill>
-                  <a:srgbClr val="000000"/>
+                  <a:srgbClr val="F2F2F2"/>
                 </a:solidFill>
                 <a:latin typeface="Trenda IG Text"/>
               </a:rPr>
@@ -26425,9 +26473,9 @@
             </a:avLst>
           </a:prstGeom>
           <a:noFill/>
-          <a:ln w="9525">
+          <a:ln w="6350">
             <a:solidFill>
-              <a:srgbClr val="000000"/>
+              <a:srgbClr val="8C8C8C"/>
             </a:solidFill>
           </a:ln>
           <a:effectLst/>
@@ -26478,7 +26526,7 @@
             <a:r>
               <a:rPr sz="459" b="1" i="0" spc="80">
                 <a:solidFill>
-                  <a:srgbClr val="000000"/>
+                  <a:srgbClr val="F2F2F2"/>
                 </a:solidFill>
                 <a:latin typeface="Trenda IG Text"/>
               </a:rPr>
@@ -26512,7 +26560,7 @@
             <a:r>
               <a:rPr sz="580" b="1" i="0">
                 <a:solidFill>
-                  <a:srgbClr val="FFFFFF"/>
+                  <a:srgbClr val="F2F2F2"/>
                 </a:solidFill>
                 <a:latin typeface="Trenda IG Text"/>
               </a:rPr>
@@ -26521,7 +26569,7 @@
             <a:r>
               <a:rPr sz="580" b="0" i="0">
                 <a:solidFill>
-                  <a:srgbClr val="BFBFBF"/>
+                  <a:srgbClr val="B3B3B3"/>
                 </a:solidFill>
                 <a:latin typeface="Trenda IG Text"/>
               </a:rPr>
@@ -26545,7 +26593,7 @@
             <a:avLst/>
           </a:prstGeom>
           <a:solidFill>
-            <a:srgbClr val="FFD700"/>
+            <a:srgbClr val="2B2B2B"/>
           </a:solidFill>
           <a:ln>
             <a:noFill/>
@@ -26597,7 +26645,7 @@
             <a:r>
               <a:rPr sz="570" b="0" i="0">
                 <a:solidFill>
-                  <a:srgbClr val="FFFFFF"/>
+                  <a:srgbClr val="F2F2F2"/>
                 </a:solidFill>
                 <a:latin typeface="Trenda IG Text"/>
               </a:rPr>
@@ -26621,7 +26669,7 @@
             <a:avLst/>
           </a:prstGeom>
           <a:solidFill>
-            <a:srgbClr val="FFD700"/>
+            <a:srgbClr val="2B2B2B"/>
           </a:solidFill>
           <a:ln>
             <a:noFill/>
@@ -26673,7 +26721,7 @@
             <a:r>
               <a:rPr sz="570" b="0" i="0">
                 <a:solidFill>
-                  <a:srgbClr val="FFFFFF"/>
+                  <a:srgbClr val="F2F2F2"/>
                 </a:solidFill>
                 <a:latin typeface="Trenda IG Text"/>
               </a:rPr>
@@ -26697,7 +26745,7 @@
             <a:avLst/>
           </a:prstGeom>
           <a:solidFill>
-            <a:srgbClr val="FFD700"/>
+            <a:srgbClr val="2B2B2B"/>
           </a:solidFill>
           <a:ln>
             <a:noFill/>
@@ -26749,7 +26797,7 @@
             <a:r>
               <a:rPr sz="570" b="0" i="0">
                 <a:solidFill>
-                  <a:srgbClr val="FFFFFF"/>
+                  <a:srgbClr val="F2F2F2"/>
                 </a:solidFill>
                 <a:latin typeface="Trenda IG Text"/>
               </a:rPr>
@@ -26766,23 +26814,71 @@
         </p:nvSpPr>
         <p:spPr>
           <a:xfrm>
-            <a:off x="3280410" y="4187952"/>
-            <a:ext cx="2759202" cy="1536192"/>
+            <a:off x="3262122" y="4169664"/>
+            <a:ext cx="2795778" cy="1572768"/>
           </a:xfrm>
           <a:prstGeom prst="roundRect">
             <a:avLst>
               <a:gd name="adj" fmla="val 5000"/>
             </a:avLst>
           </a:prstGeom>
+          <a:gradFill rotWithShape="1">
+            <a:gsLst>
+              <a:gs pos="0">
+                <a:srgbClr val="FFD700"/>
+              </a:gs>
+              <a:gs pos="50000">
+                <a:srgbClr val="FF0069"/>
+              </a:gs>
+              <a:gs pos="100000">
+                <a:srgbClr val="00D6F2"/>
+              </a:gs>
+            </a:gsLst>
+            <a:lin ang="0" scaled="0"/>
+          </a:gradFill>
+          <a:effectLst/>
+          <a:ln>
+            <a:noFill/>
+          </a:ln>
+        </p:spPr>
+        <p:style>
+          <a:lnRef idx="1">
+            <a:schemeClr val="accent1"/>
+          </a:lnRef>
+          <a:fillRef idx="3">
+            <a:schemeClr val="accent1"/>
+          </a:fillRef>
+          <a:effectRef idx="2">
+            <a:schemeClr val="accent1"/>
+          </a:effectRef>
+          <a:fontRef idx="minor">
+            <a:schemeClr val="lt1"/>
+          </a:fontRef>
+        </p:style>
+      </p:sp>
+      <p:sp>
+        <p:nvSpPr>
+          <p:cNvPr id="110" name="Shape 105"/>
+          <p:cNvSpPr/>
+          <p:nvPr/>
+        </p:nvSpPr>
+        <p:spPr>
+          <a:xfrm>
+            <a:off x="3280410" y="4187952"/>
+            <a:ext cx="2759202" cy="1536192"/>
+          </a:xfrm>
+          <a:prstGeom prst="roundRect">
+            <a:avLst>
+              <a:gd name="adj" fmla="val 5000"/>
+            </a:avLst>
+          </a:prstGeom>
           <a:solidFill>
             <a:srgbClr val="141414"/>
           </a:solidFill>
-          <a:ln w="12700">
-            <a:solidFill>
-              <a:srgbClr val="FF0069"/>
-            </a:solidFill>
-          </a:ln>
           <a:effectLst/>
+          <a:ln>
+            <a:noFill/>
+          </a:ln>
         </p:spPr>
         <p:style>
           <a:lnRef idx="1">
@@ -26819,7 +26915,7 @@
             <a:avLst/>
           </a:prstGeom>
           <a:solidFill>
-            <a:srgbClr val="FF0069"/>
+            <a:srgbClr val="2B2B2B"/>
           </a:solidFill>
           <a:ln>
             <a:noFill/>
@@ -26871,7 +26967,7 @@
             <a:r>
               <a:rPr sz="720" b="1" i="0">
                 <a:solidFill>
-                  <a:srgbClr val="FFFFFE"/>
+                  <a:srgbClr val="F2F2F2"/>
                 </a:solidFill>
                 <a:latin typeface="Trenda IG Text"/>
               </a:rPr>
@@ -26880,7 +26976,7 @@
             <a:r>
               <a:rPr sz="720" b="1" i="0">
                 <a:solidFill>
-                  <a:srgbClr val="FFFFFE"/>
+                  <a:srgbClr val="F2F2F2"/>
                 </a:solidFill>
                 <a:latin typeface="Trenda IG Text"/>
               </a:rPr>
@@ -26906,7 +27002,7 @@
             </a:avLst>
           </a:prstGeom>
           <a:noFill/>
-          <a:ln w="9525">
+          <a:ln w="6350">
             <a:solidFill>
               <a:srgbClr val="FFFFFE"/>
             </a:solidFill>
@@ -26959,7 +27055,7 @@
             <a:r>
               <a:rPr sz="459" b="1" i="0" spc="80">
                 <a:solidFill>
-                  <a:srgbClr val="FFFFFE"/>
+                  <a:srgbClr val="F2F2F2"/>
                 </a:solidFill>
                 <a:latin typeface="Trenda IG Text"/>
               </a:rPr>
@@ -26993,7 +27089,7 @@
             <a:r>
               <a:rPr sz="580" b="1" i="0">
                 <a:solidFill>
-                  <a:srgbClr val="FFFFFF"/>
+                  <a:srgbClr val="F2F2F2"/>
                 </a:solidFill>
                 <a:latin typeface="Trenda IG Text"/>
               </a:rPr>
@@ -27002,7 +27098,7 @@
             <a:r>
               <a:rPr sz="580" b="0" i="0">
                 <a:solidFill>
-                  <a:srgbClr val="BFBFBF"/>
+                  <a:srgbClr val="B3B3B3"/>
                 </a:solidFill>
                 <a:latin typeface="Trenda IG Text"/>
               </a:rPr>
@@ -27026,7 +27122,7 @@
             <a:avLst/>
           </a:prstGeom>
           <a:solidFill>
-            <a:srgbClr val="FF0069"/>
+            <a:srgbClr val="2B2B2B"/>
           </a:solidFill>
           <a:ln>
             <a:noFill/>
@@ -27078,7 +27174,7 @@
             <a:r>
               <a:rPr sz="570" b="0" i="0">
                 <a:solidFill>
-                  <a:srgbClr val="FFFFFF"/>
+                  <a:srgbClr val="F2F2F2"/>
                 </a:solidFill>
                 <a:latin typeface="Trenda IG Text"/>
               </a:rPr>
@@ -27102,7 +27198,7 @@
             <a:avLst/>
           </a:prstGeom>
           <a:solidFill>
-            <a:srgbClr val="FF0069"/>
+            <a:srgbClr val="2B2B2B"/>
           </a:solidFill>
           <a:ln>
             <a:noFill/>
@@ -27154,7 +27250,7 @@
             <a:r>
               <a:rPr sz="570" b="0" i="0">
                 <a:solidFill>
-                  <a:srgbClr val="FFFFFF"/>
+                  <a:srgbClr val="F2F2F2"/>
                 </a:solidFill>
                 <a:latin typeface="Trenda IG Text"/>
               </a:rPr>
@@ -27178,7 +27274,7 @@
             <a:avLst/>
           </a:prstGeom>
           <a:solidFill>
-            <a:srgbClr val="FF0069"/>
+            <a:srgbClr val="2B2B2B"/>
           </a:solidFill>
           <a:ln>
             <a:noFill/>
@@ -27230,7 +27326,7 @@
             <a:r>
               <a:rPr sz="570" b="0" i="0">
                 <a:solidFill>
-                  <a:srgbClr val="FFFFFF"/>
+                  <a:srgbClr val="F2F2F2"/>
                 </a:solidFill>
                 <a:latin typeface="Trenda IG Text"/>
               </a:rPr>
@@ -27247,23 +27343,71 @@
         </p:nvSpPr>
         <p:spPr>
           <a:xfrm>
-            <a:off x="6149340" y="4187952"/>
-            <a:ext cx="2759202" cy="1536192"/>
+            <a:off x="6131052" y="4169664"/>
+            <a:ext cx="2795778" cy="1572768"/>
           </a:xfrm>
           <a:prstGeom prst="roundRect">
             <a:avLst>
               <a:gd name="adj" fmla="val 5000"/>
             </a:avLst>
           </a:prstGeom>
+          <a:gradFill rotWithShape="1">
+            <a:gsLst>
+              <a:gs pos="0">
+                <a:srgbClr val="FFD700"/>
+              </a:gs>
+              <a:gs pos="50000">
+                <a:srgbClr val="FF0069"/>
+              </a:gs>
+              <a:gs pos="100000">
+                <a:srgbClr val="00D6F2"/>
+              </a:gs>
+            </a:gsLst>
+            <a:lin ang="0" scaled="0"/>
+          </a:gradFill>
+          <a:effectLst/>
+          <a:ln>
+            <a:noFill/>
+          </a:ln>
+        </p:spPr>
+        <p:style>
+          <a:lnRef idx="1">
+            <a:schemeClr val="accent1"/>
+          </a:lnRef>
+          <a:fillRef idx="3">
+            <a:schemeClr val="accent1"/>
+          </a:fillRef>
+          <a:effectRef idx="2">
+            <a:schemeClr val="accent1"/>
+          </a:effectRef>
+          <a:fontRef idx="minor">
+            <a:schemeClr val="lt1"/>
+          </a:fontRef>
+        </p:style>
+      </p:sp>
+      <p:sp>
+        <p:nvSpPr>
+          <p:cNvPr id="122" name="Shape 117"/>
+          <p:cNvSpPr/>
+          <p:nvPr/>
+        </p:nvSpPr>
+        <p:spPr>
+          <a:xfrm>
+            <a:off x="6149340" y="4187952"/>
+            <a:ext cx="2759202" cy="1536192"/>
+          </a:xfrm>
+          <a:prstGeom prst="roundRect">
+            <a:avLst>
+              <a:gd name="adj" fmla="val 5000"/>
+            </a:avLst>
+          </a:prstGeom>
           <a:solidFill>
             <a:srgbClr val="141414"/>
           </a:solidFill>
-          <a:ln w="12700">
-            <a:solidFill>
-              <a:srgbClr val="00D6F2"/>
-            </a:solidFill>
-          </a:ln>
           <a:effectLst/>
+          <a:ln>
+            <a:noFill/>
+          </a:ln>
         </p:spPr>
         <p:style>
           <a:lnRef idx="1">
@@ -27300,7 +27444,7 @@
             <a:avLst/>
           </a:prstGeom>
           <a:solidFill>
-            <a:srgbClr val="00D6F2"/>
+            <a:srgbClr val="2B2B2B"/>
           </a:solidFill>
           <a:ln>
             <a:noFill/>
@@ -27352,7 +27496,7 @@
             <a:r>
               <a:rPr sz="720" b="1" i="0">
                 <a:solidFill>
-                  <a:srgbClr val="000000"/>
+                  <a:srgbClr val="F2F2F2"/>
                 </a:solidFill>
                 <a:latin typeface="Trenda IG Text"/>
               </a:rPr>
@@ -27361,7 +27505,7 @@
             <a:r>
               <a:rPr sz="720" b="1" i="0">
                 <a:solidFill>
-                  <a:srgbClr val="000000"/>
+                  <a:srgbClr val="F2F2F2"/>
                 </a:solidFill>
                 <a:latin typeface="Trenda IG Text"/>
               </a:rPr>
@@ -27387,9 +27531,9 @@
             </a:avLst>
           </a:prstGeom>
           <a:noFill/>
-          <a:ln w="9525">
+          <a:ln w="6350">
             <a:solidFill>
-              <a:srgbClr val="000000"/>
+              <a:srgbClr val="8C8C8C"/>
             </a:solidFill>
           </a:ln>
           <a:effectLst/>
@@ -27440,7 +27584,7 @@
             <a:r>
               <a:rPr sz="459" b="1" i="0" spc="80">
                 <a:solidFill>
-                  <a:srgbClr val="000000"/>
+                  <a:srgbClr val="F2F2F2"/>
                 </a:solidFill>
                 <a:latin typeface="Trenda IG Text"/>
               </a:rPr>
@@ -27474,7 +27618,7 @@
             <a:r>
               <a:rPr sz="580" b="1" i="0">
                 <a:solidFill>
-                  <a:srgbClr val="FFFFFF"/>
+                  <a:srgbClr val="F2F2F2"/>
                 </a:solidFill>
                 <a:latin typeface="Trenda IG Text"/>
               </a:rPr>
@@ -27483,7 +27627,7 @@
             <a:r>
               <a:rPr sz="580" b="0" i="0">
                 <a:solidFill>
-                  <a:srgbClr val="BFBFBF"/>
+                  <a:srgbClr val="B3B3B3"/>
                 </a:solidFill>
                 <a:latin typeface="Trenda IG Text"/>
               </a:rPr>
@@ -27507,7 +27651,7 @@
             <a:avLst/>
           </a:prstGeom>
           <a:solidFill>
-            <a:srgbClr val="00D6F2"/>
+            <a:srgbClr val="2B2B2B"/>
           </a:solidFill>
           <a:ln>
             <a:noFill/>
@@ -27559,7 +27703,7 @@
             <a:r>
               <a:rPr sz="570" b="0" i="0">
                 <a:solidFill>
-                  <a:srgbClr val="FFFFFF"/>
+                  <a:srgbClr val="F2F2F2"/>
                 </a:solidFill>
                 <a:latin typeface="Trenda IG Text"/>
               </a:rPr>
@@ -27583,7 +27727,7 @@
             <a:avLst/>
           </a:prstGeom>
           <a:solidFill>
-            <a:srgbClr val="00D6F2"/>
+            <a:srgbClr val="2B2B2B"/>
           </a:solidFill>
           <a:ln>
             <a:noFill/>
@@ -27635,7 +27779,7 @@
             <a:r>
               <a:rPr sz="570" b="0" i="0">
                 <a:solidFill>
-                  <a:srgbClr val="FFFFFF"/>
+                  <a:srgbClr val="F2F2F2"/>
                 </a:solidFill>
                 <a:latin typeface="Trenda IG Text"/>
               </a:rPr>
@@ -27659,7 +27803,7 @@
             <a:avLst/>
           </a:prstGeom>
           <a:solidFill>
-            <a:srgbClr val="00D6F2"/>
+            <a:srgbClr val="2B2B2B"/>
           </a:solidFill>
           <a:ln>
             <a:noFill/>
@@ -27711,7 +27855,7 @@
             <a:r>
               <a:rPr sz="570" b="0" i="0">
                 <a:solidFill>
-                  <a:srgbClr val="FFFFFF"/>
+                  <a:srgbClr val="F2F2F2"/>
                 </a:solidFill>
                 <a:latin typeface="Trenda IG Text"/>
               </a:rPr>
@@ -27728,23 +27872,71 @@
         </p:nvSpPr>
         <p:spPr>
           <a:xfrm>
-            <a:off x="9018270" y="4187952"/>
-            <a:ext cx="2759202" cy="1536192"/>
+            <a:off x="8999982" y="4169664"/>
+            <a:ext cx="2795778" cy="1572768"/>
           </a:xfrm>
           <a:prstGeom prst="roundRect">
             <a:avLst>
               <a:gd name="adj" fmla="val 5000"/>
             </a:avLst>
           </a:prstGeom>
+          <a:gradFill rotWithShape="1">
+            <a:gsLst>
+              <a:gs pos="0">
+                <a:srgbClr val="FFD700"/>
+              </a:gs>
+              <a:gs pos="50000">
+                <a:srgbClr val="FF0069"/>
+              </a:gs>
+              <a:gs pos="100000">
+                <a:srgbClr val="00D6F2"/>
+              </a:gs>
+            </a:gsLst>
+            <a:lin ang="0" scaled="0"/>
+          </a:gradFill>
+          <a:effectLst/>
+          <a:ln>
+            <a:noFill/>
+          </a:ln>
+        </p:spPr>
+        <p:style>
+          <a:lnRef idx="1">
+            <a:schemeClr val="accent1"/>
+          </a:lnRef>
+          <a:fillRef idx="3">
+            <a:schemeClr val="accent1"/>
+          </a:fillRef>
+          <a:effectRef idx="2">
+            <a:schemeClr val="accent1"/>
+          </a:effectRef>
+          <a:fontRef idx="minor">
+            <a:schemeClr val="lt1"/>
+          </a:fontRef>
+        </p:style>
+      </p:sp>
+      <p:sp>
+        <p:nvSpPr>
+          <p:cNvPr id="134" name="Shape 129"/>
+          <p:cNvSpPr/>
+          <p:nvPr/>
+        </p:nvSpPr>
+        <p:spPr>
+          <a:xfrm>
+            <a:off x="9018270" y="4187952"/>
+            <a:ext cx="2759202" cy="1536192"/>
+          </a:xfrm>
+          <a:prstGeom prst="roundRect">
+            <a:avLst>
+              <a:gd name="adj" fmla="val 5000"/>
+            </a:avLst>
+          </a:prstGeom>
           <a:solidFill>
             <a:srgbClr val="141414"/>
           </a:solidFill>
-          <a:ln w="12700">
-            <a:solidFill>
-              <a:srgbClr val="56E13B"/>
-            </a:solidFill>
-          </a:ln>
           <a:effectLst/>
+          <a:ln>
+            <a:noFill/>
+          </a:ln>
         </p:spPr>
         <p:style>
           <a:lnRef idx="1">
@@ -27781,7 +27973,7 @@
             <a:avLst/>
           </a:prstGeom>
           <a:solidFill>
-            <a:srgbClr val="56E13B"/>
+            <a:srgbClr val="2B2B2B"/>
           </a:solidFill>
           <a:ln>
             <a:noFill/>
@@ -27833,7 +28025,7 @@
             <a:r>
               <a:rPr sz="720" b="1" i="0">
                 <a:solidFill>
-                  <a:srgbClr val="000000"/>
+                  <a:srgbClr val="F2F2F2"/>
                 </a:solidFill>
                 <a:latin typeface="Trenda IG Text"/>
               </a:rPr>
@@ -27842,7 +28034,7 @@
             <a:r>
               <a:rPr sz="720" b="1" i="0">
                 <a:solidFill>
-                  <a:srgbClr val="000000"/>
+                  <a:srgbClr val="F2F2F2"/>
                 </a:solidFill>
                 <a:latin typeface="Trenda IG Text"/>
               </a:rPr>
@@ -27868,9 +28060,9 @@
             </a:avLst>
           </a:prstGeom>
           <a:noFill/>
-          <a:ln w="9525">
+          <a:ln w="6350">
             <a:solidFill>
-              <a:srgbClr val="000000"/>
+              <a:srgbClr val="8C8C8C"/>
             </a:solidFill>
           </a:ln>
           <a:effectLst/>
@@ -27921,7 +28113,7 @@
             <a:r>
               <a:rPr sz="459" b="1" i="0" spc="80">
                 <a:solidFill>
-                  <a:srgbClr val="000000"/>
+                  <a:srgbClr val="F2F2F2"/>
                 </a:solidFill>
                 <a:latin typeface="Trenda IG Text"/>
               </a:rPr>
@@ -27955,7 +28147,7 @@
             <a:r>
               <a:rPr sz="580" b="1" i="0">
                 <a:solidFill>
-                  <a:srgbClr val="FFFFFF"/>
+                  <a:srgbClr val="F2F2F2"/>
                 </a:solidFill>
                 <a:latin typeface="Trenda IG Text"/>
               </a:rPr>
@@ -27964,7 +28156,7 @@
             <a:r>
               <a:rPr sz="580" b="0" i="0">
                 <a:solidFill>
-                  <a:srgbClr val="BFBFBF"/>
+                  <a:srgbClr val="B3B3B3"/>
                 </a:solidFill>
                 <a:latin typeface="Trenda IG Text"/>
               </a:rPr>
@@ -27988,7 +28180,7 @@
             <a:avLst/>
           </a:prstGeom>
           <a:solidFill>
-            <a:srgbClr val="56E13B"/>
+            <a:srgbClr val="2B2B2B"/>
           </a:solidFill>
           <a:ln>
             <a:noFill/>
@@ -28040,7 +28232,7 @@
             <a:r>
               <a:rPr sz="570" b="0" i="0">
                 <a:solidFill>
-                  <a:srgbClr val="FFFFFF"/>
+                  <a:srgbClr val="F2F2F2"/>
                 </a:solidFill>
                 <a:latin typeface="Trenda IG Text"/>
               </a:rPr>
@@ -28064,7 +28256,7 @@
             <a:avLst/>
           </a:prstGeom>
           <a:solidFill>
-            <a:srgbClr val="56E13B"/>
+            <a:srgbClr val="2B2B2B"/>
           </a:solidFill>
           <a:ln>
             <a:noFill/>
@@ -28116,7 +28308,7 @@
             <a:r>
               <a:rPr sz="570" b="0" i="0">
                 <a:solidFill>
-                  <a:srgbClr val="FFFFFF"/>
+                  <a:srgbClr val="F2F2F2"/>
                 </a:solidFill>
                 <a:latin typeface="Trenda IG Text"/>
               </a:rPr>
@@ -28140,7 +28332,7 @@
             <a:avLst/>
           </a:prstGeom>
           <a:solidFill>
-            <a:srgbClr val="56E13B"/>
+            <a:srgbClr val="2B2B2B"/>
           </a:solidFill>
           <a:ln>
             <a:noFill/>
@@ -28192,7 +28384,7 @@
             <a:r>
               <a:rPr sz="570" b="0" i="0">
                 <a:solidFill>
-                  <a:srgbClr val="FFFFFF"/>
+                  <a:srgbClr val="F2F2F2"/>
                 </a:solidFill>
                 <a:latin typeface="Trenda IG Text"/>
               </a:rPr>
@@ -28218,11 +28410,11 @@
             </a:avLst>
           </a:prstGeom>
           <a:solidFill>
-            <a:srgbClr val="0E2A08"/>
+            <a:srgbClr val="161616"/>
           </a:solidFill>
-          <a:ln w="11430">
+          <a:ln w="6858">
             <a:solidFill>
-              <a:srgbClr val="56E13B"/>
+              <a:srgbClr val="4A4A4A"/>
             </a:solidFill>
           </a:ln>
           <a:effectLst/>
@@ -28272,7 +28464,7 @@
             <a:r>
               <a:rPr sz="590" b="1" i="0" spc="100">
                 <a:solidFill>
-                  <a:srgbClr val="56E13B"/>
+                  <a:srgbClr val="F2F2F2"/>
                 </a:solidFill>
                 <a:latin typeface="Trenda IG Text"/>
               </a:rPr>
@@ -28281,7 +28473,7 @@
             <a:r>
               <a:rPr sz="590" b="0" i="0">
                 <a:solidFill>
-                  <a:srgbClr val="FFFFFF"/>
+                  <a:srgbClr val="F2F2F2"/>
                 </a:solidFill>
                 <a:latin typeface="Trenda IG Text"/>
               </a:rPr>
@@ -28290,7 +28482,7 @@
             <a:r>
               <a:rPr sz="590" b="1" i="0">
                 <a:solidFill>
-                  <a:srgbClr val="FFFFFF"/>
+                  <a:srgbClr val="F2F2F2"/>
                 </a:solidFill>
                 <a:latin typeface="Trenda IG Text"/>
               </a:rPr>
@@ -36560,7 +36752,7 @@
     <p:bg>
       <p:bgPr>
         <a:solidFill>
-          <a:srgbClr val="FFFFFF"/>
+          <a:srgbClr val="000000"/>
         </a:solidFill>
         <a:effectLst/>
       </p:bgPr>
@@ -36597,7 +36789,7 @@
             <a:r>
               <a:rPr sz="800" b="1" i="0" spc="300">
                 <a:solidFill>
-                  <a:srgbClr val="0089A0"/>
+                  <a:srgbClr val="F2F2F2"/>
                 </a:solidFill>
                 <a:latin typeface="Trenda IG Text"/>
               </a:rPr>
@@ -36631,7 +36823,7 @@
             <a:r>
               <a:rPr sz="2200" b="1" i="0">
                 <a:solidFill>
-                  <a:srgbClr val="1A1A1A"/>
+                  <a:srgbClr val="F2F2F2"/>
                 </a:solidFill>
                 <a:latin typeface="Trenda IG Text"/>
               </a:rPr>
@@ -36665,7 +36857,7 @@
             <a:r>
               <a:rPr sz="1050" b="0" i="0">
                 <a:solidFill>
-                  <a:srgbClr val="4D4D4D"/>
+                  <a:srgbClr val="B3B3B3"/>
                 </a:solidFill>
                 <a:latin typeface="Trenda IG Text"/>
               </a:rPr>
@@ -36689,7 +36881,7 @@
             <a:avLst/>
           </a:prstGeom>
           <a:solidFill>
-            <a:srgbClr val="00D6F2"/>
+            <a:srgbClr val="2B2B2B"/>
           </a:solidFill>
           <a:ln>
             <a:noFill/>
@@ -36741,7 +36933,7 @@
             <a:r>
               <a:rPr sz="620" b="1" i="0">
                 <a:solidFill>
-                  <a:srgbClr val="000000"/>
+                  <a:srgbClr val="F2F2F2"/>
                 </a:solidFill>
                 <a:latin typeface="Trenda IG Text"/>
               </a:rPr>
@@ -36750,7 +36942,7 @@
             <a:r>
               <a:rPr sz="620" b="1" i="0">
                 <a:solidFill>
-                  <a:srgbClr val="000000"/>
+                  <a:srgbClr val="F2F2F2"/>
                 </a:solidFill>
                 <a:latin typeface="Trenda IG Text"/>
               </a:rPr>
@@ -36776,11 +36968,11 @@
             </a:avLst>
           </a:prstGeom>
           <a:solidFill>
-            <a:srgbClr val="F7F7F7"/>
+            <a:srgbClr val="141414"/>
           </a:solidFill>
-          <a:ln w="12700">
+          <a:ln w="7620">
             <a:solidFill>
-              <a:srgbClr val="00D6F2"/>
+              <a:srgbClr val="4A4A4A"/>
             </a:solidFill>
           </a:ln>
           <a:effectLst/>
@@ -36830,7 +37022,7 @@
             <a:r>
               <a:rPr sz="480" b="1" i="0" spc="100">
                 <a:solidFill>
-                  <a:srgbClr val="6B6B6B"/>
+                  <a:srgbClr val="8C8C8C"/>
                 </a:solidFill>
                 <a:latin typeface="Trenda IG Text"/>
               </a:rPr>
@@ -36856,11 +37048,11 @@
             </a:avLst>
           </a:prstGeom>
           <a:solidFill>
-            <a:srgbClr val="E0FAFE"/>
+            <a:srgbClr val="161616"/>
           </a:solidFill>
-          <a:ln w="9525">
+          <a:ln w="6350">
             <a:solidFill>
-              <a:srgbClr val="00D6F2"/>
+              <a:srgbClr val="4A4A4A"/>
             </a:solidFill>
           </a:ln>
           <a:effectLst/>
@@ -36911,7 +37103,7 @@
             <a:r>
               <a:rPr sz="640" b="1" i="0">
                 <a:solidFill>
-                  <a:srgbClr val="1A1A1A"/>
+                  <a:srgbClr val="F2F2F2"/>
                 </a:solidFill>
                 <a:latin typeface="Trenda IG Text"/>
               </a:rPr>
@@ -36935,7 +37127,7 @@
             <a:avLst/>
           </a:prstGeom>
           <a:solidFill>
-            <a:srgbClr val="00D6F2"/>
+            <a:srgbClr val="2B2B2B"/>
           </a:solidFill>
           <a:ln>
             <a:noFill/>
@@ -36987,7 +37179,7 @@
             <a:r>
               <a:rPr sz="580" b="0" i="0">
                 <a:solidFill>
-                  <a:srgbClr val="4D4D4D"/>
+                  <a:srgbClr val="B3B3B3"/>
                 </a:solidFill>
                 <a:latin typeface="Trenda IG Text"/>
               </a:rPr>
@@ -37011,7 +37203,7 @@
             <a:avLst/>
           </a:prstGeom>
           <a:solidFill>
-            <a:srgbClr val="00D6F2"/>
+            <a:srgbClr val="2B2B2B"/>
           </a:solidFill>
           <a:ln>
             <a:noFill/>
@@ -37063,7 +37255,7 @@
             <a:r>
               <a:rPr sz="580" b="0" i="0">
                 <a:solidFill>
-                  <a:srgbClr val="4D4D4D"/>
+                  <a:srgbClr val="B3B3B3"/>
                 </a:solidFill>
                 <a:latin typeface="Trenda IG Text"/>
               </a:rPr>
@@ -37087,7 +37279,7 @@
             <a:avLst/>
           </a:prstGeom>
           <a:solidFill>
-            <a:srgbClr val="00D6F2"/>
+            <a:srgbClr val="2B2B2B"/>
           </a:solidFill>
           <a:ln>
             <a:noFill/>
@@ -37139,7 +37331,7 @@
             <a:r>
               <a:rPr sz="580" b="0" i="0">
                 <a:solidFill>
-                  <a:srgbClr val="4D4D4D"/>
+                  <a:srgbClr val="B3B3B3"/>
                 </a:solidFill>
                 <a:latin typeface="Trenda IG Text"/>
               </a:rPr>
@@ -37163,7 +37355,7 @@
             <a:avLst/>
           </a:prstGeom>
           <a:solidFill>
-            <a:srgbClr val="00D6F2"/>
+            <a:srgbClr val="2B2B2B"/>
           </a:solidFill>
           <a:ln>
             <a:noFill/>
@@ -37215,7 +37407,7 @@
             <a:r>
               <a:rPr sz="580" b="0" i="0">
                 <a:solidFill>
-                  <a:srgbClr val="4D4D4D"/>
+                  <a:srgbClr val="B3B3B3"/>
                 </a:solidFill>
                 <a:latin typeface="Trenda IG Text"/>
               </a:rPr>
@@ -37241,7 +37433,7 @@
             </a:avLst>
           </a:prstGeom>
           <a:solidFill>
-            <a:srgbClr val="EFEFEF"/>
+            <a:srgbClr val="1E1E1E"/>
           </a:solidFill>
           <a:ln>
             <a:noFill/>
@@ -37298,7 +37490,7 @@
             <a:r>
               <a:rPr sz="520" b="1" i="0">
                 <a:solidFill>
-                  <a:srgbClr val="0089A0"/>
+                  <a:srgbClr val="F2F2F2"/>
                 </a:solidFill>
                 <a:latin typeface="Trenda IG Text"/>
               </a:rPr>
@@ -37314,7 +37506,7 @@
             <a:r>
               <a:rPr sz="600" b="1" i="0">
                 <a:solidFill>
-                  <a:srgbClr val="1A1A1A"/>
+                  <a:srgbClr val="F2F2F2"/>
                 </a:solidFill>
                 <a:latin typeface="Trenda IG Text"/>
               </a:rPr>
@@ -37338,7 +37530,7 @@
             <a:avLst/>
           </a:prstGeom>
           <a:solidFill>
-            <a:srgbClr val="FF0069"/>
+            <a:srgbClr val="2B2B2B"/>
           </a:solidFill>
           <a:ln>
             <a:noFill/>
@@ -37390,7 +37582,7 @@
             <a:r>
               <a:rPr sz="620" b="1" i="0">
                 <a:solidFill>
-                  <a:srgbClr val="FFFFFE"/>
+                  <a:srgbClr val="F2F2F2"/>
                 </a:solidFill>
                 <a:latin typeface="Trenda IG Text"/>
               </a:rPr>
@@ -37399,7 +37591,7 @@
             <a:r>
               <a:rPr sz="620" b="1" i="0">
                 <a:solidFill>
-                  <a:srgbClr val="FFFFFE"/>
+                  <a:srgbClr val="F2F2F2"/>
                 </a:solidFill>
                 <a:latin typeface="Trenda IG Text"/>
               </a:rPr>
@@ -37425,11 +37617,11 @@
             </a:avLst>
           </a:prstGeom>
           <a:solidFill>
-            <a:srgbClr val="F7F7F7"/>
+            <a:srgbClr val="141414"/>
           </a:solidFill>
-          <a:ln w="12700">
+          <a:ln w="7620">
             <a:solidFill>
-              <a:srgbClr val="FF0069"/>
+              <a:srgbClr val="4A4A4A"/>
             </a:solidFill>
           </a:ln>
           <a:effectLst/>
@@ -37479,7 +37671,7 @@
             <a:r>
               <a:rPr sz="480" b="1" i="0" spc="100">
                 <a:solidFill>
-                  <a:srgbClr val="6B6B6B"/>
+                  <a:srgbClr val="8C8C8C"/>
                 </a:solidFill>
                 <a:latin typeface="Trenda IG Text"/>
               </a:rPr>
@@ -37505,11 +37697,11 @@
             </a:avLst>
           </a:prstGeom>
           <a:solidFill>
-            <a:srgbClr val="FFE6F0"/>
+            <a:srgbClr val="161616"/>
           </a:solidFill>
-          <a:ln w="9525">
+          <a:ln w="6350">
             <a:solidFill>
-              <a:srgbClr val="FF0069"/>
+              <a:srgbClr val="4A4A4A"/>
             </a:solidFill>
           </a:ln>
           <a:effectLst/>
@@ -37560,7 +37752,7 @@
             <a:r>
               <a:rPr sz="640" b="1" i="0">
                 <a:solidFill>
-                  <a:srgbClr val="1A1A1A"/>
+                  <a:srgbClr val="F2F2F2"/>
                 </a:solidFill>
                 <a:latin typeface="Trenda IG Text"/>
               </a:rPr>
@@ -37584,7 +37776,7 @@
             <a:avLst/>
           </a:prstGeom>
           <a:solidFill>
-            <a:srgbClr val="FF0069"/>
+            <a:srgbClr val="2B2B2B"/>
           </a:solidFill>
           <a:ln>
             <a:noFill/>
@@ -37636,7 +37828,7 @@
             <a:r>
               <a:rPr sz="580" b="0" i="0">
                 <a:solidFill>
-                  <a:srgbClr val="4D4D4D"/>
+                  <a:srgbClr val="B3B3B3"/>
                 </a:solidFill>
                 <a:latin typeface="Trenda IG Text"/>
               </a:rPr>
@@ -37660,7 +37852,7 @@
             <a:avLst/>
           </a:prstGeom>
           <a:solidFill>
-            <a:srgbClr val="FF0069"/>
+            <a:srgbClr val="2B2B2B"/>
           </a:solidFill>
           <a:ln>
             <a:noFill/>
@@ -37712,7 +37904,7 @@
             <a:r>
               <a:rPr sz="580" b="0" i="0">
                 <a:solidFill>
-                  <a:srgbClr val="4D4D4D"/>
+                  <a:srgbClr val="B3B3B3"/>
                 </a:solidFill>
                 <a:latin typeface="Trenda IG Text"/>
               </a:rPr>
@@ -37736,7 +37928,7 @@
             <a:avLst/>
           </a:prstGeom>
           <a:solidFill>
-            <a:srgbClr val="FF0069"/>
+            <a:srgbClr val="2B2B2B"/>
           </a:solidFill>
           <a:ln>
             <a:noFill/>
@@ -37788,7 +37980,7 @@
             <a:r>
               <a:rPr sz="580" b="0" i="0">
                 <a:solidFill>
-                  <a:srgbClr val="4D4D4D"/>
+                  <a:srgbClr val="B3B3B3"/>
                 </a:solidFill>
                 <a:latin typeface="Trenda IG Text"/>
               </a:rPr>
@@ -37812,7 +38004,7 @@
             <a:avLst/>
           </a:prstGeom>
           <a:solidFill>
-            <a:srgbClr val="FF0069"/>
+            <a:srgbClr val="2B2B2B"/>
           </a:solidFill>
           <a:ln>
             <a:noFill/>
@@ -37864,7 +38056,7 @@
             <a:r>
               <a:rPr sz="580" b="0" i="0">
                 <a:solidFill>
-                  <a:srgbClr val="4D4D4D"/>
+                  <a:srgbClr val="B3B3B3"/>
                 </a:solidFill>
                 <a:latin typeface="Trenda IG Text"/>
               </a:rPr>
@@ -37890,7 +38082,7 @@
             </a:avLst>
           </a:prstGeom>
           <a:solidFill>
-            <a:srgbClr val="EFEFEF"/>
+            <a:srgbClr val="1E1E1E"/>
           </a:solidFill>
           <a:ln>
             <a:noFill/>
@@ -37947,7 +38139,7 @@
             <a:r>
               <a:rPr sz="520" b="1" i="0">
                 <a:solidFill>
-                  <a:srgbClr val="FF0069"/>
+                  <a:srgbClr val="F2F2F2"/>
                 </a:solidFill>
                 <a:latin typeface="Trenda IG Text"/>
               </a:rPr>
@@ -37963,7 +38155,7 @@
             <a:r>
               <a:rPr sz="600" b="1" i="0">
                 <a:solidFill>
-                  <a:srgbClr val="1A1A1A"/>
+                  <a:srgbClr val="F2F2F2"/>
                 </a:solidFill>
                 <a:latin typeface="Trenda IG Text"/>
               </a:rPr>
@@ -37987,7 +38179,7 @@
             <a:avLst/>
           </a:prstGeom>
           <a:solidFill>
-            <a:srgbClr val="FF0069"/>
+            <a:srgbClr val="2B2B2B"/>
           </a:solidFill>
           <a:ln>
             <a:noFill/>
@@ -38039,7 +38231,7 @@
             <a:r>
               <a:rPr sz="620" b="1" i="0">
                 <a:solidFill>
-                  <a:srgbClr val="FFFFFE"/>
+                  <a:srgbClr val="F2F2F2"/>
                 </a:solidFill>
                 <a:latin typeface="Trenda IG Text"/>
               </a:rPr>
@@ -38048,7 +38240,7 @@
             <a:r>
               <a:rPr sz="620" b="1" i="0">
                 <a:solidFill>
-                  <a:srgbClr val="FFFFFE"/>
+                  <a:srgbClr val="F2F2F2"/>
                 </a:solidFill>
                 <a:latin typeface="Trenda IG Text"/>
               </a:rPr>
@@ -38074,11 +38266,11 @@
             </a:avLst>
           </a:prstGeom>
           <a:solidFill>
-            <a:srgbClr val="F7F7F7"/>
+            <a:srgbClr val="141414"/>
           </a:solidFill>
-          <a:ln w="12700">
+          <a:ln w="7620">
             <a:solidFill>
-              <a:srgbClr val="FF0069"/>
+              <a:srgbClr val="4A4A4A"/>
             </a:solidFill>
           </a:ln>
           <a:effectLst/>
@@ -38128,7 +38320,7 @@
             <a:r>
               <a:rPr sz="480" b="1" i="0" spc="100">
                 <a:solidFill>
-                  <a:srgbClr val="6B6B6B"/>
+                  <a:srgbClr val="8C8C8C"/>
                 </a:solidFill>
                 <a:latin typeface="Trenda IG Text"/>
               </a:rPr>
@@ -38154,11 +38346,11 @@
             </a:avLst>
           </a:prstGeom>
           <a:solidFill>
-            <a:srgbClr val="FFE6F0"/>
+            <a:srgbClr val="161616"/>
           </a:solidFill>
-          <a:ln w="9525">
+          <a:ln w="6350">
             <a:solidFill>
-              <a:srgbClr val="FF0069"/>
+              <a:srgbClr val="4A4A4A"/>
             </a:solidFill>
           </a:ln>
           <a:effectLst/>
@@ -38209,7 +38401,7 @@
             <a:r>
               <a:rPr sz="640" b="1" i="0">
                 <a:solidFill>
-                  <a:srgbClr val="1A1A1A"/>
+                  <a:srgbClr val="F2F2F2"/>
                 </a:solidFill>
                 <a:latin typeface="Trenda IG Text"/>
               </a:rPr>
@@ -38233,7 +38425,7 @@
             <a:avLst/>
           </a:prstGeom>
           <a:solidFill>
-            <a:srgbClr val="FF0069"/>
+            <a:srgbClr val="2B2B2B"/>
           </a:solidFill>
           <a:ln>
             <a:noFill/>
@@ -38285,7 +38477,7 @@
             <a:r>
               <a:rPr sz="580" b="0" i="0">
                 <a:solidFill>
-                  <a:srgbClr val="4D4D4D"/>
+                  <a:srgbClr val="B3B3B3"/>
                 </a:solidFill>
                 <a:latin typeface="Trenda IG Text"/>
               </a:rPr>
@@ -38309,7 +38501,7 @@
             <a:avLst/>
           </a:prstGeom>
           <a:solidFill>
-            <a:srgbClr val="FF0069"/>
+            <a:srgbClr val="2B2B2B"/>
           </a:solidFill>
           <a:ln>
             <a:noFill/>
@@ -38361,7 +38553,7 @@
             <a:r>
               <a:rPr sz="580" b="0" i="0">
                 <a:solidFill>
-                  <a:srgbClr val="4D4D4D"/>
+                  <a:srgbClr val="B3B3B3"/>
                 </a:solidFill>
                 <a:latin typeface="Trenda IG Text"/>
               </a:rPr>
@@ -38385,7 +38577,7 @@
             <a:avLst/>
           </a:prstGeom>
           <a:solidFill>
-            <a:srgbClr val="FF0069"/>
+            <a:srgbClr val="2B2B2B"/>
           </a:solidFill>
           <a:ln>
             <a:noFill/>
@@ -38437,7 +38629,7 @@
             <a:r>
               <a:rPr sz="580" b="0" i="0">
                 <a:solidFill>
-                  <a:srgbClr val="4D4D4D"/>
+                  <a:srgbClr val="B3B3B3"/>
                 </a:solidFill>
                 <a:latin typeface="Trenda IG Text"/>
               </a:rPr>
@@ -38463,7 +38655,7 @@
             </a:avLst>
           </a:prstGeom>
           <a:solidFill>
-            <a:srgbClr val="EFEFEF"/>
+            <a:srgbClr val="1E1E1E"/>
           </a:solidFill>
           <a:ln>
             <a:noFill/>
@@ -38520,7 +38712,7 @@
             <a:r>
               <a:rPr sz="520" b="1" i="0">
                 <a:solidFill>
-                  <a:srgbClr val="FF0069"/>
+                  <a:srgbClr val="F2F2F2"/>
                 </a:solidFill>
                 <a:latin typeface="Trenda IG Text"/>
               </a:rPr>
@@ -38536,7 +38728,7 @@
             <a:r>
               <a:rPr sz="600" b="1" i="0">
                 <a:solidFill>
-                  <a:srgbClr val="1A1A1A"/>
+                  <a:srgbClr val="F2F2F2"/>
                 </a:solidFill>
                 <a:latin typeface="Trenda IG Text"/>
               </a:rPr>
@@ -38560,7 +38752,7 @@
             <a:avLst/>
           </a:prstGeom>
           <a:solidFill>
-            <a:srgbClr val="8B7CD8"/>
+            <a:srgbClr val="2B2B2B"/>
           </a:solidFill>
           <a:ln>
             <a:noFill/>
@@ -38612,7 +38804,7 @@
             <a:r>
               <a:rPr sz="620" b="1" i="0">
                 <a:solidFill>
-                  <a:srgbClr val="FFFFFE"/>
+                  <a:srgbClr val="F2F2F2"/>
                 </a:solidFill>
                 <a:latin typeface="Trenda IG Text"/>
               </a:rPr>
@@ -38621,7 +38813,7 @@
             <a:r>
               <a:rPr sz="620" b="1" i="0">
                 <a:solidFill>
-                  <a:srgbClr val="FFFFFE"/>
+                  <a:srgbClr val="F2F2F2"/>
                 </a:solidFill>
                 <a:latin typeface="Trenda IG Text"/>
               </a:rPr>
@@ -38647,11 +38839,11 @@
             </a:avLst>
           </a:prstGeom>
           <a:solidFill>
-            <a:srgbClr val="F7F7F7"/>
+            <a:srgbClr val="141414"/>
           </a:solidFill>
-          <a:ln w="12700">
+          <a:ln w="7620">
             <a:solidFill>
-              <a:srgbClr val="8B7CD8"/>
+              <a:srgbClr val="4A4A4A"/>
             </a:solidFill>
           </a:ln>
           <a:effectLst/>
@@ -38701,7 +38893,7 @@
             <a:r>
               <a:rPr sz="480" b="1" i="0" spc="100">
                 <a:solidFill>
-                  <a:srgbClr val="6B6B6B"/>
+                  <a:srgbClr val="8C8C8C"/>
                 </a:solidFill>
                 <a:latin typeface="Trenda IG Text"/>
               </a:rPr>
@@ -38727,11 +38919,11 @@
             </a:avLst>
           </a:prstGeom>
           <a:solidFill>
-            <a:srgbClr val="ECE9F5"/>
+            <a:srgbClr val="161616"/>
           </a:solidFill>
-          <a:ln w="9525">
+          <a:ln w="6350">
             <a:solidFill>
-              <a:srgbClr val="8B7CD8"/>
+              <a:srgbClr val="4A4A4A"/>
             </a:solidFill>
           </a:ln>
           <a:effectLst/>
@@ -38782,7 +38974,7 @@
             <a:r>
               <a:rPr sz="640" b="1" i="0">
                 <a:solidFill>
-                  <a:srgbClr val="1A1A1A"/>
+                  <a:srgbClr val="F2F2F2"/>
                 </a:solidFill>
                 <a:latin typeface="Trenda IG Text"/>
               </a:rPr>
@@ -38806,7 +38998,7 @@
             <a:avLst/>
           </a:prstGeom>
           <a:solidFill>
-            <a:srgbClr val="8B7CD8"/>
+            <a:srgbClr val="2B2B2B"/>
           </a:solidFill>
           <a:ln>
             <a:noFill/>
@@ -38858,7 +39050,7 @@
             <a:r>
               <a:rPr sz="580" b="0" i="0">
                 <a:solidFill>
-                  <a:srgbClr val="4D4D4D"/>
+                  <a:srgbClr val="B3B3B3"/>
                 </a:solidFill>
                 <a:latin typeface="Trenda IG Text"/>
               </a:rPr>
@@ -38882,7 +39074,7 @@
             <a:avLst/>
           </a:prstGeom>
           <a:solidFill>
-            <a:srgbClr val="8B7CD8"/>
+            <a:srgbClr val="2B2B2B"/>
           </a:solidFill>
           <a:ln>
             <a:noFill/>
@@ -38934,7 +39126,7 @@
             <a:r>
               <a:rPr sz="580" b="0" i="0">
                 <a:solidFill>
-                  <a:srgbClr val="4D4D4D"/>
+                  <a:srgbClr val="B3B3B3"/>
                 </a:solidFill>
                 <a:latin typeface="Trenda IG Text"/>
               </a:rPr>
@@ -38958,7 +39150,7 @@
             <a:avLst/>
           </a:prstGeom>
           <a:solidFill>
-            <a:srgbClr val="8B7CD8"/>
+            <a:srgbClr val="2B2B2B"/>
           </a:solidFill>
           <a:ln>
             <a:noFill/>
@@ -39010,7 +39202,7 @@
             <a:r>
               <a:rPr sz="580" b="0" i="0">
                 <a:solidFill>
-                  <a:srgbClr val="4D4D4D"/>
+                  <a:srgbClr val="B3B3B3"/>
                 </a:solidFill>
                 <a:latin typeface="Trenda IG Text"/>
               </a:rPr>
@@ -39036,7 +39228,7 @@
             </a:avLst>
           </a:prstGeom>
           <a:solidFill>
-            <a:srgbClr val="EFEFEF"/>
+            <a:srgbClr val="1E1E1E"/>
           </a:solidFill>
           <a:ln>
             <a:noFill/>
@@ -39093,7 +39285,7 @@
             <a:r>
               <a:rPr sz="520" b="1" i="0">
                 <a:solidFill>
-                  <a:srgbClr val="8B7CD8"/>
+                  <a:srgbClr val="F2F2F2"/>
                 </a:solidFill>
                 <a:latin typeface="Trenda IG Text"/>
               </a:rPr>
@@ -39109,7 +39301,7 @@
             <a:r>
               <a:rPr sz="600" b="1" i="0">
                 <a:solidFill>
-                  <a:srgbClr val="1A1A1A"/>
+                  <a:srgbClr val="F2F2F2"/>
                 </a:solidFill>
                 <a:latin typeface="Trenda IG Text"/>
               </a:rPr>
@@ -39133,7 +39325,7 @@
             <a:avLst/>
           </a:prstGeom>
           <a:solidFill>
-            <a:srgbClr val="56E13B"/>
+            <a:srgbClr val="2B2B2B"/>
           </a:solidFill>
           <a:ln>
             <a:noFill/>
@@ -39185,7 +39377,7 @@
             <a:r>
               <a:rPr sz="620" b="1" i="0">
                 <a:solidFill>
-                  <a:srgbClr val="000000"/>
+                  <a:srgbClr val="F2F2F2"/>
                 </a:solidFill>
                 <a:latin typeface="Trenda IG Text"/>
               </a:rPr>
@@ -39194,7 +39386,7 @@
             <a:r>
               <a:rPr sz="620" b="1" i="0">
                 <a:solidFill>
-                  <a:srgbClr val="000000"/>
+                  <a:srgbClr val="F2F2F2"/>
                 </a:solidFill>
                 <a:latin typeface="Trenda IG Text"/>
               </a:rPr>
@@ -39220,11 +39412,11 @@
             </a:avLst>
           </a:prstGeom>
           <a:solidFill>
-            <a:srgbClr val="F7F7F7"/>
+            <a:srgbClr val="141414"/>
           </a:solidFill>
-          <a:ln w="12700">
+          <a:ln w="7620">
             <a:solidFill>
-              <a:srgbClr val="56E13B"/>
+              <a:srgbClr val="4A4A4A"/>
             </a:solidFill>
           </a:ln>
           <a:effectLst/>
@@ -39274,7 +39466,7 @@
             <a:r>
               <a:rPr sz="480" b="1" i="0" spc="100">
                 <a:solidFill>
-                  <a:srgbClr val="6B6B6B"/>
+                  <a:srgbClr val="8C8C8C"/>
                 </a:solidFill>
                 <a:latin typeface="Trenda IG Text"/>
               </a:rPr>
@@ -39300,11 +39492,11 @@
             </a:avLst>
           </a:prstGeom>
           <a:solidFill>
-            <a:srgbClr val="EAFBE6"/>
+            <a:srgbClr val="161616"/>
           </a:solidFill>
-          <a:ln w="9525">
+          <a:ln w="6350">
             <a:solidFill>
-              <a:srgbClr val="56E13B"/>
+              <a:srgbClr val="4A4A4A"/>
             </a:solidFill>
           </a:ln>
           <a:effectLst/>
@@ -39355,7 +39547,7 @@
             <a:r>
               <a:rPr sz="640" b="1" i="0">
                 <a:solidFill>
-                  <a:srgbClr val="1A1A1A"/>
+                  <a:srgbClr val="F2F2F2"/>
                 </a:solidFill>
                 <a:latin typeface="Trenda IG Text"/>
               </a:rPr>
@@ -39379,7 +39571,7 @@
             <a:avLst/>
           </a:prstGeom>
           <a:solidFill>
-            <a:srgbClr val="56E13B"/>
+            <a:srgbClr val="2B2B2B"/>
           </a:solidFill>
           <a:ln>
             <a:noFill/>
@@ -39431,7 +39623,7 @@
             <a:r>
               <a:rPr sz="580" b="0" i="0">
                 <a:solidFill>
-                  <a:srgbClr val="4D4D4D"/>
+                  <a:srgbClr val="B3B3B3"/>
                 </a:solidFill>
                 <a:latin typeface="Trenda IG Text"/>
               </a:rPr>
@@ -39455,7 +39647,7 @@
             <a:avLst/>
           </a:prstGeom>
           <a:solidFill>
-            <a:srgbClr val="56E13B"/>
+            <a:srgbClr val="2B2B2B"/>
           </a:solidFill>
           <a:ln>
             <a:noFill/>
@@ -39507,7 +39699,7 @@
             <a:r>
               <a:rPr sz="580" b="0" i="0">
                 <a:solidFill>
-                  <a:srgbClr val="4D4D4D"/>
+                  <a:srgbClr val="B3B3B3"/>
                 </a:solidFill>
                 <a:latin typeface="Trenda IG Text"/>
               </a:rPr>
@@ -39531,7 +39723,7 @@
             <a:avLst/>
           </a:prstGeom>
           <a:solidFill>
-            <a:srgbClr val="56E13B"/>
+            <a:srgbClr val="2B2B2B"/>
           </a:solidFill>
           <a:ln>
             <a:noFill/>
@@ -39583,7 +39775,7 @@
             <a:r>
               <a:rPr sz="580" b="0" i="0">
                 <a:solidFill>
-                  <a:srgbClr val="4D4D4D"/>
+                  <a:srgbClr val="B3B3B3"/>
                 </a:solidFill>
                 <a:latin typeface="Trenda IG Text"/>
               </a:rPr>
@@ -39609,7 +39801,7 @@
             </a:avLst>
           </a:prstGeom>
           <a:solidFill>
-            <a:srgbClr val="EFEFEF"/>
+            <a:srgbClr val="1E1E1E"/>
           </a:solidFill>
           <a:ln>
             <a:noFill/>
@@ -39666,7 +39858,7 @@
             <a:r>
               <a:rPr sz="520" b="1" i="0">
                 <a:solidFill>
-                  <a:srgbClr val="2E8F1C"/>
+                  <a:srgbClr val="F2F2F2"/>
                 </a:solidFill>
                 <a:latin typeface="Trenda IG Text"/>
               </a:rPr>
@@ -39682,7 +39874,7 @@
             <a:r>
               <a:rPr sz="600" b="1" i="0">
                 <a:solidFill>
-                  <a:srgbClr val="1A1A1A"/>
+                  <a:srgbClr val="F2F2F2"/>
                 </a:solidFill>
                 <a:latin typeface="Trenda IG Text"/>
               </a:rPr>
@@ -39758,7 +39950,7 @@
             <a:r>
               <a:rPr sz="620" b="1" i="0">
                 <a:solidFill>
-                  <a:srgbClr val="000000"/>
+                  <a:srgbClr val="1A1A1A"/>
                 </a:solidFill>
                 <a:latin typeface="Trenda IG Text"/>
               </a:rPr>
@@ -39767,7 +39959,7 @@
             <a:r>
               <a:rPr sz="620" b="1" i="0">
                 <a:solidFill>
-                  <a:srgbClr val="000000"/>
+                  <a:srgbClr val="1A1A1A"/>
                 </a:solidFill>
                 <a:latin typeface="Trenda IG Text"/>
               </a:rPr>
@@ -39793,9 +39985,9 @@
             </a:avLst>
           </a:prstGeom>
           <a:solidFill>
-            <a:srgbClr val="F7F7F7"/>
+            <a:srgbClr val="141414"/>
           </a:solidFill>
-          <a:ln w="12700">
+          <a:ln w="7620">
             <a:solidFill>
               <a:srgbClr val="FFD700"/>
             </a:solidFill>
@@ -39847,7 +40039,7 @@
             <a:r>
               <a:rPr sz="480" b="1" i="0" spc="100">
                 <a:solidFill>
-                  <a:srgbClr val="6B6B6B"/>
+                  <a:srgbClr val="8C8C8C"/>
                 </a:solidFill>
                 <a:latin typeface="Trenda IG Text"/>
               </a:rPr>
@@ -39873,9 +40065,9 @@
             </a:avLst>
           </a:prstGeom>
           <a:solidFill>
-            <a:srgbClr val="FFF7CC"/>
+            <a:srgbClr val="161616"/>
           </a:solidFill>
-          <a:ln w="9525">
+          <a:ln w="6350">
             <a:solidFill>
               <a:srgbClr val="FFD700"/>
             </a:solidFill>
@@ -39928,7 +40120,7 @@
             <a:r>
               <a:rPr sz="640" b="1" i="0">
                 <a:solidFill>
-                  <a:srgbClr val="1A1A1A"/>
+                  <a:srgbClr val="F2F2F2"/>
                 </a:solidFill>
                 <a:latin typeface="Trenda IG Text"/>
               </a:rPr>
@@ -40004,7 +40196,7 @@
             <a:r>
               <a:rPr sz="580" b="0" i="0">
                 <a:solidFill>
-                  <a:srgbClr val="4D4D4D"/>
+                  <a:srgbClr val="B3B3B3"/>
                 </a:solidFill>
                 <a:latin typeface="Trenda IG Text"/>
               </a:rPr>
@@ -40080,7 +40272,7 @@
             <a:r>
               <a:rPr sz="580" b="0" i="0">
                 <a:solidFill>
-                  <a:srgbClr val="4D4D4D"/>
+                  <a:srgbClr val="B3B3B3"/>
                 </a:solidFill>
                 <a:latin typeface="Trenda IG Text"/>
               </a:rPr>
@@ -40156,7 +40348,7 @@
             <a:r>
               <a:rPr sz="580" b="0" i="0">
                 <a:solidFill>
-                  <a:srgbClr val="4D4D4D"/>
+                  <a:srgbClr val="B3B3B3"/>
                 </a:solidFill>
                 <a:latin typeface="Trenda IG Text"/>
               </a:rPr>
@@ -40232,7 +40424,7 @@
             <a:r>
               <a:rPr sz="580" b="0" i="0">
                 <a:solidFill>
-                  <a:srgbClr val="4D4D4D"/>
+                  <a:srgbClr val="B3B3B3"/>
                 </a:solidFill>
                 <a:latin typeface="Trenda IG Text"/>
               </a:rPr>
@@ -40308,7 +40500,7 @@
             <a:r>
               <a:rPr sz="580" b="0" i="0">
                 <a:solidFill>
-                  <a:srgbClr val="4D4D4D"/>
+                  <a:srgbClr val="B3B3B3"/>
                 </a:solidFill>
                 <a:latin typeface="Trenda IG Text"/>
               </a:rPr>
@@ -40334,7 +40526,7 @@
             </a:avLst>
           </a:prstGeom>
           <a:solidFill>
-            <a:srgbClr val="EFEFEF"/>
+            <a:srgbClr val="1E1E1E"/>
           </a:solidFill>
           <a:ln>
             <a:noFill/>
@@ -40391,7 +40583,7 @@
             <a:r>
               <a:rPr sz="520" b="1" i="0">
                 <a:solidFill>
-                  <a:srgbClr val="9A7B00"/>
+                  <a:srgbClr val="FFD700"/>
                 </a:solidFill>
                 <a:latin typeface="Trenda IG Text"/>
               </a:rPr>
@@ -40407,7 +40599,7 @@
             <a:r>
               <a:rPr sz="600" b="1" i="0">
                 <a:solidFill>
-                  <a:srgbClr val="1A1A1A"/>
+                  <a:srgbClr val="F2F2F2"/>
                 </a:solidFill>
                 <a:latin typeface="Trenda IG Text"/>
               </a:rPr>
@@ -40431,7 +40623,7 @@
             <a:avLst/>
           </a:prstGeom>
           <a:solidFill>
-            <a:srgbClr val="00D6F2"/>
+            <a:srgbClr val="2B2B2B"/>
           </a:solidFill>
           <a:ln>
             <a:noFill/>
@@ -40483,7 +40675,7 @@
             <a:r>
               <a:rPr sz="620" b="1" i="0">
                 <a:solidFill>
-                  <a:srgbClr val="000000"/>
+                  <a:srgbClr val="F2F2F2"/>
                 </a:solidFill>
                 <a:latin typeface="Trenda IG Text"/>
               </a:rPr>
@@ -40492,7 +40684,7 @@
             <a:r>
               <a:rPr sz="620" b="1" i="0">
                 <a:solidFill>
-                  <a:srgbClr val="000000"/>
+                  <a:srgbClr val="F2F2F2"/>
                 </a:solidFill>
                 <a:latin typeface="Trenda IG Text"/>
               </a:rPr>
@@ -40518,11 +40710,11 @@
             </a:avLst>
           </a:prstGeom>
           <a:solidFill>
-            <a:srgbClr val="F7F7F7"/>
+            <a:srgbClr val="141414"/>
           </a:solidFill>
-          <a:ln w="12700">
+          <a:ln w="7620">
             <a:solidFill>
-              <a:srgbClr val="00D6F2"/>
+              <a:srgbClr val="4A4A4A"/>
             </a:solidFill>
           </a:ln>
           <a:effectLst/>
@@ -40572,7 +40764,7 @@
             <a:r>
               <a:rPr sz="480" b="1" i="0" spc="100">
                 <a:solidFill>
-                  <a:srgbClr val="6B6B6B"/>
+                  <a:srgbClr val="8C8C8C"/>
                 </a:solidFill>
                 <a:latin typeface="Trenda IG Text"/>
               </a:rPr>
@@ -40598,11 +40790,11 @@
             </a:avLst>
           </a:prstGeom>
           <a:solidFill>
-            <a:srgbClr val="E0FAFE"/>
+            <a:srgbClr val="161616"/>
           </a:solidFill>
-          <a:ln w="9525">
+          <a:ln w="6350">
             <a:solidFill>
-              <a:srgbClr val="00D6F2"/>
+              <a:srgbClr val="4A4A4A"/>
             </a:solidFill>
           </a:ln>
           <a:effectLst/>
@@ -40653,7 +40845,7 @@
             <a:r>
               <a:rPr sz="640" b="1" i="0">
                 <a:solidFill>
-                  <a:srgbClr val="1A1A1A"/>
+                  <a:srgbClr val="F2F2F2"/>
                 </a:solidFill>
                 <a:latin typeface="Trenda IG Text"/>
               </a:rPr>
@@ -40677,7 +40869,7 @@
             <a:avLst/>
           </a:prstGeom>
           <a:solidFill>
-            <a:srgbClr val="00D6F2"/>
+            <a:srgbClr val="2B2B2B"/>
           </a:solidFill>
           <a:ln>
             <a:noFill/>
@@ -40729,7 +40921,7 @@
             <a:r>
               <a:rPr sz="580" b="0" i="0">
                 <a:solidFill>
-                  <a:srgbClr val="4D4D4D"/>
+                  <a:srgbClr val="B3B3B3"/>
                 </a:solidFill>
                 <a:latin typeface="Trenda IG Text"/>
               </a:rPr>
@@ -40753,7 +40945,7 @@
             <a:avLst/>
           </a:prstGeom>
           <a:solidFill>
-            <a:srgbClr val="00D6F2"/>
+            <a:srgbClr val="2B2B2B"/>
           </a:solidFill>
           <a:ln>
             <a:noFill/>
@@ -40805,7 +40997,7 @@
             <a:r>
               <a:rPr sz="580" b="0" i="0">
                 <a:solidFill>
-                  <a:srgbClr val="4D4D4D"/>
+                  <a:srgbClr val="B3B3B3"/>
                 </a:solidFill>
                 <a:latin typeface="Trenda IG Text"/>
               </a:rPr>
@@ -40829,7 +41021,7 @@
             <a:avLst/>
           </a:prstGeom>
           <a:solidFill>
-            <a:srgbClr val="00D6F2"/>
+            <a:srgbClr val="2B2B2B"/>
           </a:solidFill>
           <a:ln>
             <a:noFill/>
@@ -40881,7 +41073,7 @@
             <a:r>
               <a:rPr sz="580" b="0" i="0">
                 <a:solidFill>
-                  <a:srgbClr val="4D4D4D"/>
+                  <a:srgbClr val="B3B3B3"/>
                 </a:solidFill>
                 <a:latin typeface="Trenda IG Text"/>
               </a:rPr>
@@ -40907,7 +41099,7 @@
             </a:avLst>
           </a:prstGeom>
           <a:solidFill>
-            <a:srgbClr val="EFEFEF"/>
+            <a:srgbClr val="1E1E1E"/>
           </a:solidFill>
           <a:ln>
             <a:noFill/>
@@ -40964,7 +41156,7 @@
             <a:r>
               <a:rPr sz="520" b="1" i="0">
                 <a:solidFill>
-                  <a:srgbClr val="0089A0"/>
+                  <a:srgbClr val="F2F2F2"/>
                 </a:solidFill>
                 <a:latin typeface="Trenda IG Text"/>
               </a:rPr>
@@ -40980,7 +41172,7 @@
             <a:r>
               <a:rPr sz="600" b="1" i="0">
                 <a:solidFill>
-                  <a:srgbClr val="1A1A1A"/>
+                  <a:srgbClr val="F2F2F2"/>
                 </a:solidFill>
                 <a:latin typeface="Trenda IG Text"/>
               </a:rPr>
@@ -41006,9 +41198,9 @@
             </a:avLst>
           </a:prstGeom>
           <a:noFill/>
-          <a:ln w="12700">
+          <a:ln w="7620">
             <a:solidFill>
-              <a:srgbClr val="FF0069"/>
+              <a:srgbClr val="4A4A4A"/>
             </a:solidFill>
             <a:prstDash val="dash"/>
           </a:ln>
@@ -41060,7 +41252,7 @@
             <a:r>
               <a:rPr sz="500" b="1" i="0" spc="80">
                 <a:solidFill>
-                  <a:srgbClr val="FF0069"/>
+                  <a:srgbClr val="F2F2F2"/>
                 </a:solidFill>
                 <a:latin typeface="Trenda IG Text"/>
               </a:rPr>
@@ -41086,11 +41278,11 @@
             </a:avLst>
           </a:prstGeom>
           <a:solidFill>
-            <a:srgbClr val="FF0069"/>
+            <a:srgbClr val="2B2B2B"/>
           </a:solidFill>
-          <a:ln w="9525">
+          <a:ln w="6350">
             <a:solidFill>
-              <a:srgbClr val="FF0069"/>
+              <a:srgbClr val="4A4A4A"/>
             </a:solidFill>
           </a:ln>
           <a:effectLst/>
@@ -41141,7 +41333,7 @@
             <a:r>
               <a:rPr sz="500" b="1" i="0" spc="80">
                 <a:solidFill>
-                  <a:srgbClr val="FFFFFE"/>
+                  <a:srgbClr val="F2F2F2"/>
                 </a:solidFill>
                 <a:latin typeface="Trenda IG Text"/>
               </a:rPr>
@@ -41167,9 +41359,9 @@
             </a:avLst>
           </a:prstGeom>
           <a:noFill/>
-          <a:ln w="12700">
+          <a:ln w="7620">
             <a:solidFill>
-              <a:srgbClr val="8B7CD8"/>
+              <a:srgbClr val="4A4A4A"/>
             </a:solidFill>
             <a:prstDash val="dash"/>
           </a:ln>
@@ -41221,7 +41413,7 @@
             <a:r>
               <a:rPr sz="459" b="1" i="0">
                 <a:solidFill>
-                  <a:srgbClr val="8B7CD8"/>
+                  <a:srgbClr val="F2F2F2"/>
                 </a:solidFill>
                 <a:latin typeface="Trenda IG Text"/>
               </a:rPr>
@@ -41300,7 +41492,7 @@
             <a:r>
               <a:rPr sz="480" b="1" i="0" spc="80">
                 <a:solidFill>
-                  <a:srgbClr val="000000"/>
+                  <a:srgbClr val="1A1A1A"/>
                 </a:solidFill>
                 <a:latin typeface="Trenda IG Text"/>
               </a:rPr>
@@ -41334,7 +41526,7 @@
             <a:r>
               <a:rPr sz="620" b="1" i="0" spc="120">
                 <a:solidFill>
-                  <a:srgbClr val="1A1A1A"/>
+                  <a:srgbClr val="F2F2F2"/>
                 </a:solidFill>
                 <a:latin typeface="Trenda IG Text"/>
               </a:rPr>
@@ -41358,7 +41550,7 @@
             <a:avLst/>
           </a:prstGeom>
           <a:solidFill>
-            <a:srgbClr val="F7F7F7"/>
+            <a:srgbClr val="141414"/>
           </a:solidFill>
           <a:ln>
             <a:noFill/>
@@ -41399,9 +41591,20 @@
           <a:prstGeom prst="rect">
             <a:avLst/>
           </a:prstGeom>
-          <a:solidFill>
-            <a:srgbClr val="FF0069"/>
-          </a:solidFill>
+          <a:gradFill rotWithShape="1">
+            <a:gsLst>
+              <a:gs pos="0">
+                <a:srgbClr val="FFD700"/>
+              </a:gs>
+              <a:gs pos="50000">
+                <a:srgbClr val="FF0069"/>
+              </a:gs>
+              <a:gs pos="100000">
+                <a:srgbClr val="00D6F2"/>
+              </a:gs>
+            </a:gsLst>
+            <a:lin ang="5400000" scaled="0"/>
+          </a:gradFill>
           <a:ln>
             <a:noFill/>
           </a:ln>
@@ -41457,7 +41660,7 @@
             <a:r>
               <a:rPr sz="760" b="1" i="0">
                 <a:solidFill>
-                  <a:srgbClr val="1A1A1A"/>
+                  <a:srgbClr val="F2F2F2"/>
                 </a:solidFill>
                 <a:latin typeface="Trenda IG Text"/>
               </a:rPr>
@@ -41473,7 +41676,7 @@
             <a:r>
               <a:rPr sz="620" b="0" i="0">
                 <a:solidFill>
-                  <a:srgbClr val="4D4D4D"/>
+                  <a:srgbClr val="B3B3B3"/>
                 </a:solidFill>
                 <a:latin typeface="Trenda IG Text"/>
               </a:rPr>
@@ -41497,7 +41700,7 @@
             <a:avLst/>
           </a:prstGeom>
           <a:solidFill>
-            <a:srgbClr val="F7F7F7"/>
+            <a:srgbClr val="141414"/>
           </a:solidFill>
           <a:ln>
             <a:noFill/>
@@ -41538,9 +41741,20 @@
           <a:prstGeom prst="rect">
             <a:avLst/>
           </a:prstGeom>
-          <a:solidFill>
-            <a:srgbClr val="56E13B"/>
-          </a:solidFill>
+          <a:gradFill rotWithShape="1">
+            <a:gsLst>
+              <a:gs pos="0">
+                <a:srgbClr val="FFD700"/>
+              </a:gs>
+              <a:gs pos="50000">
+                <a:srgbClr val="FF0069"/>
+              </a:gs>
+              <a:gs pos="100000">
+                <a:srgbClr val="00D6F2"/>
+              </a:gs>
+            </a:gsLst>
+            <a:lin ang="5400000" scaled="0"/>
+          </a:gradFill>
           <a:ln>
             <a:noFill/>
           </a:ln>
@@ -41596,7 +41810,7 @@
             <a:r>
               <a:rPr sz="760" b="1" i="0">
                 <a:solidFill>
-                  <a:srgbClr val="1A1A1A"/>
+                  <a:srgbClr val="F2F2F2"/>
                 </a:solidFill>
                 <a:latin typeface="Trenda IG Text"/>
               </a:rPr>
@@ -41612,7 +41826,7 @@
             <a:r>
               <a:rPr sz="620" b="0" i="0">
                 <a:solidFill>
-                  <a:srgbClr val="4D4D4D"/>
+                  <a:srgbClr val="B3B3B3"/>
                 </a:solidFill>
                 <a:latin typeface="Trenda IG Text"/>
               </a:rPr>
@@ -41636,7 +41850,7 @@
             <a:avLst/>
           </a:prstGeom>
           <a:solidFill>
-            <a:srgbClr val="F7F7F7"/>
+            <a:srgbClr val="141414"/>
           </a:solidFill>
           <a:ln>
             <a:noFill/>
@@ -41677,9 +41891,20 @@
           <a:prstGeom prst="rect">
             <a:avLst/>
           </a:prstGeom>
-          <a:solidFill>
-            <a:srgbClr val="00D6F2"/>
-          </a:solidFill>
+          <a:gradFill rotWithShape="1">
+            <a:gsLst>
+              <a:gs pos="0">
+                <a:srgbClr val="FFD700"/>
+              </a:gs>
+              <a:gs pos="50000">
+                <a:srgbClr val="FF0069"/>
+              </a:gs>
+              <a:gs pos="100000">
+                <a:srgbClr val="00D6F2"/>
+              </a:gs>
+            </a:gsLst>
+            <a:lin ang="5400000" scaled="0"/>
+          </a:gradFill>
           <a:ln>
             <a:noFill/>
           </a:ln>
@@ -41735,7 +41960,7 @@
             <a:r>
               <a:rPr sz="760" b="1" i="0">
                 <a:solidFill>
-                  <a:srgbClr val="1A1A1A"/>
+                  <a:srgbClr val="F2F2F2"/>
                 </a:solidFill>
                 <a:latin typeface="Trenda IG Text"/>
               </a:rPr>
@@ -41751,7 +41976,7 @@
             <a:r>
               <a:rPr sz="620" b="0" i="0">
                 <a:solidFill>
-                  <a:srgbClr val="4D4D4D"/>
+                  <a:srgbClr val="B3B3B3"/>
                 </a:solidFill>
                 <a:latin typeface="Trenda IG Text"/>
               </a:rPr>
@@ -41785,7 +42010,7 @@
             <a:r>
               <a:rPr sz="660" b="1" i="0">
                 <a:solidFill>
-                  <a:srgbClr val="1A1A1A"/>
+                  <a:srgbClr val="F2F2F2"/>
                 </a:solidFill>
                 <a:latin typeface="Trenda IG Text"/>
               </a:rPr>
@@ -41794,7 +42019,7 @@
             <a:r>
               <a:rPr sz="660" b="0" i="0">
                 <a:solidFill>
-                  <a:srgbClr val="4D4D4D"/>
+                  <a:srgbClr val="B3B3B3"/>
                 </a:solidFill>
                 <a:latin typeface="Trenda IG Text"/>
               </a:rPr>

</xml_diff>

<commit_message>
Data Harness deck: replace the blue accent with IG cyan
Slides 4, 6 and 8 used a non-brand blue; the muted style now uses IG
cyan (and yellow), and the Tableau orange connector is cyan too. A
colour audit of every content slide finds nothing outside the IG
palette, the agreed greys and the bronze/silver/gold boxes.

Co-Authored-By: Claude Opus 5.5 <noreply@anthropic.com>
Claude-Session: https://claude.ai/code/session_01Hf94kqMzSofkkrQm7kpNba
</commit_message>
<xml_diff>
--- a/poc/data_harness/Ascension Agentic Harness - Data Harness.pptx
+++ b/poc/data_harness/Ascension Agentic Harness - Data Harness.pptx
@@ -16200,7 +16200,7 @@
             <a:r>
               <a:rPr sz="800" b="1" i="0" spc="300">
                 <a:solidFill>
-                  <a:srgbClr val="6EA8FF"/>
+                  <a:srgbClr val="00D6F2"/>
                 </a:solidFill>
                 <a:latin typeface="Trenda IG Text"/>
               </a:rPr>
@@ -16298,7 +16298,7 @@
           </a:solidFill>
           <a:ln w="9525">
             <a:solidFill>
-              <a:srgbClr val="5B8DEF"/>
+              <a:srgbClr val="00D6F2"/>
             </a:solidFill>
           </a:ln>
           <a:effectLst/>
@@ -16513,7 +16513,7 @@
           </a:solidFill>
           <a:ln w="7620">
             <a:solidFill>
-              <a:srgbClr val="5B8DEF"/>
+              <a:srgbClr val="00D6F2"/>
             </a:solidFill>
           </a:ln>
           <a:effectLst/>
@@ -16751,7 +16751,7 @@
           </a:solidFill>
           <a:ln w="7620">
             <a:solidFill>
-              <a:srgbClr val="5B8DEF"/>
+              <a:srgbClr val="00D6F2"/>
             </a:solidFill>
           </a:ln>
           <a:effectLst/>
@@ -16865,7 +16865,7 @@
           </a:prstGeom>
           <a:ln w="11430">
             <a:solidFill>
-              <a:srgbClr val="5B8DEF"/>
+              <a:srgbClr val="00D6F2"/>
             </a:solidFill>
             <a:tailEnd type="triangle" w="med" len="med"/>
           </a:ln>
@@ -16906,7 +16906,7 @@
           </a:solidFill>
           <a:ln w="7620">
             <a:solidFill>
-              <a:srgbClr val="5B8DEF"/>
+              <a:srgbClr val="00D6F2"/>
             </a:solidFill>
           </a:ln>
           <a:effectLst/>
@@ -17098,11 +17098,11 @@
             </a:avLst>
           </a:prstGeom>
           <a:solidFill>
-            <a:srgbClr val="1F5FD6"/>
+            <a:srgbClr val="00D6F2"/>
           </a:solidFill>
           <a:ln w="6350">
             <a:solidFill>
-              <a:srgbClr val="5B8DEF"/>
+              <a:srgbClr val="00D6F2"/>
             </a:solidFill>
           </a:ln>
           <a:effectLst/>
@@ -17153,7 +17153,7 @@
             <a:r>
               <a:rPr sz="560" b="1" i="0" spc="80">
                 <a:solidFill>
-                  <a:srgbClr val="F2F2F2"/>
+                  <a:srgbClr val="1A1A1A"/>
                 </a:solidFill>
                 <a:latin typeface="Trenda IG Text"/>
               </a:rPr>
@@ -17321,7 +17321,7 @@
           </a:solidFill>
           <a:ln w="7620">
             <a:solidFill>
-              <a:srgbClr val="5B8DEF"/>
+              <a:srgbClr val="00D6F2"/>
             </a:solidFill>
           </a:ln>
           <a:effectLst/>
@@ -17513,11 +17513,11 @@
             </a:avLst>
           </a:prstGeom>
           <a:solidFill>
-            <a:srgbClr val="1F5FD6"/>
+            <a:srgbClr val="00D6F2"/>
           </a:solidFill>
           <a:ln w="6350">
             <a:solidFill>
-              <a:srgbClr val="5B8DEF"/>
+              <a:srgbClr val="00D6F2"/>
             </a:solidFill>
           </a:ln>
           <a:effectLst/>
@@ -17568,7 +17568,7 @@
             <a:r>
               <a:rPr sz="560" b="1" i="0" spc="80">
                 <a:solidFill>
-                  <a:srgbClr val="F2F2F2"/>
+                  <a:srgbClr val="1A1A1A"/>
                 </a:solidFill>
                 <a:latin typeface="Trenda IG Text"/>
               </a:rPr>
@@ -17736,7 +17736,7 @@
           </a:solidFill>
           <a:ln w="7620">
             <a:solidFill>
-              <a:srgbClr val="5B8DEF"/>
+              <a:srgbClr val="00D6F2"/>
             </a:solidFill>
           </a:ln>
           <a:effectLst/>
@@ -17928,11 +17928,11 @@
             </a:avLst>
           </a:prstGeom>
           <a:solidFill>
-            <a:srgbClr val="1F5FD6"/>
+            <a:srgbClr val="00D6F2"/>
           </a:solidFill>
           <a:ln w="6350">
             <a:solidFill>
-              <a:srgbClr val="5B8DEF"/>
+              <a:srgbClr val="00D6F2"/>
             </a:solidFill>
           </a:ln>
           <a:effectLst/>
@@ -17983,7 +17983,7 @@
             <a:r>
               <a:rPr sz="560" b="1" i="0" spc="80">
                 <a:solidFill>
-                  <a:srgbClr val="F2F2F2"/>
+                  <a:srgbClr val="1A1A1A"/>
                 </a:solidFill>
                 <a:latin typeface="Trenda IG Text"/>
               </a:rPr>
@@ -18013,7 +18013,7 @@
           </a:solidFill>
           <a:ln w="7620">
             <a:solidFill>
-              <a:srgbClr val="5B8DEF"/>
+              <a:srgbClr val="00D6F2"/>
             </a:solidFill>
           </a:ln>
           <a:effectLst/>
@@ -18205,11 +18205,11 @@
             </a:avLst>
           </a:prstGeom>
           <a:solidFill>
-            <a:srgbClr val="1F5FD6"/>
+            <a:srgbClr val="00D6F2"/>
           </a:solidFill>
           <a:ln w="6350">
             <a:solidFill>
-              <a:srgbClr val="5B8DEF"/>
+              <a:srgbClr val="00D6F2"/>
             </a:solidFill>
           </a:ln>
           <a:effectLst/>
@@ -18260,7 +18260,7 @@
             <a:r>
               <a:rPr sz="560" b="1" i="0" spc="80">
                 <a:solidFill>
-                  <a:srgbClr val="F2F2F2"/>
+                  <a:srgbClr val="1A1A1A"/>
                 </a:solidFill>
                 <a:latin typeface="Trenda IG Text"/>
               </a:rPr>
@@ -18428,7 +18428,7 @@
           </a:solidFill>
           <a:ln w="7620">
             <a:solidFill>
-              <a:srgbClr val="5B8DEF"/>
+              <a:srgbClr val="00D6F2"/>
             </a:solidFill>
           </a:ln>
           <a:effectLst/>
@@ -18620,11 +18620,11 @@
             </a:avLst>
           </a:prstGeom>
           <a:solidFill>
-            <a:srgbClr val="1F5FD6"/>
+            <a:srgbClr val="00D6F2"/>
           </a:solidFill>
           <a:ln w="6350">
             <a:solidFill>
-              <a:srgbClr val="5B8DEF"/>
+              <a:srgbClr val="00D6F2"/>
             </a:solidFill>
           </a:ln>
           <a:effectLst/>
@@ -18675,7 +18675,7 @@
             <a:r>
               <a:rPr sz="560" b="1" i="0" spc="80">
                 <a:solidFill>
-                  <a:srgbClr val="F2F2F2"/>
+                  <a:srgbClr val="1A1A1A"/>
                 </a:solidFill>
                 <a:latin typeface="Trenda IG Text"/>
               </a:rPr>
@@ -19277,7 +19277,7 @@
           </a:prstGeom>
           <a:ln w="13335">
             <a:solidFill>
-              <a:srgbClr val="5B8DEF"/>
+              <a:srgbClr val="00D6F2"/>
             </a:solidFill>
             <a:tailEnd type="triangle" w="med" len="med"/>
           </a:ln>
@@ -22714,7 +22714,7 @@
             <a:r>
               <a:rPr sz="800" b="1" i="0" spc="300">
                 <a:solidFill>
-                  <a:srgbClr val="6EA8FF"/>
+                  <a:srgbClr val="00D6F2"/>
                 </a:solidFill>
                 <a:latin typeface="Trenda IG Text"/>
               </a:rPr>
@@ -23453,7 +23453,7 @@
           </a:prstGeom>
           <a:ln w="9525">
             <a:solidFill>
-              <a:srgbClr val="5B8DEF"/>
+              <a:srgbClr val="00D6F2"/>
             </a:solidFill>
           </a:ln>
         </p:spPr>
@@ -23488,7 +23488,7 @@
           </a:prstGeom>
           <a:ln w="9525">
             <a:solidFill>
-              <a:srgbClr val="5B8DEF"/>
+              <a:srgbClr val="00D6F2"/>
             </a:solidFill>
           </a:ln>
         </p:spPr>
@@ -23523,7 +23523,7 @@
           </a:prstGeom>
           <a:ln w="9525">
             <a:solidFill>
-              <a:srgbClr val="5B8DEF"/>
+              <a:srgbClr val="00D6F2"/>
             </a:solidFill>
             <a:tailEnd type="triangle" w="med" len="med"/>
           </a:ln>
@@ -23559,7 +23559,7 @@
           </a:prstGeom>
           <a:ln w="9525">
             <a:solidFill>
-              <a:srgbClr val="5B8DEF"/>
+              <a:srgbClr val="00D6F2"/>
             </a:solidFill>
           </a:ln>
         </p:spPr>
@@ -23594,7 +23594,7 @@
           </a:prstGeom>
           <a:ln w="9525">
             <a:solidFill>
-              <a:srgbClr val="5B8DEF"/>
+              <a:srgbClr val="00D6F2"/>
             </a:solidFill>
           </a:ln>
         </p:spPr>
@@ -23629,7 +23629,7 @@
           </a:prstGeom>
           <a:ln w="9525">
             <a:solidFill>
-              <a:srgbClr val="5B8DEF"/>
+              <a:srgbClr val="00D6F2"/>
             </a:solidFill>
             <a:tailEnd type="triangle" w="med" len="med"/>
           </a:ln>
@@ -23665,7 +23665,7 @@
           </a:prstGeom>
           <a:ln w="9525">
             <a:solidFill>
-              <a:srgbClr val="5B8DEF"/>
+              <a:srgbClr val="00D6F2"/>
             </a:solidFill>
           </a:ln>
         </p:spPr>
@@ -23700,7 +23700,7 @@
           </a:prstGeom>
           <a:ln w="9525">
             <a:solidFill>
-              <a:srgbClr val="5B8DEF"/>
+              <a:srgbClr val="00D6F2"/>
             </a:solidFill>
           </a:ln>
         </p:spPr>
@@ -23735,7 +23735,7 @@
           </a:prstGeom>
           <a:ln w="9525">
             <a:solidFill>
-              <a:srgbClr val="5B8DEF"/>
+              <a:srgbClr val="00D6F2"/>
             </a:solidFill>
             <a:tailEnd type="triangle" w="med" len="med"/>
           </a:ln>
@@ -23771,7 +23771,7 @@
           </a:prstGeom>
           <a:ln w="9525">
             <a:solidFill>
-              <a:srgbClr val="5B8DEF"/>
+              <a:srgbClr val="00D6F2"/>
             </a:solidFill>
           </a:ln>
         </p:spPr>
@@ -23806,7 +23806,7 @@
           </a:prstGeom>
           <a:ln w="9525">
             <a:solidFill>
-              <a:srgbClr val="5B8DEF"/>
+              <a:srgbClr val="00D6F2"/>
             </a:solidFill>
           </a:ln>
         </p:spPr>
@@ -23841,7 +23841,7 @@
           </a:prstGeom>
           <a:ln w="9525">
             <a:solidFill>
-              <a:srgbClr val="5B8DEF"/>
+              <a:srgbClr val="00D6F2"/>
             </a:solidFill>
             <a:tailEnd type="triangle" w="med" len="med"/>
           </a:ln>
@@ -23877,7 +23877,7 @@
           </a:prstGeom>
           <a:ln w="9525">
             <a:solidFill>
-              <a:srgbClr val="5B8DEF"/>
+              <a:srgbClr val="00D6F2"/>
             </a:solidFill>
           </a:ln>
         </p:spPr>
@@ -23912,7 +23912,7 @@
           </a:prstGeom>
           <a:ln w="9525">
             <a:solidFill>
-              <a:srgbClr val="5B8DEF"/>
+              <a:srgbClr val="00D6F2"/>
             </a:solidFill>
           </a:ln>
         </p:spPr>
@@ -23947,7 +23947,7 @@
           </a:prstGeom>
           <a:ln w="9525">
             <a:solidFill>
-              <a:srgbClr val="5B8DEF"/>
+              <a:srgbClr val="00D6F2"/>
             </a:solidFill>
             <a:tailEnd type="triangle" w="med" len="med"/>
           </a:ln>
@@ -23983,7 +23983,7 @@
           </a:prstGeom>
           <a:ln w="9525">
             <a:solidFill>
-              <a:srgbClr val="5B8DEF"/>
+              <a:srgbClr val="00D6F2"/>
             </a:solidFill>
           </a:ln>
         </p:spPr>
@@ -24018,7 +24018,7 @@
           </a:prstGeom>
           <a:ln w="9525">
             <a:solidFill>
-              <a:srgbClr val="5B8DEF"/>
+              <a:srgbClr val="00D6F2"/>
             </a:solidFill>
           </a:ln>
         </p:spPr>
@@ -24053,7 +24053,7 @@
           </a:prstGeom>
           <a:ln w="9525">
             <a:solidFill>
-              <a:srgbClr val="5B8DEF"/>
+              <a:srgbClr val="00D6F2"/>
             </a:solidFill>
             <a:tailEnd type="triangle" w="med" len="med"/>
           </a:ln>
@@ -24944,7 +24944,7 @@
           <a:noFill/>
           <a:ln w="6350">
             <a:solidFill>
-              <a:srgbClr val="5B8DEF"/>
+              <a:srgbClr val="00D6F2"/>
             </a:solidFill>
           </a:ln>
           <a:effectLst/>
@@ -24995,7 +24995,7 @@
             <a:r>
               <a:rPr sz="420" b="1" i="0" spc="80">
                 <a:solidFill>
-                  <a:srgbClr val="6EA8FF"/>
+                  <a:srgbClr val="00D6F2"/>
                 </a:solidFill>
                 <a:latin typeface="Trenda IG Text"/>
               </a:rPr>
@@ -25108,7 +25108,7 @@
           <a:noFill/>
           <a:ln w="6350">
             <a:solidFill>
-              <a:srgbClr val="5B8DEF"/>
+              <a:srgbClr val="00D6F2"/>
             </a:solidFill>
           </a:ln>
           <a:effectLst/>
@@ -25159,7 +25159,7 @@
             <a:r>
               <a:rPr sz="420" b="1" i="0" spc="80">
                 <a:solidFill>
-                  <a:srgbClr val="6EA8FF"/>
+                  <a:srgbClr val="00D6F2"/>
                 </a:solidFill>
                 <a:latin typeface="Trenda IG Text"/>
               </a:rPr>
@@ -28631,7 +28631,7 @@
             <a:r>
               <a:rPr sz="800" b="1" i="0" spc="300">
                 <a:solidFill>
-                  <a:srgbClr val="6EA8FF"/>
+                  <a:srgbClr val="00D6F2"/>
                 </a:solidFill>
                 <a:latin typeface="Trenda IG Text"/>
               </a:rPr>
@@ -29885,7 +29885,7 @@
             <a:r>
               <a:rPr sz="660" b="1" i="0">
                 <a:solidFill>
-                  <a:srgbClr val="F2F2F2"/>
+                  <a:srgbClr val="1A1A1A"/>
                 </a:solidFill>
                 <a:latin typeface="Trenda IG Text"/>
               </a:rPr>
@@ -30081,7 +30081,7 @@
             <a:r>
               <a:rPr sz="660" b="1" i="0">
                 <a:solidFill>
-                  <a:srgbClr val="F2F2F2"/>
+                  <a:srgbClr val="1A1A1A"/>
                 </a:solidFill>
                 <a:latin typeface="Trenda IG Text"/>
               </a:rPr>
@@ -30544,7 +30544,7 @@
           </a:solidFill>
           <a:ln w="7620">
             <a:solidFill>
-              <a:srgbClr val="5B8DEF"/>
+              <a:srgbClr val="00D6F2"/>
             </a:solidFill>
           </a:ln>
           <a:effectLst/>
@@ -30960,7 +30960,7 @@
           </a:solidFill>
           <a:ln w="9525">
             <a:solidFill>
-              <a:srgbClr val="5B8DEF"/>
+              <a:srgbClr val="00D6F2"/>
             </a:solidFill>
           </a:ln>
           <a:effectLst/>
@@ -31000,7 +31000,7 @@
             <a:avLst/>
           </a:prstGeom>
           <a:solidFill>
-            <a:srgbClr val="1F5FD6"/>
+            <a:srgbClr val="00D6F2"/>
           </a:solidFill>
           <a:ln>
             <a:noFill/>
@@ -31053,7 +31053,7 @@
             <a:r>
               <a:rPr sz="660" b="1" i="0">
                 <a:solidFill>
-                  <a:srgbClr val="F2F2F2"/>
+                  <a:srgbClr val="1A1A1A"/>
                 </a:solidFill>
                 <a:latin typeface="Trenda IG Text"/>
               </a:rPr>
@@ -31137,11 +31137,11 @@
             </a:avLst>
           </a:prstGeom>
           <a:solidFill>
-            <a:srgbClr val="1F5FD6"/>
+            <a:srgbClr val="00D6F2"/>
           </a:solidFill>
           <a:ln w="6350">
             <a:solidFill>
-              <a:srgbClr val="5B8DEF"/>
+              <a:srgbClr val="00D6F2"/>
             </a:solidFill>
           </a:ln>
           <a:effectLst/>
@@ -31192,7 +31192,7 @@
             <a:r>
               <a:rPr sz="500" b="1" i="0" spc="80">
                 <a:solidFill>
-                  <a:srgbClr val="F2F2F2"/>
+                  <a:srgbClr val="1A1A1A"/>
                 </a:solidFill>
                 <a:latin typeface="Trenda IG Text"/>
               </a:rPr>
@@ -31652,7 +31652,7 @@
           </a:solidFill>
           <a:ln w="9525">
             <a:solidFill>
-              <a:srgbClr val="5B8DEF"/>
+              <a:srgbClr val="00D6F2"/>
             </a:solidFill>
           </a:ln>
           <a:effectLst/>
@@ -31692,7 +31692,7 @@
             <a:avLst/>
           </a:prstGeom>
           <a:solidFill>
-            <a:srgbClr val="1F5FD6"/>
+            <a:srgbClr val="00D6F2"/>
           </a:solidFill>
           <a:ln>
             <a:noFill/>
@@ -31745,7 +31745,7 @@
             <a:r>
               <a:rPr sz="660" b="1" i="0">
                 <a:solidFill>
-                  <a:srgbClr val="F2F2F2"/>
+                  <a:srgbClr val="1A1A1A"/>
                 </a:solidFill>
                 <a:latin typeface="Trenda IG Text"/>
               </a:rPr>
@@ -31829,11 +31829,11 @@
             </a:avLst>
           </a:prstGeom>
           <a:solidFill>
-            <a:srgbClr val="1F5FD6"/>
+            <a:srgbClr val="00D6F2"/>
           </a:solidFill>
           <a:ln w="6350">
             <a:solidFill>
-              <a:srgbClr val="5B8DEF"/>
+              <a:srgbClr val="00D6F2"/>
             </a:solidFill>
           </a:ln>
           <a:effectLst/>
@@ -31884,7 +31884,7 @@
             <a:r>
               <a:rPr sz="500" b="1" i="0" spc="80">
                 <a:solidFill>
-                  <a:srgbClr val="F2F2F2"/>
+                  <a:srgbClr val="1A1A1A"/>
                 </a:solidFill>
                 <a:latin typeface="Trenda IG Text"/>
               </a:rPr>
@@ -32813,7 +32813,7 @@
           </a:solidFill>
           <a:ln w="9525">
             <a:solidFill>
-              <a:srgbClr val="5B8DEF"/>
+              <a:srgbClr val="00D6F2"/>
             </a:solidFill>
           </a:ln>
           <a:effectLst/>
@@ -32913,11 +32913,11 @@
             </a:avLst>
           </a:prstGeom>
           <a:solidFill>
-            <a:srgbClr val="1F5FD6"/>
+            <a:srgbClr val="00D6F2"/>
           </a:solidFill>
           <a:ln w="6350">
             <a:solidFill>
-              <a:srgbClr val="5B8DEF"/>
+              <a:srgbClr val="00D6F2"/>
             </a:solidFill>
           </a:ln>
           <a:effectLst/>
@@ -32968,7 +32968,7 @@
             <a:r>
               <a:rPr sz="500" b="1" i="0" spc="80">
                 <a:solidFill>
-                  <a:srgbClr val="F2F2F2"/>
+                  <a:srgbClr val="1A1A1A"/>
                 </a:solidFill>
                 <a:latin typeface="Trenda IG Text"/>
               </a:rPr>
@@ -33063,7 +33063,7 @@
           </a:prstGeom>
           <a:ln w="9525">
             <a:solidFill>
-              <a:srgbClr val="E97627"/>
+              <a:srgbClr val="00D6F2"/>
             </a:solidFill>
             <a:tailEnd type="triangle" w="med" len="med"/>
           </a:ln>
@@ -33099,7 +33099,7 @@
           </a:prstGeom>
           <a:ln w="11430">
             <a:solidFill>
-              <a:srgbClr val="5B8DEF"/>
+              <a:srgbClr val="00D6F2"/>
             </a:solidFill>
           </a:ln>
         </p:spPr>
@@ -33134,7 +33134,7 @@
           </a:prstGeom>
           <a:ln w="11430">
             <a:solidFill>
-              <a:srgbClr val="5B8DEF"/>
+              <a:srgbClr val="00D6F2"/>
             </a:solidFill>
           </a:ln>
         </p:spPr>
@@ -33169,7 +33169,7 @@
           </a:prstGeom>
           <a:ln w="11430">
             <a:solidFill>
-              <a:srgbClr val="5B8DEF"/>
+              <a:srgbClr val="00D6F2"/>
             </a:solidFill>
             <a:tailEnd type="triangle" w="med" len="med"/>
           </a:ln>
@@ -33327,7 +33327,7 @@
           </a:solidFill>
           <a:ln w="7620">
             <a:solidFill>
-              <a:srgbClr val="5B8DEF"/>
+              <a:srgbClr val="00D6F2"/>
             </a:solidFill>
           </a:ln>
           <a:effectLst/>
@@ -33670,7 +33670,7 @@
           </a:solidFill>
           <a:ln w="9525">
             <a:solidFill>
-              <a:srgbClr val="5B8DEF"/>
+              <a:srgbClr val="00D6F2"/>
             </a:solidFill>
           </a:ln>
           <a:effectLst/>
@@ -33710,7 +33710,7 @@
             <a:avLst/>
           </a:prstGeom>
           <a:solidFill>
-            <a:srgbClr val="1F5FD6"/>
+            <a:srgbClr val="00D6F2"/>
           </a:solidFill>
           <a:ln>
             <a:noFill/>
@@ -33763,7 +33763,7 @@
             <a:r>
               <a:rPr sz="660" b="1" i="0">
                 <a:solidFill>
-                  <a:srgbClr val="F2F2F2"/>
+                  <a:srgbClr val="1A1A1A"/>
                 </a:solidFill>
                 <a:latin typeface="Trenda IG Text"/>
               </a:rPr>
@@ -33847,11 +33847,11 @@
             </a:avLst>
           </a:prstGeom>
           <a:solidFill>
-            <a:srgbClr val="1F5FD6"/>
+            <a:srgbClr val="00D6F2"/>
           </a:solidFill>
           <a:ln w="6350">
             <a:solidFill>
-              <a:srgbClr val="5B8DEF"/>
+              <a:srgbClr val="00D6F2"/>
             </a:solidFill>
           </a:ln>
           <a:effectLst/>
@@ -33902,7 +33902,7 @@
             <a:r>
               <a:rPr sz="500" b="1" i="0" spc="80">
                 <a:solidFill>
-                  <a:srgbClr val="F2F2F2"/>
+                  <a:srgbClr val="1A1A1A"/>
                 </a:solidFill>
                 <a:latin typeface="Trenda IG Text"/>
               </a:rPr>
@@ -34055,7 +34055,7 @@
             <a:avLst/>
           </a:prstGeom>
           <a:solidFill>
-            <a:srgbClr val="1F5FD6"/>
+            <a:srgbClr val="00D6F2"/>
           </a:solidFill>
           <a:ln>
             <a:noFill/>
@@ -34108,7 +34108,7 @@
             <a:r>
               <a:rPr sz="660" b="1" i="0">
                 <a:solidFill>
-                  <a:srgbClr val="F2F2F2"/>
+                  <a:srgbClr val="1A1A1A"/>
                 </a:solidFill>
                 <a:latin typeface="Trenda IG Text"/>
               </a:rPr>
@@ -34211,7 +34211,7 @@
           </a:solidFill>
           <a:ln w="7620">
             <a:solidFill>
-              <a:srgbClr val="5B8DEF"/>
+              <a:srgbClr val="00D6F2"/>
             </a:solidFill>
           </a:ln>
           <a:effectLst/>
@@ -34392,7 +34392,7 @@
           </a:solidFill>
           <a:ln w="7620">
             <a:solidFill>
-              <a:srgbClr val="5B8DEF"/>
+              <a:srgbClr val="00D6F2"/>
             </a:solidFill>
             <a:prstDash val="dash"/>
           </a:ln>

</xml_diff>

<commit_message>
Data Harness deck: add lean team and cost saving as slide 10
Co-Authored-By: Claude Opus 5.5 <noreply@anthropic.com>
Claude-Session: https://claude.ai/code/session_01Hf94kqMzSofkkrQm7kpNba
</commit_message>
<xml_diff>
--- a/poc/data_harness/Ascension Agentic Harness - Data Harness.pptx
+++ b/poc/data_harness/Ascension Agentic Harness - Data Harness.pptx
@@ -18,6 +18,7 @@
     <p:sldId id="325" r:id="rId17"/>
     <p:sldId id="323" r:id="rId15"/>
     <p:sldId id="326" r:id="rId18"/>
+    <p:sldId id="327" r:id="rId19"/>
   </p:sldIdLst>
   <p:sldSz cx="12192000" cy="6858000"/>
   <p:notesSz cx="6858000" cy="12192000"/>
@@ -1434,6 +1435,120 @@
 </p:notes>
 </file>
 
+<file path=ppt/notesSlides/notesSlide10.xml><?xml version="1.0" encoding="utf-8"?>
+<p:notes xmlns:a="http://schemas.openxmlformats.org/drawingml/2006/main" xmlns:p="http://schemas.openxmlformats.org/presentationml/2006/main" xmlns:r="http://schemas.openxmlformats.org/officeDocument/2006/relationships">
+  <p:cSld>
+    <p:spTree>
+      <p:nvGrpSpPr>
+        <p:cNvPr id="1" name=""/>
+        <p:cNvGrpSpPr/>
+        <p:nvPr/>
+      </p:nvGrpSpPr>
+      <p:grpSpPr>
+        <a:xfrm>
+          <a:off x="0" y="0"/>
+          <a:ext cx="0" cy="0"/>
+          <a:chOff x="0" y="0"/>
+          <a:chExt cx="0" cy="0"/>
+        </a:xfrm>
+      </p:grpSpPr>
+      <p:sp>
+        <p:nvSpPr>
+          <p:cNvPr id="3" name="Notes Placeholder 2"/>
+          <p:cNvSpPr>
+            <a:spLocks noGrp="1"/>
+          </p:cNvSpPr>
+          <p:nvPr>
+            <p:ph type="body" idx="1"/>
+          </p:nvPr>
+        </p:nvSpPr>
+        <p:spPr/>
+        <p:txBody>
+          <a:bodyPr/>
+          <a:lstStyle/>
+          <a:p>
+            <a:r>
+              <a:t>SLIDE: Lean team and cost saving   (about 2-3 minutes)</a:t>
+            </a:r>
+          </a:p>
+          <a:p/>
+          <a:p>
+            <a:r>
+              <a:t>KEY MESSAGE</a:t>
+            </a:r>
+          </a:p>
+          <a:p>
+            <a:r>
+              <a:t>Every squad of 4-5 developers becomes 1 developer directing the harness agent, plus 1 QA. Pods run lean on one shared platform. $16M a year today becomes $7M: $9M back every year on a $5.0M build, paid back in under 7 months.</a:t>
+            </a:r>
+          </a:p>
+          <a:p/>
+          <a:p>
+            <a:r>
+              <a:t>WALK IT</a:t>
+            </a:r>
+          </a:p>
+          <a:p>
+            <a:r>
+              <a:t>- The squad: 4 developers and a QA today; with the harness, one developer directs the agent, a QA verifies, and the agent drafts code, tests and the Copado package overnight. People review, approve and own every change.</a:t>
+            </a:r>
+          </a:p>
+          <a:p>
+            <a:r>
+              <a:t>- The pod: today every pod carries its own full stack. With the harness: owner, lead and 2-4 engineers, on one shared platform run by a small team. 20-30% smaller for the same scope, or 1.4-1.6x the output with the same team.</a:t>
+            </a:r>
+          </a:p>
+          <a:p>
+            <a:r>
+              <a:t>- The build: 17 people at peak, 10 roles, 18 months, $4.79M fixed fee paid only when each gate is signed. From month 19 a run team of 4 keeps it running, about $1.24M a year with platform usage.</a:t>
+            </a:r>
+          </a:p>
+          <a:p>
+            <a:r>
+              <a:t>- The return (target, first full year after go-live): $16M a year today, $7M with the harness, $9M saved every year, on a $5.0M investment. Paid back in under 7 months; 80% first-year return.</a:t>
+            </a:r>
+          </a:p>
+          <a:p>
+            <a:r>
+              <a:t>- Floor we commit to: 20-25% lower net run cost per pod, measured against each pod's baseline.</a:t>
+            </a:r>
+          </a:p>
+          <a:p/>
+          <a:p>
+            <a:r>
+              <a:t>KEEP IT HONEST</a:t>
+            </a:r>
+          </a:p>
+          <a:p>
+            <a:r>
+              <a:t>- Baseline every pod first. Year 1 delivers about 60-70% of steady state while pods onboard.</a:t>
+            </a:r>
+          </a:p>
+          <a:p>
+            <a:r>
+              <a:t>- Approvals, UAT and CAB stay human and take the same time.</a:t>
+            </a:r>
+          </a:p>
+          <a:p>
+            <a:r>
+              <a:t>- These figures cover delivery. The campaign data platform and the Sierra voice agent are sized separately, after Phase 0.</a:t>
+            </a:r>
+          </a:p>
+          <a:p>
+            <a:r>
+              <a:t>- Rates are assumed for sizing; replace with the Insight Global rate card before sharing.</a:t>
+            </a:r>
+          </a:p>
+        </p:txBody>
+      </p:sp>
+    </p:spTree>
+  </p:cSld>
+  <p:clrMapOvr>
+    <a:masterClrMapping/>
+  </p:clrMapOvr>
+</p:notes>
+</file>
+
 <file path=ppt/notesSlides/notesSlide2.xml><?xml version="1.0" encoding="utf-8"?>
 <p:notes xmlns:a="http://schemas.openxmlformats.org/drawingml/2006/main" xmlns:p="http://schemas.openxmlformats.org/presentationml/2006/main" xmlns:r="http://schemas.openxmlformats.org/officeDocument/2006/relationships">
   <p:cSld>
@@ -3760,6 +3875,3783 @@
         <p14:creationId xmlns:p14="http://schemas.microsoft.com/office/powerpoint/2010/main" val="3603168410"/>
       </p:ext>
     </p:extLst>
+  </p:cSld>
+  <p:clrMapOvr>
+    <a:masterClrMapping/>
+  </p:clrMapOvr>
+</p:sld>
+</file>
+
+<file path=ppt/slides/slide10.xml><?xml version="1.0" encoding="utf-8"?>
+<p:sld xmlns:a="http://schemas.openxmlformats.org/drawingml/2006/main" xmlns:p="http://schemas.openxmlformats.org/presentationml/2006/main" xmlns:r="http://schemas.openxmlformats.org/officeDocument/2006/relationships">
+  <p:cSld>
+    <p:bg>
+      <p:bgPr>
+        <a:solidFill>
+          <a:srgbClr val="000000"/>
+        </a:solidFill>
+        <a:effectLst/>
+      </p:bgPr>
+    </p:bg>
+    <p:spTree>
+      <p:nvGrpSpPr>
+        <p:cNvPr id="1" name=""/>
+        <p:cNvGrpSpPr/>
+        <p:nvPr/>
+      </p:nvGrpSpPr>
+      <p:grpSpPr/>
+      <p:sp>
+        <p:nvSpPr>
+          <p:cNvPr id="2" name="Text 1"/>
+          <p:cNvSpPr txBox="1"/>
+          <p:nvPr/>
+        </p:nvSpPr>
+        <p:spPr>
+          <a:xfrm>
+            <a:off x="411480" y="201168"/>
+            <a:ext cx="8229600" cy="182880"/>
+          </a:xfrm>
+          <a:prstGeom prst="rect">
+            <a:avLst/>
+          </a:prstGeom>
+          <a:noFill/>
+        </p:spPr>
+        <p:txBody>
+          <a:bodyPr wrap="square" lIns="0" rIns="0" tIns="0" bIns="0" anchor="ctr">
+            <a:spAutoFit/>
+          </a:bodyPr>
+          <a:lstStyle/>
+          <a:p>
+            <a:r>
+              <a:rPr sz="800" b="1" i="0" spc="300">
+                <a:solidFill>
+                  <a:srgbClr val="00D6F2"/>
+                </a:solidFill>
+                <a:latin typeface="Trenda IG Text"/>
+              </a:rPr>
+              <a:t>ASCENSION AGENTIC HARNESS · LEAN TEAM AND COST</a:t>
+            </a:r>
+          </a:p>
+        </p:txBody>
+      </p:sp>
+      <p:sp>
+        <p:nvSpPr>
+          <p:cNvPr id="3" name="Text 2"/>
+          <p:cNvSpPr txBox="1"/>
+          <p:nvPr/>
+        </p:nvSpPr>
+        <p:spPr>
+          <a:xfrm>
+            <a:off x="411480" y="384048"/>
+            <a:ext cx="11365992" cy="411480"/>
+          </a:xfrm>
+          <a:prstGeom prst="rect">
+            <a:avLst/>
+          </a:prstGeom>
+          <a:noFill/>
+        </p:spPr>
+        <p:txBody>
+          <a:bodyPr wrap="square" lIns="0" rIns="0" tIns="0" bIns="0" anchor="ctr">
+            <a:spAutoFit/>
+          </a:bodyPr>
+          <a:lstStyle/>
+          <a:p>
+            <a:r>
+              <a:rPr sz="2200" b="1" i="0">
+                <a:solidFill>
+                  <a:srgbClr val="FFFFFF"/>
+                </a:solidFill>
+                <a:latin typeface="Trenda IG Text"/>
+              </a:rPr>
+              <a:t>Lean teams on one platform: $9M back every year on a $5.0M build</a:t>
+            </a:r>
+          </a:p>
+        </p:txBody>
+      </p:sp>
+      <p:sp>
+        <p:nvSpPr>
+          <p:cNvPr id="4" name="Text 3"/>
+          <p:cNvSpPr txBox="1"/>
+          <p:nvPr/>
+        </p:nvSpPr>
+        <p:spPr>
+          <a:xfrm>
+            <a:off x="411480" y="804672"/>
+            <a:ext cx="11365992" cy="237744"/>
+          </a:xfrm>
+          <a:prstGeom prst="rect">
+            <a:avLst/>
+          </a:prstGeom>
+          <a:noFill/>
+        </p:spPr>
+        <p:txBody>
+          <a:bodyPr wrap="square" lIns="0" rIns="0" tIns="0" bIns="0" anchor="ctr">
+            <a:spAutoFit/>
+          </a:bodyPr>
+          <a:lstStyle/>
+          <a:p>
+            <a:r>
+              <a:rPr sz="1050" b="0" i="0">
+                <a:solidFill>
+                  <a:srgbClr val="BFBFBF"/>
+                </a:solidFill>
+                <a:latin typeface="Trenda IG Text"/>
+              </a:rPr>
+              <a:t>Every squad of 4-5 developers becomes 1 developer directing the harness agent, plus 1 QA. People review, approve and own every change.</a:t>
+            </a:r>
+          </a:p>
+        </p:txBody>
+      </p:sp>
+      <p:sp>
+        <p:nvSpPr>
+          <p:cNvPr id="5" name="Shape 4"/>
+          <p:cNvSpPr/>
+          <p:nvPr/>
+        </p:nvSpPr>
+        <p:spPr>
+          <a:xfrm>
+            <a:off x="411480" y="1188720"/>
+            <a:ext cx="3715512" cy="1965960"/>
+          </a:xfrm>
+          <a:prstGeom prst="roundRect">
+            <a:avLst>
+              <a:gd name="adj" fmla="val 2000"/>
+            </a:avLst>
+          </a:prstGeom>
+          <a:solidFill>
+            <a:srgbClr val="1E1E1E"/>
+          </a:solidFill>
+          <a:ln>
+            <a:noFill/>
+          </a:ln>
+          <a:effectLst/>
+        </p:spPr>
+        <p:style>
+          <a:lnRef idx="1">
+            <a:schemeClr val="accent1"/>
+          </a:lnRef>
+          <a:fillRef idx="3">
+            <a:schemeClr val="accent1"/>
+          </a:fillRef>
+          <a:effectRef idx="2">
+            <a:schemeClr val="accent1"/>
+          </a:effectRef>
+          <a:fontRef idx="minor">
+            <a:schemeClr val="lt1"/>
+          </a:fontRef>
+        </p:style>
+        <p:txBody>
+          <a:bodyPr rtlCol="0" anchor="ctr"/>
+          <a:lstStyle/>
+          <a:p/>
+        </p:txBody>
+      </p:sp>
+      <p:sp>
+        <p:nvSpPr>
+          <p:cNvPr id="6" name="Shape 5"/>
+          <p:cNvSpPr/>
+          <p:nvPr/>
+        </p:nvSpPr>
+        <p:spPr>
+          <a:xfrm>
+            <a:off x="411480" y="1188720"/>
+            <a:ext cx="3715512" cy="256032"/>
+          </a:xfrm>
+          <a:prstGeom prst="rect">
+            <a:avLst/>
+          </a:prstGeom>
+          <a:solidFill>
+            <a:srgbClr val="2B2B2B"/>
+          </a:solidFill>
+          <a:ln>
+            <a:noFill/>
+          </a:ln>
+          <a:effectLst/>
+        </p:spPr>
+        <p:style>
+          <a:lnRef idx="1">
+            <a:schemeClr val="accent1"/>
+          </a:lnRef>
+          <a:fillRef idx="3">
+            <a:schemeClr val="accent1"/>
+          </a:fillRef>
+          <a:effectRef idx="2">
+            <a:schemeClr val="accent1"/>
+          </a:effectRef>
+          <a:fontRef idx="minor">
+            <a:schemeClr val="lt1"/>
+          </a:fontRef>
+        </p:style>
+        <p:txBody>
+          <a:bodyPr rtlCol="0" anchor="ctr"/>
+          <a:lstStyle/>
+          <a:p/>
+        </p:txBody>
+      </p:sp>
+      <p:sp>
+        <p:nvSpPr>
+          <p:cNvPr id="7" name="Text 6"/>
+          <p:cNvSpPr txBox="1"/>
+          <p:nvPr/>
+        </p:nvSpPr>
+        <p:spPr>
+          <a:xfrm>
+            <a:off x="521208" y="1188720"/>
+            <a:ext cx="3496056" cy="256032"/>
+          </a:xfrm>
+          <a:prstGeom prst="rect">
+            <a:avLst/>
+          </a:prstGeom>
+          <a:noFill/>
+        </p:spPr>
+        <p:txBody>
+          <a:bodyPr wrap="square" lIns="0" rIns="0" tIns="0" bIns="0" anchor="ctr">
+            <a:spAutoFit/>
+          </a:bodyPr>
+          <a:lstStyle/>
+          <a:p>
+            <a:r>
+              <a:rPr sz="640" b="1" i="0" spc="120">
+                <a:solidFill>
+                  <a:srgbClr val="F2F2F2"/>
+                </a:solidFill>
+                <a:latin typeface="Trenda IG Text"/>
+              </a:rPr>
+              <a:t>THE SQUAD</a:t>
+            </a:r>
+            <a:r>
+              <a:rPr sz="640" b="0" i="0">
+                <a:solidFill>
+                  <a:srgbClr val="B3B3B3"/>
+                </a:solidFill>
+                <a:latin typeface="Trenda IG Text"/>
+              </a:rPr>
+              <a:t>   same scope, two people</a:t>
+            </a:r>
+          </a:p>
+        </p:txBody>
+      </p:sp>
+      <p:sp>
+        <p:nvSpPr>
+          <p:cNvPr id="8" name="Text 7"/>
+          <p:cNvSpPr txBox="1"/>
+          <p:nvPr/>
+        </p:nvSpPr>
+        <p:spPr>
+          <a:xfrm>
+            <a:off x="539496" y="1536192"/>
+            <a:ext cx="1371600" cy="164592"/>
+          </a:xfrm>
+          <a:prstGeom prst="rect">
+            <a:avLst/>
+          </a:prstGeom>
+          <a:noFill/>
+        </p:spPr>
+        <p:txBody>
+          <a:bodyPr wrap="square" lIns="0" rIns="0" tIns="0" bIns="0" anchor="ctr">
+            <a:spAutoFit/>
+          </a:bodyPr>
+          <a:lstStyle/>
+          <a:p>
+            <a:r>
+              <a:rPr sz="540" b="1" i="0" spc="100">
+                <a:solidFill>
+                  <a:srgbClr val="8C8C8C"/>
+                </a:solidFill>
+                <a:latin typeface="Trenda IG Text"/>
+              </a:rPr>
+              <a:t>TODAY</a:t>
+            </a:r>
+          </a:p>
+        </p:txBody>
+      </p:sp>
+      <p:sp>
+        <p:nvSpPr>
+          <p:cNvPr id="9" name="Shape 8"/>
+          <p:cNvSpPr/>
+          <p:nvPr/>
+        </p:nvSpPr>
+        <p:spPr>
+          <a:xfrm>
+            <a:off x="539496" y="1719072"/>
+            <a:ext cx="648004" cy="274320"/>
+          </a:xfrm>
+          <a:prstGeom prst="roundRect">
+            <a:avLst>
+              <a:gd name="adj" fmla="val 25000"/>
+            </a:avLst>
+          </a:prstGeom>
+          <a:solidFill>
+            <a:srgbClr val="141414"/>
+          </a:solidFill>
+          <a:ln w="9525">
+            <a:solidFill>
+              <a:srgbClr val="333333"/>
+            </a:solidFill>
+          </a:ln>
+          <a:effectLst/>
+        </p:spPr>
+        <p:style>
+          <a:lnRef idx="1">
+            <a:schemeClr val="accent1"/>
+          </a:lnRef>
+          <a:fillRef idx="3">
+            <a:schemeClr val="accent1"/>
+          </a:fillRef>
+          <a:effectRef idx="2">
+            <a:schemeClr val="accent1"/>
+          </a:effectRef>
+          <a:fontRef idx="minor">
+            <a:schemeClr val="lt1"/>
+          </a:fontRef>
+        </p:style>
+        <p:txBody>
+          <a:bodyPr rtlCol="0" anchor="ctr"/>
+          <a:lstStyle/>
+          <a:p/>
+        </p:txBody>
+      </p:sp>
+      <p:sp>
+        <p:nvSpPr>
+          <p:cNvPr id="10" name="Text 9"/>
+          <p:cNvSpPr txBox="1"/>
+          <p:nvPr/>
+        </p:nvSpPr>
+        <p:spPr>
+          <a:xfrm>
+            <a:off x="539496" y="1719072"/>
+            <a:ext cx="648004" cy="274320"/>
+          </a:xfrm>
+          <a:prstGeom prst="rect">
+            <a:avLst/>
+          </a:prstGeom>
+          <a:noFill/>
+        </p:spPr>
+        <p:txBody>
+          <a:bodyPr wrap="square" lIns="0" rIns="0" tIns="0" bIns="0" anchor="ctr">
+            <a:spAutoFit/>
+          </a:bodyPr>
+          <a:lstStyle/>
+          <a:p>
+            <a:pPr algn="ctr"/>
+            <a:r>
+              <a:rPr sz="640" b="1" i="0">
+                <a:solidFill>
+                  <a:srgbClr val="B3B3B3"/>
+                </a:solidFill>
+                <a:latin typeface="Trenda IG Text"/>
+              </a:rPr>
+              <a:t>Dev</a:t>
+            </a:r>
+          </a:p>
+        </p:txBody>
+      </p:sp>
+      <p:sp>
+        <p:nvSpPr>
+          <p:cNvPr id="11" name="Shape 10"/>
+          <p:cNvSpPr/>
+          <p:nvPr/>
+        </p:nvSpPr>
+        <p:spPr>
+          <a:xfrm>
+            <a:off x="1242364" y="1719072"/>
+            <a:ext cx="648004" cy="274320"/>
+          </a:xfrm>
+          <a:prstGeom prst="roundRect">
+            <a:avLst>
+              <a:gd name="adj" fmla="val 25000"/>
+            </a:avLst>
+          </a:prstGeom>
+          <a:solidFill>
+            <a:srgbClr val="141414"/>
+          </a:solidFill>
+          <a:ln w="9525">
+            <a:solidFill>
+              <a:srgbClr val="333333"/>
+            </a:solidFill>
+          </a:ln>
+          <a:effectLst/>
+        </p:spPr>
+        <p:style>
+          <a:lnRef idx="1">
+            <a:schemeClr val="accent1"/>
+          </a:lnRef>
+          <a:fillRef idx="3">
+            <a:schemeClr val="accent1"/>
+          </a:fillRef>
+          <a:effectRef idx="2">
+            <a:schemeClr val="accent1"/>
+          </a:effectRef>
+          <a:fontRef idx="minor">
+            <a:schemeClr val="lt1"/>
+          </a:fontRef>
+        </p:style>
+        <p:txBody>
+          <a:bodyPr rtlCol="0" anchor="ctr"/>
+          <a:lstStyle/>
+          <a:p/>
+        </p:txBody>
+      </p:sp>
+      <p:sp>
+        <p:nvSpPr>
+          <p:cNvPr id="12" name="Text 11"/>
+          <p:cNvSpPr txBox="1"/>
+          <p:nvPr/>
+        </p:nvSpPr>
+        <p:spPr>
+          <a:xfrm>
+            <a:off x="1242364" y="1719072"/>
+            <a:ext cx="648004" cy="274320"/>
+          </a:xfrm>
+          <a:prstGeom prst="rect">
+            <a:avLst/>
+          </a:prstGeom>
+          <a:noFill/>
+        </p:spPr>
+        <p:txBody>
+          <a:bodyPr wrap="square" lIns="0" rIns="0" tIns="0" bIns="0" anchor="ctr">
+            <a:spAutoFit/>
+          </a:bodyPr>
+          <a:lstStyle/>
+          <a:p>
+            <a:pPr algn="ctr"/>
+            <a:r>
+              <a:rPr sz="640" b="1" i="0">
+                <a:solidFill>
+                  <a:srgbClr val="B3B3B3"/>
+                </a:solidFill>
+                <a:latin typeface="Trenda IG Text"/>
+              </a:rPr>
+              <a:t>Dev</a:t>
+            </a:r>
+          </a:p>
+        </p:txBody>
+      </p:sp>
+      <p:sp>
+        <p:nvSpPr>
+          <p:cNvPr id="13" name="Shape 12"/>
+          <p:cNvSpPr/>
+          <p:nvPr/>
+        </p:nvSpPr>
+        <p:spPr>
+          <a:xfrm>
+            <a:off x="1945233" y="1719072"/>
+            <a:ext cx="648004" cy="274320"/>
+          </a:xfrm>
+          <a:prstGeom prst="roundRect">
+            <a:avLst>
+              <a:gd name="adj" fmla="val 25000"/>
+            </a:avLst>
+          </a:prstGeom>
+          <a:solidFill>
+            <a:srgbClr val="141414"/>
+          </a:solidFill>
+          <a:ln w="9525">
+            <a:solidFill>
+              <a:srgbClr val="333333"/>
+            </a:solidFill>
+          </a:ln>
+          <a:effectLst/>
+        </p:spPr>
+        <p:style>
+          <a:lnRef idx="1">
+            <a:schemeClr val="accent1"/>
+          </a:lnRef>
+          <a:fillRef idx="3">
+            <a:schemeClr val="accent1"/>
+          </a:fillRef>
+          <a:effectRef idx="2">
+            <a:schemeClr val="accent1"/>
+          </a:effectRef>
+          <a:fontRef idx="minor">
+            <a:schemeClr val="lt1"/>
+          </a:fontRef>
+        </p:style>
+        <p:txBody>
+          <a:bodyPr rtlCol="0" anchor="ctr"/>
+          <a:lstStyle/>
+          <a:p/>
+        </p:txBody>
+      </p:sp>
+      <p:sp>
+        <p:nvSpPr>
+          <p:cNvPr id="14" name="Text 13"/>
+          <p:cNvSpPr txBox="1"/>
+          <p:nvPr/>
+        </p:nvSpPr>
+        <p:spPr>
+          <a:xfrm>
+            <a:off x="1945233" y="1719072"/>
+            <a:ext cx="648004" cy="274320"/>
+          </a:xfrm>
+          <a:prstGeom prst="rect">
+            <a:avLst/>
+          </a:prstGeom>
+          <a:noFill/>
+        </p:spPr>
+        <p:txBody>
+          <a:bodyPr wrap="square" lIns="0" rIns="0" tIns="0" bIns="0" anchor="ctr">
+            <a:spAutoFit/>
+          </a:bodyPr>
+          <a:lstStyle/>
+          <a:p>
+            <a:pPr algn="ctr"/>
+            <a:r>
+              <a:rPr sz="640" b="1" i="0">
+                <a:solidFill>
+                  <a:srgbClr val="B3B3B3"/>
+                </a:solidFill>
+                <a:latin typeface="Trenda IG Text"/>
+              </a:rPr>
+              <a:t>Dev</a:t>
+            </a:r>
+          </a:p>
+        </p:txBody>
+      </p:sp>
+      <p:sp>
+        <p:nvSpPr>
+          <p:cNvPr id="15" name="Shape 14"/>
+          <p:cNvSpPr/>
+          <p:nvPr/>
+        </p:nvSpPr>
+        <p:spPr>
+          <a:xfrm>
+            <a:off x="2648102" y="1719072"/>
+            <a:ext cx="648004" cy="274320"/>
+          </a:xfrm>
+          <a:prstGeom prst="roundRect">
+            <a:avLst>
+              <a:gd name="adj" fmla="val 25000"/>
+            </a:avLst>
+          </a:prstGeom>
+          <a:solidFill>
+            <a:srgbClr val="141414"/>
+          </a:solidFill>
+          <a:ln w="9525">
+            <a:solidFill>
+              <a:srgbClr val="333333"/>
+            </a:solidFill>
+          </a:ln>
+          <a:effectLst/>
+        </p:spPr>
+        <p:style>
+          <a:lnRef idx="1">
+            <a:schemeClr val="accent1"/>
+          </a:lnRef>
+          <a:fillRef idx="3">
+            <a:schemeClr val="accent1"/>
+          </a:fillRef>
+          <a:effectRef idx="2">
+            <a:schemeClr val="accent1"/>
+          </a:effectRef>
+          <a:fontRef idx="minor">
+            <a:schemeClr val="lt1"/>
+          </a:fontRef>
+        </p:style>
+        <p:txBody>
+          <a:bodyPr rtlCol="0" anchor="ctr"/>
+          <a:lstStyle/>
+          <a:p/>
+        </p:txBody>
+      </p:sp>
+      <p:sp>
+        <p:nvSpPr>
+          <p:cNvPr id="16" name="Text 15"/>
+          <p:cNvSpPr txBox="1"/>
+          <p:nvPr/>
+        </p:nvSpPr>
+        <p:spPr>
+          <a:xfrm>
+            <a:off x="2648102" y="1719072"/>
+            <a:ext cx="648004" cy="274320"/>
+          </a:xfrm>
+          <a:prstGeom prst="rect">
+            <a:avLst/>
+          </a:prstGeom>
+          <a:noFill/>
+        </p:spPr>
+        <p:txBody>
+          <a:bodyPr wrap="square" lIns="0" rIns="0" tIns="0" bIns="0" anchor="ctr">
+            <a:spAutoFit/>
+          </a:bodyPr>
+          <a:lstStyle/>
+          <a:p>
+            <a:pPr algn="ctr"/>
+            <a:r>
+              <a:rPr sz="640" b="1" i="0">
+                <a:solidFill>
+                  <a:srgbClr val="B3B3B3"/>
+                </a:solidFill>
+                <a:latin typeface="Trenda IG Text"/>
+              </a:rPr>
+              <a:t>Dev</a:t>
+            </a:r>
+          </a:p>
+        </p:txBody>
+      </p:sp>
+      <p:sp>
+        <p:nvSpPr>
+          <p:cNvPr id="17" name="Shape 16"/>
+          <p:cNvSpPr/>
+          <p:nvPr/>
+        </p:nvSpPr>
+        <p:spPr>
+          <a:xfrm>
+            <a:off x="3350971" y="1719072"/>
+            <a:ext cx="648004" cy="274320"/>
+          </a:xfrm>
+          <a:prstGeom prst="roundRect">
+            <a:avLst>
+              <a:gd name="adj" fmla="val 25000"/>
+            </a:avLst>
+          </a:prstGeom>
+          <a:solidFill>
+            <a:srgbClr val="141414"/>
+          </a:solidFill>
+          <a:ln w="9525">
+            <a:solidFill>
+              <a:srgbClr val="333333"/>
+            </a:solidFill>
+          </a:ln>
+          <a:effectLst/>
+        </p:spPr>
+        <p:style>
+          <a:lnRef idx="1">
+            <a:schemeClr val="accent1"/>
+          </a:lnRef>
+          <a:fillRef idx="3">
+            <a:schemeClr val="accent1"/>
+          </a:fillRef>
+          <a:effectRef idx="2">
+            <a:schemeClr val="accent1"/>
+          </a:effectRef>
+          <a:fontRef idx="minor">
+            <a:schemeClr val="lt1"/>
+          </a:fontRef>
+        </p:style>
+        <p:txBody>
+          <a:bodyPr rtlCol="0" anchor="ctr"/>
+          <a:lstStyle/>
+          <a:p/>
+        </p:txBody>
+      </p:sp>
+      <p:sp>
+        <p:nvSpPr>
+          <p:cNvPr id="18" name="Text 17"/>
+          <p:cNvSpPr txBox="1"/>
+          <p:nvPr/>
+        </p:nvSpPr>
+        <p:spPr>
+          <a:xfrm>
+            <a:off x="3350971" y="1719072"/>
+            <a:ext cx="648004" cy="274320"/>
+          </a:xfrm>
+          <a:prstGeom prst="rect">
+            <a:avLst/>
+          </a:prstGeom>
+          <a:noFill/>
+        </p:spPr>
+        <p:txBody>
+          <a:bodyPr wrap="square" lIns="0" rIns="0" tIns="0" bIns="0" anchor="ctr">
+            <a:spAutoFit/>
+          </a:bodyPr>
+          <a:lstStyle/>
+          <a:p>
+            <a:pPr algn="ctr"/>
+            <a:r>
+              <a:rPr sz="640" b="1" i="0">
+                <a:solidFill>
+                  <a:srgbClr val="B3B3B3"/>
+                </a:solidFill>
+                <a:latin typeface="Trenda IG Text"/>
+              </a:rPr>
+              <a:t>QA</a:t>
+            </a:r>
+          </a:p>
+        </p:txBody>
+      </p:sp>
+      <p:sp>
+        <p:nvSpPr>
+          <p:cNvPr id="19" name="Text 18"/>
+          <p:cNvSpPr txBox="1"/>
+          <p:nvPr/>
+        </p:nvSpPr>
+        <p:spPr>
+          <a:xfrm>
+            <a:off x="539496" y="2084832"/>
+            <a:ext cx="1371600" cy="164592"/>
+          </a:xfrm>
+          <a:prstGeom prst="rect">
+            <a:avLst/>
+          </a:prstGeom>
+          <a:noFill/>
+        </p:spPr>
+        <p:txBody>
+          <a:bodyPr wrap="square" lIns="0" rIns="0" tIns="0" bIns="0" anchor="ctr">
+            <a:spAutoFit/>
+          </a:bodyPr>
+          <a:lstStyle/>
+          <a:p>
+            <a:r>
+              <a:rPr sz="540" b="1" i="0" spc="100">
+                <a:solidFill>
+                  <a:srgbClr val="00D6F2"/>
+                </a:solidFill>
+                <a:latin typeface="Trenda IG Text"/>
+              </a:rPr>
+              <a:t>WITH THE HARNESS</a:t>
+            </a:r>
+          </a:p>
+        </p:txBody>
+      </p:sp>
+      <p:sp>
+        <p:nvSpPr>
+          <p:cNvPr id="20" name="Shape 19"/>
+          <p:cNvSpPr/>
+          <p:nvPr/>
+        </p:nvSpPr>
+        <p:spPr>
+          <a:xfrm>
+            <a:off x="539496" y="2267712"/>
+            <a:ext cx="1116584" cy="274320"/>
+          </a:xfrm>
+          <a:prstGeom prst="roundRect">
+            <a:avLst>
+              <a:gd name="adj" fmla="val 25000"/>
+            </a:avLst>
+          </a:prstGeom>
+          <a:solidFill>
+            <a:srgbClr val="141414"/>
+          </a:solidFill>
+          <a:ln w="9525">
+            <a:solidFill>
+              <a:srgbClr val="00D6F2"/>
+            </a:solidFill>
+          </a:ln>
+          <a:effectLst/>
+        </p:spPr>
+        <p:style>
+          <a:lnRef idx="1">
+            <a:schemeClr val="accent1"/>
+          </a:lnRef>
+          <a:fillRef idx="3">
+            <a:schemeClr val="accent1"/>
+          </a:fillRef>
+          <a:effectRef idx="2">
+            <a:schemeClr val="accent1"/>
+          </a:effectRef>
+          <a:fontRef idx="minor">
+            <a:schemeClr val="lt1"/>
+          </a:fontRef>
+        </p:style>
+        <p:txBody>
+          <a:bodyPr rtlCol="0" anchor="ctr"/>
+          <a:lstStyle/>
+          <a:p/>
+        </p:txBody>
+      </p:sp>
+      <p:sp>
+        <p:nvSpPr>
+          <p:cNvPr id="21" name="Text 20"/>
+          <p:cNvSpPr txBox="1"/>
+          <p:nvPr/>
+        </p:nvSpPr>
+        <p:spPr>
+          <a:xfrm>
+            <a:off x="539496" y="2267712"/>
+            <a:ext cx="1116584" cy="274320"/>
+          </a:xfrm>
+          <a:prstGeom prst="rect">
+            <a:avLst/>
+          </a:prstGeom>
+          <a:noFill/>
+        </p:spPr>
+        <p:txBody>
+          <a:bodyPr wrap="square" lIns="0" rIns="0" tIns="0" bIns="0" anchor="ctr">
+            <a:spAutoFit/>
+          </a:bodyPr>
+          <a:lstStyle/>
+          <a:p>
+            <a:pPr algn="ctr"/>
+            <a:r>
+              <a:rPr sz="640" b="1" i="0">
+                <a:solidFill>
+                  <a:srgbClr val="F2F2F2"/>
+                </a:solidFill>
+                <a:latin typeface="Trenda IG Text"/>
+              </a:rPr>
+              <a:t>Developer</a:t>
+            </a:r>
+          </a:p>
+        </p:txBody>
+      </p:sp>
+      <p:sp>
+        <p:nvSpPr>
+          <p:cNvPr id="22" name="Shape 21"/>
+          <p:cNvSpPr/>
+          <p:nvPr/>
+        </p:nvSpPr>
+        <p:spPr>
+          <a:xfrm>
+            <a:off x="1710944" y="2267712"/>
+            <a:ext cx="1116584" cy="274320"/>
+          </a:xfrm>
+          <a:prstGeom prst="roundRect">
+            <a:avLst>
+              <a:gd name="adj" fmla="val 25000"/>
+            </a:avLst>
+          </a:prstGeom>
+          <a:solidFill>
+            <a:srgbClr val="06262B"/>
+          </a:solidFill>
+          <a:ln w="9525">
+            <a:solidFill>
+              <a:srgbClr val="00D6F2"/>
+            </a:solidFill>
+          </a:ln>
+          <a:effectLst/>
+        </p:spPr>
+        <p:style>
+          <a:lnRef idx="1">
+            <a:schemeClr val="accent1"/>
+          </a:lnRef>
+          <a:fillRef idx="3">
+            <a:schemeClr val="accent1"/>
+          </a:fillRef>
+          <a:effectRef idx="2">
+            <a:schemeClr val="accent1"/>
+          </a:effectRef>
+          <a:fontRef idx="minor">
+            <a:schemeClr val="lt1"/>
+          </a:fontRef>
+        </p:style>
+        <p:txBody>
+          <a:bodyPr rtlCol="0" anchor="ctr"/>
+          <a:lstStyle/>
+          <a:p/>
+        </p:txBody>
+      </p:sp>
+      <p:pic>
+        <p:nvPicPr>
+          <p:cNvPr id="23" name="Picture 22" descr="harness.png"/>
+          <p:cNvPicPr>
+            <a:picLocks noChangeAspect="1"/>
+          </p:cNvPicPr>
+          <p:nvPr/>
+        </p:nvPicPr>
+        <p:blipFill>
+          <a:blip r:embed="rId2"/>
+          <a:stretch>
+            <a:fillRect/>
+          </a:stretch>
+        </p:blipFill>
+        <p:spPr>
+          <a:xfrm>
+            <a:off x="1784096" y="2322576"/>
+            <a:ext cx="164592" cy="164592"/>
+          </a:xfrm>
+          <a:prstGeom prst="rect">
+            <a:avLst/>
+          </a:prstGeom>
+        </p:spPr>
+      </p:pic>
+      <p:sp>
+        <p:nvSpPr>
+          <p:cNvPr id="24" name="Text 22"/>
+          <p:cNvSpPr txBox="1"/>
+          <p:nvPr/>
+        </p:nvSpPr>
+        <p:spPr>
+          <a:xfrm>
+            <a:off x="1930400" y="2267712"/>
+            <a:ext cx="860551" cy="274320"/>
+          </a:xfrm>
+          <a:prstGeom prst="rect">
+            <a:avLst/>
+          </a:prstGeom>
+          <a:noFill/>
+        </p:spPr>
+        <p:txBody>
+          <a:bodyPr wrap="square" lIns="0" rIns="0" tIns="0" bIns="0" anchor="ctr">
+            <a:spAutoFit/>
+          </a:bodyPr>
+          <a:lstStyle/>
+          <a:p>
+            <a:pPr algn="ctr"/>
+            <a:r>
+              <a:rPr sz="600" b="1" i="0">
+                <a:solidFill>
+                  <a:srgbClr val="00D6F2"/>
+                </a:solidFill>
+                <a:latin typeface="Trenda IG Text"/>
+              </a:rPr>
+              <a:t>Harness agent</a:t>
+            </a:r>
+          </a:p>
+        </p:txBody>
+      </p:sp>
+      <p:sp>
+        <p:nvSpPr>
+          <p:cNvPr id="25" name="Shape 23"/>
+          <p:cNvSpPr/>
+          <p:nvPr/>
+        </p:nvSpPr>
+        <p:spPr>
+          <a:xfrm>
+            <a:off x="2882392" y="2267712"/>
+            <a:ext cx="1116584" cy="274320"/>
+          </a:xfrm>
+          <a:prstGeom prst="roundRect">
+            <a:avLst>
+              <a:gd name="adj" fmla="val 25000"/>
+            </a:avLst>
+          </a:prstGeom>
+          <a:solidFill>
+            <a:srgbClr val="141414"/>
+          </a:solidFill>
+          <a:ln w="9525">
+            <a:solidFill>
+              <a:srgbClr val="00D6F2"/>
+            </a:solidFill>
+          </a:ln>
+          <a:effectLst/>
+        </p:spPr>
+        <p:style>
+          <a:lnRef idx="1">
+            <a:schemeClr val="accent1"/>
+          </a:lnRef>
+          <a:fillRef idx="3">
+            <a:schemeClr val="accent1"/>
+          </a:fillRef>
+          <a:effectRef idx="2">
+            <a:schemeClr val="accent1"/>
+          </a:effectRef>
+          <a:fontRef idx="minor">
+            <a:schemeClr val="lt1"/>
+          </a:fontRef>
+        </p:style>
+        <p:txBody>
+          <a:bodyPr rtlCol="0" anchor="ctr"/>
+          <a:lstStyle/>
+          <a:p/>
+        </p:txBody>
+      </p:sp>
+      <p:sp>
+        <p:nvSpPr>
+          <p:cNvPr id="26" name="Text 24"/>
+          <p:cNvSpPr txBox="1"/>
+          <p:nvPr/>
+        </p:nvSpPr>
+        <p:spPr>
+          <a:xfrm>
+            <a:off x="2882392" y="2267712"/>
+            <a:ext cx="1116584" cy="274320"/>
+          </a:xfrm>
+          <a:prstGeom prst="rect">
+            <a:avLst/>
+          </a:prstGeom>
+          <a:noFill/>
+        </p:spPr>
+        <p:txBody>
+          <a:bodyPr wrap="square" lIns="0" rIns="0" tIns="0" bIns="0" anchor="ctr">
+            <a:spAutoFit/>
+          </a:bodyPr>
+          <a:lstStyle/>
+          <a:p>
+            <a:pPr algn="ctr"/>
+            <a:r>
+              <a:rPr sz="640" b="1" i="0">
+                <a:solidFill>
+                  <a:srgbClr val="F2F2F2"/>
+                </a:solidFill>
+                <a:latin typeface="Trenda IG Text"/>
+              </a:rPr>
+              <a:t>QA</a:t>
+            </a:r>
+          </a:p>
+        </p:txBody>
+      </p:sp>
+      <p:sp>
+        <p:nvSpPr>
+          <p:cNvPr id="27" name="Text 25"/>
+          <p:cNvSpPr txBox="1"/>
+          <p:nvPr/>
+        </p:nvSpPr>
+        <p:spPr>
+          <a:xfrm>
+            <a:off x="539496" y="2615184"/>
+            <a:ext cx="3459480" cy="384048"/>
+          </a:xfrm>
+          <a:prstGeom prst="rect">
+            <a:avLst/>
+          </a:prstGeom>
+          <a:noFill/>
+        </p:spPr>
+        <p:txBody>
+          <a:bodyPr wrap="square" lIns="0" rIns="0" tIns="0" bIns="0" anchor="t">
+            <a:spAutoFit/>
+          </a:bodyPr>
+          <a:lstStyle/>
+          <a:p>
+            <a:r>
+              <a:rPr sz="600" b="1" i="0">
+                <a:solidFill>
+                  <a:srgbClr val="00D6F2"/>
+                </a:solidFill>
+                <a:latin typeface="Trenda IG Text"/>
+              </a:rPr>
+              <a:t>Agent </a:t>
+            </a:r>
+            <a:r>
+              <a:rPr sz="600" b="0" i="0">
+                <a:solidFill>
+                  <a:srgbClr val="B3B3B3"/>
+                </a:solidFill>
+                <a:latin typeface="Trenda IG Text"/>
+              </a:rPr>
+              <a:t>drafts code, tests and the Copado package overnight. </a:t>
+            </a:r>
+            <a:r>
+              <a:rPr sz="600" b="1" i="0">
+                <a:solidFill>
+                  <a:srgbClr val="F2F2F2"/>
+                </a:solidFill>
+                <a:latin typeface="Trenda IG Text"/>
+              </a:rPr>
+              <a:t>Developer </a:t>
+            </a:r>
+            <a:r>
+              <a:rPr sz="600" b="0" i="0">
+                <a:solidFill>
+                  <a:srgbClr val="B3B3B3"/>
+                </a:solidFill>
+                <a:latin typeface="Trenda IG Text"/>
+              </a:rPr>
+              <a:t>directs and approves. </a:t>
+            </a:r>
+            <a:r>
+              <a:rPr sz="600" b="1" i="0">
+                <a:solidFill>
+                  <a:srgbClr val="F2F2F2"/>
+                </a:solidFill>
+                <a:latin typeface="Trenda IG Text"/>
+              </a:rPr>
+              <a:t>QA </a:t>
+            </a:r>
+            <a:r>
+              <a:rPr sz="600" b="0" i="0">
+                <a:solidFill>
+                  <a:srgbClr val="B3B3B3"/>
+                </a:solidFill>
+                <a:latin typeface="Trenda IG Text"/>
+              </a:rPr>
+              <a:t>signs off.</a:t>
+            </a:r>
+          </a:p>
+        </p:txBody>
+      </p:sp>
+      <p:sp>
+        <p:nvSpPr>
+          <p:cNvPr id="28" name="Shape 26"/>
+          <p:cNvSpPr/>
+          <p:nvPr/>
+        </p:nvSpPr>
+        <p:spPr>
+          <a:xfrm>
+            <a:off x="4236720" y="1188720"/>
+            <a:ext cx="3715512" cy="1965960"/>
+          </a:xfrm>
+          <a:prstGeom prst="roundRect">
+            <a:avLst>
+              <a:gd name="adj" fmla="val 2000"/>
+            </a:avLst>
+          </a:prstGeom>
+          <a:solidFill>
+            <a:srgbClr val="1E1E1E"/>
+          </a:solidFill>
+          <a:ln>
+            <a:noFill/>
+          </a:ln>
+          <a:effectLst/>
+        </p:spPr>
+        <p:style>
+          <a:lnRef idx="1">
+            <a:schemeClr val="accent1"/>
+          </a:lnRef>
+          <a:fillRef idx="3">
+            <a:schemeClr val="accent1"/>
+          </a:fillRef>
+          <a:effectRef idx="2">
+            <a:schemeClr val="accent1"/>
+          </a:effectRef>
+          <a:fontRef idx="minor">
+            <a:schemeClr val="lt1"/>
+          </a:fontRef>
+        </p:style>
+        <p:txBody>
+          <a:bodyPr rtlCol="0" anchor="ctr"/>
+          <a:lstStyle/>
+          <a:p/>
+        </p:txBody>
+      </p:sp>
+      <p:sp>
+        <p:nvSpPr>
+          <p:cNvPr id="29" name="Shape 27"/>
+          <p:cNvSpPr/>
+          <p:nvPr/>
+        </p:nvSpPr>
+        <p:spPr>
+          <a:xfrm>
+            <a:off x="4236720" y="1188720"/>
+            <a:ext cx="3715512" cy="256032"/>
+          </a:xfrm>
+          <a:prstGeom prst="rect">
+            <a:avLst/>
+          </a:prstGeom>
+          <a:solidFill>
+            <a:srgbClr val="2B2B2B"/>
+          </a:solidFill>
+          <a:ln>
+            <a:noFill/>
+          </a:ln>
+          <a:effectLst/>
+        </p:spPr>
+        <p:style>
+          <a:lnRef idx="1">
+            <a:schemeClr val="accent1"/>
+          </a:lnRef>
+          <a:fillRef idx="3">
+            <a:schemeClr val="accent1"/>
+          </a:fillRef>
+          <a:effectRef idx="2">
+            <a:schemeClr val="accent1"/>
+          </a:effectRef>
+          <a:fontRef idx="minor">
+            <a:schemeClr val="lt1"/>
+          </a:fontRef>
+        </p:style>
+        <p:txBody>
+          <a:bodyPr rtlCol="0" anchor="ctr"/>
+          <a:lstStyle/>
+          <a:p/>
+        </p:txBody>
+      </p:sp>
+      <p:sp>
+        <p:nvSpPr>
+          <p:cNvPr id="30" name="Text 28"/>
+          <p:cNvSpPr txBox="1"/>
+          <p:nvPr/>
+        </p:nvSpPr>
+        <p:spPr>
+          <a:xfrm>
+            <a:off x="4346448" y="1188720"/>
+            <a:ext cx="3496056" cy="256032"/>
+          </a:xfrm>
+          <a:prstGeom prst="rect">
+            <a:avLst/>
+          </a:prstGeom>
+          <a:noFill/>
+        </p:spPr>
+        <p:txBody>
+          <a:bodyPr wrap="square" lIns="0" rIns="0" tIns="0" bIns="0" anchor="ctr">
+            <a:spAutoFit/>
+          </a:bodyPr>
+          <a:lstStyle/>
+          <a:p>
+            <a:r>
+              <a:rPr sz="640" b="1" i="0" spc="120">
+                <a:solidFill>
+                  <a:srgbClr val="F2F2F2"/>
+                </a:solidFill>
+                <a:latin typeface="Trenda IG Text"/>
+              </a:rPr>
+              <a:t>THE POD</a:t>
+            </a:r>
+            <a:r>
+              <a:rPr sz="640" b="0" i="0">
+                <a:solidFill>
+                  <a:srgbClr val="B3B3B3"/>
+                </a:solidFill>
+                <a:latin typeface="Trenda IG Text"/>
+              </a:rPr>
+              <a:t>   lean pods share one platform</a:t>
+            </a:r>
+          </a:p>
+        </p:txBody>
+      </p:sp>
+      <p:sp>
+        <p:nvSpPr>
+          <p:cNvPr id="31" name="Text 29"/>
+          <p:cNvSpPr txBox="1"/>
+          <p:nvPr/>
+        </p:nvSpPr>
+        <p:spPr>
+          <a:xfrm>
+            <a:off x="4364736" y="1536192"/>
+            <a:ext cx="1828800" cy="164592"/>
+          </a:xfrm>
+          <a:prstGeom prst="rect">
+            <a:avLst/>
+          </a:prstGeom>
+          <a:noFill/>
+        </p:spPr>
+        <p:txBody>
+          <a:bodyPr wrap="square" lIns="0" rIns="0" tIns="0" bIns="0" anchor="ctr">
+            <a:spAutoFit/>
+          </a:bodyPr>
+          <a:lstStyle/>
+          <a:p>
+            <a:r>
+              <a:rPr sz="540" b="1" i="0" spc="100">
+                <a:solidFill>
+                  <a:srgbClr val="8C8C8C"/>
+                </a:solidFill>
+                <a:latin typeface="Trenda IG Text"/>
+              </a:rPr>
+              <a:t>TODAY · EVERY POD, FULL STACK</a:t>
+            </a:r>
+          </a:p>
+        </p:txBody>
+      </p:sp>
+      <p:sp>
+        <p:nvSpPr>
+          <p:cNvPr id="32" name="Shape 30"/>
+          <p:cNvSpPr/>
+          <p:nvPr/>
+        </p:nvSpPr>
+        <p:spPr>
+          <a:xfrm>
+            <a:off x="4364736" y="1719072"/>
+            <a:ext cx="3459480" cy="274320"/>
+          </a:xfrm>
+          <a:prstGeom prst="roundRect">
+            <a:avLst>
+              <a:gd name="adj" fmla="val 25000"/>
+            </a:avLst>
+          </a:prstGeom>
+          <a:solidFill>
+            <a:srgbClr val="141414"/>
+          </a:solidFill>
+          <a:ln w="9525">
+            <a:solidFill>
+              <a:srgbClr val="333333"/>
+            </a:solidFill>
+          </a:ln>
+          <a:effectLst/>
+        </p:spPr>
+        <p:style>
+          <a:lnRef idx="1">
+            <a:schemeClr val="accent1"/>
+          </a:lnRef>
+          <a:fillRef idx="3">
+            <a:schemeClr val="accent1"/>
+          </a:fillRef>
+          <a:effectRef idx="2">
+            <a:schemeClr val="accent1"/>
+          </a:effectRef>
+          <a:fontRef idx="minor">
+            <a:schemeClr val="lt1"/>
+          </a:fontRef>
+        </p:style>
+        <p:txBody>
+          <a:bodyPr rtlCol="0" anchor="ctr"/>
+          <a:lstStyle/>
+          <a:p/>
+        </p:txBody>
+      </p:sp>
+      <p:sp>
+        <p:nvSpPr>
+          <p:cNvPr id="33" name="Text 31"/>
+          <p:cNvSpPr txBox="1"/>
+          <p:nvPr/>
+        </p:nvSpPr>
+        <p:spPr>
+          <a:xfrm>
+            <a:off x="4364736" y="1719072"/>
+            <a:ext cx="3459480" cy="274320"/>
+          </a:xfrm>
+          <a:prstGeom prst="rect">
+            <a:avLst/>
+          </a:prstGeom>
+          <a:noFill/>
+        </p:spPr>
+        <p:txBody>
+          <a:bodyPr wrap="square" lIns="0" rIns="0" tIns="0" bIns="0" anchor="ctr">
+            <a:spAutoFit/>
+          </a:bodyPr>
+          <a:lstStyle/>
+          <a:p>
+            <a:pPr algn="ctr"/>
+            <a:r>
+              <a:rPr sz="620" b="1" i="0">
+                <a:solidFill>
+                  <a:srgbClr val="B3B3B3"/>
+                </a:solidFill>
+                <a:latin typeface="Trenda IG Text"/>
+              </a:rPr>
+              <a:t>BA · Devs · QA · Release · Support</a:t>
+            </a:r>
+          </a:p>
+        </p:txBody>
+      </p:sp>
+      <p:sp>
+        <p:nvSpPr>
+          <p:cNvPr id="34" name="Text 32"/>
+          <p:cNvSpPr txBox="1"/>
+          <p:nvPr/>
+        </p:nvSpPr>
+        <p:spPr>
+          <a:xfrm>
+            <a:off x="4364736" y="2084832"/>
+            <a:ext cx="2194560" cy="164592"/>
+          </a:xfrm>
+          <a:prstGeom prst="rect">
+            <a:avLst/>
+          </a:prstGeom>
+          <a:noFill/>
+        </p:spPr>
+        <p:txBody>
+          <a:bodyPr wrap="square" lIns="0" rIns="0" tIns="0" bIns="0" anchor="ctr">
+            <a:spAutoFit/>
+          </a:bodyPr>
+          <a:lstStyle/>
+          <a:p>
+            <a:r>
+              <a:rPr sz="540" b="1" i="0" spc="100">
+                <a:solidFill>
+                  <a:srgbClr val="00D6F2"/>
+                </a:solidFill>
+                <a:latin typeface="Trenda IG Text"/>
+              </a:rPr>
+              <a:t>WITH THE HARNESS</a:t>
+            </a:r>
+          </a:p>
+        </p:txBody>
+      </p:sp>
+      <p:sp>
+        <p:nvSpPr>
+          <p:cNvPr id="35" name="Shape 33"/>
+          <p:cNvSpPr/>
+          <p:nvPr/>
+        </p:nvSpPr>
+        <p:spPr>
+          <a:xfrm>
+            <a:off x="4364736" y="2267712"/>
+            <a:ext cx="1872538" cy="274320"/>
+          </a:xfrm>
+          <a:prstGeom prst="roundRect">
+            <a:avLst>
+              <a:gd name="adj" fmla="val 25000"/>
+            </a:avLst>
+          </a:prstGeom>
+          <a:solidFill>
+            <a:srgbClr val="141414"/>
+          </a:solidFill>
+          <a:ln w="9525">
+            <a:solidFill>
+              <a:srgbClr val="00D6F2"/>
+            </a:solidFill>
+          </a:ln>
+          <a:effectLst/>
+        </p:spPr>
+        <p:style>
+          <a:lnRef idx="1">
+            <a:schemeClr val="accent1"/>
+          </a:lnRef>
+          <a:fillRef idx="3">
+            <a:schemeClr val="accent1"/>
+          </a:fillRef>
+          <a:effectRef idx="2">
+            <a:schemeClr val="accent1"/>
+          </a:effectRef>
+          <a:fontRef idx="minor">
+            <a:schemeClr val="lt1"/>
+          </a:fontRef>
+        </p:style>
+        <p:txBody>
+          <a:bodyPr rtlCol="0" anchor="ctr"/>
+          <a:lstStyle/>
+          <a:p/>
+        </p:txBody>
+      </p:sp>
+      <p:sp>
+        <p:nvSpPr>
+          <p:cNvPr id="36" name="Text 34"/>
+          <p:cNvSpPr txBox="1"/>
+          <p:nvPr/>
+        </p:nvSpPr>
+        <p:spPr>
+          <a:xfrm>
+            <a:off x="4364736" y="2267712"/>
+            <a:ext cx="1872538" cy="274320"/>
+          </a:xfrm>
+          <a:prstGeom prst="rect">
+            <a:avLst/>
+          </a:prstGeom>
+          <a:noFill/>
+        </p:spPr>
+        <p:txBody>
+          <a:bodyPr wrap="square" lIns="0" rIns="0" tIns="0" bIns="0" anchor="ctr">
+            <a:spAutoFit/>
+          </a:bodyPr>
+          <a:lstStyle/>
+          <a:p>
+            <a:pPr algn="ctr"/>
+            <a:r>
+              <a:rPr sz="600" b="1" i="0">
+                <a:solidFill>
+                  <a:srgbClr val="F2F2F2"/>
+                </a:solidFill>
+                <a:latin typeface="Trenda IG Text"/>
+              </a:rPr>
+              <a:t>Owner · Lead · 2-4 engineers</a:t>
+            </a:r>
+          </a:p>
+        </p:txBody>
+      </p:sp>
+      <p:sp>
+        <p:nvSpPr>
+          <p:cNvPr id="37" name="Shape 35"/>
+          <p:cNvSpPr/>
+          <p:nvPr/>
+        </p:nvSpPr>
+        <p:spPr>
+          <a:xfrm>
+            <a:off x="6292138" y="2267712"/>
+            <a:ext cx="1532077" cy="274320"/>
+          </a:xfrm>
+          <a:prstGeom prst="roundRect">
+            <a:avLst>
+              <a:gd name="adj" fmla="val 25000"/>
+            </a:avLst>
+          </a:prstGeom>
+          <a:solidFill>
+            <a:srgbClr val="06262B"/>
+          </a:solidFill>
+          <a:ln w="9525">
+            <a:solidFill>
+              <a:srgbClr val="00D6F2"/>
+            </a:solidFill>
+          </a:ln>
+          <a:effectLst/>
+        </p:spPr>
+        <p:style>
+          <a:lnRef idx="1">
+            <a:schemeClr val="accent1"/>
+          </a:lnRef>
+          <a:fillRef idx="3">
+            <a:schemeClr val="accent1"/>
+          </a:fillRef>
+          <a:effectRef idx="2">
+            <a:schemeClr val="accent1"/>
+          </a:effectRef>
+          <a:fontRef idx="minor">
+            <a:schemeClr val="lt1"/>
+          </a:fontRef>
+        </p:style>
+        <p:txBody>
+          <a:bodyPr rtlCol="0" anchor="ctr"/>
+          <a:lstStyle/>
+          <a:p/>
+        </p:txBody>
+      </p:sp>
+      <p:sp>
+        <p:nvSpPr>
+          <p:cNvPr id="38" name="Text 36"/>
+          <p:cNvSpPr txBox="1"/>
+          <p:nvPr/>
+        </p:nvSpPr>
+        <p:spPr>
+          <a:xfrm>
+            <a:off x="6292138" y="2267712"/>
+            <a:ext cx="1532077" cy="274320"/>
+          </a:xfrm>
+          <a:prstGeom prst="rect">
+            <a:avLst/>
+          </a:prstGeom>
+          <a:noFill/>
+        </p:spPr>
+        <p:txBody>
+          <a:bodyPr wrap="square" lIns="0" rIns="0" tIns="0" bIns="0" anchor="ctr">
+            <a:spAutoFit/>
+          </a:bodyPr>
+          <a:lstStyle/>
+          <a:p>
+            <a:pPr algn="ctr"/>
+            <a:r>
+              <a:rPr sz="600" b="1" i="0">
+                <a:solidFill>
+                  <a:srgbClr val="00D6F2"/>
+                </a:solidFill>
+                <a:latin typeface="Trenda IG Text"/>
+              </a:rPr>
+              <a:t>Shared platform</a:t>
+            </a:r>
+          </a:p>
+        </p:txBody>
+      </p:sp>
+      <p:sp>
+        <p:nvSpPr>
+          <p:cNvPr id="39" name="Text 37"/>
+          <p:cNvSpPr txBox="1"/>
+          <p:nvPr/>
+        </p:nvSpPr>
+        <p:spPr>
+          <a:xfrm>
+            <a:off x="4364736" y="2615184"/>
+            <a:ext cx="1702308" cy="384048"/>
+          </a:xfrm>
+          <a:prstGeom prst="rect">
+            <a:avLst/>
+          </a:prstGeom>
+          <a:noFill/>
+        </p:spPr>
+        <p:txBody>
+          <a:bodyPr wrap="square" lIns="0" rIns="0" tIns="0" bIns="0" anchor="ctr">
+            <a:spAutoFit/>
+          </a:bodyPr>
+          <a:lstStyle/>
+          <a:p>
+            <a:r>
+              <a:rPr sz="1200" b="0" i="0">
+                <a:solidFill>
+                  <a:srgbClr val="00D6F2"/>
+                </a:solidFill>
+                <a:latin typeface="Trenda IG Text"/>
+              </a:rPr>
+              <a:t>20-30%</a:t>
+            </a:r>
+          </a:p>
+          <a:p>
+            <a:r>
+              <a:rPr sz="600" b="0" i="0">
+                <a:solidFill>
+                  <a:srgbClr val="B3B3B3"/>
+                </a:solidFill>
+                <a:latin typeface="Trenda IG Text"/>
+              </a:rPr>
+              <a:t>smaller team, same scope</a:t>
+            </a:r>
+          </a:p>
+        </p:txBody>
+      </p:sp>
+      <p:sp>
+        <p:nvSpPr>
+          <p:cNvPr id="40" name="Text 38"/>
+          <p:cNvSpPr txBox="1"/>
+          <p:nvPr/>
+        </p:nvSpPr>
+        <p:spPr>
+          <a:xfrm>
+            <a:off x="6121908" y="2615184"/>
+            <a:ext cx="1702308" cy="384048"/>
+          </a:xfrm>
+          <a:prstGeom prst="rect">
+            <a:avLst/>
+          </a:prstGeom>
+          <a:noFill/>
+        </p:spPr>
+        <p:txBody>
+          <a:bodyPr wrap="square" lIns="0" rIns="0" tIns="0" bIns="0" anchor="ctr">
+            <a:spAutoFit/>
+          </a:bodyPr>
+          <a:lstStyle/>
+          <a:p>
+            <a:r>
+              <a:rPr sz="1200" b="0" i="0">
+                <a:solidFill>
+                  <a:srgbClr val="00D6F2"/>
+                </a:solidFill>
+                <a:latin typeface="Trenda IG Text"/>
+              </a:rPr>
+              <a:t>1.4-1.6x</a:t>
+            </a:r>
+          </a:p>
+          <a:p>
+            <a:r>
+              <a:rPr sz="600" b="0" i="0">
+                <a:solidFill>
+                  <a:srgbClr val="B3B3B3"/>
+                </a:solidFill>
+                <a:latin typeface="Trenda IG Text"/>
+              </a:rPr>
+              <a:t>output, same team</a:t>
+            </a:r>
+          </a:p>
+        </p:txBody>
+      </p:sp>
+      <p:sp>
+        <p:nvSpPr>
+          <p:cNvPr id="41" name="Shape 39"/>
+          <p:cNvSpPr/>
+          <p:nvPr/>
+        </p:nvSpPr>
+        <p:spPr>
+          <a:xfrm>
+            <a:off x="8061960" y="1188720"/>
+            <a:ext cx="3715512" cy="1965960"/>
+          </a:xfrm>
+          <a:prstGeom prst="roundRect">
+            <a:avLst>
+              <a:gd name="adj" fmla="val 2000"/>
+            </a:avLst>
+          </a:prstGeom>
+          <a:solidFill>
+            <a:srgbClr val="1E1E1E"/>
+          </a:solidFill>
+          <a:ln>
+            <a:noFill/>
+          </a:ln>
+          <a:effectLst/>
+        </p:spPr>
+        <p:style>
+          <a:lnRef idx="1">
+            <a:schemeClr val="accent1"/>
+          </a:lnRef>
+          <a:fillRef idx="3">
+            <a:schemeClr val="accent1"/>
+          </a:fillRef>
+          <a:effectRef idx="2">
+            <a:schemeClr val="accent1"/>
+          </a:effectRef>
+          <a:fontRef idx="minor">
+            <a:schemeClr val="lt1"/>
+          </a:fontRef>
+        </p:style>
+        <p:txBody>
+          <a:bodyPr rtlCol="0" anchor="ctr"/>
+          <a:lstStyle/>
+          <a:p/>
+        </p:txBody>
+      </p:sp>
+      <p:sp>
+        <p:nvSpPr>
+          <p:cNvPr id="42" name="Shape 40"/>
+          <p:cNvSpPr/>
+          <p:nvPr/>
+        </p:nvSpPr>
+        <p:spPr>
+          <a:xfrm>
+            <a:off x="8061960" y="1188720"/>
+            <a:ext cx="3715512" cy="256032"/>
+          </a:xfrm>
+          <a:prstGeom prst="rect">
+            <a:avLst/>
+          </a:prstGeom>
+          <a:solidFill>
+            <a:srgbClr val="2B2B2B"/>
+          </a:solidFill>
+          <a:ln>
+            <a:noFill/>
+          </a:ln>
+          <a:effectLst/>
+        </p:spPr>
+        <p:style>
+          <a:lnRef idx="1">
+            <a:schemeClr val="accent1"/>
+          </a:lnRef>
+          <a:fillRef idx="3">
+            <a:schemeClr val="accent1"/>
+          </a:fillRef>
+          <a:effectRef idx="2">
+            <a:schemeClr val="accent1"/>
+          </a:effectRef>
+          <a:fontRef idx="minor">
+            <a:schemeClr val="lt1"/>
+          </a:fontRef>
+        </p:style>
+        <p:txBody>
+          <a:bodyPr rtlCol="0" anchor="ctr"/>
+          <a:lstStyle/>
+          <a:p/>
+        </p:txBody>
+      </p:sp>
+      <p:sp>
+        <p:nvSpPr>
+          <p:cNvPr id="43" name="Text 41"/>
+          <p:cNvSpPr txBox="1"/>
+          <p:nvPr/>
+        </p:nvSpPr>
+        <p:spPr>
+          <a:xfrm>
+            <a:off x="8171687" y="1188720"/>
+            <a:ext cx="3496056" cy="256032"/>
+          </a:xfrm>
+          <a:prstGeom prst="rect">
+            <a:avLst/>
+          </a:prstGeom>
+          <a:noFill/>
+        </p:spPr>
+        <p:txBody>
+          <a:bodyPr wrap="square" lIns="0" rIns="0" tIns="0" bIns="0" anchor="ctr">
+            <a:spAutoFit/>
+          </a:bodyPr>
+          <a:lstStyle/>
+          <a:p>
+            <a:r>
+              <a:rPr sz="640" b="1" i="0" spc="120">
+                <a:solidFill>
+                  <a:srgbClr val="F2F2F2"/>
+                </a:solidFill>
+                <a:latin typeface="Trenda IG Text"/>
+              </a:rPr>
+              <a:t>THE BUILD AND RUN</a:t>
+            </a:r>
+            <a:r>
+              <a:rPr sz="640" b="0" i="0">
+                <a:solidFill>
+                  <a:srgbClr val="B3B3B3"/>
+                </a:solidFill>
+                <a:latin typeface="Trenda IG Text"/>
+              </a:rPr>
+              <a:t>   fixed fee, paid by gate</a:t>
+            </a:r>
+          </a:p>
+        </p:txBody>
+      </p:sp>
+      <p:sp>
+        <p:nvSpPr>
+          <p:cNvPr id="44" name="Shape 42"/>
+          <p:cNvSpPr/>
+          <p:nvPr/>
+        </p:nvSpPr>
+        <p:spPr>
+          <a:xfrm>
+            <a:off x="8189976" y="1554480"/>
+            <a:ext cx="1104391" cy="896112"/>
+          </a:xfrm>
+          <a:prstGeom prst="rect">
+            <a:avLst/>
+          </a:prstGeom>
+          <a:solidFill>
+            <a:srgbClr val="141414"/>
+          </a:solidFill>
+          <a:ln>
+            <a:noFill/>
+          </a:ln>
+          <a:effectLst/>
+        </p:spPr>
+        <p:style>
+          <a:lnRef idx="1">
+            <a:schemeClr val="accent1"/>
+          </a:lnRef>
+          <a:fillRef idx="3">
+            <a:schemeClr val="accent1"/>
+          </a:fillRef>
+          <a:effectRef idx="2">
+            <a:schemeClr val="accent1"/>
+          </a:effectRef>
+          <a:fontRef idx="minor">
+            <a:schemeClr val="lt1"/>
+          </a:fontRef>
+        </p:style>
+        <p:txBody>
+          <a:bodyPr rtlCol="0" anchor="ctr"/>
+          <a:lstStyle/>
+          <a:p/>
+        </p:txBody>
+      </p:sp>
+      <p:sp>
+        <p:nvSpPr>
+          <p:cNvPr id="45" name="Text 43"/>
+          <p:cNvSpPr txBox="1"/>
+          <p:nvPr/>
+        </p:nvSpPr>
+        <p:spPr>
+          <a:xfrm>
+            <a:off x="8281416" y="1591056"/>
+            <a:ext cx="976376" cy="402336"/>
+          </a:xfrm>
+          <a:prstGeom prst="rect">
+            <a:avLst/>
+          </a:prstGeom>
+          <a:noFill/>
+        </p:spPr>
+        <p:txBody>
+          <a:bodyPr wrap="square" lIns="0" rIns="0" tIns="0" bIns="0" anchor="ctr">
+            <a:spAutoFit/>
+          </a:bodyPr>
+          <a:lstStyle/>
+          <a:p>
+            <a:r>
+              <a:rPr sz="1600" b="0" i="0">
+                <a:solidFill>
+                  <a:srgbClr val="F2F2F2"/>
+                </a:solidFill>
+                <a:latin typeface="Trenda IG Text"/>
+              </a:rPr>
+              <a:t>17</a:t>
+            </a:r>
+          </a:p>
+        </p:txBody>
+      </p:sp>
+      <p:sp>
+        <p:nvSpPr>
+          <p:cNvPr id="46" name="Text 44"/>
+          <p:cNvSpPr txBox="1"/>
+          <p:nvPr/>
+        </p:nvSpPr>
+        <p:spPr>
+          <a:xfrm>
+            <a:off x="8281416" y="1993392"/>
+            <a:ext cx="976376" cy="420624"/>
+          </a:xfrm>
+          <a:prstGeom prst="rect">
+            <a:avLst/>
+          </a:prstGeom>
+          <a:noFill/>
+        </p:spPr>
+        <p:txBody>
+          <a:bodyPr wrap="square" lIns="0" rIns="0" tIns="0" bIns="0" anchor="t">
+            <a:spAutoFit/>
+          </a:bodyPr>
+          <a:lstStyle/>
+          <a:p>
+            <a:r>
+              <a:rPr sz="590" b="0" i="0">
+                <a:solidFill>
+                  <a:srgbClr val="B3B3B3"/>
+                </a:solidFill>
+                <a:latin typeface="Trenda IG Text"/>
+              </a:rPr>
+              <a:t>people at peak, 10 roles</a:t>
+            </a:r>
+          </a:p>
+        </p:txBody>
+      </p:sp>
+      <p:sp>
+        <p:nvSpPr>
+          <p:cNvPr id="47" name="Shape 45"/>
+          <p:cNvSpPr/>
+          <p:nvPr/>
+        </p:nvSpPr>
+        <p:spPr>
+          <a:xfrm>
+            <a:off x="9367520" y="1554480"/>
+            <a:ext cx="1104391" cy="896112"/>
+          </a:xfrm>
+          <a:prstGeom prst="rect">
+            <a:avLst/>
+          </a:prstGeom>
+          <a:solidFill>
+            <a:srgbClr val="141414"/>
+          </a:solidFill>
+          <a:ln>
+            <a:noFill/>
+          </a:ln>
+          <a:effectLst/>
+        </p:spPr>
+        <p:style>
+          <a:lnRef idx="1">
+            <a:schemeClr val="accent1"/>
+          </a:lnRef>
+          <a:fillRef idx="3">
+            <a:schemeClr val="accent1"/>
+          </a:fillRef>
+          <a:effectRef idx="2">
+            <a:schemeClr val="accent1"/>
+          </a:effectRef>
+          <a:fontRef idx="minor">
+            <a:schemeClr val="lt1"/>
+          </a:fontRef>
+        </p:style>
+        <p:txBody>
+          <a:bodyPr rtlCol="0" anchor="ctr"/>
+          <a:lstStyle/>
+          <a:p/>
+        </p:txBody>
+      </p:sp>
+      <p:sp>
+        <p:nvSpPr>
+          <p:cNvPr id="48" name="Text 46"/>
+          <p:cNvSpPr txBox="1"/>
+          <p:nvPr/>
+        </p:nvSpPr>
+        <p:spPr>
+          <a:xfrm>
+            <a:off x="9458960" y="1591056"/>
+            <a:ext cx="976376" cy="402336"/>
+          </a:xfrm>
+          <a:prstGeom prst="rect">
+            <a:avLst/>
+          </a:prstGeom>
+          <a:noFill/>
+        </p:spPr>
+        <p:txBody>
+          <a:bodyPr wrap="square" lIns="0" rIns="0" tIns="0" bIns="0" anchor="ctr">
+            <a:spAutoFit/>
+          </a:bodyPr>
+          <a:lstStyle/>
+          <a:p>
+            <a:r>
+              <a:rPr sz="1600" b="0" i="0">
+                <a:solidFill>
+                  <a:srgbClr val="F2F2F2"/>
+                </a:solidFill>
+                <a:latin typeface="Trenda IG Text"/>
+              </a:rPr>
+              <a:t>18</a:t>
+            </a:r>
+          </a:p>
+        </p:txBody>
+      </p:sp>
+      <p:sp>
+        <p:nvSpPr>
+          <p:cNvPr id="49" name="Text 47"/>
+          <p:cNvSpPr txBox="1"/>
+          <p:nvPr/>
+        </p:nvSpPr>
+        <p:spPr>
+          <a:xfrm>
+            <a:off x="9458960" y="1993392"/>
+            <a:ext cx="976376" cy="420624"/>
+          </a:xfrm>
+          <a:prstGeom prst="rect">
+            <a:avLst/>
+          </a:prstGeom>
+          <a:noFill/>
+        </p:spPr>
+        <p:txBody>
+          <a:bodyPr wrap="square" lIns="0" rIns="0" tIns="0" bIns="0" anchor="t">
+            <a:spAutoFit/>
+          </a:bodyPr>
+          <a:lstStyle/>
+          <a:p>
+            <a:r>
+              <a:rPr sz="590" b="0" i="0">
+                <a:solidFill>
+                  <a:srgbClr val="B3B3B3"/>
+                </a:solidFill>
+                <a:latin typeface="Trenda IG Text"/>
+              </a:rPr>
+              <a:t>months, seven phases</a:t>
+            </a:r>
+          </a:p>
+        </p:txBody>
+      </p:sp>
+      <p:sp>
+        <p:nvSpPr>
+          <p:cNvPr id="50" name="Shape 48"/>
+          <p:cNvSpPr/>
+          <p:nvPr/>
+        </p:nvSpPr>
+        <p:spPr>
+          <a:xfrm>
+            <a:off x="10545064" y="1554480"/>
+            <a:ext cx="1104391" cy="896112"/>
+          </a:xfrm>
+          <a:prstGeom prst="rect">
+            <a:avLst/>
+          </a:prstGeom>
+          <a:solidFill>
+            <a:srgbClr val="141414"/>
+          </a:solidFill>
+          <a:ln>
+            <a:noFill/>
+          </a:ln>
+          <a:effectLst/>
+        </p:spPr>
+        <p:style>
+          <a:lnRef idx="1">
+            <a:schemeClr val="accent1"/>
+          </a:lnRef>
+          <a:fillRef idx="3">
+            <a:schemeClr val="accent1"/>
+          </a:fillRef>
+          <a:effectRef idx="2">
+            <a:schemeClr val="accent1"/>
+          </a:effectRef>
+          <a:fontRef idx="minor">
+            <a:schemeClr val="lt1"/>
+          </a:fontRef>
+        </p:style>
+        <p:txBody>
+          <a:bodyPr rtlCol="0" anchor="ctr"/>
+          <a:lstStyle/>
+          <a:p/>
+        </p:txBody>
+      </p:sp>
+      <p:sp>
+        <p:nvSpPr>
+          <p:cNvPr id="51" name="Text 49"/>
+          <p:cNvSpPr txBox="1"/>
+          <p:nvPr/>
+        </p:nvSpPr>
+        <p:spPr>
+          <a:xfrm>
+            <a:off x="10636504" y="1591056"/>
+            <a:ext cx="976376" cy="402336"/>
+          </a:xfrm>
+          <a:prstGeom prst="rect">
+            <a:avLst/>
+          </a:prstGeom>
+          <a:noFill/>
+        </p:spPr>
+        <p:txBody>
+          <a:bodyPr wrap="square" lIns="0" rIns="0" tIns="0" bIns="0" anchor="ctr">
+            <a:spAutoFit/>
+          </a:bodyPr>
+          <a:lstStyle/>
+          <a:p>
+            <a:r>
+              <a:rPr sz="1600" b="0" i="0">
+                <a:solidFill>
+                  <a:srgbClr val="F2F2F2"/>
+                </a:solidFill>
+                <a:latin typeface="Trenda IG Text"/>
+              </a:rPr>
+              <a:t>$4.79M</a:t>
+            </a:r>
+          </a:p>
+        </p:txBody>
+      </p:sp>
+      <p:sp>
+        <p:nvSpPr>
+          <p:cNvPr id="52" name="Text 50"/>
+          <p:cNvSpPr txBox="1"/>
+          <p:nvPr/>
+        </p:nvSpPr>
+        <p:spPr>
+          <a:xfrm>
+            <a:off x="10636504" y="1993392"/>
+            <a:ext cx="976376" cy="420624"/>
+          </a:xfrm>
+          <a:prstGeom prst="rect">
+            <a:avLst/>
+          </a:prstGeom>
+          <a:noFill/>
+        </p:spPr>
+        <p:txBody>
+          <a:bodyPr wrap="square" lIns="0" rIns="0" tIns="0" bIns="0" anchor="t">
+            <a:spAutoFit/>
+          </a:bodyPr>
+          <a:lstStyle/>
+          <a:p>
+            <a:r>
+              <a:rPr sz="590" b="0" i="0">
+                <a:solidFill>
+                  <a:srgbClr val="B3B3B3"/>
+                </a:solidFill>
+                <a:latin typeface="Trenda IG Text"/>
+              </a:rPr>
+              <a:t>fixed fee, paid as each gate is signed</a:t>
+            </a:r>
+          </a:p>
+        </p:txBody>
+      </p:sp>
+      <p:sp>
+        <p:nvSpPr>
+          <p:cNvPr id="53" name="Text 51"/>
+          <p:cNvSpPr txBox="1"/>
+          <p:nvPr/>
+        </p:nvSpPr>
+        <p:spPr>
+          <a:xfrm>
+            <a:off x="8189976" y="2542032"/>
+            <a:ext cx="3459480" cy="457200"/>
+          </a:xfrm>
+          <a:prstGeom prst="rect">
+            <a:avLst/>
+          </a:prstGeom>
+          <a:noFill/>
+        </p:spPr>
+        <p:txBody>
+          <a:bodyPr wrap="square" lIns="0" rIns="0" tIns="0" bIns="0" anchor="t">
+            <a:spAutoFit/>
+          </a:bodyPr>
+          <a:lstStyle/>
+          <a:p>
+            <a:r>
+              <a:rPr sz="600" b="1" i="0">
+                <a:solidFill>
+                  <a:srgbClr val="F2F2F2"/>
+                </a:solidFill>
+                <a:latin typeface="Trenda IG Text"/>
+              </a:rPr>
+              <a:t>From month 19 </a:t>
+            </a:r>
+            <a:r>
+              <a:rPr sz="600" b="0" i="0">
+                <a:solidFill>
+                  <a:srgbClr val="B3B3B3"/>
+                </a:solidFill>
+                <a:latin typeface="Trenda IG Text"/>
+              </a:rPr>
+              <a:t>a run team of 4 keeps the graph, agents and evals current: about $1.24M a year with platform usage.</a:t>
+            </a:r>
+          </a:p>
+        </p:txBody>
+      </p:sp>
+      <p:sp>
+        <p:nvSpPr>
+          <p:cNvPr id="54" name="Shape 52"/>
+          <p:cNvSpPr/>
+          <p:nvPr/>
+        </p:nvSpPr>
+        <p:spPr>
+          <a:xfrm>
+            <a:off x="411480" y="3291840"/>
+            <a:ext cx="11365992" cy="1965960"/>
+          </a:xfrm>
+          <a:prstGeom prst="roundRect">
+            <a:avLst>
+              <a:gd name="adj" fmla="val 2000"/>
+            </a:avLst>
+          </a:prstGeom>
+          <a:solidFill>
+            <a:srgbClr val="1E1E1E"/>
+          </a:solidFill>
+          <a:ln>
+            <a:noFill/>
+          </a:ln>
+          <a:effectLst/>
+        </p:spPr>
+        <p:style>
+          <a:lnRef idx="1">
+            <a:schemeClr val="accent1"/>
+          </a:lnRef>
+          <a:fillRef idx="3">
+            <a:schemeClr val="accent1"/>
+          </a:fillRef>
+          <a:effectRef idx="2">
+            <a:schemeClr val="accent1"/>
+          </a:effectRef>
+          <a:fontRef idx="minor">
+            <a:schemeClr val="lt1"/>
+          </a:fontRef>
+        </p:style>
+        <p:txBody>
+          <a:bodyPr rtlCol="0" anchor="ctr"/>
+          <a:lstStyle/>
+          <a:p/>
+        </p:txBody>
+      </p:sp>
+      <p:sp>
+        <p:nvSpPr>
+          <p:cNvPr id="55" name="Shape 53"/>
+          <p:cNvSpPr/>
+          <p:nvPr/>
+        </p:nvSpPr>
+        <p:spPr>
+          <a:xfrm>
+            <a:off x="411480" y="3291840"/>
+            <a:ext cx="11365992" cy="256032"/>
+          </a:xfrm>
+          <a:prstGeom prst="rect">
+            <a:avLst/>
+          </a:prstGeom>
+          <a:solidFill>
+            <a:srgbClr val="2B2B2B"/>
+          </a:solidFill>
+          <a:ln>
+            <a:noFill/>
+          </a:ln>
+          <a:effectLst/>
+        </p:spPr>
+        <p:style>
+          <a:lnRef idx="1">
+            <a:schemeClr val="accent1"/>
+          </a:lnRef>
+          <a:fillRef idx="3">
+            <a:schemeClr val="accent1"/>
+          </a:fillRef>
+          <a:effectRef idx="2">
+            <a:schemeClr val="accent1"/>
+          </a:effectRef>
+          <a:fontRef idx="minor">
+            <a:schemeClr val="lt1"/>
+          </a:fontRef>
+        </p:style>
+        <p:txBody>
+          <a:bodyPr rtlCol="0" anchor="ctr"/>
+          <a:lstStyle/>
+          <a:p/>
+        </p:txBody>
+      </p:sp>
+      <p:sp>
+        <p:nvSpPr>
+          <p:cNvPr id="56" name="Text 54"/>
+          <p:cNvSpPr txBox="1"/>
+          <p:nvPr/>
+        </p:nvSpPr>
+        <p:spPr>
+          <a:xfrm>
+            <a:off x="521208" y="3291840"/>
+            <a:ext cx="11146536" cy="256032"/>
+          </a:xfrm>
+          <a:prstGeom prst="rect">
+            <a:avLst/>
+          </a:prstGeom>
+          <a:noFill/>
+        </p:spPr>
+        <p:txBody>
+          <a:bodyPr wrap="square" lIns="0" rIns="0" tIns="0" bIns="0" anchor="ctr">
+            <a:spAutoFit/>
+          </a:bodyPr>
+          <a:lstStyle/>
+          <a:p>
+            <a:r>
+              <a:rPr sz="640" b="1" i="0" spc="120">
+                <a:solidFill>
+                  <a:srgbClr val="F2F2F2"/>
+                </a:solidFill>
+                <a:latin typeface="Trenda IG Text"/>
+              </a:rPr>
+              <a:t>THE RETURN</a:t>
+            </a:r>
+            <a:r>
+              <a:rPr sz="640" b="0" i="0">
+                <a:solidFill>
+                  <a:srgbClr val="B3B3B3"/>
+                </a:solidFill>
+                <a:latin typeface="Trenda IG Text"/>
+              </a:rPr>
+              <a:t>   target · first full year after go-live</a:t>
+            </a:r>
+          </a:p>
+        </p:txBody>
+      </p:sp>
+      <p:sp>
+        <p:nvSpPr>
+          <p:cNvPr id="57" name="Shape 55"/>
+          <p:cNvSpPr/>
+          <p:nvPr/>
+        </p:nvSpPr>
+        <p:spPr>
+          <a:xfrm>
+            <a:off x="539496" y="3639312"/>
+            <a:ext cx="1796796" cy="1490472"/>
+          </a:xfrm>
+          <a:prstGeom prst="rect">
+            <a:avLst/>
+          </a:prstGeom>
+          <a:solidFill>
+            <a:srgbClr val="141414"/>
+          </a:solidFill>
+          <a:ln>
+            <a:noFill/>
+          </a:ln>
+          <a:effectLst/>
+        </p:spPr>
+        <p:style>
+          <a:lnRef idx="1">
+            <a:schemeClr val="accent1"/>
+          </a:lnRef>
+          <a:fillRef idx="3">
+            <a:schemeClr val="accent1"/>
+          </a:fillRef>
+          <a:effectRef idx="2">
+            <a:schemeClr val="accent1"/>
+          </a:effectRef>
+          <a:fontRef idx="minor">
+            <a:schemeClr val="lt1"/>
+          </a:fontRef>
+        </p:style>
+        <p:txBody>
+          <a:bodyPr rtlCol="0" anchor="ctr"/>
+          <a:lstStyle/>
+          <a:p/>
+        </p:txBody>
+      </p:sp>
+      <p:sp>
+        <p:nvSpPr>
+          <p:cNvPr id="58" name="Text 56"/>
+          <p:cNvSpPr txBox="1"/>
+          <p:nvPr/>
+        </p:nvSpPr>
+        <p:spPr>
+          <a:xfrm>
+            <a:off x="667512" y="3977639"/>
+            <a:ext cx="1577340" cy="457200"/>
+          </a:xfrm>
+          <a:prstGeom prst="rect">
+            <a:avLst/>
+          </a:prstGeom>
+          <a:noFill/>
+        </p:spPr>
+        <p:txBody>
+          <a:bodyPr wrap="square" lIns="0" rIns="0" tIns="0" bIns="0" anchor="ctr">
+            <a:spAutoFit/>
+          </a:bodyPr>
+          <a:lstStyle/>
+          <a:p>
+            <a:r>
+              <a:rPr sz="2200" b="0" i="0">
+                <a:solidFill>
+                  <a:srgbClr val="F2F2F2"/>
+                </a:solidFill>
+                <a:latin typeface="Trenda IG Text"/>
+              </a:rPr>
+              <a:t>$16M</a:t>
+            </a:r>
+          </a:p>
+        </p:txBody>
+      </p:sp>
+      <p:sp>
+        <p:nvSpPr>
+          <p:cNvPr id="59" name="Text 57"/>
+          <p:cNvSpPr txBox="1"/>
+          <p:nvPr/>
+        </p:nvSpPr>
+        <p:spPr>
+          <a:xfrm>
+            <a:off x="667512" y="4453127"/>
+            <a:ext cx="1577340" cy="201168"/>
+          </a:xfrm>
+          <a:prstGeom prst="rect">
+            <a:avLst/>
+          </a:prstGeom>
+          <a:noFill/>
+        </p:spPr>
+        <p:txBody>
+          <a:bodyPr wrap="square" lIns="0" rIns="0" tIns="0" bIns="0" anchor="ctr">
+            <a:spAutoFit/>
+          </a:bodyPr>
+          <a:lstStyle/>
+          <a:p>
+            <a:r>
+              <a:rPr sz="700" b="1" i="0">
+                <a:solidFill>
+                  <a:srgbClr val="F2F2F2"/>
+                </a:solidFill>
+                <a:latin typeface="Trenda IG Text"/>
+              </a:rPr>
+              <a:t>a year today</a:t>
+            </a:r>
+          </a:p>
+        </p:txBody>
+      </p:sp>
+      <p:sp>
+        <p:nvSpPr>
+          <p:cNvPr id="60" name="Text 58"/>
+          <p:cNvSpPr txBox="1"/>
+          <p:nvPr/>
+        </p:nvSpPr>
+        <p:spPr>
+          <a:xfrm>
+            <a:off x="667512" y="4654296"/>
+            <a:ext cx="1577340" cy="201168"/>
+          </a:xfrm>
+          <a:prstGeom prst="rect">
+            <a:avLst/>
+          </a:prstGeom>
+          <a:noFill/>
+        </p:spPr>
+        <p:txBody>
+          <a:bodyPr wrap="square" lIns="0" rIns="0" tIns="0" bIns="0" anchor="ctr">
+            <a:spAutoFit/>
+          </a:bodyPr>
+          <a:lstStyle/>
+          <a:p>
+            <a:r>
+              <a:rPr sz="600" b="0" i="0">
+                <a:solidFill>
+                  <a:srgbClr val="B3B3B3"/>
+                </a:solidFill>
+                <a:latin typeface="Trenda IG Text"/>
+              </a:rPr>
+              <a:t>as provided by Ascension</a:t>
+            </a:r>
+          </a:p>
+        </p:txBody>
+      </p:sp>
+      <p:sp>
+        <p:nvSpPr>
+          <p:cNvPr id="61" name="Shape 59"/>
+          <p:cNvSpPr/>
+          <p:nvPr/>
+        </p:nvSpPr>
+        <p:spPr>
+          <a:xfrm>
+            <a:off x="2427732" y="3639312"/>
+            <a:ext cx="1796796" cy="1490472"/>
+          </a:xfrm>
+          <a:prstGeom prst="rect">
+            <a:avLst/>
+          </a:prstGeom>
+          <a:solidFill>
+            <a:srgbClr val="141414"/>
+          </a:solidFill>
+          <a:ln>
+            <a:noFill/>
+          </a:ln>
+          <a:effectLst/>
+        </p:spPr>
+        <p:style>
+          <a:lnRef idx="1">
+            <a:schemeClr val="accent1"/>
+          </a:lnRef>
+          <a:fillRef idx="3">
+            <a:schemeClr val="accent1"/>
+          </a:fillRef>
+          <a:effectRef idx="2">
+            <a:schemeClr val="accent1"/>
+          </a:effectRef>
+          <a:fontRef idx="minor">
+            <a:schemeClr val="lt1"/>
+          </a:fontRef>
+        </p:style>
+        <p:txBody>
+          <a:bodyPr rtlCol="0" anchor="ctr"/>
+          <a:lstStyle/>
+          <a:p/>
+        </p:txBody>
+      </p:sp>
+      <p:sp>
+        <p:nvSpPr>
+          <p:cNvPr id="62" name="Text 60"/>
+          <p:cNvSpPr txBox="1"/>
+          <p:nvPr/>
+        </p:nvSpPr>
+        <p:spPr>
+          <a:xfrm>
+            <a:off x="2555748" y="3977639"/>
+            <a:ext cx="1577340" cy="457200"/>
+          </a:xfrm>
+          <a:prstGeom prst="rect">
+            <a:avLst/>
+          </a:prstGeom>
+          <a:noFill/>
+        </p:spPr>
+        <p:txBody>
+          <a:bodyPr wrap="square" lIns="0" rIns="0" tIns="0" bIns="0" anchor="ctr">
+            <a:spAutoFit/>
+          </a:bodyPr>
+          <a:lstStyle/>
+          <a:p>
+            <a:r>
+              <a:rPr sz="2200" b="0" i="0">
+                <a:solidFill>
+                  <a:srgbClr val="F2F2F2"/>
+                </a:solidFill>
+                <a:latin typeface="Trenda IG Text"/>
+              </a:rPr>
+              <a:t>$7M</a:t>
+            </a:r>
+          </a:p>
+        </p:txBody>
+      </p:sp>
+      <p:sp>
+        <p:nvSpPr>
+          <p:cNvPr id="63" name="Text 61"/>
+          <p:cNvSpPr txBox="1"/>
+          <p:nvPr/>
+        </p:nvSpPr>
+        <p:spPr>
+          <a:xfrm>
+            <a:off x="2555748" y="4453127"/>
+            <a:ext cx="1577340" cy="201168"/>
+          </a:xfrm>
+          <a:prstGeom prst="rect">
+            <a:avLst/>
+          </a:prstGeom>
+          <a:noFill/>
+        </p:spPr>
+        <p:txBody>
+          <a:bodyPr wrap="square" lIns="0" rIns="0" tIns="0" bIns="0" anchor="ctr">
+            <a:spAutoFit/>
+          </a:bodyPr>
+          <a:lstStyle/>
+          <a:p>
+            <a:r>
+              <a:rPr sz="700" b="1" i="0">
+                <a:solidFill>
+                  <a:srgbClr val="F2F2F2"/>
+                </a:solidFill>
+                <a:latin typeface="Trenda IG Text"/>
+              </a:rPr>
+              <a:t>a year with the harness</a:t>
+            </a:r>
+          </a:p>
+        </p:txBody>
+      </p:sp>
+      <p:sp>
+        <p:nvSpPr>
+          <p:cNvPr id="64" name="Text 62"/>
+          <p:cNvSpPr txBox="1"/>
+          <p:nvPr/>
+        </p:nvSpPr>
+        <p:spPr>
+          <a:xfrm>
+            <a:off x="2555748" y="4654296"/>
+            <a:ext cx="1577340" cy="201168"/>
+          </a:xfrm>
+          <a:prstGeom prst="rect">
+            <a:avLst/>
+          </a:prstGeom>
+          <a:noFill/>
+        </p:spPr>
+        <p:txBody>
+          <a:bodyPr wrap="square" lIns="0" rIns="0" tIns="0" bIns="0" anchor="ctr">
+            <a:spAutoFit/>
+          </a:bodyPr>
+          <a:lstStyle/>
+          <a:p>
+            <a:r>
+              <a:rPr sz="600" b="0" i="0">
+                <a:solidFill>
+                  <a:srgbClr val="B3B3B3"/>
+                </a:solidFill>
+                <a:latin typeface="Trenda IG Text"/>
+              </a:rPr>
+              <a:t>agents and run team included</a:t>
+            </a:r>
+          </a:p>
+        </p:txBody>
+      </p:sp>
+      <p:sp>
+        <p:nvSpPr>
+          <p:cNvPr id="65" name="Differentiator Border 64"/>
+          <p:cNvSpPr/>
+          <p:nvPr/>
+        </p:nvSpPr>
+        <p:spPr>
+          <a:xfrm>
+            <a:off x="4315968" y="3639312"/>
+            <a:ext cx="1796796" cy="1490472"/>
+          </a:xfrm>
+          <a:prstGeom prst="rect">
+            <a:avLst/>
+          </a:prstGeom>
+          <a:gradFill rotWithShape="1">
+            <a:gsLst>
+              <a:gs pos="0">
+                <a:srgbClr val="FFD700"/>
+              </a:gs>
+              <a:gs pos="50000">
+                <a:srgbClr val="FF0069"/>
+              </a:gs>
+              <a:gs pos="100000">
+                <a:srgbClr val="00D6F2"/>
+              </a:gs>
+            </a:gsLst>
+            <a:lin ang="0" scaled="0"/>
+          </a:gradFill>
+          <a:ln>
+            <a:noFill/>
+          </a:ln>
+          <a:effectLst/>
+        </p:spPr>
+        <p:style>
+          <a:lnRef idx="1">
+            <a:schemeClr val="accent1"/>
+          </a:lnRef>
+          <a:fillRef idx="3">
+            <a:schemeClr val="accent1"/>
+          </a:fillRef>
+          <a:effectRef idx="2">
+            <a:schemeClr val="accent1"/>
+          </a:effectRef>
+          <a:fontRef idx="minor">
+            <a:schemeClr val="lt1"/>
+          </a:fontRef>
+        </p:style>
+        <p:txBody>
+          <a:bodyPr rtlCol="0" anchor="ctr"/>
+          <a:lstStyle/>
+          <a:p/>
+        </p:txBody>
+      </p:sp>
+      <p:sp>
+        <p:nvSpPr>
+          <p:cNvPr id="66" name="Shape 65"/>
+          <p:cNvSpPr/>
+          <p:nvPr/>
+        </p:nvSpPr>
+        <p:spPr>
+          <a:xfrm>
+            <a:off x="4334255" y="3657600"/>
+            <a:ext cx="1760220" cy="1453895"/>
+          </a:xfrm>
+          <a:prstGeom prst="rect">
+            <a:avLst/>
+          </a:prstGeom>
+          <a:solidFill>
+            <a:srgbClr val="141414"/>
+          </a:solidFill>
+          <a:ln>
+            <a:noFill/>
+          </a:ln>
+          <a:effectLst/>
+        </p:spPr>
+        <p:style>
+          <a:lnRef idx="1">
+            <a:schemeClr val="accent1"/>
+          </a:lnRef>
+          <a:fillRef idx="3">
+            <a:schemeClr val="accent1"/>
+          </a:fillRef>
+          <a:effectRef idx="2">
+            <a:schemeClr val="accent1"/>
+          </a:effectRef>
+          <a:fontRef idx="minor">
+            <a:schemeClr val="lt1"/>
+          </a:fontRef>
+        </p:style>
+        <p:txBody>
+          <a:bodyPr rtlCol="0" anchor="ctr"/>
+          <a:lstStyle/>
+          <a:p/>
+        </p:txBody>
+      </p:sp>
+      <p:sp>
+        <p:nvSpPr>
+          <p:cNvPr id="67" name="Text 66"/>
+          <p:cNvSpPr txBox="1"/>
+          <p:nvPr/>
+        </p:nvSpPr>
+        <p:spPr>
+          <a:xfrm>
+            <a:off x="4443983" y="3977639"/>
+            <a:ext cx="1577340" cy="457200"/>
+          </a:xfrm>
+          <a:prstGeom prst="rect">
+            <a:avLst/>
+          </a:prstGeom>
+          <a:noFill/>
+        </p:spPr>
+        <p:txBody>
+          <a:bodyPr wrap="square" lIns="0" rIns="0" tIns="0" bIns="0" anchor="ctr">
+            <a:spAutoFit/>
+          </a:bodyPr>
+          <a:lstStyle/>
+          <a:p>
+            <a:r>
+              <a:rPr sz="2200" b="0" i="0">
+                <a:solidFill>
+                  <a:srgbClr val="00D6F2"/>
+                </a:solidFill>
+                <a:latin typeface="Trenda IG Text"/>
+              </a:rPr>
+              <a:t>$9M</a:t>
+            </a:r>
+          </a:p>
+        </p:txBody>
+      </p:sp>
+      <p:sp>
+        <p:nvSpPr>
+          <p:cNvPr id="68" name="Text 67"/>
+          <p:cNvSpPr txBox="1"/>
+          <p:nvPr/>
+        </p:nvSpPr>
+        <p:spPr>
+          <a:xfrm>
+            <a:off x="4443983" y="4453127"/>
+            <a:ext cx="1577340" cy="201168"/>
+          </a:xfrm>
+          <a:prstGeom prst="rect">
+            <a:avLst/>
+          </a:prstGeom>
+          <a:noFill/>
+        </p:spPr>
+        <p:txBody>
+          <a:bodyPr wrap="square" lIns="0" rIns="0" tIns="0" bIns="0" anchor="ctr">
+            <a:spAutoFit/>
+          </a:bodyPr>
+          <a:lstStyle/>
+          <a:p>
+            <a:r>
+              <a:rPr sz="700" b="1" i="0">
+                <a:solidFill>
+                  <a:srgbClr val="F2F2F2"/>
+                </a:solidFill>
+                <a:latin typeface="Trenda IG Text"/>
+              </a:rPr>
+              <a:t>saved every year</a:t>
+            </a:r>
+          </a:p>
+        </p:txBody>
+      </p:sp>
+      <p:sp>
+        <p:nvSpPr>
+          <p:cNvPr id="69" name="Text 68"/>
+          <p:cNvSpPr txBox="1"/>
+          <p:nvPr/>
+        </p:nvSpPr>
+        <p:spPr>
+          <a:xfrm>
+            <a:off x="4443983" y="4654296"/>
+            <a:ext cx="1577340" cy="201168"/>
+          </a:xfrm>
+          <a:prstGeom prst="rect">
+            <a:avLst/>
+          </a:prstGeom>
+          <a:noFill/>
+        </p:spPr>
+        <p:txBody>
+          <a:bodyPr wrap="square" lIns="0" rIns="0" tIns="0" bIns="0" anchor="ctr">
+            <a:spAutoFit/>
+          </a:bodyPr>
+          <a:lstStyle/>
+          <a:p>
+            <a:r>
+              <a:rPr sz="600" b="0" i="0">
+                <a:solidFill>
+                  <a:srgbClr val="B3B3B3"/>
+                </a:solidFill>
+                <a:latin typeface="Trenda IG Text"/>
+              </a:rPr>
+              <a:t>from go-live</a:t>
+            </a:r>
+          </a:p>
+        </p:txBody>
+      </p:sp>
+      <p:sp>
+        <p:nvSpPr>
+          <p:cNvPr id="70" name="Shape 69"/>
+          <p:cNvSpPr/>
+          <p:nvPr/>
+        </p:nvSpPr>
+        <p:spPr>
+          <a:xfrm>
+            <a:off x="6204204" y="3639312"/>
+            <a:ext cx="1796796" cy="1490472"/>
+          </a:xfrm>
+          <a:prstGeom prst="rect">
+            <a:avLst/>
+          </a:prstGeom>
+          <a:solidFill>
+            <a:srgbClr val="141414"/>
+          </a:solidFill>
+          <a:ln>
+            <a:noFill/>
+          </a:ln>
+          <a:effectLst/>
+        </p:spPr>
+        <p:style>
+          <a:lnRef idx="1">
+            <a:schemeClr val="accent1"/>
+          </a:lnRef>
+          <a:fillRef idx="3">
+            <a:schemeClr val="accent1"/>
+          </a:fillRef>
+          <a:effectRef idx="2">
+            <a:schemeClr val="accent1"/>
+          </a:effectRef>
+          <a:fontRef idx="minor">
+            <a:schemeClr val="lt1"/>
+          </a:fontRef>
+        </p:style>
+        <p:txBody>
+          <a:bodyPr rtlCol="0" anchor="ctr"/>
+          <a:lstStyle/>
+          <a:p/>
+        </p:txBody>
+      </p:sp>
+      <p:sp>
+        <p:nvSpPr>
+          <p:cNvPr id="71" name="Text 70"/>
+          <p:cNvSpPr txBox="1"/>
+          <p:nvPr/>
+        </p:nvSpPr>
+        <p:spPr>
+          <a:xfrm>
+            <a:off x="6332220" y="3977639"/>
+            <a:ext cx="1577340" cy="457200"/>
+          </a:xfrm>
+          <a:prstGeom prst="rect">
+            <a:avLst/>
+          </a:prstGeom>
+          <a:noFill/>
+        </p:spPr>
+        <p:txBody>
+          <a:bodyPr wrap="square" lIns="0" rIns="0" tIns="0" bIns="0" anchor="ctr">
+            <a:spAutoFit/>
+          </a:bodyPr>
+          <a:lstStyle/>
+          <a:p>
+            <a:r>
+              <a:rPr sz="2200" b="0" i="0">
+                <a:solidFill>
+                  <a:srgbClr val="F2F2F2"/>
+                </a:solidFill>
+                <a:latin typeface="Trenda IG Text"/>
+              </a:rPr>
+              <a:t>$5.0M</a:t>
+            </a:r>
+          </a:p>
+        </p:txBody>
+      </p:sp>
+      <p:sp>
+        <p:nvSpPr>
+          <p:cNvPr id="72" name="Text 71"/>
+          <p:cNvSpPr txBox="1"/>
+          <p:nvPr/>
+        </p:nvSpPr>
+        <p:spPr>
+          <a:xfrm>
+            <a:off x="6332220" y="4453127"/>
+            <a:ext cx="1577340" cy="201168"/>
+          </a:xfrm>
+          <a:prstGeom prst="rect">
+            <a:avLst/>
+          </a:prstGeom>
+          <a:noFill/>
+        </p:spPr>
+        <p:txBody>
+          <a:bodyPr wrap="square" lIns="0" rIns="0" tIns="0" bIns="0" anchor="ctr">
+            <a:spAutoFit/>
+          </a:bodyPr>
+          <a:lstStyle/>
+          <a:p>
+            <a:r>
+              <a:rPr sz="700" b="1" i="0">
+                <a:solidFill>
+                  <a:srgbClr val="F2F2F2"/>
+                </a:solidFill>
+                <a:latin typeface="Trenda IG Text"/>
+              </a:rPr>
+              <a:t>invested once</a:t>
+            </a:r>
+          </a:p>
+        </p:txBody>
+      </p:sp>
+      <p:sp>
+        <p:nvSpPr>
+          <p:cNvPr id="73" name="Text 72"/>
+          <p:cNvSpPr txBox="1"/>
+          <p:nvPr/>
+        </p:nvSpPr>
+        <p:spPr>
+          <a:xfrm>
+            <a:off x="6332220" y="4654296"/>
+            <a:ext cx="1577340" cy="201168"/>
+          </a:xfrm>
+          <a:prstGeom prst="rect">
+            <a:avLst/>
+          </a:prstGeom>
+          <a:noFill/>
+        </p:spPr>
+        <p:txBody>
+          <a:bodyPr wrap="square" lIns="0" rIns="0" tIns="0" bIns="0" anchor="ctr">
+            <a:spAutoFit/>
+          </a:bodyPr>
+          <a:lstStyle/>
+          <a:p>
+            <a:r>
+              <a:rPr sz="600" b="0" i="0">
+                <a:solidFill>
+                  <a:srgbClr val="B3B3B3"/>
+                </a:solidFill>
+                <a:latin typeface="Trenda IG Text"/>
+              </a:rPr>
+              <a:t>$4.79M build + $0.23M usage</a:t>
+            </a:r>
+          </a:p>
+        </p:txBody>
+      </p:sp>
+      <p:sp>
+        <p:nvSpPr>
+          <p:cNvPr id="74" name="Shape 73"/>
+          <p:cNvSpPr/>
+          <p:nvPr/>
+        </p:nvSpPr>
+        <p:spPr>
+          <a:xfrm>
+            <a:off x="8220456" y="3639312"/>
+            <a:ext cx="3429000" cy="699515"/>
+          </a:xfrm>
+          <a:prstGeom prst="rect">
+            <a:avLst/>
+          </a:prstGeom>
+          <a:solidFill>
+            <a:srgbClr val="141414"/>
+          </a:solidFill>
+          <a:ln>
+            <a:noFill/>
+          </a:ln>
+          <a:effectLst/>
+        </p:spPr>
+        <p:style>
+          <a:lnRef idx="1">
+            <a:schemeClr val="accent1"/>
+          </a:lnRef>
+          <a:fillRef idx="3">
+            <a:schemeClr val="accent1"/>
+          </a:fillRef>
+          <a:effectRef idx="2">
+            <a:schemeClr val="accent1"/>
+          </a:effectRef>
+          <a:fontRef idx="minor">
+            <a:schemeClr val="lt1"/>
+          </a:fontRef>
+        </p:style>
+        <p:txBody>
+          <a:bodyPr rtlCol="0" anchor="ctr"/>
+          <a:lstStyle/>
+          <a:p/>
+        </p:txBody>
+      </p:sp>
+      <p:sp>
+        <p:nvSpPr>
+          <p:cNvPr id="75" name="Shape 74"/>
+          <p:cNvSpPr/>
+          <p:nvPr/>
+        </p:nvSpPr>
+        <p:spPr>
+          <a:xfrm>
+            <a:off x="8220456" y="3639312"/>
+            <a:ext cx="45720" cy="699515"/>
+          </a:xfrm>
+          <a:prstGeom prst="rect">
+            <a:avLst/>
+          </a:prstGeom>
+          <a:gradFill rotWithShape="1">
+            <a:gsLst>
+              <a:gs pos="0">
+                <a:srgbClr val="FFD700"/>
+              </a:gs>
+              <a:gs pos="50000">
+                <a:srgbClr val="FF0069"/>
+              </a:gs>
+              <a:gs pos="100000">
+                <a:srgbClr val="00D6F2"/>
+              </a:gs>
+            </a:gsLst>
+            <a:lin ang="5400000" scaled="0"/>
+          </a:gradFill>
+          <a:ln>
+            <a:noFill/>
+          </a:ln>
+          <a:effectLst/>
+        </p:spPr>
+        <p:style>
+          <a:lnRef idx="1">
+            <a:schemeClr val="accent1"/>
+          </a:lnRef>
+          <a:fillRef idx="3">
+            <a:schemeClr val="accent1"/>
+          </a:fillRef>
+          <a:effectRef idx="2">
+            <a:schemeClr val="accent1"/>
+          </a:effectRef>
+          <a:fontRef idx="minor">
+            <a:schemeClr val="lt1"/>
+          </a:fontRef>
+        </p:style>
+        <p:txBody>
+          <a:bodyPr rtlCol="0" anchor="ctr"/>
+          <a:lstStyle/>
+          <a:p/>
+        </p:txBody>
+      </p:sp>
+      <p:sp>
+        <p:nvSpPr>
+          <p:cNvPr id="76" name="Text 75"/>
+          <p:cNvSpPr txBox="1"/>
+          <p:nvPr/>
+        </p:nvSpPr>
+        <p:spPr>
+          <a:xfrm>
+            <a:off x="8385048" y="3639312"/>
+            <a:ext cx="3191256" cy="699515"/>
+          </a:xfrm>
+          <a:prstGeom prst="rect">
+            <a:avLst/>
+          </a:prstGeom>
+          <a:noFill/>
+        </p:spPr>
+        <p:txBody>
+          <a:bodyPr wrap="square" lIns="0" rIns="0" tIns="0" bIns="0" anchor="ctr">
+            <a:spAutoFit/>
+          </a:bodyPr>
+          <a:lstStyle/>
+          <a:p>
+            <a:pPr>
+              <a:spcAft>
+                <a:spcPts val="200"/>
+              </a:spcAft>
+            </a:pPr>
+            <a:r>
+              <a:rPr sz="800" b="1" i="0">
+                <a:solidFill>
+                  <a:srgbClr val="00D6F2"/>
+                </a:solidFill>
+                <a:latin typeface="Trenda IG Text"/>
+              </a:rPr>
+              <a:t>Paid back in under 7 months</a:t>
+            </a:r>
+          </a:p>
+          <a:p>
+            <a:pPr>
+              <a:spcAft>
+                <a:spcPts val="200"/>
+              </a:spcAft>
+            </a:pPr>
+            <a:r>
+              <a:rPr sz="640" b="0" i="0">
+                <a:solidFill>
+                  <a:srgbClr val="B3B3B3"/>
+                </a:solidFill>
+                <a:latin typeface="Trenda IG Text"/>
+              </a:rPr>
+              <a:t>80% first-year return; 1.8x the investment back in year one</a:t>
+            </a:r>
+          </a:p>
+        </p:txBody>
+      </p:sp>
+      <p:sp>
+        <p:nvSpPr>
+          <p:cNvPr id="77" name="Shape 76"/>
+          <p:cNvSpPr/>
+          <p:nvPr/>
+        </p:nvSpPr>
+        <p:spPr>
+          <a:xfrm>
+            <a:off x="8220456" y="4430268"/>
+            <a:ext cx="3429000" cy="699515"/>
+          </a:xfrm>
+          <a:prstGeom prst="rect">
+            <a:avLst/>
+          </a:prstGeom>
+          <a:solidFill>
+            <a:srgbClr val="141414"/>
+          </a:solidFill>
+          <a:ln>
+            <a:noFill/>
+          </a:ln>
+          <a:effectLst/>
+        </p:spPr>
+        <p:style>
+          <a:lnRef idx="1">
+            <a:schemeClr val="accent1"/>
+          </a:lnRef>
+          <a:fillRef idx="3">
+            <a:schemeClr val="accent1"/>
+          </a:fillRef>
+          <a:effectRef idx="2">
+            <a:schemeClr val="accent1"/>
+          </a:effectRef>
+          <a:fontRef idx="minor">
+            <a:schemeClr val="lt1"/>
+          </a:fontRef>
+        </p:style>
+        <p:txBody>
+          <a:bodyPr rtlCol="0" anchor="ctr"/>
+          <a:lstStyle/>
+          <a:p/>
+        </p:txBody>
+      </p:sp>
+      <p:sp>
+        <p:nvSpPr>
+          <p:cNvPr id="78" name="Shape 77"/>
+          <p:cNvSpPr/>
+          <p:nvPr/>
+        </p:nvSpPr>
+        <p:spPr>
+          <a:xfrm>
+            <a:off x="8220456" y="4430268"/>
+            <a:ext cx="45720" cy="699515"/>
+          </a:xfrm>
+          <a:prstGeom prst="rect">
+            <a:avLst/>
+          </a:prstGeom>
+          <a:gradFill rotWithShape="1">
+            <a:gsLst>
+              <a:gs pos="0">
+                <a:srgbClr val="FFD700"/>
+              </a:gs>
+              <a:gs pos="50000">
+                <a:srgbClr val="FF0069"/>
+              </a:gs>
+              <a:gs pos="100000">
+                <a:srgbClr val="00D6F2"/>
+              </a:gs>
+            </a:gsLst>
+            <a:lin ang="5400000" scaled="0"/>
+          </a:gradFill>
+          <a:ln>
+            <a:noFill/>
+          </a:ln>
+          <a:effectLst/>
+        </p:spPr>
+        <p:style>
+          <a:lnRef idx="1">
+            <a:schemeClr val="accent1"/>
+          </a:lnRef>
+          <a:fillRef idx="3">
+            <a:schemeClr val="accent1"/>
+          </a:fillRef>
+          <a:effectRef idx="2">
+            <a:schemeClr val="accent1"/>
+          </a:effectRef>
+          <a:fontRef idx="minor">
+            <a:schemeClr val="lt1"/>
+          </a:fontRef>
+        </p:style>
+        <p:txBody>
+          <a:bodyPr rtlCol="0" anchor="ctr"/>
+          <a:lstStyle/>
+          <a:p/>
+        </p:txBody>
+      </p:sp>
+      <p:sp>
+        <p:nvSpPr>
+          <p:cNvPr id="79" name="Text 78"/>
+          <p:cNvSpPr txBox="1"/>
+          <p:nvPr/>
+        </p:nvSpPr>
+        <p:spPr>
+          <a:xfrm>
+            <a:off x="8385048" y="4430268"/>
+            <a:ext cx="3191256" cy="699515"/>
+          </a:xfrm>
+          <a:prstGeom prst="rect">
+            <a:avLst/>
+          </a:prstGeom>
+          <a:noFill/>
+        </p:spPr>
+        <p:txBody>
+          <a:bodyPr wrap="square" lIns="0" rIns="0" tIns="0" bIns="0" anchor="ctr">
+            <a:spAutoFit/>
+          </a:bodyPr>
+          <a:lstStyle/>
+          <a:p>
+            <a:pPr>
+              <a:spcAft>
+                <a:spcPts val="200"/>
+              </a:spcAft>
+            </a:pPr>
+            <a:r>
+              <a:rPr sz="800" b="1" i="0">
+                <a:solidFill>
+                  <a:srgbClr val="FFD700"/>
+                </a:solidFill>
+                <a:latin typeface="Trenda IG Text"/>
+              </a:rPr>
+              <a:t>Floor we commit to</a:t>
+            </a:r>
+          </a:p>
+          <a:p>
+            <a:pPr>
+              <a:spcAft>
+                <a:spcPts val="200"/>
+              </a:spcAft>
+            </a:pPr>
+            <a:r>
+              <a:rPr sz="640" b="0" i="0">
+                <a:solidFill>
+                  <a:srgbClr val="B3B3B3"/>
+                </a:solidFill>
+                <a:latin typeface="Trenda IG Text"/>
+              </a:rPr>
+              <a:t>20-25% lower net run cost per pod, against its own baseline</a:t>
+            </a:r>
+          </a:p>
+        </p:txBody>
+      </p:sp>
+      <p:sp>
+        <p:nvSpPr>
+          <p:cNvPr id="80" name="Text 79"/>
+          <p:cNvSpPr txBox="1"/>
+          <p:nvPr/>
+        </p:nvSpPr>
+        <p:spPr>
+          <a:xfrm>
+            <a:off x="411480" y="5394960"/>
+            <a:ext cx="1188720" cy="640080"/>
+          </a:xfrm>
+          <a:prstGeom prst="rect">
+            <a:avLst/>
+          </a:prstGeom>
+          <a:noFill/>
+        </p:spPr>
+        <p:txBody>
+          <a:bodyPr wrap="square" lIns="0" rIns="0" tIns="0" bIns="0" anchor="ctr">
+            <a:spAutoFit/>
+          </a:bodyPr>
+          <a:lstStyle/>
+          <a:p>
+            <a:pPr>
+              <a:spcAft>
+                <a:spcPts val="100"/>
+              </a:spcAft>
+            </a:pPr>
+            <a:r>
+              <a:rPr sz="640" b="1" i="0" spc="120">
+                <a:solidFill>
+                  <a:srgbClr val="F2F2F2"/>
+                </a:solidFill>
+                <a:latin typeface="Trenda IG Text"/>
+              </a:rPr>
+              <a:t>KEEP IT HONEST</a:t>
+            </a:r>
+          </a:p>
+          <a:p>
+            <a:pPr>
+              <a:spcAft>
+                <a:spcPts val="100"/>
+              </a:spcAft>
+            </a:pPr>
+            <a:r>
+              <a:rPr sz="520" b="0" i="0">
+                <a:solidFill>
+                  <a:srgbClr val="8C8C8C"/>
+                </a:solidFill>
+                <a:latin typeface="Trenda IG Text"/>
+              </a:rPr>
+              <a:t>how the numbers hold</a:t>
+            </a:r>
+          </a:p>
+        </p:txBody>
+      </p:sp>
+      <p:sp>
+        <p:nvSpPr>
+          <p:cNvPr id="81" name="Shape 80"/>
+          <p:cNvSpPr/>
+          <p:nvPr/>
+        </p:nvSpPr>
+        <p:spPr>
+          <a:xfrm>
+            <a:off x="1645920" y="5394960"/>
+            <a:ext cx="2464308" cy="640080"/>
+          </a:xfrm>
+          <a:prstGeom prst="rect">
+            <a:avLst/>
+          </a:prstGeom>
+          <a:solidFill>
+            <a:srgbClr val="141414"/>
+          </a:solidFill>
+          <a:ln>
+            <a:noFill/>
+          </a:ln>
+          <a:effectLst/>
+        </p:spPr>
+        <p:style>
+          <a:lnRef idx="1">
+            <a:schemeClr val="accent1"/>
+          </a:lnRef>
+          <a:fillRef idx="3">
+            <a:schemeClr val="accent1"/>
+          </a:fillRef>
+          <a:effectRef idx="2">
+            <a:schemeClr val="accent1"/>
+          </a:effectRef>
+          <a:fontRef idx="minor">
+            <a:schemeClr val="lt1"/>
+          </a:fontRef>
+        </p:style>
+        <p:txBody>
+          <a:bodyPr rtlCol="0" anchor="ctr"/>
+          <a:lstStyle/>
+          <a:p/>
+        </p:txBody>
+      </p:sp>
+      <p:sp>
+        <p:nvSpPr>
+          <p:cNvPr id="82" name="Shape 81"/>
+          <p:cNvSpPr/>
+          <p:nvPr/>
+        </p:nvSpPr>
+        <p:spPr>
+          <a:xfrm>
+            <a:off x="1645920" y="5394960"/>
+            <a:ext cx="36576" cy="640080"/>
+          </a:xfrm>
+          <a:prstGeom prst="rect">
+            <a:avLst/>
+          </a:prstGeom>
+          <a:solidFill>
+            <a:srgbClr val="00D6F2"/>
+          </a:solidFill>
+          <a:ln>
+            <a:noFill/>
+          </a:ln>
+          <a:effectLst/>
+        </p:spPr>
+        <p:style>
+          <a:lnRef idx="1">
+            <a:schemeClr val="accent1"/>
+          </a:lnRef>
+          <a:fillRef idx="3">
+            <a:schemeClr val="accent1"/>
+          </a:fillRef>
+          <a:effectRef idx="2">
+            <a:schemeClr val="accent1"/>
+          </a:effectRef>
+          <a:fontRef idx="minor">
+            <a:schemeClr val="lt1"/>
+          </a:fontRef>
+        </p:style>
+        <p:txBody>
+          <a:bodyPr rtlCol="0" anchor="ctr"/>
+          <a:lstStyle/>
+          <a:p/>
+        </p:txBody>
+      </p:sp>
+      <p:sp>
+        <p:nvSpPr>
+          <p:cNvPr id="83" name="Text 82"/>
+          <p:cNvSpPr txBox="1"/>
+          <p:nvPr/>
+        </p:nvSpPr>
+        <p:spPr>
+          <a:xfrm>
+            <a:off x="1773936" y="5394960"/>
+            <a:ext cx="2281427" cy="640080"/>
+          </a:xfrm>
+          <a:prstGeom prst="rect">
+            <a:avLst/>
+          </a:prstGeom>
+          <a:noFill/>
+        </p:spPr>
+        <p:txBody>
+          <a:bodyPr wrap="square" lIns="0" rIns="0" tIns="0" bIns="0" anchor="ctr">
+            <a:spAutoFit/>
+          </a:bodyPr>
+          <a:lstStyle/>
+          <a:p>
+            <a:pPr>
+              <a:spcAft>
+                <a:spcPts val="100"/>
+              </a:spcAft>
+            </a:pPr>
+            <a:r>
+              <a:rPr sz="700" b="1" i="0">
+                <a:solidFill>
+                  <a:srgbClr val="F2F2F2"/>
+                </a:solidFill>
+                <a:latin typeface="Trenda IG Text"/>
+              </a:rPr>
+              <a:t>Baseline every pod first</a:t>
+            </a:r>
+          </a:p>
+          <a:p>
+            <a:pPr>
+              <a:spcAft>
+                <a:spcPts val="100"/>
+              </a:spcAft>
+            </a:pPr>
+            <a:r>
+              <a:rPr sz="600" b="0" i="0">
+                <a:solidFill>
+                  <a:srgbClr val="B3B3B3"/>
+                </a:solidFill>
+                <a:latin typeface="Trenda IG Text"/>
+              </a:rPr>
+              <a:t>savings counted against each pod's own numbers</a:t>
+            </a:r>
+          </a:p>
+        </p:txBody>
+      </p:sp>
+      <p:sp>
+        <p:nvSpPr>
+          <p:cNvPr id="84" name="Shape 83"/>
+          <p:cNvSpPr/>
+          <p:nvPr/>
+        </p:nvSpPr>
+        <p:spPr>
+          <a:xfrm>
+            <a:off x="4201668" y="5394960"/>
+            <a:ext cx="2464308" cy="640080"/>
+          </a:xfrm>
+          <a:prstGeom prst="rect">
+            <a:avLst/>
+          </a:prstGeom>
+          <a:solidFill>
+            <a:srgbClr val="141414"/>
+          </a:solidFill>
+          <a:ln>
+            <a:noFill/>
+          </a:ln>
+          <a:effectLst/>
+        </p:spPr>
+        <p:style>
+          <a:lnRef idx="1">
+            <a:schemeClr val="accent1"/>
+          </a:lnRef>
+          <a:fillRef idx="3">
+            <a:schemeClr val="accent1"/>
+          </a:fillRef>
+          <a:effectRef idx="2">
+            <a:schemeClr val="accent1"/>
+          </a:effectRef>
+          <a:fontRef idx="minor">
+            <a:schemeClr val="lt1"/>
+          </a:fontRef>
+        </p:style>
+        <p:txBody>
+          <a:bodyPr rtlCol="0" anchor="ctr"/>
+          <a:lstStyle/>
+          <a:p/>
+        </p:txBody>
+      </p:sp>
+      <p:sp>
+        <p:nvSpPr>
+          <p:cNvPr id="85" name="Shape 84"/>
+          <p:cNvSpPr/>
+          <p:nvPr/>
+        </p:nvSpPr>
+        <p:spPr>
+          <a:xfrm>
+            <a:off x="4201668" y="5394960"/>
+            <a:ext cx="36576" cy="640080"/>
+          </a:xfrm>
+          <a:prstGeom prst="rect">
+            <a:avLst/>
+          </a:prstGeom>
+          <a:solidFill>
+            <a:srgbClr val="00D6F2"/>
+          </a:solidFill>
+          <a:ln>
+            <a:noFill/>
+          </a:ln>
+          <a:effectLst/>
+        </p:spPr>
+        <p:style>
+          <a:lnRef idx="1">
+            <a:schemeClr val="accent1"/>
+          </a:lnRef>
+          <a:fillRef idx="3">
+            <a:schemeClr val="accent1"/>
+          </a:fillRef>
+          <a:effectRef idx="2">
+            <a:schemeClr val="accent1"/>
+          </a:effectRef>
+          <a:fontRef idx="minor">
+            <a:schemeClr val="lt1"/>
+          </a:fontRef>
+        </p:style>
+        <p:txBody>
+          <a:bodyPr rtlCol="0" anchor="ctr"/>
+          <a:lstStyle/>
+          <a:p/>
+        </p:txBody>
+      </p:sp>
+      <p:sp>
+        <p:nvSpPr>
+          <p:cNvPr id="86" name="Text 85"/>
+          <p:cNvSpPr txBox="1"/>
+          <p:nvPr/>
+        </p:nvSpPr>
+        <p:spPr>
+          <a:xfrm>
+            <a:off x="4329683" y="5394960"/>
+            <a:ext cx="2281427" cy="640080"/>
+          </a:xfrm>
+          <a:prstGeom prst="rect">
+            <a:avLst/>
+          </a:prstGeom>
+          <a:noFill/>
+        </p:spPr>
+        <p:txBody>
+          <a:bodyPr wrap="square" lIns="0" rIns="0" tIns="0" bIns="0" anchor="ctr">
+            <a:spAutoFit/>
+          </a:bodyPr>
+          <a:lstStyle/>
+          <a:p>
+            <a:pPr>
+              <a:spcAft>
+                <a:spcPts val="100"/>
+              </a:spcAft>
+            </a:pPr>
+            <a:r>
+              <a:rPr sz="700" b="1" i="0">
+                <a:solidFill>
+                  <a:srgbClr val="F2F2F2"/>
+                </a:solidFill>
+                <a:latin typeface="Trenda IG Text"/>
+              </a:rPr>
+              <a:t>Year 1 at 60-70%</a:t>
+            </a:r>
+          </a:p>
+          <a:p>
+            <a:pPr>
+              <a:spcAft>
+                <a:spcPts val="100"/>
+              </a:spcAft>
+            </a:pPr>
+            <a:r>
+              <a:rPr sz="600" b="0" i="0">
+                <a:solidFill>
+                  <a:srgbClr val="B3B3B3"/>
+                </a:solidFill>
+                <a:latin typeface="Trenda IG Text"/>
+              </a:rPr>
+              <a:t>of steady state while pods onboard</a:t>
+            </a:r>
+          </a:p>
+        </p:txBody>
+      </p:sp>
+      <p:sp>
+        <p:nvSpPr>
+          <p:cNvPr id="87" name="Shape 86"/>
+          <p:cNvSpPr/>
+          <p:nvPr/>
+        </p:nvSpPr>
+        <p:spPr>
+          <a:xfrm>
+            <a:off x="6757416" y="5394960"/>
+            <a:ext cx="2464308" cy="640080"/>
+          </a:xfrm>
+          <a:prstGeom prst="rect">
+            <a:avLst/>
+          </a:prstGeom>
+          <a:solidFill>
+            <a:srgbClr val="141414"/>
+          </a:solidFill>
+          <a:ln>
+            <a:noFill/>
+          </a:ln>
+          <a:effectLst/>
+        </p:spPr>
+        <p:style>
+          <a:lnRef idx="1">
+            <a:schemeClr val="accent1"/>
+          </a:lnRef>
+          <a:fillRef idx="3">
+            <a:schemeClr val="accent1"/>
+          </a:fillRef>
+          <a:effectRef idx="2">
+            <a:schemeClr val="accent1"/>
+          </a:effectRef>
+          <a:fontRef idx="minor">
+            <a:schemeClr val="lt1"/>
+          </a:fontRef>
+        </p:style>
+        <p:txBody>
+          <a:bodyPr rtlCol="0" anchor="ctr"/>
+          <a:lstStyle/>
+          <a:p/>
+        </p:txBody>
+      </p:sp>
+      <p:sp>
+        <p:nvSpPr>
+          <p:cNvPr id="88" name="Shape 87"/>
+          <p:cNvSpPr/>
+          <p:nvPr/>
+        </p:nvSpPr>
+        <p:spPr>
+          <a:xfrm>
+            <a:off x="6757416" y="5394960"/>
+            <a:ext cx="36576" cy="640080"/>
+          </a:xfrm>
+          <a:prstGeom prst="rect">
+            <a:avLst/>
+          </a:prstGeom>
+          <a:solidFill>
+            <a:srgbClr val="00D6F2"/>
+          </a:solidFill>
+          <a:ln>
+            <a:noFill/>
+          </a:ln>
+          <a:effectLst/>
+        </p:spPr>
+        <p:style>
+          <a:lnRef idx="1">
+            <a:schemeClr val="accent1"/>
+          </a:lnRef>
+          <a:fillRef idx="3">
+            <a:schemeClr val="accent1"/>
+          </a:fillRef>
+          <a:effectRef idx="2">
+            <a:schemeClr val="accent1"/>
+          </a:effectRef>
+          <a:fontRef idx="minor">
+            <a:schemeClr val="lt1"/>
+          </a:fontRef>
+        </p:style>
+        <p:txBody>
+          <a:bodyPr rtlCol="0" anchor="ctr"/>
+          <a:lstStyle/>
+          <a:p/>
+        </p:txBody>
+      </p:sp>
+      <p:sp>
+        <p:nvSpPr>
+          <p:cNvPr id="89" name="Text 88"/>
+          <p:cNvSpPr txBox="1"/>
+          <p:nvPr/>
+        </p:nvSpPr>
+        <p:spPr>
+          <a:xfrm>
+            <a:off x="6885431" y="5394960"/>
+            <a:ext cx="2281427" cy="640080"/>
+          </a:xfrm>
+          <a:prstGeom prst="rect">
+            <a:avLst/>
+          </a:prstGeom>
+          <a:noFill/>
+        </p:spPr>
+        <p:txBody>
+          <a:bodyPr wrap="square" lIns="0" rIns="0" tIns="0" bIns="0" anchor="ctr">
+            <a:spAutoFit/>
+          </a:bodyPr>
+          <a:lstStyle/>
+          <a:p>
+            <a:pPr>
+              <a:spcAft>
+                <a:spcPts val="100"/>
+              </a:spcAft>
+            </a:pPr>
+            <a:r>
+              <a:rPr sz="700" b="1" i="0">
+                <a:solidFill>
+                  <a:srgbClr val="F2F2F2"/>
+                </a:solidFill>
+                <a:latin typeface="Trenda IG Text"/>
+              </a:rPr>
+              <a:t>Approvals stay human</a:t>
+            </a:r>
+          </a:p>
+          <a:p>
+            <a:pPr>
+              <a:spcAft>
+                <a:spcPts val="100"/>
+              </a:spcAft>
+            </a:pPr>
+            <a:r>
+              <a:rPr sz="600" b="0" i="0">
+                <a:solidFill>
+                  <a:srgbClr val="B3B3B3"/>
+                </a:solidFill>
+                <a:latin typeface="Trenda IG Text"/>
+              </a:rPr>
+              <a:t>UAT and CAB take the same time</a:t>
+            </a:r>
+          </a:p>
+        </p:txBody>
+      </p:sp>
+      <p:sp>
+        <p:nvSpPr>
+          <p:cNvPr id="90" name="Shape 89"/>
+          <p:cNvSpPr/>
+          <p:nvPr/>
+        </p:nvSpPr>
+        <p:spPr>
+          <a:xfrm>
+            <a:off x="9313164" y="5394960"/>
+            <a:ext cx="2464308" cy="640080"/>
+          </a:xfrm>
+          <a:prstGeom prst="rect">
+            <a:avLst/>
+          </a:prstGeom>
+          <a:solidFill>
+            <a:srgbClr val="141414"/>
+          </a:solidFill>
+          <a:ln>
+            <a:noFill/>
+          </a:ln>
+          <a:effectLst/>
+        </p:spPr>
+        <p:style>
+          <a:lnRef idx="1">
+            <a:schemeClr val="accent1"/>
+          </a:lnRef>
+          <a:fillRef idx="3">
+            <a:schemeClr val="accent1"/>
+          </a:fillRef>
+          <a:effectRef idx="2">
+            <a:schemeClr val="accent1"/>
+          </a:effectRef>
+          <a:fontRef idx="minor">
+            <a:schemeClr val="lt1"/>
+          </a:fontRef>
+        </p:style>
+        <p:txBody>
+          <a:bodyPr rtlCol="0" anchor="ctr"/>
+          <a:lstStyle/>
+          <a:p/>
+        </p:txBody>
+      </p:sp>
+      <p:sp>
+        <p:nvSpPr>
+          <p:cNvPr id="91" name="Shape 90"/>
+          <p:cNvSpPr/>
+          <p:nvPr/>
+        </p:nvSpPr>
+        <p:spPr>
+          <a:xfrm>
+            <a:off x="9313164" y="5394960"/>
+            <a:ext cx="36576" cy="640080"/>
+          </a:xfrm>
+          <a:prstGeom prst="rect">
+            <a:avLst/>
+          </a:prstGeom>
+          <a:solidFill>
+            <a:srgbClr val="00D6F2"/>
+          </a:solidFill>
+          <a:ln>
+            <a:noFill/>
+          </a:ln>
+          <a:effectLst/>
+        </p:spPr>
+        <p:style>
+          <a:lnRef idx="1">
+            <a:schemeClr val="accent1"/>
+          </a:lnRef>
+          <a:fillRef idx="3">
+            <a:schemeClr val="accent1"/>
+          </a:fillRef>
+          <a:effectRef idx="2">
+            <a:schemeClr val="accent1"/>
+          </a:effectRef>
+          <a:fontRef idx="minor">
+            <a:schemeClr val="lt1"/>
+          </a:fontRef>
+        </p:style>
+        <p:txBody>
+          <a:bodyPr rtlCol="0" anchor="ctr"/>
+          <a:lstStyle/>
+          <a:p/>
+        </p:txBody>
+      </p:sp>
+      <p:sp>
+        <p:nvSpPr>
+          <p:cNvPr id="92" name="Text 91"/>
+          <p:cNvSpPr txBox="1"/>
+          <p:nvPr/>
+        </p:nvSpPr>
+        <p:spPr>
+          <a:xfrm>
+            <a:off x="9441180" y="5394960"/>
+            <a:ext cx="2281427" cy="640080"/>
+          </a:xfrm>
+          <a:prstGeom prst="rect">
+            <a:avLst/>
+          </a:prstGeom>
+          <a:noFill/>
+        </p:spPr>
+        <p:txBody>
+          <a:bodyPr wrap="square" lIns="0" rIns="0" tIns="0" bIns="0" anchor="ctr">
+            <a:spAutoFit/>
+          </a:bodyPr>
+          <a:lstStyle/>
+          <a:p>
+            <a:pPr>
+              <a:spcAft>
+                <a:spcPts val="100"/>
+              </a:spcAft>
+            </a:pPr>
+            <a:r>
+              <a:rPr sz="700" b="1" i="0">
+                <a:solidFill>
+                  <a:srgbClr val="F2F2F2"/>
+                </a:solidFill>
+                <a:latin typeface="Trenda IG Text"/>
+              </a:rPr>
+              <a:t>Delivery only</a:t>
+            </a:r>
+          </a:p>
+          <a:p>
+            <a:pPr>
+              <a:spcAft>
+                <a:spcPts val="100"/>
+              </a:spcAft>
+            </a:pPr>
+            <a:r>
+              <a:rPr sz="600" b="0" i="0">
+                <a:solidFill>
+                  <a:srgbClr val="B3B3B3"/>
+                </a:solidFill>
+                <a:latin typeface="Trenda IG Text"/>
+              </a:rPr>
+              <a:t>campaign data platform and Sierra sized after Phase 0</a:t>
+            </a:r>
+          </a:p>
+        </p:txBody>
+      </p:sp>
+    </p:spTree>
   </p:cSld>
   <p:clrMapOvr>
     <a:masterClrMapping/>

</xml_diff>

<commit_message>
Lean team slide: remove the pod panel
Co-Authored-By: Claude Opus 5.5 <noreply@anthropic.com>
Claude-Session: https://claude.ai/code/session_01Hf94kqMzSofkkrQm7kpNba
</commit_message>
<xml_diff>
--- a/poc/data_harness/Ascension Agentic Harness - Data Harness.pptx
+++ b/poc/data_harness/Ascension Agentic Harness - Data Harness.pptx
@@ -1479,7 +1479,7 @@
           </a:p>
           <a:p>
             <a:r>
-              <a:t>Every squad of 4-5 developers becomes 1 developer directing the harness agent, plus 1 QA. Pods run lean on one shared platform. $16M a year today becomes $7M: $9M back every year on a $5.0M build, paid back in under 7 months.</a:t>
+              <a:t>Every squad of 4-5 developers becomes 1 developer directing the harness agent, plus 1 QA. $16M a year today becomes $7M: $9M back every year on a $5.0M build, paid back in under 7 months.</a:t>
             </a:r>
           </a:p>
           <a:p/>
@@ -1491,11 +1491,6 @@
           <a:p>
             <a:r>
               <a:t>- The squad: 4 developers and a QA today; with the harness, one developer directs the agent, a QA verifies, and the agent drafts code, tests and the Copado package overnight. People review, approve and own every change.</a:t>
-            </a:r>
-          </a:p>
-          <a:p>
-            <a:r>
-              <a:t>- The pod: today every pod carries its own full stack. With the harness: owner, lead and 2-4 engineers, on one shared platform run by a small team. 20-30% smaller for the same scope, or 1.4-1.6x the output with the same team.</a:t>
             </a:r>
           </a:p>
           <a:p>
@@ -4011,7 +4006,7 @@
         <p:spPr>
           <a:xfrm>
             <a:off x="411480" y="1188720"/>
-            <a:ext cx="3715512" cy="1965960"/>
+            <a:ext cx="5628132" cy="1965960"/>
           </a:xfrm>
           <a:prstGeom prst="roundRect">
             <a:avLst>
@@ -4055,7 +4050,7 @@
         <p:spPr>
           <a:xfrm>
             <a:off x="411480" y="1188720"/>
-            <a:ext cx="3715512" cy="256032"/>
+            <a:ext cx="5628132" cy="256032"/>
           </a:xfrm>
           <a:prstGeom prst="rect">
             <a:avLst/>
@@ -4097,7 +4092,7 @@
         <p:spPr>
           <a:xfrm>
             <a:off x="521208" y="1188720"/>
-            <a:ext cx="3496056" cy="256032"/>
+            <a:ext cx="5408676" cy="256032"/>
           </a:xfrm>
           <a:prstGeom prst="rect">
             <a:avLst/>
@@ -4174,7 +4169,7 @@
         <p:spPr>
           <a:xfrm>
             <a:off x="539496" y="1719072"/>
-            <a:ext cx="648004" cy="274320"/>
+            <a:ext cx="1030528" cy="274320"/>
           </a:xfrm>
           <a:prstGeom prst="roundRect">
             <a:avLst>
@@ -4220,7 +4215,7 @@
         <p:spPr>
           <a:xfrm>
             <a:off x="539496" y="1719072"/>
-            <a:ext cx="648004" cy="274320"/>
+            <a:ext cx="1030528" cy="274320"/>
           </a:xfrm>
           <a:prstGeom prst="rect">
             <a:avLst/>
@@ -4254,8 +4249,8 @@
         </p:nvSpPr>
         <p:spPr>
           <a:xfrm>
-            <a:off x="1242364" y="1719072"/>
-            <a:ext cx="648004" cy="274320"/>
+            <a:off x="1624888" y="1719072"/>
+            <a:ext cx="1030528" cy="274320"/>
           </a:xfrm>
           <a:prstGeom prst="roundRect">
             <a:avLst>
@@ -4300,8 +4295,8 @@
         </p:nvSpPr>
         <p:spPr>
           <a:xfrm>
-            <a:off x="1242364" y="1719072"/>
-            <a:ext cx="648004" cy="274320"/>
+            <a:off x="1624888" y="1719072"/>
+            <a:ext cx="1030528" cy="274320"/>
           </a:xfrm>
           <a:prstGeom prst="rect">
             <a:avLst/>
@@ -4335,8 +4330,8 @@
         </p:nvSpPr>
         <p:spPr>
           <a:xfrm>
-            <a:off x="1945233" y="1719072"/>
-            <a:ext cx="648004" cy="274320"/>
+            <a:off x="2710281" y="1719072"/>
+            <a:ext cx="1030528" cy="274320"/>
           </a:xfrm>
           <a:prstGeom prst="roundRect">
             <a:avLst>
@@ -4381,8 +4376,8 @@
         </p:nvSpPr>
         <p:spPr>
           <a:xfrm>
-            <a:off x="1945233" y="1719072"/>
-            <a:ext cx="648004" cy="274320"/>
+            <a:off x="2710281" y="1719072"/>
+            <a:ext cx="1030528" cy="274320"/>
           </a:xfrm>
           <a:prstGeom prst="rect">
             <a:avLst/>
@@ -4416,8 +4411,8 @@
         </p:nvSpPr>
         <p:spPr>
           <a:xfrm>
-            <a:off x="2648102" y="1719072"/>
-            <a:ext cx="648004" cy="274320"/>
+            <a:off x="3795674" y="1719072"/>
+            <a:ext cx="1030528" cy="274320"/>
           </a:xfrm>
           <a:prstGeom prst="roundRect">
             <a:avLst>
@@ -4462,8 +4457,8 @@
         </p:nvSpPr>
         <p:spPr>
           <a:xfrm>
-            <a:off x="2648102" y="1719072"/>
-            <a:ext cx="648004" cy="274320"/>
+            <a:off x="3795674" y="1719072"/>
+            <a:ext cx="1030528" cy="274320"/>
           </a:xfrm>
           <a:prstGeom prst="rect">
             <a:avLst/>
@@ -4497,8 +4492,8 @@
         </p:nvSpPr>
         <p:spPr>
           <a:xfrm>
-            <a:off x="3350971" y="1719072"/>
-            <a:ext cx="648004" cy="274320"/>
+            <a:off x="4881067" y="1719072"/>
+            <a:ext cx="1030528" cy="274320"/>
           </a:xfrm>
           <a:prstGeom prst="roundRect">
             <a:avLst>
@@ -4543,8 +4538,8 @@
         </p:nvSpPr>
         <p:spPr>
           <a:xfrm>
-            <a:off x="3350971" y="1719072"/>
-            <a:ext cx="648004" cy="274320"/>
+            <a:off x="4881067" y="1719072"/>
+            <a:ext cx="1030528" cy="274320"/>
           </a:xfrm>
           <a:prstGeom prst="rect">
             <a:avLst/>
@@ -4613,7 +4608,7 @@
         <p:spPr>
           <a:xfrm>
             <a:off x="539496" y="2267712"/>
-            <a:ext cx="1116584" cy="274320"/>
+            <a:ext cx="1754124" cy="274320"/>
           </a:xfrm>
           <a:prstGeom prst="roundRect">
             <a:avLst>
@@ -4659,7 +4654,7 @@
         <p:spPr>
           <a:xfrm>
             <a:off x="539496" y="2267712"/>
-            <a:ext cx="1116584" cy="274320"/>
+            <a:ext cx="1754124" cy="274320"/>
           </a:xfrm>
           <a:prstGeom prst="rect">
             <a:avLst/>
@@ -4693,8 +4688,8 @@
         </p:nvSpPr>
         <p:spPr>
           <a:xfrm>
-            <a:off x="1710944" y="2267712"/>
-            <a:ext cx="1116584" cy="274320"/>
+            <a:off x="2348484" y="2267712"/>
+            <a:ext cx="1754124" cy="274320"/>
           </a:xfrm>
           <a:prstGeom prst="roundRect">
             <a:avLst>
@@ -4747,7 +4742,7 @@
         </p:blipFill>
         <p:spPr>
           <a:xfrm>
-            <a:off x="1784096" y="2322576"/>
+            <a:off x="2421636" y="2322576"/>
             <a:ext cx="164592" cy="164592"/>
           </a:xfrm>
           <a:prstGeom prst="rect">
@@ -4763,8 +4758,8 @@
         </p:nvSpPr>
         <p:spPr>
           <a:xfrm>
-            <a:off x="1930400" y="2267712"/>
-            <a:ext cx="860551" cy="274320"/>
+            <a:off x="2567940" y="2267712"/>
+            <a:ext cx="1498091" cy="274320"/>
           </a:xfrm>
           <a:prstGeom prst="rect">
             <a:avLst/>
@@ -4798,8 +4793,8 @@
         </p:nvSpPr>
         <p:spPr>
           <a:xfrm>
-            <a:off x="2882392" y="2267712"/>
-            <a:ext cx="1116584" cy="274320"/>
+            <a:off x="4157472" y="2267712"/>
+            <a:ext cx="1754124" cy="274320"/>
           </a:xfrm>
           <a:prstGeom prst="roundRect">
             <a:avLst>
@@ -4844,8 +4839,8 @@
         </p:nvSpPr>
         <p:spPr>
           <a:xfrm>
-            <a:off x="2882392" y="2267712"/>
-            <a:ext cx="1116584" cy="274320"/>
+            <a:off x="4157472" y="2267712"/>
+            <a:ext cx="1754124" cy="274320"/>
           </a:xfrm>
           <a:prstGeom prst="rect">
             <a:avLst/>
@@ -4880,7 +4875,7 @@
         <p:spPr>
           <a:xfrm>
             <a:off x="539496" y="2615184"/>
-            <a:ext cx="3459480" cy="384048"/>
+            <a:ext cx="5372100" cy="384048"/>
           </a:xfrm>
           <a:prstGeom prst="rect">
             <a:avLst/>
@@ -4958,8 +4953,8 @@
         </p:nvSpPr>
         <p:spPr>
           <a:xfrm>
-            <a:off x="4236720" y="1188720"/>
-            <a:ext cx="3715512" cy="1965960"/>
+            <a:off x="6149340" y="1188720"/>
+            <a:ext cx="5628132" cy="1965960"/>
           </a:xfrm>
           <a:prstGeom prst="roundRect">
             <a:avLst>
@@ -5002,8 +4997,8 @@
         </p:nvSpPr>
         <p:spPr>
           <a:xfrm>
-            <a:off x="4236720" y="1188720"/>
-            <a:ext cx="3715512" cy="256032"/>
+            <a:off x="6149340" y="1188720"/>
+            <a:ext cx="5628132" cy="256032"/>
           </a:xfrm>
           <a:prstGeom prst="rect">
             <a:avLst/>
@@ -5044,8 +5039,8 @@
         </p:nvSpPr>
         <p:spPr>
           <a:xfrm>
-            <a:off x="4346448" y="1188720"/>
-            <a:ext cx="3496056" cy="256032"/>
+            <a:off x="6259068" y="1188720"/>
+            <a:ext cx="5408676" cy="256032"/>
           </a:xfrm>
           <a:prstGeom prst="rect">
             <a:avLst/>
@@ -5065,7 +5060,7 @@
                 </a:solidFill>
                 <a:latin typeface="Trenda IG Text"/>
               </a:rPr>
-              <a:t>THE POD</a:t>
+              <a:t>THE BUILD AND RUN</a:t>
             </a:r>
             <a:r>
               <a:rPr sz="640" b="0" i="0">
@@ -5074,68 +5069,30 @@
                 </a:solidFill>
                 <a:latin typeface="Trenda IG Text"/>
               </a:rPr>
-              <a:t>   lean pods share one platform</a:t>
-            </a:r>
-          </a:p>
-        </p:txBody>
-      </p:sp>
-      <p:sp>
-        <p:nvSpPr>
-          <p:cNvPr id="31" name="Text 29"/>
-          <p:cNvSpPr txBox="1"/>
-          <p:nvPr/>
-        </p:nvSpPr>
-        <p:spPr>
-          <a:xfrm>
-            <a:off x="4364736" y="1536192"/>
-            <a:ext cx="1828800" cy="164592"/>
-          </a:xfrm>
-          <a:prstGeom prst="rect">
-            <a:avLst/>
-          </a:prstGeom>
-          <a:noFill/>
-        </p:spPr>
-        <p:txBody>
-          <a:bodyPr wrap="square" lIns="0" rIns="0" tIns="0" bIns="0" anchor="ctr">
-            <a:spAutoFit/>
-          </a:bodyPr>
-          <a:lstStyle/>
-          <a:p>
-            <a:r>
-              <a:rPr sz="540" b="1" i="0" spc="100">
-                <a:solidFill>
-                  <a:srgbClr val="8C8C8C"/>
-                </a:solidFill>
-                <a:latin typeface="Trenda IG Text"/>
-              </a:rPr>
-              <a:t>TODAY · EVERY POD, FULL STACK</a:t>
-            </a:r>
-          </a:p>
-        </p:txBody>
-      </p:sp>
-      <p:sp>
-        <p:nvSpPr>
-          <p:cNvPr id="32" name="Shape 30"/>
+              <a:t>   fixed fee, paid by gate</a:t>
+            </a:r>
+          </a:p>
+        </p:txBody>
+      </p:sp>
+      <p:sp>
+        <p:nvSpPr>
+          <p:cNvPr id="31" name="Shape 29"/>
           <p:cNvSpPr/>
           <p:nvPr/>
         </p:nvSpPr>
         <p:spPr>
           <a:xfrm>
-            <a:off x="4364736" y="1719072"/>
-            <a:ext cx="3459480" cy="274320"/>
-          </a:xfrm>
-          <a:prstGeom prst="roundRect">
-            <a:avLst>
-              <a:gd name="adj" fmla="val 25000"/>
-            </a:avLst>
+            <a:off x="6277356" y="1554480"/>
+            <a:ext cx="1741932" cy="896112"/>
+          </a:xfrm>
+          <a:prstGeom prst="rect">
+            <a:avLst/>
           </a:prstGeom>
           <a:solidFill>
             <a:srgbClr val="141414"/>
           </a:solidFill>
-          <a:ln w="9525">
-            <a:solidFill>
-              <a:srgbClr val="333333"/>
-            </a:solidFill>
+          <a:ln>
+            <a:noFill/>
           </a:ln>
           <a:effectLst/>
         </p:spPr>
@@ -5161,96 +5118,91 @@
       </p:sp>
       <p:sp>
         <p:nvSpPr>
+          <p:cNvPr id="32" name="Text 30"/>
+          <p:cNvSpPr txBox="1"/>
+          <p:nvPr/>
+        </p:nvSpPr>
+        <p:spPr>
+          <a:xfrm>
+            <a:off x="6368796" y="1591056"/>
+            <a:ext cx="1613916" cy="402336"/>
+          </a:xfrm>
+          <a:prstGeom prst="rect">
+            <a:avLst/>
+          </a:prstGeom>
+          <a:noFill/>
+        </p:spPr>
+        <p:txBody>
+          <a:bodyPr wrap="square" lIns="0" rIns="0" tIns="0" bIns="0" anchor="ctr">
+            <a:spAutoFit/>
+          </a:bodyPr>
+          <a:lstStyle/>
+          <a:p>
+            <a:r>
+              <a:rPr sz="1600" b="0" i="0">
+                <a:solidFill>
+                  <a:srgbClr val="F2F2F2"/>
+                </a:solidFill>
+                <a:latin typeface="Trenda IG Text"/>
+              </a:rPr>
+              <a:t>17</a:t>
+            </a:r>
+          </a:p>
+        </p:txBody>
+      </p:sp>
+      <p:sp>
+        <p:nvSpPr>
           <p:cNvPr id="33" name="Text 31"/>
           <p:cNvSpPr txBox="1"/>
           <p:nvPr/>
         </p:nvSpPr>
         <p:spPr>
           <a:xfrm>
-            <a:off x="4364736" y="1719072"/>
-            <a:ext cx="3459480" cy="274320"/>
-          </a:xfrm>
-          <a:prstGeom prst="rect">
-            <a:avLst/>
-          </a:prstGeom>
-          <a:noFill/>
-        </p:spPr>
-        <p:txBody>
-          <a:bodyPr wrap="square" lIns="0" rIns="0" tIns="0" bIns="0" anchor="ctr">
-            <a:spAutoFit/>
-          </a:bodyPr>
-          <a:lstStyle/>
-          <a:p>
-            <a:pPr algn="ctr"/>
-            <a:r>
-              <a:rPr sz="620" b="1" i="0">
+            <a:off x="6368796" y="1993392"/>
+            <a:ext cx="1613916" cy="420624"/>
+          </a:xfrm>
+          <a:prstGeom prst="rect">
+            <a:avLst/>
+          </a:prstGeom>
+          <a:noFill/>
+        </p:spPr>
+        <p:txBody>
+          <a:bodyPr wrap="square" lIns="0" rIns="0" tIns="0" bIns="0" anchor="t">
+            <a:spAutoFit/>
+          </a:bodyPr>
+          <a:lstStyle/>
+          <a:p>
+            <a:r>
+              <a:rPr sz="590" b="0" i="0">
                 <a:solidFill>
                   <a:srgbClr val="B3B3B3"/>
                 </a:solidFill>
                 <a:latin typeface="Trenda IG Text"/>
               </a:rPr>
-              <a:t>BA · Devs · QA · Release · Support</a:t>
-            </a:r>
-          </a:p>
-        </p:txBody>
-      </p:sp>
-      <p:sp>
-        <p:nvSpPr>
-          <p:cNvPr id="34" name="Text 32"/>
-          <p:cNvSpPr txBox="1"/>
-          <p:nvPr/>
-        </p:nvSpPr>
-        <p:spPr>
-          <a:xfrm>
-            <a:off x="4364736" y="2084832"/>
-            <a:ext cx="2194560" cy="164592"/>
-          </a:xfrm>
-          <a:prstGeom prst="rect">
-            <a:avLst/>
-          </a:prstGeom>
-          <a:noFill/>
-        </p:spPr>
-        <p:txBody>
-          <a:bodyPr wrap="square" lIns="0" rIns="0" tIns="0" bIns="0" anchor="ctr">
-            <a:spAutoFit/>
-          </a:bodyPr>
-          <a:lstStyle/>
-          <a:p>
-            <a:r>
-              <a:rPr sz="540" b="1" i="0" spc="100">
-                <a:solidFill>
-                  <a:srgbClr val="00D6F2"/>
-                </a:solidFill>
-                <a:latin typeface="Trenda IG Text"/>
-              </a:rPr>
-              <a:t>WITH THE HARNESS</a:t>
-            </a:r>
-          </a:p>
-        </p:txBody>
-      </p:sp>
-      <p:sp>
-        <p:nvSpPr>
-          <p:cNvPr id="35" name="Shape 33"/>
+              <a:t>people at peak, 10 roles</a:t>
+            </a:r>
+          </a:p>
+        </p:txBody>
+      </p:sp>
+      <p:sp>
+        <p:nvSpPr>
+          <p:cNvPr id="34" name="Shape 32"/>
           <p:cNvSpPr/>
           <p:nvPr/>
         </p:nvSpPr>
         <p:spPr>
           <a:xfrm>
-            <a:off x="4364736" y="2267712"/>
-            <a:ext cx="1872538" cy="274320"/>
-          </a:xfrm>
-          <a:prstGeom prst="roundRect">
-            <a:avLst>
-              <a:gd name="adj" fmla="val 25000"/>
-            </a:avLst>
+            <a:off x="8092440" y="1554480"/>
+            <a:ext cx="1741932" cy="896112"/>
+          </a:xfrm>
+          <a:prstGeom prst="rect">
+            <a:avLst/>
           </a:prstGeom>
           <a:solidFill>
             <a:srgbClr val="141414"/>
           </a:solidFill>
-          <a:ln w="9525">
-            <a:solidFill>
-              <a:srgbClr val="00D6F2"/>
-            </a:solidFill>
+          <a:ln>
+            <a:noFill/>
           </a:ln>
           <a:effectLst/>
         </p:spPr>
@@ -5276,35 +5228,68 @@
       </p:sp>
       <p:sp>
         <p:nvSpPr>
+          <p:cNvPr id="35" name="Text 33"/>
+          <p:cNvSpPr txBox="1"/>
+          <p:nvPr/>
+        </p:nvSpPr>
+        <p:spPr>
+          <a:xfrm>
+            <a:off x="8183879" y="1591056"/>
+            <a:ext cx="1613916" cy="402336"/>
+          </a:xfrm>
+          <a:prstGeom prst="rect">
+            <a:avLst/>
+          </a:prstGeom>
+          <a:noFill/>
+        </p:spPr>
+        <p:txBody>
+          <a:bodyPr wrap="square" lIns="0" rIns="0" tIns="0" bIns="0" anchor="ctr">
+            <a:spAutoFit/>
+          </a:bodyPr>
+          <a:lstStyle/>
+          <a:p>
+            <a:r>
+              <a:rPr sz="1600" b="0" i="0">
+                <a:solidFill>
+                  <a:srgbClr val="F2F2F2"/>
+                </a:solidFill>
+                <a:latin typeface="Trenda IG Text"/>
+              </a:rPr>
+              <a:t>18</a:t>
+            </a:r>
+          </a:p>
+        </p:txBody>
+      </p:sp>
+      <p:sp>
+        <p:nvSpPr>
           <p:cNvPr id="36" name="Text 34"/>
           <p:cNvSpPr txBox="1"/>
           <p:nvPr/>
         </p:nvSpPr>
         <p:spPr>
           <a:xfrm>
-            <a:off x="4364736" y="2267712"/>
-            <a:ext cx="1872538" cy="274320"/>
-          </a:xfrm>
-          <a:prstGeom prst="rect">
-            <a:avLst/>
-          </a:prstGeom>
-          <a:noFill/>
-        </p:spPr>
-        <p:txBody>
-          <a:bodyPr wrap="square" lIns="0" rIns="0" tIns="0" bIns="0" anchor="ctr">
-            <a:spAutoFit/>
-          </a:bodyPr>
-          <a:lstStyle/>
-          <a:p>
-            <a:pPr algn="ctr"/>
-            <a:r>
-              <a:rPr sz="600" b="1" i="0">
-                <a:solidFill>
-                  <a:srgbClr val="F2F2F2"/>
-                </a:solidFill>
-                <a:latin typeface="Trenda IG Text"/>
-              </a:rPr>
-              <a:t>Owner · Lead · 2-4 engineers</a:t>
+            <a:off x="8183879" y="1993392"/>
+            <a:ext cx="1613916" cy="420624"/>
+          </a:xfrm>
+          <a:prstGeom prst="rect">
+            <a:avLst/>
+          </a:prstGeom>
+          <a:noFill/>
+        </p:spPr>
+        <p:txBody>
+          <a:bodyPr wrap="square" lIns="0" rIns="0" tIns="0" bIns="0" anchor="t">
+            <a:spAutoFit/>
+          </a:bodyPr>
+          <a:lstStyle/>
+          <a:p>
+            <a:r>
+              <a:rPr sz="590" b="0" i="0">
+                <a:solidFill>
+                  <a:srgbClr val="B3B3B3"/>
+                </a:solidFill>
+                <a:latin typeface="Trenda IG Text"/>
+              </a:rPr>
+              <a:t>months, seven phases</a:t>
             </a:r>
           </a:p>
         </p:txBody>
@@ -5317,21 +5302,17 @@
         </p:nvSpPr>
         <p:spPr>
           <a:xfrm>
-            <a:off x="6292138" y="2267712"/>
-            <a:ext cx="1532077" cy="274320"/>
-          </a:xfrm>
-          <a:prstGeom prst="roundRect">
-            <a:avLst>
-              <a:gd name="adj" fmla="val 25000"/>
-            </a:avLst>
+            <a:off x="9907524" y="1554480"/>
+            <a:ext cx="1741932" cy="896112"/>
+          </a:xfrm>
+          <a:prstGeom prst="rect">
+            <a:avLst/>
           </a:prstGeom>
           <a:solidFill>
-            <a:srgbClr val="06262B"/>
+            <a:srgbClr val="141414"/>
           </a:solidFill>
-          <a:ln w="9525">
-            <a:solidFill>
-              <a:srgbClr val="00D6F2"/>
-            </a:solidFill>
+          <a:ln>
+            <a:noFill/>
           </a:ln>
           <a:effectLst/>
         </p:spPr>
@@ -5363,8 +5344,8 @@
         </p:nvSpPr>
         <p:spPr>
           <a:xfrm>
-            <a:off x="6292138" y="2267712"/>
-            <a:ext cx="1532077" cy="274320"/>
+            <a:off x="9998964" y="1591056"/>
+            <a:ext cx="1613916" cy="402336"/>
           </a:xfrm>
           <a:prstGeom prst="rect">
             <a:avLst/>
@@ -5377,52 +5358,83 @@
           </a:bodyPr>
           <a:lstStyle/>
           <a:p>
-            <a:pPr algn="ctr"/>
+            <a:r>
+              <a:rPr sz="1600" b="0" i="0">
+                <a:solidFill>
+                  <a:srgbClr val="F2F2F2"/>
+                </a:solidFill>
+                <a:latin typeface="Trenda IG Text"/>
+              </a:rPr>
+              <a:t>$4.79M</a:t>
+            </a:r>
+          </a:p>
+        </p:txBody>
+      </p:sp>
+      <p:sp>
+        <p:nvSpPr>
+          <p:cNvPr id="39" name="Text 37"/>
+          <p:cNvSpPr txBox="1"/>
+          <p:nvPr/>
+        </p:nvSpPr>
+        <p:spPr>
+          <a:xfrm>
+            <a:off x="9998964" y="1993392"/>
+            <a:ext cx="1613916" cy="420624"/>
+          </a:xfrm>
+          <a:prstGeom prst="rect">
+            <a:avLst/>
+          </a:prstGeom>
+          <a:noFill/>
+        </p:spPr>
+        <p:txBody>
+          <a:bodyPr wrap="square" lIns="0" rIns="0" tIns="0" bIns="0" anchor="t">
+            <a:spAutoFit/>
+          </a:bodyPr>
+          <a:lstStyle/>
+          <a:p>
+            <a:r>
+              <a:rPr sz="590" b="0" i="0">
+                <a:solidFill>
+                  <a:srgbClr val="B3B3B3"/>
+                </a:solidFill>
+                <a:latin typeface="Trenda IG Text"/>
+              </a:rPr>
+              <a:t>fixed fee, paid as each gate is signed</a:t>
+            </a:r>
+          </a:p>
+        </p:txBody>
+      </p:sp>
+      <p:sp>
+        <p:nvSpPr>
+          <p:cNvPr id="40" name="Text 38"/>
+          <p:cNvSpPr txBox="1"/>
+          <p:nvPr/>
+        </p:nvSpPr>
+        <p:spPr>
+          <a:xfrm>
+            <a:off x="6277356" y="2542032"/>
+            <a:ext cx="5372100" cy="457200"/>
+          </a:xfrm>
+          <a:prstGeom prst="rect">
+            <a:avLst/>
+          </a:prstGeom>
+          <a:noFill/>
+        </p:spPr>
+        <p:txBody>
+          <a:bodyPr wrap="square" lIns="0" rIns="0" tIns="0" bIns="0" anchor="t">
+            <a:spAutoFit/>
+          </a:bodyPr>
+          <a:lstStyle/>
+          <a:p>
             <a:r>
               <a:rPr sz="600" b="1" i="0">
                 <a:solidFill>
-                  <a:srgbClr val="00D6F2"/>
-                </a:solidFill>
-                <a:latin typeface="Trenda IG Text"/>
-              </a:rPr>
-              <a:t>Shared platform</a:t>
-            </a:r>
-          </a:p>
-        </p:txBody>
-      </p:sp>
-      <p:sp>
-        <p:nvSpPr>
-          <p:cNvPr id="39" name="Text 37"/>
-          <p:cNvSpPr txBox="1"/>
-          <p:nvPr/>
-        </p:nvSpPr>
-        <p:spPr>
-          <a:xfrm>
-            <a:off x="4364736" y="2615184"/>
-            <a:ext cx="1702308" cy="384048"/>
-          </a:xfrm>
-          <a:prstGeom prst="rect">
-            <a:avLst/>
-          </a:prstGeom>
-          <a:noFill/>
-        </p:spPr>
-        <p:txBody>
-          <a:bodyPr wrap="square" lIns="0" rIns="0" tIns="0" bIns="0" anchor="ctr">
-            <a:spAutoFit/>
-          </a:bodyPr>
-          <a:lstStyle/>
-          <a:p>
-            <a:r>
-              <a:rPr sz="1200" b="0" i="0">
-                <a:solidFill>
-                  <a:srgbClr val="00D6F2"/>
-                </a:solidFill>
-                <a:latin typeface="Trenda IG Text"/>
-              </a:rPr>
-              <a:t>20-30%</a:t>
-            </a:r>
-          </a:p>
-          <a:p>
+                  <a:srgbClr val="F2F2F2"/>
+                </a:solidFill>
+                <a:latin typeface="Trenda IG Text"/>
+              </a:rPr>
+              <a:t>From month 19 </a:t>
+            </a:r>
             <a:r>
               <a:rPr sz="600" b="0" i="0">
                 <a:solidFill>
@@ -5430,52 +5442,7 @@
                 </a:solidFill>
                 <a:latin typeface="Trenda IG Text"/>
               </a:rPr>
-              <a:t>smaller team, same scope</a:t>
-            </a:r>
-          </a:p>
-        </p:txBody>
-      </p:sp>
-      <p:sp>
-        <p:nvSpPr>
-          <p:cNvPr id="40" name="Text 38"/>
-          <p:cNvSpPr txBox="1"/>
-          <p:nvPr/>
-        </p:nvSpPr>
-        <p:spPr>
-          <a:xfrm>
-            <a:off x="6121908" y="2615184"/>
-            <a:ext cx="1702308" cy="384048"/>
-          </a:xfrm>
-          <a:prstGeom prst="rect">
-            <a:avLst/>
-          </a:prstGeom>
-          <a:noFill/>
-        </p:spPr>
-        <p:txBody>
-          <a:bodyPr wrap="square" lIns="0" rIns="0" tIns="0" bIns="0" anchor="ctr">
-            <a:spAutoFit/>
-          </a:bodyPr>
-          <a:lstStyle/>
-          <a:p>
-            <a:r>
-              <a:rPr sz="1200" b="0" i="0">
-                <a:solidFill>
-                  <a:srgbClr val="00D6F2"/>
-                </a:solidFill>
-                <a:latin typeface="Trenda IG Text"/>
-              </a:rPr>
-              <a:t>1.4-1.6x</a:t>
-            </a:r>
-          </a:p>
-          <a:p>
-            <a:r>
-              <a:rPr sz="600" b="0" i="0">
-                <a:solidFill>
-                  <a:srgbClr val="B3B3B3"/>
-                </a:solidFill>
-                <a:latin typeface="Trenda IG Text"/>
-              </a:rPr>
-              <a:t>output, same team</a:t>
+              <a:t>a run team of 4 keeps the graph, agents and evals current: about $1.24M a year with platform usage.</a:t>
             </a:r>
           </a:p>
         </p:txBody>
@@ -5488,8 +5455,8 @@
         </p:nvSpPr>
         <p:spPr>
           <a:xfrm>
-            <a:off x="8061960" y="1188720"/>
-            <a:ext cx="3715512" cy="1965960"/>
+            <a:off x="411480" y="3291840"/>
+            <a:ext cx="11365992" cy="1965960"/>
           </a:xfrm>
           <a:prstGeom prst="roundRect">
             <a:avLst>
@@ -5532,8 +5499,8 @@
         </p:nvSpPr>
         <p:spPr>
           <a:xfrm>
-            <a:off x="8061960" y="1188720"/>
-            <a:ext cx="3715512" cy="256032"/>
+            <a:off x="411480" y="3291840"/>
+            <a:ext cx="11365992" cy="256032"/>
           </a:xfrm>
           <a:prstGeom prst="rect">
             <a:avLst/>
@@ -5574,8 +5541,8 @@
         </p:nvSpPr>
         <p:spPr>
           <a:xfrm>
-            <a:off x="8171687" y="1188720"/>
-            <a:ext cx="3496056" cy="256032"/>
+            <a:off x="521208" y="3291840"/>
+            <a:ext cx="11146536" cy="256032"/>
           </a:xfrm>
           <a:prstGeom prst="rect">
             <a:avLst/>
@@ -5595,7 +5562,7 @@
                 </a:solidFill>
                 <a:latin typeface="Trenda IG Text"/>
               </a:rPr>
-              <a:t>THE BUILD AND RUN</a:t>
+              <a:t>THE RETURN</a:t>
             </a:r>
             <a:r>
               <a:rPr sz="640" b="0" i="0">
@@ -5604,7 +5571,7 @@
                 </a:solidFill>
                 <a:latin typeface="Trenda IG Text"/>
               </a:rPr>
-              <a:t>   fixed fee, paid by gate</a:t>
+              <a:t>   target · first full year after go-live</a:t>
             </a:r>
           </a:p>
         </p:txBody>
@@ -5617,8 +5584,8 @@
         </p:nvSpPr>
         <p:spPr>
           <a:xfrm>
-            <a:off x="8189976" y="1554480"/>
-            <a:ext cx="1104391" cy="896112"/>
+            <a:off x="539496" y="3639312"/>
+            <a:ext cx="1796796" cy="1490472"/>
           </a:xfrm>
           <a:prstGeom prst="rect">
             <a:avLst/>
@@ -5659,8 +5626,8 @@
         </p:nvSpPr>
         <p:spPr>
           <a:xfrm>
-            <a:off x="8281416" y="1591056"/>
-            <a:ext cx="976376" cy="402336"/>
+            <a:off x="667512" y="3977639"/>
+            <a:ext cx="1577340" cy="457200"/>
           </a:xfrm>
           <a:prstGeom prst="rect">
             <a:avLst/>
@@ -5674,13 +5641,13 @@
           <a:lstStyle/>
           <a:p>
             <a:r>
-              <a:rPr sz="1600" b="0" i="0">
+              <a:rPr sz="2200" b="0" i="0">
                 <a:solidFill>
                   <a:srgbClr val="F2F2F2"/>
                 </a:solidFill>
                 <a:latin typeface="Trenda IG Text"/>
               </a:rPr>
-              <a:t>17</a:t>
+              <a:t>$16M</a:t>
             </a:r>
           </a:p>
         </p:txBody>
@@ -5693,42 +5660,76 @@
         </p:nvSpPr>
         <p:spPr>
           <a:xfrm>
-            <a:off x="8281416" y="1993392"/>
-            <a:ext cx="976376" cy="420624"/>
-          </a:xfrm>
-          <a:prstGeom prst="rect">
-            <a:avLst/>
-          </a:prstGeom>
-          <a:noFill/>
-        </p:spPr>
-        <p:txBody>
-          <a:bodyPr wrap="square" lIns="0" rIns="0" tIns="0" bIns="0" anchor="t">
-            <a:spAutoFit/>
-          </a:bodyPr>
-          <a:lstStyle/>
-          <a:p>
-            <a:r>
-              <a:rPr sz="590" b="0" i="0">
+            <a:off x="667512" y="4453127"/>
+            <a:ext cx="1577340" cy="201168"/>
+          </a:xfrm>
+          <a:prstGeom prst="rect">
+            <a:avLst/>
+          </a:prstGeom>
+          <a:noFill/>
+        </p:spPr>
+        <p:txBody>
+          <a:bodyPr wrap="square" lIns="0" rIns="0" tIns="0" bIns="0" anchor="ctr">
+            <a:spAutoFit/>
+          </a:bodyPr>
+          <a:lstStyle/>
+          <a:p>
+            <a:r>
+              <a:rPr sz="700" b="1" i="0">
+                <a:solidFill>
+                  <a:srgbClr val="F2F2F2"/>
+                </a:solidFill>
+                <a:latin typeface="Trenda IG Text"/>
+              </a:rPr>
+              <a:t>a year today</a:t>
+            </a:r>
+          </a:p>
+        </p:txBody>
+      </p:sp>
+      <p:sp>
+        <p:nvSpPr>
+          <p:cNvPr id="47" name="Text 45"/>
+          <p:cNvSpPr txBox="1"/>
+          <p:nvPr/>
+        </p:nvSpPr>
+        <p:spPr>
+          <a:xfrm>
+            <a:off x="667512" y="4654296"/>
+            <a:ext cx="1577340" cy="201168"/>
+          </a:xfrm>
+          <a:prstGeom prst="rect">
+            <a:avLst/>
+          </a:prstGeom>
+          <a:noFill/>
+        </p:spPr>
+        <p:txBody>
+          <a:bodyPr wrap="square" lIns="0" rIns="0" tIns="0" bIns="0" anchor="ctr">
+            <a:spAutoFit/>
+          </a:bodyPr>
+          <a:lstStyle/>
+          <a:p>
+            <a:r>
+              <a:rPr sz="600" b="0" i="0">
                 <a:solidFill>
                   <a:srgbClr val="B3B3B3"/>
                 </a:solidFill>
                 <a:latin typeface="Trenda IG Text"/>
               </a:rPr>
-              <a:t>people at peak, 10 roles</a:t>
-            </a:r>
-          </a:p>
-        </p:txBody>
-      </p:sp>
-      <p:sp>
-        <p:nvSpPr>
-          <p:cNvPr id="47" name="Shape 45"/>
+              <a:t>as provided by Ascension</a:t>
+            </a:r>
+          </a:p>
+        </p:txBody>
+      </p:sp>
+      <p:sp>
+        <p:nvSpPr>
+          <p:cNvPr id="48" name="Shape 46"/>
           <p:cNvSpPr/>
           <p:nvPr/>
         </p:nvSpPr>
         <p:spPr>
           <a:xfrm>
-            <a:off x="9367520" y="1554480"/>
-            <a:ext cx="1104391" cy="896112"/>
+            <a:off x="2427732" y="3639312"/>
+            <a:ext cx="1796796" cy="1490472"/>
           </a:xfrm>
           <a:prstGeom prst="rect">
             <a:avLst/>
@@ -5763,543 +5764,7 @@
       </p:sp>
       <p:sp>
         <p:nvSpPr>
-          <p:cNvPr id="48" name="Text 46"/>
-          <p:cNvSpPr txBox="1"/>
-          <p:nvPr/>
-        </p:nvSpPr>
-        <p:spPr>
-          <a:xfrm>
-            <a:off x="9458960" y="1591056"/>
-            <a:ext cx="976376" cy="402336"/>
-          </a:xfrm>
-          <a:prstGeom prst="rect">
-            <a:avLst/>
-          </a:prstGeom>
-          <a:noFill/>
-        </p:spPr>
-        <p:txBody>
-          <a:bodyPr wrap="square" lIns="0" rIns="0" tIns="0" bIns="0" anchor="ctr">
-            <a:spAutoFit/>
-          </a:bodyPr>
-          <a:lstStyle/>
-          <a:p>
-            <a:r>
-              <a:rPr sz="1600" b="0" i="0">
-                <a:solidFill>
-                  <a:srgbClr val="F2F2F2"/>
-                </a:solidFill>
-                <a:latin typeface="Trenda IG Text"/>
-              </a:rPr>
-              <a:t>18</a:t>
-            </a:r>
-          </a:p>
-        </p:txBody>
-      </p:sp>
-      <p:sp>
-        <p:nvSpPr>
           <p:cNvPr id="49" name="Text 47"/>
-          <p:cNvSpPr txBox="1"/>
-          <p:nvPr/>
-        </p:nvSpPr>
-        <p:spPr>
-          <a:xfrm>
-            <a:off x="9458960" y="1993392"/>
-            <a:ext cx="976376" cy="420624"/>
-          </a:xfrm>
-          <a:prstGeom prst="rect">
-            <a:avLst/>
-          </a:prstGeom>
-          <a:noFill/>
-        </p:spPr>
-        <p:txBody>
-          <a:bodyPr wrap="square" lIns="0" rIns="0" tIns="0" bIns="0" anchor="t">
-            <a:spAutoFit/>
-          </a:bodyPr>
-          <a:lstStyle/>
-          <a:p>
-            <a:r>
-              <a:rPr sz="590" b="0" i="0">
-                <a:solidFill>
-                  <a:srgbClr val="B3B3B3"/>
-                </a:solidFill>
-                <a:latin typeface="Trenda IG Text"/>
-              </a:rPr>
-              <a:t>months, seven phases</a:t>
-            </a:r>
-          </a:p>
-        </p:txBody>
-      </p:sp>
-      <p:sp>
-        <p:nvSpPr>
-          <p:cNvPr id="50" name="Shape 48"/>
-          <p:cNvSpPr/>
-          <p:nvPr/>
-        </p:nvSpPr>
-        <p:spPr>
-          <a:xfrm>
-            <a:off x="10545064" y="1554480"/>
-            <a:ext cx="1104391" cy="896112"/>
-          </a:xfrm>
-          <a:prstGeom prst="rect">
-            <a:avLst/>
-          </a:prstGeom>
-          <a:solidFill>
-            <a:srgbClr val="141414"/>
-          </a:solidFill>
-          <a:ln>
-            <a:noFill/>
-          </a:ln>
-          <a:effectLst/>
-        </p:spPr>
-        <p:style>
-          <a:lnRef idx="1">
-            <a:schemeClr val="accent1"/>
-          </a:lnRef>
-          <a:fillRef idx="3">
-            <a:schemeClr val="accent1"/>
-          </a:fillRef>
-          <a:effectRef idx="2">
-            <a:schemeClr val="accent1"/>
-          </a:effectRef>
-          <a:fontRef idx="minor">
-            <a:schemeClr val="lt1"/>
-          </a:fontRef>
-        </p:style>
-        <p:txBody>
-          <a:bodyPr rtlCol="0" anchor="ctr"/>
-          <a:lstStyle/>
-          <a:p/>
-        </p:txBody>
-      </p:sp>
-      <p:sp>
-        <p:nvSpPr>
-          <p:cNvPr id="51" name="Text 49"/>
-          <p:cNvSpPr txBox="1"/>
-          <p:nvPr/>
-        </p:nvSpPr>
-        <p:spPr>
-          <a:xfrm>
-            <a:off x="10636504" y="1591056"/>
-            <a:ext cx="976376" cy="402336"/>
-          </a:xfrm>
-          <a:prstGeom prst="rect">
-            <a:avLst/>
-          </a:prstGeom>
-          <a:noFill/>
-        </p:spPr>
-        <p:txBody>
-          <a:bodyPr wrap="square" lIns="0" rIns="0" tIns="0" bIns="0" anchor="ctr">
-            <a:spAutoFit/>
-          </a:bodyPr>
-          <a:lstStyle/>
-          <a:p>
-            <a:r>
-              <a:rPr sz="1600" b="0" i="0">
-                <a:solidFill>
-                  <a:srgbClr val="F2F2F2"/>
-                </a:solidFill>
-                <a:latin typeface="Trenda IG Text"/>
-              </a:rPr>
-              <a:t>$4.79M</a:t>
-            </a:r>
-          </a:p>
-        </p:txBody>
-      </p:sp>
-      <p:sp>
-        <p:nvSpPr>
-          <p:cNvPr id="52" name="Text 50"/>
-          <p:cNvSpPr txBox="1"/>
-          <p:nvPr/>
-        </p:nvSpPr>
-        <p:spPr>
-          <a:xfrm>
-            <a:off x="10636504" y="1993392"/>
-            <a:ext cx="976376" cy="420624"/>
-          </a:xfrm>
-          <a:prstGeom prst="rect">
-            <a:avLst/>
-          </a:prstGeom>
-          <a:noFill/>
-        </p:spPr>
-        <p:txBody>
-          <a:bodyPr wrap="square" lIns="0" rIns="0" tIns="0" bIns="0" anchor="t">
-            <a:spAutoFit/>
-          </a:bodyPr>
-          <a:lstStyle/>
-          <a:p>
-            <a:r>
-              <a:rPr sz="590" b="0" i="0">
-                <a:solidFill>
-                  <a:srgbClr val="B3B3B3"/>
-                </a:solidFill>
-                <a:latin typeface="Trenda IG Text"/>
-              </a:rPr>
-              <a:t>fixed fee, paid as each gate is signed</a:t>
-            </a:r>
-          </a:p>
-        </p:txBody>
-      </p:sp>
-      <p:sp>
-        <p:nvSpPr>
-          <p:cNvPr id="53" name="Text 51"/>
-          <p:cNvSpPr txBox="1"/>
-          <p:nvPr/>
-        </p:nvSpPr>
-        <p:spPr>
-          <a:xfrm>
-            <a:off x="8189976" y="2542032"/>
-            <a:ext cx="3459480" cy="457200"/>
-          </a:xfrm>
-          <a:prstGeom prst="rect">
-            <a:avLst/>
-          </a:prstGeom>
-          <a:noFill/>
-        </p:spPr>
-        <p:txBody>
-          <a:bodyPr wrap="square" lIns="0" rIns="0" tIns="0" bIns="0" anchor="t">
-            <a:spAutoFit/>
-          </a:bodyPr>
-          <a:lstStyle/>
-          <a:p>
-            <a:r>
-              <a:rPr sz="600" b="1" i="0">
-                <a:solidFill>
-                  <a:srgbClr val="F2F2F2"/>
-                </a:solidFill>
-                <a:latin typeface="Trenda IG Text"/>
-              </a:rPr>
-              <a:t>From month 19 </a:t>
-            </a:r>
-            <a:r>
-              <a:rPr sz="600" b="0" i="0">
-                <a:solidFill>
-                  <a:srgbClr val="B3B3B3"/>
-                </a:solidFill>
-                <a:latin typeface="Trenda IG Text"/>
-              </a:rPr>
-              <a:t>a run team of 4 keeps the graph, agents and evals current: about $1.24M a year with platform usage.</a:t>
-            </a:r>
-          </a:p>
-        </p:txBody>
-      </p:sp>
-      <p:sp>
-        <p:nvSpPr>
-          <p:cNvPr id="54" name="Shape 52"/>
-          <p:cNvSpPr/>
-          <p:nvPr/>
-        </p:nvSpPr>
-        <p:spPr>
-          <a:xfrm>
-            <a:off x="411480" y="3291840"/>
-            <a:ext cx="11365992" cy="1965960"/>
-          </a:xfrm>
-          <a:prstGeom prst="roundRect">
-            <a:avLst>
-              <a:gd name="adj" fmla="val 2000"/>
-            </a:avLst>
-          </a:prstGeom>
-          <a:solidFill>
-            <a:srgbClr val="1E1E1E"/>
-          </a:solidFill>
-          <a:ln>
-            <a:noFill/>
-          </a:ln>
-          <a:effectLst/>
-        </p:spPr>
-        <p:style>
-          <a:lnRef idx="1">
-            <a:schemeClr val="accent1"/>
-          </a:lnRef>
-          <a:fillRef idx="3">
-            <a:schemeClr val="accent1"/>
-          </a:fillRef>
-          <a:effectRef idx="2">
-            <a:schemeClr val="accent1"/>
-          </a:effectRef>
-          <a:fontRef idx="minor">
-            <a:schemeClr val="lt1"/>
-          </a:fontRef>
-        </p:style>
-        <p:txBody>
-          <a:bodyPr rtlCol="0" anchor="ctr"/>
-          <a:lstStyle/>
-          <a:p/>
-        </p:txBody>
-      </p:sp>
-      <p:sp>
-        <p:nvSpPr>
-          <p:cNvPr id="55" name="Shape 53"/>
-          <p:cNvSpPr/>
-          <p:nvPr/>
-        </p:nvSpPr>
-        <p:spPr>
-          <a:xfrm>
-            <a:off x="411480" y="3291840"/>
-            <a:ext cx="11365992" cy="256032"/>
-          </a:xfrm>
-          <a:prstGeom prst="rect">
-            <a:avLst/>
-          </a:prstGeom>
-          <a:solidFill>
-            <a:srgbClr val="2B2B2B"/>
-          </a:solidFill>
-          <a:ln>
-            <a:noFill/>
-          </a:ln>
-          <a:effectLst/>
-        </p:spPr>
-        <p:style>
-          <a:lnRef idx="1">
-            <a:schemeClr val="accent1"/>
-          </a:lnRef>
-          <a:fillRef idx="3">
-            <a:schemeClr val="accent1"/>
-          </a:fillRef>
-          <a:effectRef idx="2">
-            <a:schemeClr val="accent1"/>
-          </a:effectRef>
-          <a:fontRef idx="minor">
-            <a:schemeClr val="lt1"/>
-          </a:fontRef>
-        </p:style>
-        <p:txBody>
-          <a:bodyPr rtlCol="0" anchor="ctr"/>
-          <a:lstStyle/>
-          <a:p/>
-        </p:txBody>
-      </p:sp>
-      <p:sp>
-        <p:nvSpPr>
-          <p:cNvPr id="56" name="Text 54"/>
-          <p:cNvSpPr txBox="1"/>
-          <p:nvPr/>
-        </p:nvSpPr>
-        <p:spPr>
-          <a:xfrm>
-            <a:off x="521208" y="3291840"/>
-            <a:ext cx="11146536" cy="256032"/>
-          </a:xfrm>
-          <a:prstGeom prst="rect">
-            <a:avLst/>
-          </a:prstGeom>
-          <a:noFill/>
-        </p:spPr>
-        <p:txBody>
-          <a:bodyPr wrap="square" lIns="0" rIns="0" tIns="0" bIns="0" anchor="ctr">
-            <a:spAutoFit/>
-          </a:bodyPr>
-          <a:lstStyle/>
-          <a:p>
-            <a:r>
-              <a:rPr sz="640" b="1" i="0" spc="120">
-                <a:solidFill>
-                  <a:srgbClr val="F2F2F2"/>
-                </a:solidFill>
-                <a:latin typeface="Trenda IG Text"/>
-              </a:rPr>
-              <a:t>THE RETURN</a:t>
-            </a:r>
-            <a:r>
-              <a:rPr sz="640" b="0" i="0">
-                <a:solidFill>
-                  <a:srgbClr val="B3B3B3"/>
-                </a:solidFill>
-                <a:latin typeface="Trenda IG Text"/>
-              </a:rPr>
-              <a:t>   target · first full year after go-live</a:t>
-            </a:r>
-          </a:p>
-        </p:txBody>
-      </p:sp>
-      <p:sp>
-        <p:nvSpPr>
-          <p:cNvPr id="57" name="Shape 55"/>
-          <p:cNvSpPr/>
-          <p:nvPr/>
-        </p:nvSpPr>
-        <p:spPr>
-          <a:xfrm>
-            <a:off x="539496" y="3639312"/>
-            <a:ext cx="1796796" cy="1490472"/>
-          </a:xfrm>
-          <a:prstGeom prst="rect">
-            <a:avLst/>
-          </a:prstGeom>
-          <a:solidFill>
-            <a:srgbClr val="141414"/>
-          </a:solidFill>
-          <a:ln>
-            <a:noFill/>
-          </a:ln>
-          <a:effectLst/>
-        </p:spPr>
-        <p:style>
-          <a:lnRef idx="1">
-            <a:schemeClr val="accent1"/>
-          </a:lnRef>
-          <a:fillRef idx="3">
-            <a:schemeClr val="accent1"/>
-          </a:fillRef>
-          <a:effectRef idx="2">
-            <a:schemeClr val="accent1"/>
-          </a:effectRef>
-          <a:fontRef idx="minor">
-            <a:schemeClr val="lt1"/>
-          </a:fontRef>
-        </p:style>
-        <p:txBody>
-          <a:bodyPr rtlCol="0" anchor="ctr"/>
-          <a:lstStyle/>
-          <a:p/>
-        </p:txBody>
-      </p:sp>
-      <p:sp>
-        <p:nvSpPr>
-          <p:cNvPr id="58" name="Text 56"/>
-          <p:cNvSpPr txBox="1"/>
-          <p:nvPr/>
-        </p:nvSpPr>
-        <p:spPr>
-          <a:xfrm>
-            <a:off x="667512" y="3977639"/>
-            <a:ext cx="1577340" cy="457200"/>
-          </a:xfrm>
-          <a:prstGeom prst="rect">
-            <a:avLst/>
-          </a:prstGeom>
-          <a:noFill/>
-        </p:spPr>
-        <p:txBody>
-          <a:bodyPr wrap="square" lIns="0" rIns="0" tIns="0" bIns="0" anchor="ctr">
-            <a:spAutoFit/>
-          </a:bodyPr>
-          <a:lstStyle/>
-          <a:p>
-            <a:r>
-              <a:rPr sz="2200" b="0" i="0">
-                <a:solidFill>
-                  <a:srgbClr val="F2F2F2"/>
-                </a:solidFill>
-                <a:latin typeface="Trenda IG Text"/>
-              </a:rPr>
-              <a:t>$16M</a:t>
-            </a:r>
-          </a:p>
-        </p:txBody>
-      </p:sp>
-      <p:sp>
-        <p:nvSpPr>
-          <p:cNvPr id="59" name="Text 57"/>
-          <p:cNvSpPr txBox="1"/>
-          <p:nvPr/>
-        </p:nvSpPr>
-        <p:spPr>
-          <a:xfrm>
-            <a:off x="667512" y="4453127"/>
-            <a:ext cx="1577340" cy="201168"/>
-          </a:xfrm>
-          <a:prstGeom prst="rect">
-            <a:avLst/>
-          </a:prstGeom>
-          <a:noFill/>
-        </p:spPr>
-        <p:txBody>
-          <a:bodyPr wrap="square" lIns="0" rIns="0" tIns="0" bIns="0" anchor="ctr">
-            <a:spAutoFit/>
-          </a:bodyPr>
-          <a:lstStyle/>
-          <a:p>
-            <a:r>
-              <a:rPr sz="700" b="1" i="0">
-                <a:solidFill>
-                  <a:srgbClr val="F2F2F2"/>
-                </a:solidFill>
-                <a:latin typeface="Trenda IG Text"/>
-              </a:rPr>
-              <a:t>a year today</a:t>
-            </a:r>
-          </a:p>
-        </p:txBody>
-      </p:sp>
-      <p:sp>
-        <p:nvSpPr>
-          <p:cNvPr id="60" name="Text 58"/>
-          <p:cNvSpPr txBox="1"/>
-          <p:nvPr/>
-        </p:nvSpPr>
-        <p:spPr>
-          <a:xfrm>
-            <a:off x="667512" y="4654296"/>
-            <a:ext cx="1577340" cy="201168"/>
-          </a:xfrm>
-          <a:prstGeom prst="rect">
-            <a:avLst/>
-          </a:prstGeom>
-          <a:noFill/>
-        </p:spPr>
-        <p:txBody>
-          <a:bodyPr wrap="square" lIns="0" rIns="0" tIns="0" bIns="0" anchor="ctr">
-            <a:spAutoFit/>
-          </a:bodyPr>
-          <a:lstStyle/>
-          <a:p>
-            <a:r>
-              <a:rPr sz="600" b="0" i="0">
-                <a:solidFill>
-                  <a:srgbClr val="B3B3B3"/>
-                </a:solidFill>
-                <a:latin typeface="Trenda IG Text"/>
-              </a:rPr>
-              <a:t>as provided by Ascension</a:t>
-            </a:r>
-          </a:p>
-        </p:txBody>
-      </p:sp>
-      <p:sp>
-        <p:nvSpPr>
-          <p:cNvPr id="61" name="Shape 59"/>
-          <p:cNvSpPr/>
-          <p:nvPr/>
-        </p:nvSpPr>
-        <p:spPr>
-          <a:xfrm>
-            <a:off x="2427732" y="3639312"/>
-            <a:ext cx="1796796" cy="1490472"/>
-          </a:xfrm>
-          <a:prstGeom prst="rect">
-            <a:avLst/>
-          </a:prstGeom>
-          <a:solidFill>
-            <a:srgbClr val="141414"/>
-          </a:solidFill>
-          <a:ln>
-            <a:noFill/>
-          </a:ln>
-          <a:effectLst/>
-        </p:spPr>
-        <p:style>
-          <a:lnRef idx="1">
-            <a:schemeClr val="accent1"/>
-          </a:lnRef>
-          <a:fillRef idx="3">
-            <a:schemeClr val="accent1"/>
-          </a:fillRef>
-          <a:effectRef idx="2">
-            <a:schemeClr val="accent1"/>
-          </a:effectRef>
-          <a:fontRef idx="minor">
-            <a:schemeClr val="lt1"/>
-          </a:fontRef>
-        </p:style>
-        <p:txBody>
-          <a:bodyPr rtlCol="0" anchor="ctr"/>
-          <a:lstStyle/>
-          <a:p/>
-        </p:txBody>
-      </p:sp>
-      <p:sp>
-        <p:nvSpPr>
-          <p:cNvPr id="62" name="Text 60"/>
           <p:cNvSpPr txBox="1"/>
           <p:nvPr/>
         </p:nvSpPr>
@@ -6333,7 +5798,7 @@
       </p:sp>
       <p:sp>
         <p:nvSpPr>
-          <p:cNvPr id="63" name="Text 61"/>
+          <p:cNvPr id="50" name="Text 48"/>
           <p:cNvSpPr txBox="1"/>
           <p:nvPr/>
         </p:nvSpPr>
@@ -6367,7 +5832,7 @@
       </p:sp>
       <p:sp>
         <p:nvSpPr>
-          <p:cNvPr id="64" name="Text 62"/>
+          <p:cNvPr id="51" name="Text 49"/>
           <p:cNvSpPr txBox="1"/>
           <p:nvPr/>
         </p:nvSpPr>
@@ -6401,7 +5866,7 @@
       </p:sp>
       <p:sp>
         <p:nvSpPr>
-          <p:cNvPr id="65" name="Differentiator Border 64"/>
+          <p:cNvPr id="52" name="Differentiator Border 51"/>
           <p:cNvSpPr/>
           <p:nvPr/>
         </p:nvSpPr>
@@ -6454,7 +5919,7 @@
       </p:sp>
       <p:sp>
         <p:nvSpPr>
-          <p:cNvPr id="66" name="Shape 65"/>
+          <p:cNvPr id="53" name="Shape 52"/>
           <p:cNvSpPr/>
           <p:nvPr/>
         </p:nvSpPr>
@@ -6496,7 +5961,7 @@
       </p:sp>
       <p:sp>
         <p:nvSpPr>
-          <p:cNvPr id="67" name="Text 66"/>
+          <p:cNvPr id="54" name="Text 53"/>
           <p:cNvSpPr txBox="1"/>
           <p:nvPr/>
         </p:nvSpPr>
@@ -6530,7 +5995,7 @@
       </p:sp>
       <p:sp>
         <p:nvSpPr>
-          <p:cNvPr id="68" name="Text 67"/>
+          <p:cNvPr id="55" name="Text 54"/>
           <p:cNvSpPr txBox="1"/>
           <p:nvPr/>
         </p:nvSpPr>
@@ -6564,7 +6029,7 @@
       </p:sp>
       <p:sp>
         <p:nvSpPr>
-          <p:cNvPr id="69" name="Text 68"/>
+          <p:cNvPr id="56" name="Text 55"/>
           <p:cNvSpPr txBox="1"/>
           <p:nvPr/>
         </p:nvSpPr>
@@ -6598,7 +6063,7 @@
       </p:sp>
       <p:sp>
         <p:nvSpPr>
-          <p:cNvPr id="70" name="Shape 69"/>
+          <p:cNvPr id="57" name="Shape 56"/>
           <p:cNvSpPr/>
           <p:nvPr/>
         </p:nvSpPr>
@@ -6640,7 +6105,7 @@
       </p:sp>
       <p:sp>
         <p:nvSpPr>
-          <p:cNvPr id="71" name="Text 70"/>
+          <p:cNvPr id="58" name="Text 57"/>
           <p:cNvSpPr txBox="1"/>
           <p:nvPr/>
         </p:nvSpPr>
@@ -6674,7 +6139,7 @@
       </p:sp>
       <p:sp>
         <p:nvSpPr>
-          <p:cNvPr id="72" name="Text 71"/>
+          <p:cNvPr id="59" name="Text 58"/>
           <p:cNvSpPr txBox="1"/>
           <p:nvPr/>
         </p:nvSpPr>
@@ -6708,7 +6173,7 @@
       </p:sp>
       <p:sp>
         <p:nvSpPr>
-          <p:cNvPr id="73" name="Text 72"/>
+          <p:cNvPr id="60" name="Text 59"/>
           <p:cNvSpPr txBox="1"/>
           <p:nvPr/>
         </p:nvSpPr>
@@ -6742,7 +6207,7 @@
       </p:sp>
       <p:sp>
         <p:nvSpPr>
-          <p:cNvPr id="74" name="Shape 73"/>
+          <p:cNvPr id="61" name="Shape 60"/>
           <p:cNvSpPr/>
           <p:nvPr/>
         </p:nvSpPr>
@@ -6784,7 +6249,7 @@
       </p:sp>
       <p:sp>
         <p:nvSpPr>
-          <p:cNvPr id="75" name="Shape 74"/>
+          <p:cNvPr id="62" name="Shape 61"/>
           <p:cNvSpPr/>
           <p:nvPr/>
         </p:nvSpPr>
@@ -6837,7 +6302,7 @@
       </p:sp>
       <p:sp>
         <p:nvSpPr>
-          <p:cNvPr id="76" name="Text 75"/>
+          <p:cNvPr id="63" name="Text 62"/>
           <p:cNvSpPr txBox="1"/>
           <p:nvPr/>
         </p:nvSpPr>
@@ -6892,7 +6357,7 @@
       </p:sp>
       <p:sp>
         <p:nvSpPr>
-          <p:cNvPr id="77" name="Shape 76"/>
+          <p:cNvPr id="64" name="Shape 63"/>
           <p:cNvSpPr/>
           <p:nvPr/>
         </p:nvSpPr>
@@ -6934,7 +6399,7 @@
       </p:sp>
       <p:sp>
         <p:nvSpPr>
-          <p:cNvPr id="78" name="Shape 77"/>
+          <p:cNvPr id="65" name="Shape 64"/>
           <p:cNvSpPr/>
           <p:nvPr/>
         </p:nvSpPr>
@@ -6987,7 +6452,7 @@
       </p:sp>
       <p:sp>
         <p:nvSpPr>
-          <p:cNvPr id="79" name="Text 78"/>
+          <p:cNvPr id="66" name="Text 65"/>
           <p:cNvSpPr txBox="1"/>
           <p:nvPr/>
         </p:nvSpPr>
@@ -7042,7 +6507,7 @@
       </p:sp>
       <p:sp>
         <p:nvSpPr>
-          <p:cNvPr id="80" name="Text 79"/>
+          <p:cNvPr id="67" name="Text 66"/>
           <p:cNvSpPr txBox="1"/>
           <p:nvPr/>
         </p:nvSpPr>
@@ -7097,7 +6562,7 @@
       </p:sp>
       <p:sp>
         <p:nvSpPr>
-          <p:cNvPr id="81" name="Shape 80"/>
+          <p:cNvPr id="68" name="Shape 67"/>
           <p:cNvSpPr/>
           <p:nvPr/>
         </p:nvSpPr>
@@ -7139,7 +6604,7 @@
       </p:sp>
       <p:sp>
         <p:nvSpPr>
-          <p:cNvPr id="82" name="Shape 81"/>
+          <p:cNvPr id="69" name="Shape 68"/>
           <p:cNvSpPr/>
           <p:nvPr/>
         </p:nvSpPr>
@@ -7181,7 +6646,7 @@
       </p:sp>
       <p:sp>
         <p:nvSpPr>
-          <p:cNvPr id="83" name="Text 82"/>
+          <p:cNvPr id="70" name="Text 69"/>
           <p:cNvSpPr txBox="1"/>
           <p:nvPr/>
         </p:nvSpPr>
@@ -7236,7 +6701,7 @@
       </p:sp>
       <p:sp>
         <p:nvSpPr>
-          <p:cNvPr id="84" name="Shape 83"/>
+          <p:cNvPr id="71" name="Shape 70"/>
           <p:cNvSpPr/>
           <p:nvPr/>
         </p:nvSpPr>
@@ -7278,7 +6743,7 @@
       </p:sp>
       <p:sp>
         <p:nvSpPr>
-          <p:cNvPr id="85" name="Shape 84"/>
+          <p:cNvPr id="72" name="Shape 71"/>
           <p:cNvSpPr/>
           <p:nvPr/>
         </p:nvSpPr>
@@ -7320,7 +6785,7 @@
       </p:sp>
       <p:sp>
         <p:nvSpPr>
-          <p:cNvPr id="86" name="Text 85"/>
+          <p:cNvPr id="73" name="Text 72"/>
           <p:cNvSpPr txBox="1"/>
           <p:nvPr/>
         </p:nvSpPr>
@@ -7375,7 +6840,7 @@
       </p:sp>
       <p:sp>
         <p:nvSpPr>
-          <p:cNvPr id="87" name="Shape 86"/>
+          <p:cNvPr id="74" name="Shape 73"/>
           <p:cNvSpPr/>
           <p:nvPr/>
         </p:nvSpPr>
@@ -7417,7 +6882,7 @@
       </p:sp>
       <p:sp>
         <p:nvSpPr>
-          <p:cNvPr id="88" name="Shape 87"/>
+          <p:cNvPr id="75" name="Shape 74"/>
           <p:cNvSpPr/>
           <p:nvPr/>
         </p:nvSpPr>
@@ -7459,7 +6924,7 @@
       </p:sp>
       <p:sp>
         <p:nvSpPr>
-          <p:cNvPr id="89" name="Text 88"/>
+          <p:cNvPr id="76" name="Text 75"/>
           <p:cNvSpPr txBox="1"/>
           <p:nvPr/>
         </p:nvSpPr>
@@ -7514,7 +6979,7 @@
       </p:sp>
       <p:sp>
         <p:nvSpPr>
-          <p:cNvPr id="90" name="Shape 89"/>
+          <p:cNvPr id="77" name="Shape 76"/>
           <p:cNvSpPr/>
           <p:nvPr/>
         </p:nvSpPr>
@@ -7556,7 +7021,7 @@
       </p:sp>
       <p:sp>
         <p:nvSpPr>
-          <p:cNvPr id="91" name="Shape 90"/>
+          <p:cNvPr id="78" name="Shape 77"/>
           <p:cNvSpPr/>
           <p:nvPr/>
         </p:nvSpPr>
@@ -7598,7 +7063,7 @@
       </p:sp>
       <p:sp>
         <p:nvSpPr>
-          <p:cNvPr id="92" name="Text 91"/>
+          <p:cNvPr id="79" name="Text 78"/>
           <p:cNvSpPr txBox="1"/>
           <p:nvPr/>
         </p:nvSpPr>

</xml_diff>

<commit_message>
Lean team slide: keep the pod panel, rewritten as concrete before/after values
New engineer productive, delivery hours a day, changes checked and time
to bring a new pod live, from the operational efficiency pilot targets;
plus the 1.4-1.6x output / 20-30% smaller team line.

Co-Authored-By: Claude Opus 5.5 <noreply@anthropic.com>
Claude-Session: https://claude.ai/code/session_01Hf94kqMzSofkkrQm7kpNba
</commit_message>
<xml_diff>
--- a/poc/data_harness/Ascension Agentic Harness - Data Harness.pptx
+++ b/poc/data_harness/Ascension Agentic Harness - Data Harness.pptx
@@ -1495,6 +1495,11 @@
           </a:p>
           <a:p>
             <a:r>
+              <a:t>- The pod: what changes for every pod (pilot targets, baselined per pod): a new engineer is productive in about a week instead of 4-6 weeks, because they ask the graph; agents work overnight, so delivery runs about 20 hours a day instead of office hours; every change is checked against the same standards; a new pod goes live on the platform in 2 weeks instead of about 2 months. The same team delivers 1.4-1.6x the output, or the same scope with 20-30% fewer people.</a:t>
+            </a:r>
+          </a:p>
+          <a:p>
+            <a:r>
               <a:t>- The build: 17 people at peak, 10 roles, 18 months, $4.79M fixed fee paid only when each gate is signed. From month 19 a run team of 4 keeps it running, about $1.24M a year with platform usage.</a:t>
             </a:r>
           </a:p>
@@ -4006,7 +4011,7 @@
         <p:spPr>
           <a:xfrm>
             <a:off x="411480" y="1188720"/>
-            <a:ext cx="5628132" cy="1965960"/>
+            <a:ext cx="3715512" cy="1965960"/>
           </a:xfrm>
           <a:prstGeom prst="roundRect">
             <a:avLst>
@@ -4050,7 +4055,7 @@
         <p:spPr>
           <a:xfrm>
             <a:off x="411480" y="1188720"/>
-            <a:ext cx="5628132" cy="256032"/>
+            <a:ext cx="3715512" cy="256032"/>
           </a:xfrm>
           <a:prstGeom prst="rect">
             <a:avLst/>
@@ -4092,7 +4097,7 @@
         <p:spPr>
           <a:xfrm>
             <a:off x="521208" y="1188720"/>
-            <a:ext cx="5408676" cy="256032"/>
+            <a:ext cx="3496056" cy="256032"/>
           </a:xfrm>
           <a:prstGeom prst="rect">
             <a:avLst/>
@@ -4169,7 +4174,7 @@
         <p:spPr>
           <a:xfrm>
             <a:off x="539496" y="1719072"/>
-            <a:ext cx="1030528" cy="274320"/>
+            <a:ext cx="648004" cy="274320"/>
           </a:xfrm>
           <a:prstGeom prst="roundRect">
             <a:avLst>
@@ -4215,7 +4220,7 @@
         <p:spPr>
           <a:xfrm>
             <a:off x="539496" y="1719072"/>
-            <a:ext cx="1030528" cy="274320"/>
+            <a:ext cx="648004" cy="274320"/>
           </a:xfrm>
           <a:prstGeom prst="rect">
             <a:avLst/>
@@ -4249,8 +4254,8 @@
         </p:nvSpPr>
         <p:spPr>
           <a:xfrm>
-            <a:off x="1624888" y="1719072"/>
-            <a:ext cx="1030528" cy="274320"/>
+            <a:off x="1242364" y="1719072"/>
+            <a:ext cx="648004" cy="274320"/>
           </a:xfrm>
           <a:prstGeom prst="roundRect">
             <a:avLst>
@@ -4295,8 +4300,8 @@
         </p:nvSpPr>
         <p:spPr>
           <a:xfrm>
-            <a:off x="1624888" y="1719072"/>
-            <a:ext cx="1030528" cy="274320"/>
+            <a:off x="1242364" y="1719072"/>
+            <a:ext cx="648004" cy="274320"/>
           </a:xfrm>
           <a:prstGeom prst="rect">
             <a:avLst/>
@@ -4330,8 +4335,8 @@
         </p:nvSpPr>
         <p:spPr>
           <a:xfrm>
-            <a:off x="2710281" y="1719072"/>
-            <a:ext cx="1030528" cy="274320"/>
+            <a:off x="1945233" y="1719072"/>
+            <a:ext cx="648004" cy="274320"/>
           </a:xfrm>
           <a:prstGeom prst="roundRect">
             <a:avLst>
@@ -4376,8 +4381,8 @@
         </p:nvSpPr>
         <p:spPr>
           <a:xfrm>
-            <a:off x="2710281" y="1719072"/>
-            <a:ext cx="1030528" cy="274320"/>
+            <a:off x="1945233" y="1719072"/>
+            <a:ext cx="648004" cy="274320"/>
           </a:xfrm>
           <a:prstGeom prst="rect">
             <a:avLst/>
@@ -4411,8 +4416,8 @@
         </p:nvSpPr>
         <p:spPr>
           <a:xfrm>
-            <a:off x="3795674" y="1719072"/>
-            <a:ext cx="1030528" cy="274320"/>
+            <a:off x="2648102" y="1719072"/>
+            <a:ext cx="648004" cy="274320"/>
           </a:xfrm>
           <a:prstGeom prst="roundRect">
             <a:avLst>
@@ -4457,8 +4462,8 @@
         </p:nvSpPr>
         <p:spPr>
           <a:xfrm>
-            <a:off x="3795674" y="1719072"/>
-            <a:ext cx="1030528" cy="274320"/>
+            <a:off x="2648102" y="1719072"/>
+            <a:ext cx="648004" cy="274320"/>
           </a:xfrm>
           <a:prstGeom prst="rect">
             <a:avLst/>
@@ -4492,8 +4497,8 @@
         </p:nvSpPr>
         <p:spPr>
           <a:xfrm>
-            <a:off x="4881067" y="1719072"/>
-            <a:ext cx="1030528" cy="274320"/>
+            <a:off x="3350971" y="1719072"/>
+            <a:ext cx="648004" cy="274320"/>
           </a:xfrm>
           <a:prstGeom prst="roundRect">
             <a:avLst>
@@ -4538,8 +4543,8 @@
         </p:nvSpPr>
         <p:spPr>
           <a:xfrm>
-            <a:off x="4881067" y="1719072"/>
-            <a:ext cx="1030528" cy="274320"/>
+            <a:off x="3350971" y="1719072"/>
+            <a:ext cx="648004" cy="274320"/>
           </a:xfrm>
           <a:prstGeom prst="rect">
             <a:avLst/>
@@ -4608,7 +4613,7 @@
         <p:spPr>
           <a:xfrm>
             <a:off x="539496" y="2267712"/>
-            <a:ext cx="1754124" cy="274320"/>
+            <a:ext cx="1116584" cy="274320"/>
           </a:xfrm>
           <a:prstGeom prst="roundRect">
             <a:avLst>
@@ -4654,7 +4659,7 @@
         <p:spPr>
           <a:xfrm>
             <a:off x="539496" y="2267712"/>
-            <a:ext cx="1754124" cy="274320"/>
+            <a:ext cx="1116584" cy="274320"/>
           </a:xfrm>
           <a:prstGeom prst="rect">
             <a:avLst/>
@@ -4688,8 +4693,8 @@
         </p:nvSpPr>
         <p:spPr>
           <a:xfrm>
-            <a:off x="2348484" y="2267712"/>
-            <a:ext cx="1754124" cy="274320"/>
+            <a:off x="1710944" y="2267712"/>
+            <a:ext cx="1116584" cy="274320"/>
           </a:xfrm>
           <a:prstGeom prst="roundRect">
             <a:avLst>
@@ -4742,7 +4747,7 @@
         </p:blipFill>
         <p:spPr>
           <a:xfrm>
-            <a:off x="2421636" y="2322576"/>
+            <a:off x="1784096" y="2322576"/>
             <a:ext cx="164592" cy="164592"/>
           </a:xfrm>
           <a:prstGeom prst="rect">
@@ -4758,8 +4763,8 @@
         </p:nvSpPr>
         <p:spPr>
           <a:xfrm>
-            <a:off x="2567940" y="2267712"/>
-            <a:ext cx="1498091" cy="274320"/>
+            <a:off x="1930400" y="2267712"/>
+            <a:ext cx="860551" cy="274320"/>
           </a:xfrm>
           <a:prstGeom prst="rect">
             <a:avLst/>
@@ -4793,8 +4798,8 @@
         </p:nvSpPr>
         <p:spPr>
           <a:xfrm>
-            <a:off x="4157472" y="2267712"/>
-            <a:ext cx="1754124" cy="274320"/>
+            <a:off x="2882392" y="2267712"/>
+            <a:ext cx="1116584" cy="274320"/>
           </a:xfrm>
           <a:prstGeom prst="roundRect">
             <a:avLst>
@@ -4839,8 +4844,8 @@
         </p:nvSpPr>
         <p:spPr>
           <a:xfrm>
-            <a:off x="4157472" y="2267712"/>
-            <a:ext cx="1754124" cy="274320"/>
+            <a:off x="2882392" y="2267712"/>
+            <a:ext cx="1116584" cy="274320"/>
           </a:xfrm>
           <a:prstGeom prst="rect">
             <a:avLst/>
@@ -4875,7 +4880,7 @@
         <p:spPr>
           <a:xfrm>
             <a:off x="539496" y="2615184"/>
-            <a:ext cx="5372100" cy="384048"/>
+            <a:ext cx="3459480" cy="384048"/>
           </a:xfrm>
           <a:prstGeom prst="rect">
             <a:avLst/>
@@ -4953,8 +4958,8 @@
         </p:nvSpPr>
         <p:spPr>
           <a:xfrm>
-            <a:off x="6149340" y="1188720"/>
-            <a:ext cx="5628132" cy="1965960"/>
+            <a:off x="4236720" y="1188720"/>
+            <a:ext cx="3715512" cy="1965960"/>
           </a:xfrm>
           <a:prstGeom prst="roundRect">
             <a:avLst>
@@ -4997,8 +5002,8 @@
         </p:nvSpPr>
         <p:spPr>
           <a:xfrm>
-            <a:off x="6149340" y="1188720"/>
-            <a:ext cx="5628132" cy="256032"/>
+            <a:off x="4236720" y="1188720"/>
+            <a:ext cx="3715512" cy="256032"/>
           </a:xfrm>
           <a:prstGeom prst="rect">
             <a:avLst/>
@@ -5039,8 +5044,8 @@
         </p:nvSpPr>
         <p:spPr>
           <a:xfrm>
-            <a:off x="6259068" y="1188720"/>
-            <a:ext cx="5408676" cy="256032"/>
+            <a:off x="4346448" y="1188720"/>
+            <a:ext cx="3496056" cy="256032"/>
           </a:xfrm>
           <a:prstGeom prst="rect">
             <a:avLst/>
@@ -5060,7 +5065,7 @@
                 </a:solidFill>
                 <a:latin typeface="Trenda IG Text"/>
               </a:rPr>
-              <a:t>THE BUILD AND RUN</a:t>
+              <a:t>THE POD</a:t>
             </a:r>
             <a:r>
               <a:rPr sz="640" b="0" i="0">
@@ -5069,21 +5074,89 @@
                 </a:solidFill>
                 <a:latin typeface="Trenda IG Text"/>
               </a:rPr>
-              <a:t>   fixed fee, paid by gate</a:t>
-            </a:r>
-          </a:p>
-        </p:txBody>
-      </p:sp>
-      <p:sp>
-        <p:nvSpPr>
-          <p:cNvPr id="31" name="Shape 29"/>
+              <a:t>   what changes for every pod</a:t>
+            </a:r>
+          </a:p>
+        </p:txBody>
+      </p:sp>
+      <p:sp>
+        <p:nvSpPr>
+          <p:cNvPr id="31" name="Text 29"/>
+          <p:cNvSpPr txBox="1"/>
+          <p:nvPr/>
+        </p:nvSpPr>
+        <p:spPr>
+          <a:xfrm>
+            <a:off x="5608320" y="1517904"/>
+            <a:ext cx="914400" cy="164592"/>
+          </a:xfrm>
+          <a:prstGeom prst="rect">
+            <a:avLst/>
+          </a:prstGeom>
+          <a:noFill/>
+        </p:spPr>
+        <p:txBody>
+          <a:bodyPr wrap="square" lIns="0" rIns="0" tIns="0" bIns="0" anchor="ctr">
+            <a:spAutoFit/>
+          </a:bodyPr>
+          <a:lstStyle/>
+          <a:p>
+            <a:r>
+              <a:rPr sz="540" b="1" i="0" spc="100">
+                <a:solidFill>
+                  <a:srgbClr val="8C8C8C"/>
+                </a:solidFill>
+                <a:latin typeface="Trenda IG Text"/>
+              </a:rPr>
+              <a:t>TODAY</a:t>
+            </a:r>
+          </a:p>
+        </p:txBody>
+      </p:sp>
+      <p:sp>
+        <p:nvSpPr>
+          <p:cNvPr id="32" name="Text 30"/>
+          <p:cNvSpPr txBox="1"/>
+          <p:nvPr/>
+        </p:nvSpPr>
+        <p:spPr>
+          <a:xfrm>
+            <a:off x="6614160" y="1517904"/>
+            <a:ext cx="1280160" cy="164592"/>
+          </a:xfrm>
+          <a:prstGeom prst="rect">
+            <a:avLst/>
+          </a:prstGeom>
+          <a:noFill/>
+        </p:spPr>
+        <p:txBody>
+          <a:bodyPr wrap="square" lIns="0" rIns="0" tIns="0" bIns="0" anchor="ctr">
+            <a:spAutoFit/>
+          </a:bodyPr>
+          <a:lstStyle/>
+          <a:p>
+            <a:r>
+              <a:rPr sz="540" b="1" i="0" spc="100">
+                <a:solidFill>
+                  <a:srgbClr val="00D6F2"/>
+                </a:solidFill>
+                <a:latin typeface="Trenda IG Text"/>
+              </a:rPr>
+              <a:t>WITH THE HARNESS</a:t>
+            </a:r>
+          </a:p>
+        </p:txBody>
+      </p:sp>
+      <p:sp>
+        <p:nvSpPr>
+          <p:cNvPr id="33" name="Shape 31"/>
           <p:cNvSpPr/>
           <p:nvPr/>
         </p:nvSpPr>
         <p:spPr>
           <a:xfrm>
-            <a:off x="6277356" y="1554480"/>
-            <a:ext cx="1741932" cy="896112"/>
+            <a:off x="4364736" y="1700784"/>
+            <a:ext cx="3459480" cy="228600"/>
           </a:xfrm>
           <a:prstGeom prst="rect">
             <a:avLst/>
@@ -5118,14 +5191,14 @@
       </p:sp>
       <p:sp>
         <p:nvSpPr>
-          <p:cNvPr id="32" name="Text 30"/>
-          <p:cNvSpPr txBox="1"/>
-          <p:nvPr/>
-        </p:nvSpPr>
-        <p:spPr>
-          <a:xfrm>
-            <a:off x="6368796" y="1591056"/>
-            <a:ext cx="1613916" cy="402336"/>
+          <p:cNvPr id="34" name="Text 32"/>
+          <p:cNvSpPr txBox="1"/>
+          <p:nvPr/>
+        </p:nvSpPr>
+        <p:spPr>
+          <a:xfrm>
+            <a:off x="4437888" y="1700784"/>
+            <a:ext cx="1188720" cy="228600"/>
           </a:xfrm>
           <a:prstGeom prst="rect">
             <a:avLst/>
@@ -5139,61 +5212,95 @@
           <a:lstStyle/>
           <a:p>
             <a:r>
-              <a:rPr sz="1600" b="0" i="0">
+              <a:rPr sz="600" b="1" i="0">
                 <a:solidFill>
                   <a:srgbClr val="F2F2F2"/>
                 </a:solidFill>
                 <a:latin typeface="Trenda IG Text"/>
               </a:rPr>
-              <a:t>17</a:t>
-            </a:r>
-          </a:p>
-        </p:txBody>
-      </p:sp>
-      <p:sp>
-        <p:nvSpPr>
-          <p:cNvPr id="33" name="Text 31"/>
-          <p:cNvSpPr txBox="1"/>
-          <p:nvPr/>
-        </p:nvSpPr>
-        <p:spPr>
-          <a:xfrm>
-            <a:off x="6368796" y="1993392"/>
-            <a:ext cx="1613916" cy="420624"/>
-          </a:xfrm>
-          <a:prstGeom prst="rect">
-            <a:avLst/>
-          </a:prstGeom>
-          <a:noFill/>
-        </p:spPr>
-        <p:txBody>
-          <a:bodyPr wrap="square" lIns="0" rIns="0" tIns="0" bIns="0" anchor="t">
-            <a:spAutoFit/>
-          </a:bodyPr>
-          <a:lstStyle/>
-          <a:p>
-            <a:r>
-              <a:rPr sz="590" b="0" i="0">
+              <a:t>New engineer productive</a:t>
+            </a:r>
+          </a:p>
+        </p:txBody>
+      </p:sp>
+      <p:sp>
+        <p:nvSpPr>
+          <p:cNvPr id="35" name="Text 33"/>
+          <p:cNvSpPr txBox="1"/>
+          <p:nvPr/>
+        </p:nvSpPr>
+        <p:spPr>
+          <a:xfrm>
+            <a:off x="5608320" y="1700784"/>
+            <a:ext cx="987552" cy="228600"/>
+          </a:xfrm>
+          <a:prstGeom prst="rect">
+            <a:avLst/>
+          </a:prstGeom>
+          <a:noFill/>
+        </p:spPr>
+        <p:txBody>
+          <a:bodyPr wrap="square" lIns="0" rIns="0" tIns="0" bIns="0" anchor="ctr">
+            <a:spAutoFit/>
+          </a:bodyPr>
+          <a:lstStyle/>
+          <a:p>
+            <a:r>
+              <a:rPr sz="600" b="0" i="0">
                 <a:solidFill>
                   <a:srgbClr val="B3B3B3"/>
                 </a:solidFill>
                 <a:latin typeface="Trenda IG Text"/>
               </a:rPr>
-              <a:t>people at peak, 10 roles</a:t>
-            </a:r>
-          </a:p>
-        </p:txBody>
-      </p:sp>
-      <p:sp>
-        <p:nvSpPr>
-          <p:cNvPr id="34" name="Shape 32"/>
+              <a:t>4-6 weeks</a:t>
+            </a:r>
+          </a:p>
+        </p:txBody>
+      </p:sp>
+      <p:sp>
+        <p:nvSpPr>
+          <p:cNvPr id="36" name="Text 34"/>
+          <p:cNvSpPr txBox="1"/>
+          <p:nvPr/>
+        </p:nvSpPr>
+        <p:spPr>
+          <a:xfrm>
+            <a:off x="6614160" y="1700784"/>
+            <a:ext cx="1429512" cy="228600"/>
+          </a:xfrm>
+          <a:prstGeom prst="rect">
+            <a:avLst/>
+          </a:prstGeom>
+          <a:noFill/>
+        </p:spPr>
+        <p:txBody>
+          <a:bodyPr wrap="square" lIns="0" rIns="0" tIns="0" bIns="0" anchor="ctr">
+            <a:spAutoFit/>
+          </a:bodyPr>
+          <a:lstStyle/>
+          <a:p>
+            <a:r>
+              <a:rPr sz="600" b="1" i="0">
+                <a:solidFill>
+                  <a:srgbClr val="00D6F2"/>
+                </a:solidFill>
+                <a:latin typeface="Trenda IG Text"/>
+              </a:rPr>
+              <a:t>about 1 week</a:t>
+            </a:r>
+          </a:p>
+        </p:txBody>
+      </p:sp>
+      <p:sp>
+        <p:nvSpPr>
+          <p:cNvPr id="37" name="Shape 35"/>
           <p:cNvSpPr/>
           <p:nvPr/>
         </p:nvSpPr>
         <p:spPr>
           <a:xfrm>
-            <a:off x="8092440" y="1554480"/>
-            <a:ext cx="1741932" cy="896112"/>
+            <a:off x="4364736" y="1965960"/>
+            <a:ext cx="3459480" cy="228600"/>
           </a:xfrm>
           <a:prstGeom prst="rect">
             <a:avLst/>
@@ -5228,14 +5335,14 @@
       </p:sp>
       <p:sp>
         <p:nvSpPr>
-          <p:cNvPr id="35" name="Text 33"/>
-          <p:cNvSpPr txBox="1"/>
-          <p:nvPr/>
-        </p:nvSpPr>
-        <p:spPr>
-          <a:xfrm>
-            <a:off x="8183879" y="1591056"/>
-            <a:ext cx="1613916" cy="402336"/>
+          <p:cNvPr id="38" name="Text 36"/>
+          <p:cNvSpPr txBox="1"/>
+          <p:nvPr/>
+        </p:nvSpPr>
+        <p:spPr>
+          <a:xfrm>
+            <a:off x="4437888" y="1965960"/>
+            <a:ext cx="1188720" cy="228600"/>
           </a:xfrm>
           <a:prstGeom prst="rect">
             <a:avLst/>
@@ -5249,61 +5356,95 @@
           <a:lstStyle/>
           <a:p>
             <a:r>
-              <a:rPr sz="1600" b="0" i="0">
+              <a:rPr sz="600" b="1" i="0">
                 <a:solidFill>
                   <a:srgbClr val="F2F2F2"/>
                 </a:solidFill>
                 <a:latin typeface="Trenda IG Text"/>
               </a:rPr>
-              <a:t>18</a:t>
-            </a:r>
-          </a:p>
-        </p:txBody>
-      </p:sp>
-      <p:sp>
-        <p:nvSpPr>
-          <p:cNvPr id="36" name="Text 34"/>
-          <p:cNvSpPr txBox="1"/>
-          <p:nvPr/>
-        </p:nvSpPr>
-        <p:spPr>
-          <a:xfrm>
-            <a:off x="8183879" y="1993392"/>
-            <a:ext cx="1613916" cy="420624"/>
-          </a:xfrm>
-          <a:prstGeom prst="rect">
-            <a:avLst/>
-          </a:prstGeom>
-          <a:noFill/>
-        </p:spPr>
-        <p:txBody>
-          <a:bodyPr wrap="square" lIns="0" rIns="0" tIns="0" bIns="0" anchor="t">
-            <a:spAutoFit/>
-          </a:bodyPr>
-          <a:lstStyle/>
-          <a:p>
-            <a:r>
-              <a:rPr sz="590" b="0" i="0">
+              <a:t>Delivery each day</a:t>
+            </a:r>
+          </a:p>
+        </p:txBody>
+      </p:sp>
+      <p:sp>
+        <p:nvSpPr>
+          <p:cNvPr id="39" name="Text 37"/>
+          <p:cNvSpPr txBox="1"/>
+          <p:nvPr/>
+        </p:nvSpPr>
+        <p:spPr>
+          <a:xfrm>
+            <a:off x="5608320" y="1965960"/>
+            <a:ext cx="987552" cy="228600"/>
+          </a:xfrm>
+          <a:prstGeom prst="rect">
+            <a:avLst/>
+          </a:prstGeom>
+          <a:noFill/>
+        </p:spPr>
+        <p:txBody>
+          <a:bodyPr wrap="square" lIns="0" rIns="0" tIns="0" bIns="0" anchor="ctr">
+            <a:spAutoFit/>
+          </a:bodyPr>
+          <a:lstStyle/>
+          <a:p>
+            <a:r>
+              <a:rPr sz="600" b="0" i="0">
                 <a:solidFill>
                   <a:srgbClr val="B3B3B3"/>
                 </a:solidFill>
                 <a:latin typeface="Trenda IG Text"/>
               </a:rPr>
-              <a:t>months, seven phases</a:t>
-            </a:r>
-          </a:p>
-        </p:txBody>
-      </p:sp>
-      <p:sp>
-        <p:nvSpPr>
-          <p:cNvPr id="37" name="Shape 35"/>
+              <a:t>office hours</a:t>
+            </a:r>
+          </a:p>
+        </p:txBody>
+      </p:sp>
+      <p:sp>
+        <p:nvSpPr>
+          <p:cNvPr id="40" name="Text 38"/>
+          <p:cNvSpPr txBox="1"/>
+          <p:nvPr/>
+        </p:nvSpPr>
+        <p:spPr>
+          <a:xfrm>
+            <a:off x="6614160" y="1965960"/>
+            <a:ext cx="1429512" cy="228600"/>
+          </a:xfrm>
+          <a:prstGeom prst="rect">
+            <a:avLst/>
+          </a:prstGeom>
+          <a:noFill/>
+        </p:spPr>
+        <p:txBody>
+          <a:bodyPr wrap="square" lIns="0" rIns="0" tIns="0" bIns="0" anchor="ctr">
+            <a:spAutoFit/>
+          </a:bodyPr>
+          <a:lstStyle/>
+          <a:p>
+            <a:r>
+              <a:rPr sz="600" b="1" i="0">
+                <a:solidFill>
+                  <a:srgbClr val="00D6F2"/>
+                </a:solidFill>
+                <a:latin typeface="Trenda IG Text"/>
+              </a:rPr>
+              <a:t>about 20 hours</a:t>
+            </a:r>
+          </a:p>
+        </p:txBody>
+      </p:sp>
+      <p:sp>
+        <p:nvSpPr>
+          <p:cNvPr id="41" name="Shape 39"/>
           <p:cNvSpPr/>
           <p:nvPr/>
         </p:nvSpPr>
         <p:spPr>
           <a:xfrm>
-            <a:off x="9907524" y="1554480"/>
-            <a:ext cx="1741932" cy="896112"/>
+            <a:off x="4364736" y="2231136"/>
+            <a:ext cx="3459480" cy="228600"/>
           </a:xfrm>
           <a:prstGeom prst="rect">
             <a:avLst/>
@@ -5338,14 +5479,14 @@
       </p:sp>
       <p:sp>
         <p:nvSpPr>
-          <p:cNvPr id="38" name="Text 36"/>
-          <p:cNvSpPr txBox="1"/>
-          <p:nvPr/>
-        </p:nvSpPr>
-        <p:spPr>
-          <a:xfrm>
-            <a:off x="9998964" y="1591056"/>
-            <a:ext cx="1613916" cy="402336"/>
+          <p:cNvPr id="42" name="Text 40"/>
+          <p:cNvSpPr txBox="1"/>
+          <p:nvPr/>
+        </p:nvSpPr>
+        <p:spPr>
+          <a:xfrm>
+            <a:off x="4437888" y="2231136"/>
+            <a:ext cx="1188720" cy="228600"/>
           </a:xfrm>
           <a:prstGeom prst="rect">
             <a:avLst/>
@@ -5359,39 +5500,260 @@
           <a:lstStyle/>
           <a:p>
             <a:r>
-              <a:rPr sz="1600" b="0" i="0">
+              <a:rPr sz="600" b="1" i="0">
                 <a:solidFill>
                   <a:srgbClr val="F2F2F2"/>
                 </a:solidFill>
                 <a:latin typeface="Trenda IG Text"/>
               </a:rPr>
-              <a:t>$4.79M</a:t>
-            </a:r>
-          </a:p>
-        </p:txBody>
-      </p:sp>
-      <p:sp>
-        <p:nvSpPr>
-          <p:cNvPr id="39" name="Text 37"/>
-          <p:cNvSpPr txBox="1"/>
-          <p:nvPr/>
-        </p:nvSpPr>
-        <p:spPr>
-          <a:xfrm>
-            <a:off x="9998964" y="1993392"/>
-            <a:ext cx="1613916" cy="420624"/>
-          </a:xfrm>
-          <a:prstGeom prst="rect">
-            <a:avLst/>
-          </a:prstGeom>
-          <a:noFill/>
-        </p:spPr>
-        <p:txBody>
-          <a:bodyPr wrap="square" lIns="0" rIns="0" tIns="0" bIns="0" anchor="t">
-            <a:spAutoFit/>
-          </a:bodyPr>
-          <a:lstStyle/>
-          <a:p>
+              <a:t>Changes checked</a:t>
+            </a:r>
+          </a:p>
+        </p:txBody>
+      </p:sp>
+      <p:sp>
+        <p:nvSpPr>
+          <p:cNvPr id="43" name="Text 41"/>
+          <p:cNvSpPr txBox="1"/>
+          <p:nvPr/>
+        </p:nvSpPr>
+        <p:spPr>
+          <a:xfrm>
+            <a:off x="5608320" y="2231136"/>
+            <a:ext cx="987552" cy="228600"/>
+          </a:xfrm>
+          <a:prstGeom prst="rect">
+            <a:avLst/>
+          </a:prstGeom>
+          <a:noFill/>
+        </p:spPr>
+        <p:txBody>
+          <a:bodyPr wrap="square" lIns="0" rIns="0" tIns="0" bIns="0" anchor="ctr">
+            <a:spAutoFit/>
+          </a:bodyPr>
+          <a:lstStyle/>
+          <a:p>
+            <a:r>
+              <a:rPr sz="600" b="0" i="0">
+                <a:solidFill>
+                  <a:srgbClr val="B3B3B3"/>
+                </a:solidFill>
+                <a:latin typeface="Trenda IG Text"/>
+              </a:rPr>
+              <a:t>depends on reviewer</a:t>
+            </a:r>
+          </a:p>
+        </p:txBody>
+      </p:sp>
+      <p:sp>
+        <p:nvSpPr>
+          <p:cNvPr id="44" name="Text 42"/>
+          <p:cNvSpPr txBox="1"/>
+          <p:nvPr/>
+        </p:nvSpPr>
+        <p:spPr>
+          <a:xfrm>
+            <a:off x="6614160" y="2231136"/>
+            <a:ext cx="1429512" cy="228600"/>
+          </a:xfrm>
+          <a:prstGeom prst="rect">
+            <a:avLst/>
+          </a:prstGeom>
+          <a:noFill/>
+        </p:spPr>
+        <p:txBody>
+          <a:bodyPr wrap="square" lIns="0" rIns="0" tIns="0" bIns="0" anchor="ctr">
+            <a:spAutoFit/>
+          </a:bodyPr>
+          <a:lstStyle/>
+          <a:p>
+            <a:r>
+              <a:rPr sz="600" b="1" i="0">
+                <a:solidFill>
+                  <a:srgbClr val="00D6F2"/>
+                </a:solidFill>
+                <a:latin typeface="Trenda IG Text"/>
+              </a:rPr>
+              <a:t>100%, same standards</a:t>
+            </a:r>
+          </a:p>
+        </p:txBody>
+      </p:sp>
+      <p:sp>
+        <p:nvSpPr>
+          <p:cNvPr id="45" name="Shape 43"/>
+          <p:cNvSpPr/>
+          <p:nvPr/>
+        </p:nvSpPr>
+        <p:spPr>
+          <a:xfrm>
+            <a:off x="4364736" y="2496312"/>
+            <a:ext cx="3459480" cy="228600"/>
+          </a:xfrm>
+          <a:prstGeom prst="rect">
+            <a:avLst/>
+          </a:prstGeom>
+          <a:solidFill>
+            <a:srgbClr val="141414"/>
+          </a:solidFill>
+          <a:ln>
+            <a:noFill/>
+          </a:ln>
+          <a:effectLst/>
+        </p:spPr>
+        <p:style>
+          <a:lnRef idx="1">
+            <a:schemeClr val="accent1"/>
+          </a:lnRef>
+          <a:fillRef idx="3">
+            <a:schemeClr val="accent1"/>
+          </a:fillRef>
+          <a:effectRef idx="2">
+            <a:schemeClr val="accent1"/>
+          </a:effectRef>
+          <a:fontRef idx="minor">
+            <a:schemeClr val="lt1"/>
+          </a:fontRef>
+        </p:style>
+        <p:txBody>
+          <a:bodyPr rtlCol="0" anchor="ctr"/>
+          <a:lstStyle/>
+          <a:p/>
+        </p:txBody>
+      </p:sp>
+      <p:sp>
+        <p:nvSpPr>
+          <p:cNvPr id="46" name="Text 44"/>
+          <p:cNvSpPr txBox="1"/>
+          <p:nvPr/>
+        </p:nvSpPr>
+        <p:spPr>
+          <a:xfrm>
+            <a:off x="4437888" y="2496312"/>
+            <a:ext cx="1188720" cy="228600"/>
+          </a:xfrm>
+          <a:prstGeom prst="rect">
+            <a:avLst/>
+          </a:prstGeom>
+          <a:noFill/>
+        </p:spPr>
+        <p:txBody>
+          <a:bodyPr wrap="square" lIns="0" rIns="0" tIns="0" bIns="0" anchor="ctr">
+            <a:spAutoFit/>
+          </a:bodyPr>
+          <a:lstStyle/>
+          <a:p>
+            <a:r>
+              <a:rPr sz="600" b="1" i="0">
+                <a:solidFill>
+                  <a:srgbClr val="F2F2F2"/>
+                </a:solidFill>
+                <a:latin typeface="Trenda IG Text"/>
+              </a:rPr>
+              <a:t>New pod live</a:t>
+            </a:r>
+          </a:p>
+        </p:txBody>
+      </p:sp>
+      <p:sp>
+        <p:nvSpPr>
+          <p:cNvPr id="47" name="Text 45"/>
+          <p:cNvSpPr txBox="1"/>
+          <p:nvPr/>
+        </p:nvSpPr>
+        <p:spPr>
+          <a:xfrm>
+            <a:off x="5608320" y="2496312"/>
+            <a:ext cx="987552" cy="228600"/>
+          </a:xfrm>
+          <a:prstGeom prst="rect">
+            <a:avLst/>
+          </a:prstGeom>
+          <a:noFill/>
+        </p:spPr>
+        <p:txBody>
+          <a:bodyPr wrap="square" lIns="0" rIns="0" tIns="0" bIns="0" anchor="ctr">
+            <a:spAutoFit/>
+          </a:bodyPr>
+          <a:lstStyle/>
+          <a:p>
+            <a:r>
+              <a:rPr sz="600" b="0" i="0">
+                <a:solidFill>
+                  <a:srgbClr val="B3B3B3"/>
+                </a:solidFill>
+                <a:latin typeface="Trenda IG Text"/>
+              </a:rPr>
+              <a:t>about 2 months</a:t>
+            </a:r>
+          </a:p>
+        </p:txBody>
+      </p:sp>
+      <p:sp>
+        <p:nvSpPr>
+          <p:cNvPr id="48" name="Text 46"/>
+          <p:cNvSpPr txBox="1"/>
+          <p:nvPr/>
+        </p:nvSpPr>
+        <p:spPr>
+          <a:xfrm>
+            <a:off x="6614160" y="2496312"/>
+            <a:ext cx="1429512" cy="228600"/>
+          </a:xfrm>
+          <a:prstGeom prst="rect">
+            <a:avLst/>
+          </a:prstGeom>
+          <a:noFill/>
+        </p:spPr>
+        <p:txBody>
+          <a:bodyPr wrap="square" lIns="0" rIns="0" tIns="0" bIns="0" anchor="ctr">
+            <a:spAutoFit/>
+          </a:bodyPr>
+          <a:lstStyle/>
+          <a:p>
+            <a:r>
+              <a:rPr sz="600" b="1" i="0">
+                <a:solidFill>
+                  <a:srgbClr val="00D6F2"/>
+                </a:solidFill>
+                <a:latin typeface="Trenda IG Text"/>
+              </a:rPr>
+              <a:t>2 weeks</a:t>
+            </a:r>
+          </a:p>
+        </p:txBody>
+      </p:sp>
+      <p:sp>
+        <p:nvSpPr>
+          <p:cNvPr id="49" name="Text 47"/>
+          <p:cNvSpPr txBox="1"/>
+          <p:nvPr/>
+        </p:nvSpPr>
+        <p:spPr>
+          <a:xfrm>
+            <a:off x="4364736" y="2779776"/>
+            <a:ext cx="3459480" cy="329184"/>
+          </a:xfrm>
+          <a:prstGeom prst="rect">
+            <a:avLst/>
+          </a:prstGeom>
+          <a:noFill/>
+        </p:spPr>
+        <p:txBody>
+          <a:bodyPr wrap="square" lIns="0" rIns="0" tIns="0" bIns="0" anchor="ctr">
+            <a:spAutoFit/>
+          </a:bodyPr>
+          <a:lstStyle/>
+          <a:p>
+            <a:r>
+              <a:rPr sz="590" b="1" i="0">
+                <a:solidFill>
+                  <a:srgbClr val="F2F2F2"/>
+                </a:solidFill>
+                <a:latin typeface="Trenda IG Text"/>
+              </a:rPr>
+              <a:t>Same team: </a:t>
+            </a:r>
             <a:r>
               <a:rPr sz="590" b="0" i="0">
                 <a:solidFill>
@@ -5399,64 +5761,30 @@
                 </a:solidFill>
                 <a:latin typeface="Trenda IG Text"/>
               </a:rPr>
-              <a:t>fixed fee, paid as each gate is signed</a:t>
-            </a:r>
-          </a:p>
-        </p:txBody>
-      </p:sp>
-      <p:sp>
-        <p:nvSpPr>
-          <p:cNvPr id="40" name="Text 38"/>
-          <p:cNvSpPr txBox="1"/>
-          <p:nvPr/>
-        </p:nvSpPr>
-        <p:spPr>
-          <a:xfrm>
-            <a:off x="6277356" y="2542032"/>
-            <a:ext cx="5372100" cy="457200"/>
-          </a:xfrm>
-          <a:prstGeom prst="rect">
-            <a:avLst/>
-          </a:prstGeom>
-          <a:noFill/>
-        </p:spPr>
-        <p:txBody>
-          <a:bodyPr wrap="square" lIns="0" rIns="0" tIns="0" bIns="0" anchor="t">
-            <a:spAutoFit/>
-          </a:bodyPr>
-          <a:lstStyle/>
-          <a:p>
-            <a:r>
-              <a:rPr sz="600" b="1" i="0">
-                <a:solidFill>
-                  <a:srgbClr val="F2F2F2"/>
-                </a:solidFill>
-                <a:latin typeface="Trenda IG Text"/>
-              </a:rPr>
-              <a:t>From month 19 </a:t>
-            </a:r>
-            <a:r>
-              <a:rPr sz="600" b="0" i="0">
-                <a:solidFill>
-                  <a:srgbClr val="B3B3B3"/>
-                </a:solidFill>
-                <a:latin typeface="Trenda IG Text"/>
-              </a:rPr>
-              <a:t>a run team of 4 keeps the graph, agents and evals current: about $1.24M a year with platform usage.</a:t>
-            </a:r>
-          </a:p>
-        </p:txBody>
-      </p:sp>
-      <p:sp>
-        <p:nvSpPr>
-          <p:cNvPr id="41" name="Shape 39"/>
+              <a:t>1.4-1.6x the output, or the same scope with 20-30% fewer people. </a:t>
+            </a:r>
+            <a:r>
+              <a:rPr sz="590" b="0" i="0">
+                <a:solidFill>
+                  <a:srgbClr val="8C8C8C"/>
+                </a:solidFill>
+                <a:latin typeface="Trenda IG Text"/>
+              </a:rPr>
+              <a:t>Pilot targets, baselined per pod.</a:t>
+            </a:r>
+          </a:p>
+        </p:txBody>
+      </p:sp>
+      <p:sp>
+        <p:nvSpPr>
+          <p:cNvPr id="50" name="Shape 48"/>
           <p:cNvSpPr/>
           <p:nvPr/>
         </p:nvSpPr>
         <p:spPr>
           <a:xfrm>
-            <a:off x="411480" y="3291840"/>
-            <a:ext cx="11365992" cy="1965960"/>
+            <a:off x="8061960" y="1188720"/>
+            <a:ext cx="3715512" cy="1965960"/>
           </a:xfrm>
           <a:prstGeom prst="roundRect">
             <a:avLst>
@@ -5493,14 +5821,14 @@
       </p:sp>
       <p:sp>
         <p:nvSpPr>
-          <p:cNvPr id="42" name="Shape 40"/>
+          <p:cNvPr id="51" name="Shape 49"/>
           <p:cNvSpPr/>
           <p:nvPr/>
         </p:nvSpPr>
         <p:spPr>
           <a:xfrm>
-            <a:off x="411480" y="3291840"/>
-            <a:ext cx="11365992" cy="256032"/>
+            <a:off x="8061960" y="1188720"/>
+            <a:ext cx="3715512" cy="256032"/>
           </a:xfrm>
           <a:prstGeom prst="rect">
             <a:avLst/>
@@ -5535,14 +5863,14 @@
       </p:sp>
       <p:sp>
         <p:nvSpPr>
-          <p:cNvPr id="43" name="Text 41"/>
-          <p:cNvSpPr txBox="1"/>
-          <p:nvPr/>
-        </p:nvSpPr>
-        <p:spPr>
-          <a:xfrm>
-            <a:off x="521208" y="3291840"/>
-            <a:ext cx="11146536" cy="256032"/>
+          <p:cNvPr id="52" name="Text 50"/>
+          <p:cNvSpPr txBox="1"/>
+          <p:nvPr/>
+        </p:nvSpPr>
+        <p:spPr>
+          <a:xfrm>
+            <a:off x="8171687" y="1188720"/>
+            <a:ext cx="3496056" cy="256032"/>
           </a:xfrm>
           <a:prstGeom prst="rect">
             <a:avLst/>
@@ -5562,7 +5890,7 @@
                 </a:solidFill>
                 <a:latin typeface="Trenda IG Text"/>
               </a:rPr>
-              <a:t>THE RETURN</a:t>
+              <a:t>THE BUILD AND RUN</a:t>
             </a:r>
             <a:r>
               <a:rPr sz="640" b="0" i="0">
@@ -5571,21 +5899,21 @@
                 </a:solidFill>
                 <a:latin typeface="Trenda IG Text"/>
               </a:rPr>
-              <a:t>   target · first full year after go-live</a:t>
-            </a:r>
-          </a:p>
-        </p:txBody>
-      </p:sp>
-      <p:sp>
-        <p:nvSpPr>
-          <p:cNvPr id="44" name="Shape 42"/>
+              <a:t>   fixed fee, paid by gate</a:t>
+            </a:r>
+          </a:p>
+        </p:txBody>
+      </p:sp>
+      <p:sp>
+        <p:nvSpPr>
+          <p:cNvPr id="53" name="Shape 51"/>
           <p:cNvSpPr/>
           <p:nvPr/>
         </p:nvSpPr>
         <p:spPr>
           <a:xfrm>
-            <a:off x="539496" y="3639312"/>
-            <a:ext cx="1796796" cy="1490472"/>
+            <a:off x="8189976" y="1554480"/>
+            <a:ext cx="1104391" cy="896112"/>
           </a:xfrm>
           <a:prstGeom prst="rect">
             <a:avLst/>
@@ -5620,14 +5948,14 @@
       </p:sp>
       <p:sp>
         <p:nvSpPr>
-          <p:cNvPr id="45" name="Text 43"/>
-          <p:cNvSpPr txBox="1"/>
-          <p:nvPr/>
-        </p:nvSpPr>
-        <p:spPr>
-          <a:xfrm>
-            <a:off x="667512" y="3977639"/>
-            <a:ext cx="1577340" cy="457200"/>
+          <p:cNvPr id="54" name="Text 52"/>
+          <p:cNvSpPr txBox="1"/>
+          <p:nvPr/>
+        </p:nvSpPr>
+        <p:spPr>
+          <a:xfrm>
+            <a:off x="8281416" y="1591056"/>
+            <a:ext cx="976376" cy="402336"/>
           </a:xfrm>
           <a:prstGeom prst="rect">
             <a:avLst/>
@@ -5641,95 +5969,61 @@
           <a:lstStyle/>
           <a:p>
             <a:r>
-              <a:rPr sz="2200" b="0" i="0">
+              <a:rPr sz="1600" b="0" i="0">
                 <a:solidFill>
                   <a:srgbClr val="F2F2F2"/>
                 </a:solidFill>
                 <a:latin typeface="Trenda IG Text"/>
               </a:rPr>
-              <a:t>$16M</a:t>
-            </a:r>
-          </a:p>
-        </p:txBody>
-      </p:sp>
-      <p:sp>
-        <p:nvSpPr>
-          <p:cNvPr id="46" name="Text 44"/>
-          <p:cNvSpPr txBox="1"/>
-          <p:nvPr/>
-        </p:nvSpPr>
-        <p:spPr>
-          <a:xfrm>
-            <a:off x="667512" y="4453127"/>
-            <a:ext cx="1577340" cy="201168"/>
-          </a:xfrm>
-          <a:prstGeom prst="rect">
-            <a:avLst/>
-          </a:prstGeom>
-          <a:noFill/>
-        </p:spPr>
-        <p:txBody>
-          <a:bodyPr wrap="square" lIns="0" rIns="0" tIns="0" bIns="0" anchor="ctr">
-            <a:spAutoFit/>
-          </a:bodyPr>
-          <a:lstStyle/>
-          <a:p>
-            <a:r>
-              <a:rPr sz="700" b="1" i="0">
-                <a:solidFill>
-                  <a:srgbClr val="F2F2F2"/>
-                </a:solidFill>
-                <a:latin typeface="Trenda IG Text"/>
-              </a:rPr>
-              <a:t>a year today</a:t>
-            </a:r>
-          </a:p>
-        </p:txBody>
-      </p:sp>
-      <p:sp>
-        <p:nvSpPr>
-          <p:cNvPr id="47" name="Text 45"/>
-          <p:cNvSpPr txBox="1"/>
-          <p:nvPr/>
-        </p:nvSpPr>
-        <p:spPr>
-          <a:xfrm>
-            <a:off x="667512" y="4654296"/>
-            <a:ext cx="1577340" cy="201168"/>
-          </a:xfrm>
-          <a:prstGeom prst="rect">
-            <a:avLst/>
-          </a:prstGeom>
-          <a:noFill/>
-        </p:spPr>
-        <p:txBody>
-          <a:bodyPr wrap="square" lIns="0" rIns="0" tIns="0" bIns="0" anchor="ctr">
-            <a:spAutoFit/>
-          </a:bodyPr>
-          <a:lstStyle/>
-          <a:p>
-            <a:r>
-              <a:rPr sz="600" b="0" i="0">
+              <a:t>17</a:t>
+            </a:r>
+          </a:p>
+        </p:txBody>
+      </p:sp>
+      <p:sp>
+        <p:nvSpPr>
+          <p:cNvPr id="55" name="Text 53"/>
+          <p:cNvSpPr txBox="1"/>
+          <p:nvPr/>
+        </p:nvSpPr>
+        <p:spPr>
+          <a:xfrm>
+            <a:off x="8281416" y="1993392"/>
+            <a:ext cx="976376" cy="420624"/>
+          </a:xfrm>
+          <a:prstGeom prst="rect">
+            <a:avLst/>
+          </a:prstGeom>
+          <a:noFill/>
+        </p:spPr>
+        <p:txBody>
+          <a:bodyPr wrap="square" lIns="0" rIns="0" tIns="0" bIns="0" anchor="t">
+            <a:spAutoFit/>
+          </a:bodyPr>
+          <a:lstStyle/>
+          <a:p>
+            <a:r>
+              <a:rPr sz="590" b="0" i="0">
                 <a:solidFill>
                   <a:srgbClr val="B3B3B3"/>
                 </a:solidFill>
                 <a:latin typeface="Trenda IG Text"/>
               </a:rPr>
-              <a:t>as provided by Ascension</a:t>
-            </a:r>
-          </a:p>
-        </p:txBody>
-      </p:sp>
-      <p:sp>
-        <p:nvSpPr>
-          <p:cNvPr id="48" name="Shape 46"/>
+              <a:t>people at peak, 10 roles</a:t>
+            </a:r>
+          </a:p>
+        </p:txBody>
+      </p:sp>
+      <p:sp>
+        <p:nvSpPr>
+          <p:cNvPr id="56" name="Shape 54"/>
           <p:cNvSpPr/>
           <p:nvPr/>
         </p:nvSpPr>
         <p:spPr>
           <a:xfrm>
-            <a:off x="2427732" y="3639312"/>
-            <a:ext cx="1796796" cy="1490472"/>
+            <a:off x="9367520" y="1554480"/>
+            <a:ext cx="1104391" cy="896112"/>
           </a:xfrm>
           <a:prstGeom prst="rect">
             <a:avLst/>
@@ -5764,7 +6058,543 @@
       </p:sp>
       <p:sp>
         <p:nvSpPr>
-          <p:cNvPr id="49" name="Text 47"/>
+          <p:cNvPr id="57" name="Text 55"/>
+          <p:cNvSpPr txBox="1"/>
+          <p:nvPr/>
+        </p:nvSpPr>
+        <p:spPr>
+          <a:xfrm>
+            <a:off x="9458960" y="1591056"/>
+            <a:ext cx="976376" cy="402336"/>
+          </a:xfrm>
+          <a:prstGeom prst="rect">
+            <a:avLst/>
+          </a:prstGeom>
+          <a:noFill/>
+        </p:spPr>
+        <p:txBody>
+          <a:bodyPr wrap="square" lIns="0" rIns="0" tIns="0" bIns="0" anchor="ctr">
+            <a:spAutoFit/>
+          </a:bodyPr>
+          <a:lstStyle/>
+          <a:p>
+            <a:r>
+              <a:rPr sz="1600" b="0" i="0">
+                <a:solidFill>
+                  <a:srgbClr val="F2F2F2"/>
+                </a:solidFill>
+                <a:latin typeface="Trenda IG Text"/>
+              </a:rPr>
+              <a:t>18</a:t>
+            </a:r>
+          </a:p>
+        </p:txBody>
+      </p:sp>
+      <p:sp>
+        <p:nvSpPr>
+          <p:cNvPr id="58" name="Text 56"/>
+          <p:cNvSpPr txBox="1"/>
+          <p:nvPr/>
+        </p:nvSpPr>
+        <p:spPr>
+          <a:xfrm>
+            <a:off x="9458960" y="1993392"/>
+            <a:ext cx="976376" cy="420624"/>
+          </a:xfrm>
+          <a:prstGeom prst="rect">
+            <a:avLst/>
+          </a:prstGeom>
+          <a:noFill/>
+        </p:spPr>
+        <p:txBody>
+          <a:bodyPr wrap="square" lIns="0" rIns="0" tIns="0" bIns="0" anchor="t">
+            <a:spAutoFit/>
+          </a:bodyPr>
+          <a:lstStyle/>
+          <a:p>
+            <a:r>
+              <a:rPr sz="590" b="0" i="0">
+                <a:solidFill>
+                  <a:srgbClr val="B3B3B3"/>
+                </a:solidFill>
+                <a:latin typeface="Trenda IG Text"/>
+              </a:rPr>
+              <a:t>months, seven phases</a:t>
+            </a:r>
+          </a:p>
+        </p:txBody>
+      </p:sp>
+      <p:sp>
+        <p:nvSpPr>
+          <p:cNvPr id="59" name="Shape 57"/>
+          <p:cNvSpPr/>
+          <p:nvPr/>
+        </p:nvSpPr>
+        <p:spPr>
+          <a:xfrm>
+            <a:off x="10545064" y="1554480"/>
+            <a:ext cx="1104391" cy="896112"/>
+          </a:xfrm>
+          <a:prstGeom prst="rect">
+            <a:avLst/>
+          </a:prstGeom>
+          <a:solidFill>
+            <a:srgbClr val="141414"/>
+          </a:solidFill>
+          <a:ln>
+            <a:noFill/>
+          </a:ln>
+          <a:effectLst/>
+        </p:spPr>
+        <p:style>
+          <a:lnRef idx="1">
+            <a:schemeClr val="accent1"/>
+          </a:lnRef>
+          <a:fillRef idx="3">
+            <a:schemeClr val="accent1"/>
+          </a:fillRef>
+          <a:effectRef idx="2">
+            <a:schemeClr val="accent1"/>
+          </a:effectRef>
+          <a:fontRef idx="minor">
+            <a:schemeClr val="lt1"/>
+          </a:fontRef>
+        </p:style>
+        <p:txBody>
+          <a:bodyPr rtlCol="0" anchor="ctr"/>
+          <a:lstStyle/>
+          <a:p/>
+        </p:txBody>
+      </p:sp>
+      <p:sp>
+        <p:nvSpPr>
+          <p:cNvPr id="60" name="Text 58"/>
+          <p:cNvSpPr txBox="1"/>
+          <p:nvPr/>
+        </p:nvSpPr>
+        <p:spPr>
+          <a:xfrm>
+            <a:off x="10636504" y="1591056"/>
+            <a:ext cx="976376" cy="402336"/>
+          </a:xfrm>
+          <a:prstGeom prst="rect">
+            <a:avLst/>
+          </a:prstGeom>
+          <a:noFill/>
+        </p:spPr>
+        <p:txBody>
+          <a:bodyPr wrap="square" lIns="0" rIns="0" tIns="0" bIns="0" anchor="ctr">
+            <a:spAutoFit/>
+          </a:bodyPr>
+          <a:lstStyle/>
+          <a:p>
+            <a:r>
+              <a:rPr sz="1600" b="0" i="0">
+                <a:solidFill>
+                  <a:srgbClr val="F2F2F2"/>
+                </a:solidFill>
+                <a:latin typeface="Trenda IG Text"/>
+              </a:rPr>
+              <a:t>$4.79M</a:t>
+            </a:r>
+          </a:p>
+        </p:txBody>
+      </p:sp>
+      <p:sp>
+        <p:nvSpPr>
+          <p:cNvPr id="61" name="Text 59"/>
+          <p:cNvSpPr txBox="1"/>
+          <p:nvPr/>
+        </p:nvSpPr>
+        <p:spPr>
+          <a:xfrm>
+            <a:off x="10636504" y="1993392"/>
+            <a:ext cx="976376" cy="420624"/>
+          </a:xfrm>
+          <a:prstGeom prst="rect">
+            <a:avLst/>
+          </a:prstGeom>
+          <a:noFill/>
+        </p:spPr>
+        <p:txBody>
+          <a:bodyPr wrap="square" lIns="0" rIns="0" tIns="0" bIns="0" anchor="t">
+            <a:spAutoFit/>
+          </a:bodyPr>
+          <a:lstStyle/>
+          <a:p>
+            <a:r>
+              <a:rPr sz="590" b="0" i="0">
+                <a:solidFill>
+                  <a:srgbClr val="B3B3B3"/>
+                </a:solidFill>
+                <a:latin typeface="Trenda IG Text"/>
+              </a:rPr>
+              <a:t>fixed fee, paid as each gate is signed</a:t>
+            </a:r>
+          </a:p>
+        </p:txBody>
+      </p:sp>
+      <p:sp>
+        <p:nvSpPr>
+          <p:cNvPr id="62" name="Text 60"/>
+          <p:cNvSpPr txBox="1"/>
+          <p:nvPr/>
+        </p:nvSpPr>
+        <p:spPr>
+          <a:xfrm>
+            <a:off x="8189976" y="2542032"/>
+            <a:ext cx="3459480" cy="457200"/>
+          </a:xfrm>
+          <a:prstGeom prst="rect">
+            <a:avLst/>
+          </a:prstGeom>
+          <a:noFill/>
+        </p:spPr>
+        <p:txBody>
+          <a:bodyPr wrap="square" lIns="0" rIns="0" tIns="0" bIns="0" anchor="t">
+            <a:spAutoFit/>
+          </a:bodyPr>
+          <a:lstStyle/>
+          <a:p>
+            <a:r>
+              <a:rPr sz="600" b="1" i="0">
+                <a:solidFill>
+                  <a:srgbClr val="F2F2F2"/>
+                </a:solidFill>
+                <a:latin typeface="Trenda IG Text"/>
+              </a:rPr>
+              <a:t>From month 19 </a:t>
+            </a:r>
+            <a:r>
+              <a:rPr sz="600" b="0" i="0">
+                <a:solidFill>
+                  <a:srgbClr val="B3B3B3"/>
+                </a:solidFill>
+                <a:latin typeface="Trenda IG Text"/>
+              </a:rPr>
+              <a:t>a run team of 4 keeps the graph, agents and evals current: about $1.24M a year with platform usage.</a:t>
+            </a:r>
+          </a:p>
+        </p:txBody>
+      </p:sp>
+      <p:sp>
+        <p:nvSpPr>
+          <p:cNvPr id="63" name="Shape 61"/>
+          <p:cNvSpPr/>
+          <p:nvPr/>
+        </p:nvSpPr>
+        <p:spPr>
+          <a:xfrm>
+            <a:off x="411480" y="3291840"/>
+            <a:ext cx="11365992" cy="1965960"/>
+          </a:xfrm>
+          <a:prstGeom prst="roundRect">
+            <a:avLst>
+              <a:gd name="adj" fmla="val 2000"/>
+            </a:avLst>
+          </a:prstGeom>
+          <a:solidFill>
+            <a:srgbClr val="1E1E1E"/>
+          </a:solidFill>
+          <a:ln>
+            <a:noFill/>
+          </a:ln>
+          <a:effectLst/>
+        </p:spPr>
+        <p:style>
+          <a:lnRef idx="1">
+            <a:schemeClr val="accent1"/>
+          </a:lnRef>
+          <a:fillRef idx="3">
+            <a:schemeClr val="accent1"/>
+          </a:fillRef>
+          <a:effectRef idx="2">
+            <a:schemeClr val="accent1"/>
+          </a:effectRef>
+          <a:fontRef idx="minor">
+            <a:schemeClr val="lt1"/>
+          </a:fontRef>
+        </p:style>
+        <p:txBody>
+          <a:bodyPr rtlCol="0" anchor="ctr"/>
+          <a:lstStyle/>
+          <a:p/>
+        </p:txBody>
+      </p:sp>
+      <p:sp>
+        <p:nvSpPr>
+          <p:cNvPr id="64" name="Shape 62"/>
+          <p:cNvSpPr/>
+          <p:nvPr/>
+        </p:nvSpPr>
+        <p:spPr>
+          <a:xfrm>
+            <a:off x="411480" y="3291840"/>
+            <a:ext cx="11365992" cy="256032"/>
+          </a:xfrm>
+          <a:prstGeom prst="rect">
+            <a:avLst/>
+          </a:prstGeom>
+          <a:solidFill>
+            <a:srgbClr val="2B2B2B"/>
+          </a:solidFill>
+          <a:ln>
+            <a:noFill/>
+          </a:ln>
+          <a:effectLst/>
+        </p:spPr>
+        <p:style>
+          <a:lnRef idx="1">
+            <a:schemeClr val="accent1"/>
+          </a:lnRef>
+          <a:fillRef idx="3">
+            <a:schemeClr val="accent1"/>
+          </a:fillRef>
+          <a:effectRef idx="2">
+            <a:schemeClr val="accent1"/>
+          </a:effectRef>
+          <a:fontRef idx="minor">
+            <a:schemeClr val="lt1"/>
+          </a:fontRef>
+        </p:style>
+        <p:txBody>
+          <a:bodyPr rtlCol="0" anchor="ctr"/>
+          <a:lstStyle/>
+          <a:p/>
+        </p:txBody>
+      </p:sp>
+      <p:sp>
+        <p:nvSpPr>
+          <p:cNvPr id="65" name="Text 63"/>
+          <p:cNvSpPr txBox="1"/>
+          <p:nvPr/>
+        </p:nvSpPr>
+        <p:spPr>
+          <a:xfrm>
+            <a:off x="521208" y="3291840"/>
+            <a:ext cx="11146536" cy="256032"/>
+          </a:xfrm>
+          <a:prstGeom prst="rect">
+            <a:avLst/>
+          </a:prstGeom>
+          <a:noFill/>
+        </p:spPr>
+        <p:txBody>
+          <a:bodyPr wrap="square" lIns="0" rIns="0" tIns="0" bIns="0" anchor="ctr">
+            <a:spAutoFit/>
+          </a:bodyPr>
+          <a:lstStyle/>
+          <a:p>
+            <a:r>
+              <a:rPr sz="640" b="1" i="0" spc="120">
+                <a:solidFill>
+                  <a:srgbClr val="F2F2F2"/>
+                </a:solidFill>
+                <a:latin typeface="Trenda IG Text"/>
+              </a:rPr>
+              <a:t>THE RETURN</a:t>
+            </a:r>
+            <a:r>
+              <a:rPr sz="640" b="0" i="0">
+                <a:solidFill>
+                  <a:srgbClr val="B3B3B3"/>
+                </a:solidFill>
+                <a:latin typeface="Trenda IG Text"/>
+              </a:rPr>
+              <a:t>   target · first full year after go-live</a:t>
+            </a:r>
+          </a:p>
+        </p:txBody>
+      </p:sp>
+      <p:sp>
+        <p:nvSpPr>
+          <p:cNvPr id="66" name="Shape 64"/>
+          <p:cNvSpPr/>
+          <p:nvPr/>
+        </p:nvSpPr>
+        <p:spPr>
+          <a:xfrm>
+            <a:off x="539496" y="3639312"/>
+            <a:ext cx="1796796" cy="1490472"/>
+          </a:xfrm>
+          <a:prstGeom prst="rect">
+            <a:avLst/>
+          </a:prstGeom>
+          <a:solidFill>
+            <a:srgbClr val="141414"/>
+          </a:solidFill>
+          <a:ln>
+            <a:noFill/>
+          </a:ln>
+          <a:effectLst/>
+        </p:spPr>
+        <p:style>
+          <a:lnRef idx="1">
+            <a:schemeClr val="accent1"/>
+          </a:lnRef>
+          <a:fillRef idx="3">
+            <a:schemeClr val="accent1"/>
+          </a:fillRef>
+          <a:effectRef idx="2">
+            <a:schemeClr val="accent1"/>
+          </a:effectRef>
+          <a:fontRef idx="minor">
+            <a:schemeClr val="lt1"/>
+          </a:fontRef>
+        </p:style>
+        <p:txBody>
+          <a:bodyPr rtlCol="0" anchor="ctr"/>
+          <a:lstStyle/>
+          <a:p/>
+        </p:txBody>
+      </p:sp>
+      <p:sp>
+        <p:nvSpPr>
+          <p:cNvPr id="67" name="Text 65"/>
+          <p:cNvSpPr txBox="1"/>
+          <p:nvPr/>
+        </p:nvSpPr>
+        <p:spPr>
+          <a:xfrm>
+            <a:off x="667512" y="3977639"/>
+            <a:ext cx="1577340" cy="457200"/>
+          </a:xfrm>
+          <a:prstGeom prst="rect">
+            <a:avLst/>
+          </a:prstGeom>
+          <a:noFill/>
+        </p:spPr>
+        <p:txBody>
+          <a:bodyPr wrap="square" lIns="0" rIns="0" tIns="0" bIns="0" anchor="ctr">
+            <a:spAutoFit/>
+          </a:bodyPr>
+          <a:lstStyle/>
+          <a:p>
+            <a:r>
+              <a:rPr sz="2200" b="0" i="0">
+                <a:solidFill>
+                  <a:srgbClr val="F2F2F2"/>
+                </a:solidFill>
+                <a:latin typeface="Trenda IG Text"/>
+              </a:rPr>
+              <a:t>$16M</a:t>
+            </a:r>
+          </a:p>
+        </p:txBody>
+      </p:sp>
+      <p:sp>
+        <p:nvSpPr>
+          <p:cNvPr id="68" name="Text 66"/>
+          <p:cNvSpPr txBox="1"/>
+          <p:nvPr/>
+        </p:nvSpPr>
+        <p:spPr>
+          <a:xfrm>
+            <a:off x="667512" y="4453127"/>
+            <a:ext cx="1577340" cy="201168"/>
+          </a:xfrm>
+          <a:prstGeom prst="rect">
+            <a:avLst/>
+          </a:prstGeom>
+          <a:noFill/>
+        </p:spPr>
+        <p:txBody>
+          <a:bodyPr wrap="square" lIns="0" rIns="0" tIns="0" bIns="0" anchor="ctr">
+            <a:spAutoFit/>
+          </a:bodyPr>
+          <a:lstStyle/>
+          <a:p>
+            <a:r>
+              <a:rPr sz="700" b="1" i="0">
+                <a:solidFill>
+                  <a:srgbClr val="F2F2F2"/>
+                </a:solidFill>
+                <a:latin typeface="Trenda IG Text"/>
+              </a:rPr>
+              <a:t>a year today</a:t>
+            </a:r>
+          </a:p>
+        </p:txBody>
+      </p:sp>
+      <p:sp>
+        <p:nvSpPr>
+          <p:cNvPr id="69" name="Text 67"/>
+          <p:cNvSpPr txBox="1"/>
+          <p:nvPr/>
+        </p:nvSpPr>
+        <p:spPr>
+          <a:xfrm>
+            <a:off x="667512" y="4654296"/>
+            <a:ext cx="1577340" cy="201168"/>
+          </a:xfrm>
+          <a:prstGeom prst="rect">
+            <a:avLst/>
+          </a:prstGeom>
+          <a:noFill/>
+        </p:spPr>
+        <p:txBody>
+          <a:bodyPr wrap="square" lIns="0" rIns="0" tIns="0" bIns="0" anchor="ctr">
+            <a:spAutoFit/>
+          </a:bodyPr>
+          <a:lstStyle/>
+          <a:p>
+            <a:r>
+              <a:rPr sz="600" b="0" i="0">
+                <a:solidFill>
+                  <a:srgbClr val="B3B3B3"/>
+                </a:solidFill>
+                <a:latin typeface="Trenda IG Text"/>
+              </a:rPr>
+              <a:t>as provided by Ascension</a:t>
+            </a:r>
+          </a:p>
+        </p:txBody>
+      </p:sp>
+      <p:sp>
+        <p:nvSpPr>
+          <p:cNvPr id="70" name="Shape 68"/>
+          <p:cNvSpPr/>
+          <p:nvPr/>
+        </p:nvSpPr>
+        <p:spPr>
+          <a:xfrm>
+            <a:off x="2427732" y="3639312"/>
+            <a:ext cx="1796796" cy="1490472"/>
+          </a:xfrm>
+          <a:prstGeom prst="rect">
+            <a:avLst/>
+          </a:prstGeom>
+          <a:solidFill>
+            <a:srgbClr val="141414"/>
+          </a:solidFill>
+          <a:ln>
+            <a:noFill/>
+          </a:ln>
+          <a:effectLst/>
+        </p:spPr>
+        <p:style>
+          <a:lnRef idx="1">
+            <a:schemeClr val="accent1"/>
+          </a:lnRef>
+          <a:fillRef idx="3">
+            <a:schemeClr val="accent1"/>
+          </a:fillRef>
+          <a:effectRef idx="2">
+            <a:schemeClr val="accent1"/>
+          </a:effectRef>
+          <a:fontRef idx="minor">
+            <a:schemeClr val="lt1"/>
+          </a:fontRef>
+        </p:style>
+        <p:txBody>
+          <a:bodyPr rtlCol="0" anchor="ctr"/>
+          <a:lstStyle/>
+          <a:p/>
+        </p:txBody>
+      </p:sp>
+      <p:sp>
+        <p:nvSpPr>
+          <p:cNvPr id="71" name="Text 69"/>
           <p:cNvSpPr txBox="1"/>
           <p:nvPr/>
         </p:nvSpPr>
@@ -5798,7 +6628,7 @@
       </p:sp>
       <p:sp>
         <p:nvSpPr>
-          <p:cNvPr id="50" name="Text 48"/>
+          <p:cNvPr id="72" name="Text 70"/>
           <p:cNvSpPr txBox="1"/>
           <p:nvPr/>
         </p:nvSpPr>
@@ -5832,7 +6662,7 @@
       </p:sp>
       <p:sp>
         <p:nvSpPr>
-          <p:cNvPr id="51" name="Text 49"/>
+          <p:cNvPr id="73" name="Text 71"/>
           <p:cNvSpPr txBox="1"/>
           <p:nvPr/>
         </p:nvSpPr>
@@ -5866,7 +6696,7 @@
       </p:sp>
       <p:sp>
         <p:nvSpPr>
-          <p:cNvPr id="52" name="Differentiator Border 51"/>
+          <p:cNvPr id="74" name="Differentiator Border 73"/>
           <p:cNvSpPr/>
           <p:nvPr/>
         </p:nvSpPr>
@@ -5919,7 +6749,7 @@
       </p:sp>
       <p:sp>
         <p:nvSpPr>
-          <p:cNvPr id="53" name="Shape 52"/>
+          <p:cNvPr id="75" name="Shape 74"/>
           <p:cNvSpPr/>
           <p:nvPr/>
         </p:nvSpPr>
@@ -5961,7 +6791,7 @@
       </p:sp>
       <p:sp>
         <p:nvSpPr>
-          <p:cNvPr id="54" name="Text 53"/>
+          <p:cNvPr id="76" name="Text 75"/>
           <p:cNvSpPr txBox="1"/>
           <p:nvPr/>
         </p:nvSpPr>
@@ -5995,7 +6825,7 @@
       </p:sp>
       <p:sp>
         <p:nvSpPr>
-          <p:cNvPr id="55" name="Text 54"/>
+          <p:cNvPr id="77" name="Text 76"/>
           <p:cNvSpPr txBox="1"/>
           <p:nvPr/>
         </p:nvSpPr>
@@ -6029,7 +6859,7 @@
       </p:sp>
       <p:sp>
         <p:nvSpPr>
-          <p:cNvPr id="56" name="Text 55"/>
+          <p:cNvPr id="78" name="Text 77"/>
           <p:cNvSpPr txBox="1"/>
           <p:nvPr/>
         </p:nvSpPr>
@@ -6063,7 +6893,7 @@
       </p:sp>
       <p:sp>
         <p:nvSpPr>
-          <p:cNvPr id="57" name="Shape 56"/>
+          <p:cNvPr id="79" name="Shape 78"/>
           <p:cNvSpPr/>
           <p:nvPr/>
         </p:nvSpPr>
@@ -6105,7 +6935,7 @@
       </p:sp>
       <p:sp>
         <p:nvSpPr>
-          <p:cNvPr id="58" name="Text 57"/>
+          <p:cNvPr id="80" name="Text 79"/>
           <p:cNvSpPr txBox="1"/>
           <p:nvPr/>
         </p:nvSpPr>
@@ -6139,7 +6969,7 @@
       </p:sp>
       <p:sp>
         <p:nvSpPr>
-          <p:cNvPr id="59" name="Text 58"/>
+          <p:cNvPr id="81" name="Text 80"/>
           <p:cNvSpPr txBox="1"/>
           <p:nvPr/>
         </p:nvSpPr>
@@ -6173,7 +7003,7 @@
       </p:sp>
       <p:sp>
         <p:nvSpPr>
-          <p:cNvPr id="60" name="Text 59"/>
+          <p:cNvPr id="82" name="Text 81"/>
           <p:cNvSpPr txBox="1"/>
           <p:nvPr/>
         </p:nvSpPr>
@@ -6207,7 +7037,7 @@
       </p:sp>
       <p:sp>
         <p:nvSpPr>
-          <p:cNvPr id="61" name="Shape 60"/>
+          <p:cNvPr id="83" name="Shape 82"/>
           <p:cNvSpPr/>
           <p:nvPr/>
         </p:nvSpPr>
@@ -6249,7 +7079,7 @@
       </p:sp>
       <p:sp>
         <p:nvSpPr>
-          <p:cNvPr id="62" name="Shape 61"/>
+          <p:cNvPr id="84" name="Shape 83"/>
           <p:cNvSpPr/>
           <p:nvPr/>
         </p:nvSpPr>
@@ -6302,7 +7132,7 @@
       </p:sp>
       <p:sp>
         <p:nvSpPr>
-          <p:cNvPr id="63" name="Text 62"/>
+          <p:cNvPr id="85" name="Text 84"/>
           <p:cNvSpPr txBox="1"/>
           <p:nvPr/>
         </p:nvSpPr>
@@ -6357,7 +7187,7 @@
       </p:sp>
       <p:sp>
         <p:nvSpPr>
-          <p:cNvPr id="64" name="Shape 63"/>
+          <p:cNvPr id="86" name="Shape 85"/>
           <p:cNvSpPr/>
           <p:nvPr/>
         </p:nvSpPr>
@@ -6399,7 +7229,7 @@
       </p:sp>
       <p:sp>
         <p:nvSpPr>
-          <p:cNvPr id="65" name="Shape 64"/>
+          <p:cNvPr id="87" name="Shape 86"/>
           <p:cNvSpPr/>
           <p:nvPr/>
         </p:nvSpPr>
@@ -6452,7 +7282,7 @@
       </p:sp>
       <p:sp>
         <p:nvSpPr>
-          <p:cNvPr id="66" name="Text 65"/>
+          <p:cNvPr id="88" name="Text 87"/>
           <p:cNvSpPr txBox="1"/>
           <p:nvPr/>
         </p:nvSpPr>
@@ -6507,7 +7337,7 @@
       </p:sp>
       <p:sp>
         <p:nvSpPr>
-          <p:cNvPr id="67" name="Text 66"/>
+          <p:cNvPr id="89" name="Text 88"/>
           <p:cNvSpPr txBox="1"/>
           <p:nvPr/>
         </p:nvSpPr>
@@ -6562,7 +7392,7 @@
       </p:sp>
       <p:sp>
         <p:nvSpPr>
-          <p:cNvPr id="68" name="Shape 67"/>
+          <p:cNvPr id="90" name="Shape 89"/>
           <p:cNvSpPr/>
           <p:nvPr/>
         </p:nvSpPr>
@@ -6604,7 +7434,7 @@
       </p:sp>
       <p:sp>
         <p:nvSpPr>
-          <p:cNvPr id="69" name="Shape 68"/>
+          <p:cNvPr id="91" name="Shape 90"/>
           <p:cNvSpPr/>
           <p:nvPr/>
         </p:nvSpPr>
@@ -6646,7 +7476,7 @@
       </p:sp>
       <p:sp>
         <p:nvSpPr>
-          <p:cNvPr id="70" name="Text 69"/>
+          <p:cNvPr id="92" name="Text 91"/>
           <p:cNvSpPr txBox="1"/>
           <p:nvPr/>
         </p:nvSpPr>
@@ -6701,7 +7531,7 @@
       </p:sp>
       <p:sp>
         <p:nvSpPr>
-          <p:cNvPr id="71" name="Shape 70"/>
+          <p:cNvPr id="93" name="Shape 92"/>
           <p:cNvSpPr/>
           <p:nvPr/>
         </p:nvSpPr>
@@ -6743,7 +7573,7 @@
       </p:sp>
       <p:sp>
         <p:nvSpPr>
-          <p:cNvPr id="72" name="Shape 71"/>
+          <p:cNvPr id="94" name="Shape 93"/>
           <p:cNvSpPr/>
           <p:nvPr/>
         </p:nvSpPr>
@@ -6785,7 +7615,7 @@
       </p:sp>
       <p:sp>
         <p:nvSpPr>
-          <p:cNvPr id="73" name="Text 72"/>
+          <p:cNvPr id="95" name="Text 94"/>
           <p:cNvSpPr txBox="1"/>
           <p:nvPr/>
         </p:nvSpPr>
@@ -6840,7 +7670,7 @@
       </p:sp>
       <p:sp>
         <p:nvSpPr>
-          <p:cNvPr id="74" name="Shape 73"/>
+          <p:cNvPr id="96" name="Shape 95"/>
           <p:cNvSpPr/>
           <p:nvPr/>
         </p:nvSpPr>
@@ -6882,7 +7712,7 @@
       </p:sp>
       <p:sp>
         <p:nvSpPr>
-          <p:cNvPr id="75" name="Shape 74"/>
+          <p:cNvPr id="97" name="Shape 96"/>
           <p:cNvSpPr/>
           <p:nvPr/>
         </p:nvSpPr>
@@ -6924,7 +7754,7 @@
       </p:sp>
       <p:sp>
         <p:nvSpPr>
-          <p:cNvPr id="76" name="Text 75"/>
+          <p:cNvPr id="98" name="Text 97"/>
           <p:cNvSpPr txBox="1"/>
           <p:nvPr/>
         </p:nvSpPr>
@@ -6979,7 +7809,7 @@
       </p:sp>
       <p:sp>
         <p:nvSpPr>
-          <p:cNvPr id="77" name="Shape 76"/>
+          <p:cNvPr id="99" name="Shape 98"/>
           <p:cNvSpPr/>
           <p:nvPr/>
         </p:nvSpPr>
@@ -7021,7 +7851,7 @@
       </p:sp>
       <p:sp>
         <p:nvSpPr>
-          <p:cNvPr id="78" name="Shape 77"/>
+          <p:cNvPr id="100" name="Shape 99"/>
           <p:cNvSpPr/>
           <p:nvPr/>
         </p:nvSpPr>
@@ -7063,7 +7893,7 @@
       </p:sp>
       <p:sp>
         <p:nvSpPr>
-          <p:cNvPr id="79" name="Text 78"/>
+          <p:cNvPr id="101" name="Text 100"/>
           <p:cNvSpPr txBox="1"/>
           <p:nvPr/>
         </p:nvSpPr>

</xml_diff>

<commit_message>
Lean team slide: drop the same-team output line from the pod panel
Co-Authored-By: Claude Opus 5.5 <noreply@anthropic.com>
Claude-Session: https://claude.ai/code/session_01Hf94kqMzSofkkrQm7kpNba
</commit_message>
<xml_diff>
--- a/poc/data_harness/Ascension Agentic Harness - Data Harness.pptx
+++ b/poc/data_harness/Ascension Agentic Harness - Data Harness.pptx
@@ -1495,7 +1495,7 @@
           </a:p>
           <a:p>
             <a:r>
-              <a:t>- The pod: what changes for every pod (pilot targets, baselined per pod): a new engineer is productive in about a week instead of 4-6 weeks, because they ask the graph; agents work overnight, so delivery runs about 20 hours a day instead of office hours; every change is checked against the same standards; a new pod goes live on the platform in 2 weeks instead of about 2 months. The same team delivers 1.4-1.6x the output, or the same scope with 20-30% fewer people.</a:t>
+              <a:t>- The pod: what changes for every pod (pilot targets, baselined per pod): a new engineer is productive in about a week instead of 4-6 weeks, because they ask the graph; agents work overnight, so delivery runs about 20 hours a day instead of office hours; every change is checked against the same standards; a new pod goes live on the platform in 2 weeks instead of about 2 months.</a:t>
             </a:r>
           </a:p>
           <a:p>
@@ -5745,24 +5745,6 @@
           </a:bodyPr>
           <a:lstStyle/>
           <a:p>
-            <a:r>
-              <a:rPr sz="590" b="1" i="0">
-                <a:solidFill>
-                  <a:srgbClr val="F2F2F2"/>
-                </a:solidFill>
-                <a:latin typeface="Trenda IG Text"/>
-              </a:rPr>
-              <a:t>Same team: </a:t>
-            </a:r>
-            <a:r>
-              <a:rPr sz="590" b="0" i="0">
-                <a:solidFill>
-                  <a:srgbClr val="B3B3B3"/>
-                </a:solidFill>
-                <a:latin typeface="Trenda IG Text"/>
-              </a:rPr>
-              <a:t>1.4-1.6x the output, or the same scope with 20-30% fewer people. </a:t>
-            </a:r>
             <a:r>
               <a:rPr sz="590" b="0" i="0">
                 <a:solidFill>

</xml_diff>